<commit_message>
Add Operations-Koordination Ist/Soll (IPS-spezifisch)
Neue Analyse in IPS-Terminologie:
- Step 1 (Ist): Service Owner koordiniert Support selbst, Support-Einheiten
  verstreut (DXC/AMS, TSS, Service Desk, RSC) - 8 Probleme (P1-P8)
- Step 2 (Soll): Klammer trennt WAS (Service Owner) von WIE (neuer Service
  Delivery Manager), SIAM-Funktion verankert im IPS Management Office;
  Verortungsempfehlung inkl. Abgrenzung zur Alternative TSS

Deck erweitert auf 11 Slides (Slides 10-11 mit Ist/Soll-Diagrammen),
Markdown um Abschnitt 10.

Co-Authored-By: Claude Opus 4.8 <noreply@anthropic.com>
Claude-Session: https://claude.ai/code/session_01HefpCknsZ9fVeMqj75mAqW
</commit_message>
<xml_diff>
--- a/2026_07_08_IT_Ablauforganisation_Homebase_Mannschaft.pptx
+++ b/2026_07_08_IT_Ablauforganisation_Homebase_Mannschaft.pptx
@@ -14,6 +14,8 @@
     <p:sldId id="262" r:id="rId13"/>
     <p:sldId id="263" r:id="rId14"/>
     <p:sldId id="264" r:id="rId15"/>
+    <p:sldId id="265" r:id="rId16"/>
+    <p:sldId id="266" r:id="rId17"/>
   </p:sldIdLst>
   <p:sldSz cx="12192000" cy="6858000" type="screen4x3"/>
   <p:notesSz cx="6858000" cy="9144000"/>
@@ -3650,6 +3652,4935 @@
                 <a:latin typeface="Calibri"/>
               </a:rPr>
               <a:t>End-to-End-Verantwortung für Services &amp; Produkte, besetzt aus mehreren Homebases. Hier wird geliefert.</a:t>
+            </a:r>
+          </a:p>
+        </p:txBody>
+      </p:sp>
+    </p:spTree>
+  </p:cSld>
+  <p:clrMapOvr>
+    <a:masterClrMapping/>
+  </p:clrMapOvr>
+</p:sld>
+</file>
+
+<file path=ppt/slides/slide10.xml><?xml version="1.0" encoding="utf-8"?>
+<p:sld xmlns:a="http://schemas.openxmlformats.org/drawingml/2006/main" xmlns:p="http://schemas.openxmlformats.org/presentationml/2006/main" xmlns:r="http://schemas.openxmlformats.org/officeDocument/2006/relationships">
+  <p:cSld>
+    <p:spTree>
+      <p:nvGrpSpPr>
+        <p:cNvPr id="1" name=""/>
+        <p:cNvGrpSpPr/>
+        <p:nvPr/>
+      </p:nvGrpSpPr>
+      <p:grpSpPr/>
+      <p:sp>
+        <p:nvSpPr>
+          <p:cNvPr id="2" name="Rectangle 1"/>
+          <p:cNvSpPr/>
+          <p:nvPr/>
+        </p:nvSpPr>
+        <p:spPr>
+          <a:xfrm>
+            <a:off x="0" y="0"/>
+            <a:ext cx="12192000" cy="6858000"/>
+          </a:xfrm>
+          <a:prstGeom prst="rect">
+            <a:avLst/>
+          </a:prstGeom>
+          <a:solidFill>
+            <a:srgbClr val="FFFFFF"/>
+          </a:solidFill>
+          <a:ln>
+            <a:noFill/>
+          </a:ln>
+          <a:effectLst/>
+        </p:spPr>
+        <p:style>
+          <a:lnRef idx="1">
+            <a:schemeClr val="accent1"/>
+          </a:lnRef>
+          <a:fillRef idx="3">
+            <a:schemeClr val="accent1"/>
+          </a:fillRef>
+          <a:effectRef idx="2">
+            <a:schemeClr val="accent1"/>
+          </a:effectRef>
+          <a:fontRef idx="minor">
+            <a:schemeClr val="lt1"/>
+          </a:fontRef>
+        </p:style>
+        <p:txBody>
+          <a:bodyPr rtlCol="0" anchor="ctr"/>
+          <a:lstStyle/>
+          <a:p>
+            <a:pPr algn="ctr"/>
+          </a:p>
+        </p:txBody>
+      </p:sp>
+      <p:sp>
+        <p:nvSpPr>
+          <p:cNvPr id="3" name="Rectangle 2"/>
+          <p:cNvSpPr/>
+          <p:nvPr/>
+        </p:nvSpPr>
+        <p:spPr>
+          <a:xfrm>
+            <a:off x="0" y="0"/>
+            <a:ext cx="121920" cy="6858000"/>
+          </a:xfrm>
+          <a:prstGeom prst="rect">
+            <a:avLst/>
+          </a:prstGeom>
+          <a:solidFill>
+            <a:srgbClr val="F07F12"/>
+          </a:solidFill>
+          <a:ln>
+            <a:noFill/>
+          </a:ln>
+          <a:effectLst/>
+        </p:spPr>
+        <p:style>
+          <a:lnRef idx="1">
+            <a:schemeClr val="accent1"/>
+          </a:lnRef>
+          <a:fillRef idx="3">
+            <a:schemeClr val="accent1"/>
+          </a:fillRef>
+          <a:effectRef idx="2">
+            <a:schemeClr val="accent1"/>
+          </a:effectRef>
+          <a:fontRef idx="minor">
+            <a:schemeClr val="lt1"/>
+          </a:fontRef>
+        </p:style>
+        <p:txBody>
+          <a:bodyPr rtlCol="0" anchor="ctr"/>
+          <a:lstStyle/>
+          <a:p>
+            <a:pPr algn="ctr"/>
+          </a:p>
+        </p:txBody>
+      </p:sp>
+      <p:sp>
+        <p:nvSpPr>
+          <p:cNvPr id="4" name="TextBox 3"/>
+          <p:cNvSpPr txBox="1"/>
+          <p:nvPr/>
+        </p:nvSpPr>
+        <p:spPr>
+          <a:xfrm>
+            <a:off x="533400" y="381000"/>
+            <a:ext cx="9906000" cy="304800"/>
+          </a:xfrm>
+          <a:prstGeom prst="rect">
+            <a:avLst/>
+          </a:prstGeom>
+          <a:noFill/>
+          <a:ln>
+            <a:noFill/>
+          </a:ln>
+        </p:spPr>
+        <p:txBody>
+          <a:bodyPr wrap="square" anchor="t" lIns="45000" rIns="45000" tIns="15000" bIns="15000">
+            <a:spAutoFit/>
+          </a:bodyPr>
+          <a:lstStyle/>
+          <a:p>
+            <a:pPr algn="l"/>
+            <a:r>
+              <a:rPr sz="1100" b="1" i="0">
+                <a:solidFill>
+                  <a:srgbClr val="F07F12"/>
+                </a:solidFill>
+                <a:latin typeface="Calibri"/>
+              </a:rPr>
+              <a:t>OPERATIONS · STATUS QUO</a:t>
+            </a:r>
+          </a:p>
+        </p:txBody>
+      </p:sp>
+      <p:sp>
+        <p:nvSpPr>
+          <p:cNvPr id="5" name="TextBox 4"/>
+          <p:cNvSpPr txBox="1"/>
+          <p:nvPr/>
+        </p:nvSpPr>
+        <p:spPr>
+          <a:xfrm>
+            <a:off x="533400" y="647700"/>
+            <a:ext cx="11125200" cy="685800"/>
+          </a:xfrm>
+          <a:prstGeom prst="rect">
+            <a:avLst/>
+          </a:prstGeom>
+          <a:noFill/>
+          <a:ln>
+            <a:noFill/>
+          </a:ln>
+        </p:spPr>
+        <p:txBody>
+          <a:bodyPr wrap="square" anchor="t" lIns="45000" rIns="45000" tIns="15000" bIns="15000">
+            <a:spAutoFit/>
+          </a:bodyPr>
+          <a:lstStyle/>
+          <a:p>
+            <a:pPr algn="l"/>
+            <a:r>
+              <a:rPr sz="2400" b="1" i="0">
+                <a:solidFill>
+                  <a:srgbClr val="1F2937"/>
+                </a:solidFill>
+                <a:latin typeface="Calibri"/>
+              </a:rPr>
+              <a:t>Heute koordiniert jeder Service Owner seinen Support selbst</a:t>
+            </a:r>
+          </a:p>
+        </p:txBody>
+      </p:sp>
+      <p:sp>
+        <p:nvSpPr>
+          <p:cNvPr id="6" name="Rectangle 5"/>
+          <p:cNvSpPr/>
+          <p:nvPr/>
+        </p:nvSpPr>
+        <p:spPr>
+          <a:xfrm>
+            <a:off x="533400" y="1333500"/>
+            <a:ext cx="11125200" cy="9144"/>
+          </a:xfrm>
+          <a:prstGeom prst="rect">
+            <a:avLst/>
+          </a:prstGeom>
+          <a:solidFill>
+            <a:srgbClr val="D1D5DB"/>
+          </a:solidFill>
+          <a:ln>
+            <a:noFill/>
+          </a:ln>
+          <a:effectLst/>
+        </p:spPr>
+        <p:style>
+          <a:lnRef idx="1">
+            <a:schemeClr val="accent1"/>
+          </a:lnRef>
+          <a:fillRef idx="3">
+            <a:schemeClr val="accent1"/>
+          </a:fillRef>
+          <a:effectRef idx="2">
+            <a:schemeClr val="accent1"/>
+          </a:effectRef>
+          <a:fontRef idx="minor">
+            <a:schemeClr val="lt1"/>
+          </a:fontRef>
+        </p:style>
+        <p:txBody>
+          <a:bodyPr rtlCol="0" anchor="ctr"/>
+          <a:lstStyle/>
+          <a:p>
+            <a:pPr algn="ctr"/>
+          </a:p>
+        </p:txBody>
+      </p:sp>
+      <p:sp>
+        <p:nvSpPr>
+          <p:cNvPr id="7" name="TextBox 6"/>
+          <p:cNvSpPr txBox="1"/>
+          <p:nvPr/>
+        </p:nvSpPr>
+        <p:spPr>
+          <a:xfrm>
+            <a:off x="11430000" y="6438900"/>
+            <a:ext cx="609600" cy="304800"/>
+          </a:xfrm>
+          <a:prstGeom prst="rect">
+            <a:avLst/>
+          </a:prstGeom>
+          <a:noFill/>
+          <a:ln>
+            <a:noFill/>
+          </a:ln>
+        </p:spPr>
+        <p:txBody>
+          <a:bodyPr wrap="square" anchor="t" lIns="45000" rIns="45000" tIns="15000" bIns="15000">
+            <a:spAutoFit/>
+          </a:bodyPr>
+          <a:lstStyle/>
+          <a:p>
+            <a:pPr algn="r"/>
+            <a:r>
+              <a:rPr sz="1000" b="0" i="0">
+                <a:solidFill>
+                  <a:srgbClr val="D1D5DB"/>
+                </a:solidFill>
+                <a:latin typeface="Calibri"/>
+              </a:rPr>
+              <a:t>10</a:t>
+            </a:r>
+          </a:p>
+        </p:txBody>
+      </p:sp>
+      <p:sp>
+        <p:nvSpPr>
+          <p:cNvPr id="8" name="TextBox 7"/>
+          <p:cNvSpPr txBox="1"/>
+          <p:nvPr/>
+        </p:nvSpPr>
+        <p:spPr>
+          <a:xfrm>
+            <a:off x="533400" y="6438900"/>
+            <a:ext cx="6858000" cy="304800"/>
+          </a:xfrm>
+          <a:prstGeom prst="rect">
+            <a:avLst/>
+          </a:prstGeom>
+          <a:noFill/>
+          <a:ln>
+            <a:noFill/>
+          </a:ln>
+        </p:spPr>
+        <p:txBody>
+          <a:bodyPr wrap="square" anchor="t" lIns="45000" rIns="45000" tIns="15000" bIns="15000">
+            <a:spAutoFit/>
+          </a:bodyPr>
+          <a:lstStyle/>
+          <a:p>
+            <a:pPr algn="l"/>
+            <a:r>
+              <a:rPr sz="900" b="0" i="0">
+                <a:solidFill>
+                  <a:srgbClr val="D1D5DB"/>
+                </a:solidFill>
+                <a:latin typeface="Calibri"/>
+              </a:rPr>
+              <a:t>IT-Ablauforganisation · Zielbild</a:t>
+            </a:r>
+          </a:p>
+        </p:txBody>
+      </p:sp>
+      <p:sp>
+        <p:nvSpPr>
+          <p:cNvPr id="9" name="TextBox 8"/>
+          <p:cNvSpPr txBox="1"/>
+          <p:nvPr/>
+        </p:nvSpPr>
+        <p:spPr>
+          <a:xfrm>
+            <a:off x="533400" y="1470660"/>
+            <a:ext cx="6858000" cy="304800"/>
+          </a:xfrm>
+          <a:prstGeom prst="rect">
+            <a:avLst/>
+          </a:prstGeom>
+          <a:noFill/>
+          <a:ln>
+            <a:noFill/>
+          </a:ln>
+        </p:spPr>
+        <p:txBody>
+          <a:bodyPr wrap="square" anchor="t" lIns="45000" rIns="45000" tIns="15000" bIns="15000">
+            <a:spAutoFit/>
+          </a:bodyPr>
+          <a:lstStyle/>
+          <a:p>
+            <a:pPr algn="l">
+              <a:lnSpc>
+                <a:spcPct val="112000"/>
+              </a:lnSpc>
+            </a:pPr>
+            <a:r>
+              <a:rPr sz="1050" b="0" i="0">
+                <a:solidFill>
+                  <a:srgbClr val="4B5563"/>
+                </a:solidFill>
+                <a:latin typeface="Calibri"/>
+              </a:rPr>
+              <a:t>Beispiel BSS: ein Service = Applikation + DXC (AMS) + TSS-Services (Windows Server) + Service Desk. Alle Koordinationslinien laufen beim Service Owner zusammen.</a:t>
+            </a:r>
+          </a:p>
+        </p:txBody>
+      </p:sp>
+      <p:sp>
+        <p:nvSpPr>
+          <p:cNvPr id="10" name="Rounded Rectangle 9"/>
+          <p:cNvSpPr/>
+          <p:nvPr/>
+        </p:nvSpPr>
+        <p:spPr>
+          <a:xfrm>
+            <a:off x="1600200" y="1981200"/>
+            <a:ext cx="1981200" cy="647700"/>
+          </a:xfrm>
+          <a:prstGeom prst="roundRect">
+            <a:avLst>
+              <a:gd name="adj" fmla="val 8000"/>
+            </a:avLst>
+          </a:prstGeom>
+          <a:solidFill>
+            <a:srgbClr val="F07F12"/>
+          </a:solidFill>
+          <a:ln>
+            <a:noFill/>
+          </a:ln>
+          <a:effectLst/>
+        </p:spPr>
+        <p:style>
+          <a:lnRef idx="1">
+            <a:schemeClr val="accent1"/>
+          </a:lnRef>
+          <a:fillRef idx="3">
+            <a:schemeClr val="accent1"/>
+          </a:fillRef>
+          <a:effectRef idx="2">
+            <a:schemeClr val="accent1"/>
+          </a:effectRef>
+          <a:fontRef idx="minor">
+            <a:schemeClr val="lt1"/>
+          </a:fontRef>
+        </p:style>
+        <p:txBody>
+          <a:bodyPr rtlCol="0" anchor="ctr"/>
+          <a:lstStyle/>
+          <a:p>
+            <a:pPr algn="ctr"/>
+          </a:p>
+        </p:txBody>
+      </p:sp>
+      <p:sp>
+        <p:nvSpPr>
+          <p:cNvPr id="11" name="TextBox 10"/>
+          <p:cNvSpPr txBox="1"/>
+          <p:nvPr/>
+        </p:nvSpPr>
+        <p:spPr>
+          <a:xfrm>
+            <a:off x="1600200" y="1981200"/>
+            <a:ext cx="1981200" cy="647700"/>
+          </a:xfrm>
+          <a:prstGeom prst="rect">
+            <a:avLst/>
+          </a:prstGeom>
+          <a:noFill/>
+          <a:ln>
+            <a:noFill/>
+          </a:ln>
+        </p:spPr>
+        <p:txBody>
+          <a:bodyPr wrap="square" anchor="ctr" lIns="45000" rIns="45000" tIns="15000" bIns="15000">
+            <a:spAutoFit/>
+          </a:bodyPr>
+          <a:lstStyle/>
+          <a:p>
+            <a:pPr algn="ctr"/>
+            <a:r>
+              <a:rPr sz="1050" b="1" i="0">
+                <a:solidFill>
+                  <a:srgbClr val="FFFFFF"/>
+                </a:solidFill>
+                <a:latin typeface="Calibri"/>
+              </a:rPr>
+              <a:t>Service Owner (BSS)</a:t>
+            </a:r>
+          </a:p>
+          <a:p>
+            <a:pPr algn="ctr"/>
+            <a:r>
+              <a:rPr sz="850" b="0" i="0">
+                <a:solidFill>
+                  <a:srgbClr val="FDE6CC"/>
+                </a:solidFill>
+                <a:latin typeface="Calibri"/>
+              </a:rPr>
+              <a:t>koordiniert ALLES selbst</a:t>
+            </a:r>
+          </a:p>
+        </p:txBody>
+      </p:sp>
+      <p:cxnSp>
+        <p:nvCxnSpPr>
+          <p:cNvPr id="12" name="Connector 11"/>
+          <p:cNvCxnSpPr/>
+          <p:nvPr/>
+        </p:nvCxnSpPr>
+        <p:spPr>
+          <a:xfrm flipH="1">
+            <a:off x="990600" y="2628900"/>
+            <a:ext cx="1600200" cy="419100"/>
+          </a:xfrm>
+          <a:prstGeom prst="line">
+            <a:avLst/>
+          </a:prstGeom>
+          <a:ln w="15875">
+            <a:solidFill>
+              <a:srgbClr val="B91C1C"/>
+            </a:solidFill>
+          </a:ln>
+          <a:effectLst/>
+        </p:spPr>
+        <p:style>
+          <a:lnRef idx="2">
+            <a:schemeClr val="accent1"/>
+          </a:lnRef>
+          <a:fillRef idx="0">
+            <a:schemeClr val="accent1"/>
+          </a:fillRef>
+          <a:effectRef idx="1">
+            <a:schemeClr val="accent1"/>
+          </a:effectRef>
+          <a:fontRef idx="minor">
+            <a:schemeClr val="tx1"/>
+          </a:fontRef>
+        </p:style>
+      </p:cxnSp>
+      <p:cxnSp>
+        <p:nvCxnSpPr>
+          <p:cNvPr id="13" name="Connector 12"/>
+          <p:cNvCxnSpPr/>
+          <p:nvPr/>
+        </p:nvCxnSpPr>
+        <p:spPr>
+          <a:xfrm>
+            <a:off x="2590800" y="2628900"/>
+            <a:ext cx="266700" cy="419100"/>
+          </a:xfrm>
+          <a:prstGeom prst="line">
+            <a:avLst/>
+          </a:prstGeom>
+          <a:ln w="15875">
+            <a:solidFill>
+              <a:srgbClr val="B91C1C"/>
+            </a:solidFill>
+          </a:ln>
+          <a:effectLst/>
+        </p:spPr>
+        <p:style>
+          <a:lnRef idx="2">
+            <a:schemeClr val="accent1"/>
+          </a:lnRef>
+          <a:fillRef idx="0">
+            <a:schemeClr val="accent1"/>
+          </a:fillRef>
+          <a:effectRef idx="1">
+            <a:schemeClr val="accent1"/>
+          </a:effectRef>
+          <a:fontRef idx="minor">
+            <a:schemeClr val="tx1"/>
+          </a:fontRef>
+        </p:style>
+      </p:cxnSp>
+      <p:cxnSp>
+        <p:nvCxnSpPr>
+          <p:cNvPr id="14" name="Connector 13"/>
+          <p:cNvCxnSpPr/>
+          <p:nvPr/>
+        </p:nvCxnSpPr>
+        <p:spPr>
+          <a:xfrm>
+            <a:off x="2590800" y="2628900"/>
+            <a:ext cx="2133600" cy="419100"/>
+          </a:xfrm>
+          <a:prstGeom prst="line">
+            <a:avLst/>
+          </a:prstGeom>
+          <a:ln w="15875">
+            <a:solidFill>
+              <a:srgbClr val="B91C1C"/>
+            </a:solidFill>
+          </a:ln>
+          <a:effectLst/>
+        </p:spPr>
+        <p:style>
+          <a:lnRef idx="2">
+            <a:schemeClr val="accent1"/>
+          </a:lnRef>
+          <a:fillRef idx="0">
+            <a:schemeClr val="accent1"/>
+          </a:fillRef>
+          <a:effectRef idx="1">
+            <a:schemeClr val="accent1"/>
+          </a:effectRef>
+          <a:fontRef idx="minor">
+            <a:schemeClr val="tx1"/>
+          </a:fontRef>
+        </p:style>
+      </p:cxnSp>
+      <p:cxnSp>
+        <p:nvCxnSpPr>
+          <p:cNvPr id="15" name="Connector 14"/>
+          <p:cNvCxnSpPr/>
+          <p:nvPr/>
+        </p:nvCxnSpPr>
+        <p:spPr>
+          <a:xfrm flipH="1">
+            <a:off x="990600" y="2628900"/>
+            <a:ext cx="1600200" cy="1371600"/>
+          </a:xfrm>
+          <a:prstGeom prst="line">
+            <a:avLst/>
+          </a:prstGeom>
+          <a:ln w="15875">
+            <a:solidFill>
+              <a:srgbClr val="B91C1C"/>
+            </a:solidFill>
+          </a:ln>
+          <a:effectLst/>
+        </p:spPr>
+        <p:style>
+          <a:lnRef idx="2">
+            <a:schemeClr val="accent1"/>
+          </a:lnRef>
+          <a:fillRef idx="0">
+            <a:schemeClr val="accent1"/>
+          </a:fillRef>
+          <a:effectRef idx="1">
+            <a:schemeClr val="accent1"/>
+          </a:effectRef>
+          <a:fontRef idx="minor">
+            <a:schemeClr val="tx1"/>
+          </a:fontRef>
+        </p:style>
+      </p:cxnSp>
+      <p:cxnSp>
+        <p:nvCxnSpPr>
+          <p:cNvPr id="16" name="Connector 15"/>
+          <p:cNvCxnSpPr/>
+          <p:nvPr/>
+        </p:nvCxnSpPr>
+        <p:spPr>
+          <a:xfrm>
+            <a:off x="2590800" y="2628900"/>
+            <a:ext cx="266700" cy="1371600"/>
+          </a:xfrm>
+          <a:prstGeom prst="line">
+            <a:avLst/>
+          </a:prstGeom>
+          <a:ln w="15875">
+            <a:solidFill>
+              <a:srgbClr val="B91C1C"/>
+            </a:solidFill>
+          </a:ln>
+          <a:effectLst/>
+        </p:spPr>
+        <p:style>
+          <a:lnRef idx="2">
+            <a:schemeClr val="accent1"/>
+          </a:lnRef>
+          <a:fillRef idx="0">
+            <a:schemeClr val="accent1"/>
+          </a:fillRef>
+          <a:effectRef idx="1">
+            <a:schemeClr val="accent1"/>
+          </a:effectRef>
+          <a:fontRef idx="minor">
+            <a:schemeClr val="tx1"/>
+          </a:fontRef>
+        </p:style>
+      </p:cxnSp>
+      <p:cxnSp>
+        <p:nvCxnSpPr>
+          <p:cNvPr id="17" name="Connector 16"/>
+          <p:cNvCxnSpPr/>
+          <p:nvPr/>
+        </p:nvCxnSpPr>
+        <p:spPr>
+          <a:xfrm>
+            <a:off x="2590800" y="2628900"/>
+            <a:ext cx="2133600" cy="1371600"/>
+          </a:xfrm>
+          <a:prstGeom prst="line">
+            <a:avLst/>
+          </a:prstGeom>
+          <a:ln w="15875">
+            <a:solidFill>
+              <a:srgbClr val="B91C1C"/>
+            </a:solidFill>
+          </a:ln>
+          <a:effectLst/>
+        </p:spPr>
+        <p:style>
+          <a:lnRef idx="2">
+            <a:schemeClr val="accent1"/>
+          </a:lnRef>
+          <a:fillRef idx="0">
+            <a:schemeClr val="accent1"/>
+          </a:fillRef>
+          <a:effectRef idx="1">
+            <a:schemeClr val="accent1"/>
+          </a:effectRef>
+          <a:fontRef idx="minor">
+            <a:schemeClr val="tx1"/>
+          </a:fontRef>
+        </p:style>
+      </p:cxnSp>
+      <p:sp>
+        <p:nvSpPr>
+          <p:cNvPr id="18" name="Rounded Rectangle 17"/>
+          <p:cNvSpPr/>
+          <p:nvPr/>
+        </p:nvSpPr>
+        <p:spPr>
+          <a:xfrm>
+            <a:off x="228600" y="3048000"/>
+            <a:ext cx="1524000" cy="685800"/>
+          </a:xfrm>
+          <a:prstGeom prst="roundRect">
+            <a:avLst>
+              <a:gd name="adj" fmla="val 8000"/>
+            </a:avLst>
+          </a:prstGeom>
+          <a:solidFill>
+            <a:srgbClr val="E4ECF4"/>
+          </a:solidFill>
+          <a:ln w="12700">
+            <a:solidFill>
+              <a:srgbClr val="2E5A8F"/>
+            </a:solidFill>
+          </a:ln>
+          <a:effectLst/>
+        </p:spPr>
+        <p:style>
+          <a:lnRef idx="1">
+            <a:schemeClr val="accent1"/>
+          </a:lnRef>
+          <a:fillRef idx="3">
+            <a:schemeClr val="accent1"/>
+          </a:fillRef>
+          <a:effectRef idx="2">
+            <a:schemeClr val="accent1"/>
+          </a:effectRef>
+          <a:fontRef idx="minor">
+            <a:schemeClr val="lt1"/>
+          </a:fontRef>
+        </p:style>
+        <p:txBody>
+          <a:bodyPr rtlCol="0" anchor="ctr"/>
+          <a:lstStyle/>
+          <a:p>
+            <a:pPr algn="ctr"/>
+          </a:p>
+        </p:txBody>
+      </p:sp>
+      <p:sp>
+        <p:nvSpPr>
+          <p:cNvPr id="19" name="TextBox 18"/>
+          <p:cNvSpPr txBox="1"/>
+          <p:nvPr/>
+        </p:nvSpPr>
+        <p:spPr>
+          <a:xfrm>
+            <a:off x="228600" y="3048000"/>
+            <a:ext cx="1524000" cy="685800"/>
+          </a:xfrm>
+          <a:prstGeom prst="rect">
+            <a:avLst/>
+          </a:prstGeom>
+          <a:noFill/>
+          <a:ln>
+            <a:noFill/>
+          </a:ln>
+        </p:spPr>
+        <p:txBody>
+          <a:bodyPr wrap="square" anchor="ctr" lIns="45000" rIns="45000" tIns="15000" bIns="15000">
+            <a:spAutoFit/>
+          </a:bodyPr>
+          <a:lstStyle/>
+          <a:p>
+            <a:pPr algn="ctr">
+              <a:lnSpc>
+                <a:spcPct val="100000"/>
+              </a:lnSpc>
+            </a:pPr>
+            <a:r>
+              <a:rPr sz="860" b="1" i="0">
+                <a:solidFill>
+                  <a:srgbClr val="1F2937"/>
+                </a:solidFill>
+                <a:latin typeface="Calibri"/>
+              </a:rPr>
+              <a:t>Business-Applikation</a:t>
+            </a:r>
+          </a:p>
+          <a:p>
+            <a:pPr algn="ctr">
+              <a:lnSpc>
+                <a:spcPct val="100000"/>
+              </a:lnSpc>
+            </a:pPr>
+            <a:r>
+              <a:rPr sz="780" b="0" i="0">
+                <a:solidFill>
+                  <a:srgbClr val="4B5563"/>
+                </a:solidFill>
+                <a:latin typeface="Calibri"/>
+              </a:rPr>
+              <a:t>(BSS)</a:t>
+            </a:r>
+          </a:p>
+        </p:txBody>
+      </p:sp>
+      <p:sp>
+        <p:nvSpPr>
+          <p:cNvPr id="20" name="Rounded Rectangle 19"/>
+          <p:cNvSpPr/>
+          <p:nvPr/>
+        </p:nvSpPr>
+        <p:spPr>
+          <a:xfrm>
+            <a:off x="2095500" y="3048000"/>
+            <a:ext cx="1524000" cy="685800"/>
+          </a:xfrm>
+          <a:prstGeom prst="roundRect">
+            <a:avLst>
+              <a:gd name="adj" fmla="val 8000"/>
+            </a:avLst>
+          </a:prstGeom>
+          <a:solidFill>
+            <a:srgbClr val="EBE6F5"/>
+          </a:solidFill>
+          <a:ln w="12700">
+            <a:solidFill>
+              <a:srgbClr val="6B4FA0"/>
+            </a:solidFill>
+          </a:ln>
+          <a:effectLst/>
+        </p:spPr>
+        <p:style>
+          <a:lnRef idx="1">
+            <a:schemeClr val="accent1"/>
+          </a:lnRef>
+          <a:fillRef idx="3">
+            <a:schemeClr val="accent1"/>
+          </a:fillRef>
+          <a:effectRef idx="2">
+            <a:schemeClr val="accent1"/>
+          </a:effectRef>
+          <a:fontRef idx="minor">
+            <a:schemeClr val="lt1"/>
+          </a:fontRef>
+        </p:style>
+        <p:txBody>
+          <a:bodyPr rtlCol="0" anchor="ctr"/>
+          <a:lstStyle/>
+          <a:p>
+            <a:pPr algn="ctr"/>
+          </a:p>
+        </p:txBody>
+      </p:sp>
+      <p:sp>
+        <p:nvSpPr>
+          <p:cNvPr id="21" name="TextBox 20"/>
+          <p:cNvSpPr txBox="1"/>
+          <p:nvPr/>
+        </p:nvSpPr>
+        <p:spPr>
+          <a:xfrm>
+            <a:off x="2095500" y="3048000"/>
+            <a:ext cx="1524000" cy="685800"/>
+          </a:xfrm>
+          <a:prstGeom prst="rect">
+            <a:avLst/>
+          </a:prstGeom>
+          <a:noFill/>
+          <a:ln>
+            <a:noFill/>
+          </a:ln>
+        </p:spPr>
+        <p:txBody>
+          <a:bodyPr wrap="square" anchor="ctr" lIns="45000" rIns="45000" tIns="15000" bIns="15000">
+            <a:spAutoFit/>
+          </a:bodyPr>
+          <a:lstStyle/>
+          <a:p>
+            <a:pPr algn="ctr">
+              <a:lnSpc>
+                <a:spcPct val="100000"/>
+              </a:lnSpc>
+            </a:pPr>
+            <a:r>
+              <a:rPr sz="860" b="1" i="0">
+                <a:solidFill>
+                  <a:srgbClr val="1F2937"/>
+                </a:solidFill>
+                <a:latin typeface="Calibri"/>
+              </a:rPr>
+              <a:t>AMS · DXC</a:t>
+            </a:r>
+          </a:p>
+          <a:p>
+            <a:pPr algn="ctr">
+              <a:lnSpc>
+                <a:spcPct val="100000"/>
+              </a:lnSpc>
+            </a:pPr>
+            <a:r>
+              <a:rPr sz="780" b="0" i="0">
+                <a:solidFill>
+                  <a:srgbClr val="4B5563"/>
+                </a:solidFill>
+                <a:latin typeface="Calibri"/>
+              </a:rPr>
+              <a:t>SAP L1–L3</a:t>
+            </a:r>
+          </a:p>
+        </p:txBody>
+      </p:sp>
+      <p:sp>
+        <p:nvSpPr>
+          <p:cNvPr id="22" name="Rounded Rectangle 21"/>
+          <p:cNvSpPr/>
+          <p:nvPr/>
+        </p:nvSpPr>
+        <p:spPr>
+          <a:xfrm>
+            <a:off x="3962400" y="3048000"/>
+            <a:ext cx="1524000" cy="685800"/>
+          </a:xfrm>
+          <a:prstGeom prst="roundRect">
+            <a:avLst>
+              <a:gd name="adj" fmla="val 8000"/>
+            </a:avLst>
+          </a:prstGeom>
+          <a:solidFill>
+            <a:srgbClr val="EBE6F5"/>
+          </a:solidFill>
+          <a:ln w="12700">
+            <a:solidFill>
+              <a:srgbClr val="6B4FA0"/>
+            </a:solidFill>
+          </a:ln>
+          <a:effectLst/>
+        </p:spPr>
+        <p:style>
+          <a:lnRef idx="1">
+            <a:schemeClr val="accent1"/>
+          </a:lnRef>
+          <a:fillRef idx="3">
+            <a:schemeClr val="accent1"/>
+          </a:fillRef>
+          <a:effectRef idx="2">
+            <a:schemeClr val="accent1"/>
+          </a:effectRef>
+          <a:fontRef idx="minor">
+            <a:schemeClr val="lt1"/>
+          </a:fontRef>
+        </p:style>
+        <p:txBody>
+          <a:bodyPr rtlCol="0" anchor="ctr"/>
+          <a:lstStyle/>
+          <a:p>
+            <a:pPr algn="ctr"/>
+          </a:p>
+        </p:txBody>
+      </p:sp>
+      <p:sp>
+        <p:nvSpPr>
+          <p:cNvPr id="23" name="TextBox 22"/>
+          <p:cNvSpPr txBox="1"/>
+          <p:nvPr/>
+        </p:nvSpPr>
+        <p:spPr>
+          <a:xfrm>
+            <a:off x="3962400" y="3048000"/>
+            <a:ext cx="1524000" cy="685800"/>
+          </a:xfrm>
+          <a:prstGeom prst="rect">
+            <a:avLst/>
+          </a:prstGeom>
+          <a:noFill/>
+          <a:ln>
+            <a:noFill/>
+          </a:ln>
+        </p:spPr>
+        <p:txBody>
+          <a:bodyPr wrap="square" anchor="ctr" lIns="45000" rIns="45000" tIns="15000" bIns="15000">
+            <a:spAutoFit/>
+          </a:bodyPr>
+          <a:lstStyle/>
+          <a:p>
+            <a:pPr algn="ctr">
+              <a:lnSpc>
+                <a:spcPct val="100000"/>
+              </a:lnSpc>
+            </a:pPr>
+            <a:r>
+              <a:rPr sz="860" b="1" i="0">
+                <a:solidFill>
+                  <a:srgbClr val="1F2937"/>
+                </a:solidFill>
+                <a:latin typeface="Calibri"/>
+              </a:rPr>
+              <a:t>weitere AMS-</a:t>
+            </a:r>
+          </a:p>
+          <a:p>
+            <a:pPr algn="ctr">
+              <a:lnSpc>
+                <a:spcPct val="100000"/>
+              </a:lnSpc>
+            </a:pPr>
+            <a:r>
+              <a:rPr sz="780" b="0" i="0">
+                <a:solidFill>
+                  <a:srgbClr val="4B5563"/>
+                </a:solidFill>
+                <a:latin typeface="Calibri"/>
+              </a:rPr>
+              <a:t>Dienstleister</a:t>
+            </a:r>
+          </a:p>
+        </p:txBody>
+      </p:sp>
+      <p:sp>
+        <p:nvSpPr>
+          <p:cNvPr id="24" name="Rounded Rectangle 23"/>
+          <p:cNvSpPr/>
+          <p:nvPr/>
+        </p:nvSpPr>
+        <p:spPr>
+          <a:xfrm>
+            <a:off x="228600" y="4000500"/>
+            <a:ext cx="1524000" cy="685800"/>
+          </a:xfrm>
+          <a:prstGeom prst="roundRect">
+            <a:avLst>
+              <a:gd name="adj" fmla="val 8000"/>
+            </a:avLst>
+          </a:prstGeom>
+          <a:solidFill>
+            <a:srgbClr val="E4ECF4"/>
+          </a:solidFill>
+          <a:ln w="12700">
+            <a:solidFill>
+              <a:srgbClr val="2E5A8F"/>
+            </a:solidFill>
+          </a:ln>
+          <a:effectLst/>
+        </p:spPr>
+        <p:style>
+          <a:lnRef idx="1">
+            <a:schemeClr val="accent1"/>
+          </a:lnRef>
+          <a:fillRef idx="3">
+            <a:schemeClr val="accent1"/>
+          </a:fillRef>
+          <a:effectRef idx="2">
+            <a:schemeClr val="accent1"/>
+          </a:effectRef>
+          <a:fontRef idx="minor">
+            <a:schemeClr val="lt1"/>
+          </a:fontRef>
+        </p:style>
+        <p:txBody>
+          <a:bodyPr rtlCol="0" anchor="ctr"/>
+          <a:lstStyle/>
+          <a:p>
+            <a:pPr algn="ctr"/>
+          </a:p>
+        </p:txBody>
+      </p:sp>
+      <p:sp>
+        <p:nvSpPr>
+          <p:cNvPr id="25" name="TextBox 24"/>
+          <p:cNvSpPr txBox="1"/>
+          <p:nvPr/>
+        </p:nvSpPr>
+        <p:spPr>
+          <a:xfrm>
+            <a:off x="228600" y="4000500"/>
+            <a:ext cx="1524000" cy="685800"/>
+          </a:xfrm>
+          <a:prstGeom prst="rect">
+            <a:avLst/>
+          </a:prstGeom>
+          <a:noFill/>
+          <a:ln>
+            <a:noFill/>
+          </a:ln>
+        </p:spPr>
+        <p:txBody>
+          <a:bodyPr wrap="square" anchor="ctr" lIns="45000" rIns="45000" tIns="15000" bIns="15000">
+            <a:spAutoFit/>
+          </a:bodyPr>
+          <a:lstStyle/>
+          <a:p>
+            <a:pPr algn="ctr">
+              <a:lnSpc>
+                <a:spcPct val="100000"/>
+              </a:lnSpc>
+            </a:pPr>
+            <a:r>
+              <a:rPr sz="860" b="1" i="0">
+                <a:solidFill>
+                  <a:srgbClr val="1F2937"/>
+                </a:solidFill>
+                <a:latin typeface="Calibri"/>
+              </a:rPr>
+              <a:t>TSS · Windows Server</a:t>
+            </a:r>
+          </a:p>
+          <a:p>
+            <a:pPr algn="ctr">
+              <a:lnSpc>
+                <a:spcPct val="100000"/>
+              </a:lnSpc>
+            </a:pPr>
+            <a:r>
+              <a:rPr sz="780" b="0" i="0">
+                <a:solidFill>
+                  <a:srgbClr val="4B5563"/>
+                </a:solidFill>
+                <a:latin typeface="Calibri"/>
+              </a:rPr>
+              <a:t>Infra-Operations</a:t>
+            </a:r>
+          </a:p>
+        </p:txBody>
+      </p:sp>
+      <p:sp>
+        <p:nvSpPr>
+          <p:cNvPr id="26" name="Rounded Rectangle 25"/>
+          <p:cNvSpPr/>
+          <p:nvPr/>
+        </p:nvSpPr>
+        <p:spPr>
+          <a:xfrm>
+            <a:off x="2095500" y="4000500"/>
+            <a:ext cx="1524000" cy="685800"/>
+          </a:xfrm>
+          <a:prstGeom prst="roundRect">
+            <a:avLst>
+              <a:gd name="adj" fmla="val 8000"/>
+            </a:avLst>
+          </a:prstGeom>
+          <a:solidFill>
+            <a:srgbClr val="E4ECF4"/>
+          </a:solidFill>
+          <a:ln w="12700">
+            <a:solidFill>
+              <a:srgbClr val="2E5A8F"/>
+            </a:solidFill>
+          </a:ln>
+          <a:effectLst/>
+        </p:spPr>
+        <p:style>
+          <a:lnRef idx="1">
+            <a:schemeClr val="accent1"/>
+          </a:lnRef>
+          <a:fillRef idx="3">
+            <a:schemeClr val="accent1"/>
+          </a:fillRef>
+          <a:effectRef idx="2">
+            <a:schemeClr val="accent1"/>
+          </a:effectRef>
+          <a:fontRef idx="minor">
+            <a:schemeClr val="lt1"/>
+          </a:fontRef>
+        </p:style>
+        <p:txBody>
+          <a:bodyPr rtlCol="0" anchor="ctr"/>
+          <a:lstStyle/>
+          <a:p>
+            <a:pPr algn="ctr"/>
+          </a:p>
+        </p:txBody>
+      </p:sp>
+      <p:sp>
+        <p:nvSpPr>
+          <p:cNvPr id="27" name="TextBox 26"/>
+          <p:cNvSpPr txBox="1"/>
+          <p:nvPr/>
+        </p:nvSpPr>
+        <p:spPr>
+          <a:xfrm>
+            <a:off x="2095500" y="4000500"/>
+            <a:ext cx="1524000" cy="685800"/>
+          </a:xfrm>
+          <a:prstGeom prst="rect">
+            <a:avLst/>
+          </a:prstGeom>
+          <a:noFill/>
+          <a:ln>
+            <a:noFill/>
+          </a:ln>
+        </p:spPr>
+        <p:txBody>
+          <a:bodyPr wrap="square" anchor="ctr" lIns="45000" rIns="45000" tIns="15000" bIns="15000">
+            <a:spAutoFit/>
+          </a:bodyPr>
+          <a:lstStyle/>
+          <a:p>
+            <a:pPr algn="ctr">
+              <a:lnSpc>
+                <a:spcPct val="100000"/>
+              </a:lnSpc>
+            </a:pPr>
+            <a:r>
+              <a:rPr sz="860" b="1" i="0">
+                <a:solidFill>
+                  <a:srgbClr val="1F2937"/>
+                </a:solidFill>
+                <a:latin typeface="Calibri"/>
+              </a:rPr>
+              <a:t>Zentraler</a:t>
+            </a:r>
+          </a:p>
+          <a:p>
+            <a:pPr algn="ctr">
+              <a:lnSpc>
+                <a:spcPct val="100000"/>
+              </a:lnSpc>
+            </a:pPr>
+            <a:r>
+              <a:rPr sz="780" b="0" i="0">
+                <a:solidFill>
+                  <a:srgbClr val="4B5563"/>
+                </a:solidFill>
+                <a:latin typeface="Calibri"/>
+              </a:rPr>
+              <a:t>Service Desk (L1)</a:t>
+            </a:r>
+          </a:p>
+        </p:txBody>
+      </p:sp>
+      <p:sp>
+        <p:nvSpPr>
+          <p:cNvPr id="28" name="Rounded Rectangle 27"/>
+          <p:cNvSpPr/>
+          <p:nvPr/>
+        </p:nvSpPr>
+        <p:spPr>
+          <a:xfrm>
+            <a:off x="3962400" y="4000500"/>
+            <a:ext cx="1524000" cy="685800"/>
+          </a:xfrm>
+          <a:prstGeom prst="roundRect">
+            <a:avLst>
+              <a:gd name="adj" fmla="val 8000"/>
+            </a:avLst>
+          </a:prstGeom>
+          <a:solidFill>
+            <a:srgbClr val="E4ECF4"/>
+          </a:solidFill>
+          <a:ln w="12700">
+            <a:solidFill>
+              <a:srgbClr val="2E5A8F"/>
+            </a:solidFill>
+          </a:ln>
+          <a:effectLst/>
+        </p:spPr>
+        <p:style>
+          <a:lnRef idx="1">
+            <a:schemeClr val="accent1"/>
+          </a:lnRef>
+          <a:fillRef idx="3">
+            <a:schemeClr val="accent1"/>
+          </a:fillRef>
+          <a:effectRef idx="2">
+            <a:schemeClr val="accent1"/>
+          </a:effectRef>
+          <a:fontRef idx="minor">
+            <a:schemeClr val="lt1"/>
+          </a:fontRef>
+        </p:style>
+        <p:txBody>
+          <a:bodyPr rtlCol="0" anchor="ctr"/>
+          <a:lstStyle/>
+          <a:p>
+            <a:pPr algn="ctr"/>
+          </a:p>
+        </p:txBody>
+      </p:sp>
+      <p:sp>
+        <p:nvSpPr>
+          <p:cNvPr id="29" name="TextBox 28"/>
+          <p:cNvSpPr txBox="1"/>
+          <p:nvPr/>
+        </p:nvSpPr>
+        <p:spPr>
+          <a:xfrm>
+            <a:off x="3962400" y="4000500"/>
+            <a:ext cx="1524000" cy="685800"/>
+          </a:xfrm>
+          <a:prstGeom prst="rect">
+            <a:avLst/>
+          </a:prstGeom>
+          <a:noFill/>
+          <a:ln>
+            <a:noFill/>
+          </a:ln>
+        </p:spPr>
+        <p:txBody>
+          <a:bodyPr wrap="square" anchor="ctr" lIns="45000" rIns="45000" tIns="15000" bIns="15000">
+            <a:spAutoFit/>
+          </a:bodyPr>
+          <a:lstStyle/>
+          <a:p>
+            <a:pPr algn="ctr">
+              <a:lnSpc>
+                <a:spcPct val="100000"/>
+              </a:lnSpc>
+            </a:pPr>
+            <a:r>
+              <a:rPr sz="860" b="1" i="0">
+                <a:solidFill>
+                  <a:srgbClr val="1F2937"/>
+                </a:solidFill>
+                <a:latin typeface="Calibri"/>
+              </a:rPr>
+              <a:t>Regional</a:t>
+            </a:r>
+          </a:p>
+          <a:p>
+            <a:pPr algn="ctr">
+              <a:lnSpc>
+                <a:spcPct val="100000"/>
+              </a:lnSpc>
+            </a:pPr>
+            <a:r>
+              <a:rPr sz="780" b="0" i="0">
+                <a:solidFill>
+                  <a:srgbClr val="4B5563"/>
+                </a:solidFill>
+                <a:latin typeface="Calibri"/>
+              </a:rPr>
+              <a:t>Support Center</a:t>
+            </a:r>
+          </a:p>
+        </p:txBody>
+      </p:sp>
+      <p:sp>
+        <p:nvSpPr>
+          <p:cNvPr id="30" name="TextBox 29"/>
+          <p:cNvSpPr txBox="1"/>
+          <p:nvPr/>
+        </p:nvSpPr>
+        <p:spPr>
+          <a:xfrm>
+            <a:off x="228600" y="4762500"/>
+            <a:ext cx="5029200" cy="304800"/>
+          </a:xfrm>
+          <a:prstGeom prst="rect">
+            <a:avLst/>
+          </a:prstGeom>
+          <a:noFill/>
+          <a:ln>
+            <a:noFill/>
+          </a:ln>
+        </p:spPr>
+        <p:txBody>
+          <a:bodyPr wrap="square" anchor="t" lIns="45000" rIns="45000" tIns="15000" bIns="15000">
+            <a:spAutoFit/>
+          </a:bodyPr>
+          <a:lstStyle/>
+          <a:p>
+            <a:pPr algn="ctr"/>
+            <a:r>
+              <a:rPr sz="850" b="0" i="1">
+                <a:solidFill>
+                  <a:srgbClr val="B91C1C"/>
+                </a:solidFill>
+                <a:latin typeface="Calibri"/>
+              </a:rPr>
+              <a:t>Jede Linie = manuelle, individuelle Koordination — keine Klammer, kein Standard.</a:t>
+            </a:r>
+          </a:p>
+        </p:txBody>
+      </p:sp>
+      <p:sp>
+        <p:nvSpPr>
+          <p:cNvPr id="31" name="TextBox 30"/>
+          <p:cNvSpPr txBox="1"/>
+          <p:nvPr/>
+        </p:nvSpPr>
+        <p:spPr>
+          <a:xfrm>
+            <a:off x="5638800" y="1905000"/>
+            <a:ext cx="6019800" cy="304800"/>
+          </a:xfrm>
+          <a:prstGeom prst="rect">
+            <a:avLst/>
+          </a:prstGeom>
+          <a:noFill/>
+          <a:ln>
+            <a:noFill/>
+          </a:ln>
+        </p:spPr>
+        <p:txBody>
+          <a:bodyPr wrap="square" anchor="t" lIns="45000" rIns="45000" tIns="15000" bIns="15000">
+            <a:spAutoFit/>
+          </a:bodyPr>
+          <a:lstStyle/>
+          <a:p>
+            <a:pPr algn="l"/>
+            <a:r>
+              <a:rPr sz="1300" b="1" i="0">
+                <a:solidFill>
+                  <a:srgbClr val="1F2937"/>
+                </a:solidFill>
+                <a:latin typeface="Calibri"/>
+              </a:rPr>
+              <a:t>Probleme, die daraus entstehen</a:t>
+            </a:r>
+          </a:p>
+        </p:txBody>
+      </p:sp>
+      <p:sp>
+        <p:nvSpPr>
+          <p:cNvPr id="32" name="Rounded Rectangle 31"/>
+          <p:cNvSpPr/>
+          <p:nvPr/>
+        </p:nvSpPr>
+        <p:spPr>
+          <a:xfrm>
+            <a:off x="5638800" y="2286000"/>
+            <a:ext cx="6019800" cy="655320"/>
+          </a:xfrm>
+          <a:prstGeom prst="roundRect">
+            <a:avLst>
+              <a:gd name="adj" fmla="val 8000"/>
+            </a:avLst>
+          </a:prstGeom>
+          <a:solidFill>
+            <a:srgbClr val="FFFFFF"/>
+          </a:solidFill>
+          <a:ln w="9525">
+            <a:solidFill>
+              <a:srgbClr val="D1D5DB"/>
+            </a:solidFill>
+          </a:ln>
+          <a:effectLst/>
+        </p:spPr>
+        <p:style>
+          <a:lnRef idx="1">
+            <a:schemeClr val="accent1"/>
+          </a:lnRef>
+          <a:fillRef idx="3">
+            <a:schemeClr val="accent1"/>
+          </a:fillRef>
+          <a:effectRef idx="2">
+            <a:schemeClr val="accent1"/>
+          </a:effectRef>
+          <a:fontRef idx="minor">
+            <a:schemeClr val="lt1"/>
+          </a:fontRef>
+        </p:style>
+        <p:txBody>
+          <a:bodyPr rtlCol="0" anchor="ctr"/>
+          <a:lstStyle/>
+          <a:p>
+            <a:pPr algn="ctr"/>
+          </a:p>
+        </p:txBody>
+      </p:sp>
+      <p:sp>
+        <p:nvSpPr>
+          <p:cNvPr id="33" name="Rectangle 32"/>
+          <p:cNvSpPr/>
+          <p:nvPr/>
+        </p:nvSpPr>
+        <p:spPr>
+          <a:xfrm>
+            <a:off x="5638800" y="2286000"/>
+            <a:ext cx="53340" cy="655320"/>
+          </a:xfrm>
+          <a:prstGeom prst="rect">
+            <a:avLst/>
+          </a:prstGeom>
+          <a:solidFill>
+            <a:srgbClr val="B91C1C"/>
+          </a:solidFill>
+          <a:ln>
+            <a:noFill/>
+          </a:ln>
+          <a:effectLst/>
+        </p:spPr>
+        <p:style>
+          <a:lnRef idx="1">
+            <a:schemeClr val="accent1"/>
+          </a:lnRef>
+          <a:fillRef idx="3">
+            <a:schemeClr val="accent1"/>
+          </a:fillRef>
+          <a:effectRef idx="2">
+            <a:schemeClr val="accent1"/>
+          </a:effectRef>
+          <a:fontRef idx="minor">
+            <a:schemeClr val="lt1"/>
+          </a:fontRef>
+        </p:style>
+        <p:txBody>
+          <a:bodyPr rtlCol="0" anchor="ctr"/>
+          <a:lstStyle/>
+          <a:p>
+            <a:pPr algn="ctr"/>
+          </a:p>
+        </p:txBody>
+      </p:sp>
+      <p:sp>
+        <p:nvSpPr>
+          <p:cNvPr id="34" name="TextBox 33"/>
+          <p:cNvSpPr txBox="1"/>
+          <p:nvPr/>
+        </p:nvSpPr>
+        <p:spPr>
+          <a:xfrm>
+            <a:off x="5745480" y="2324100"/>
+            <a:ext cx="5867400" cy="259080"/>
+          </a:xfrm>
+          <a:prstGeom prst="rect">
+            <a:avLst/>
+          </a:prstGeom>
+          <a:noFill/>
+          <a:ln>
+            <a:noFill/>
+          </a:ln>
+        </p:spPr>
+        <p:txBody>
+          <a:bodyPr wrap="square" anchor="t" lIns="45000" rIns="45000" tIns="15000" bIns="15000">
+            <a:spAutoFit/>
+          </a:bodyPr>
+          <a:lstStyle/>
+          <a:p>
+            <a:pPr algn="l"/>
+            <a:r>
+              <a:rPr sz="850" b="1" i="0">
+                <a:solidFill>
+                  <a:srgbClr val="B91C1C"/>
+                </a:solidFill>
+                <a:latin typeface="Calibri"/>
+              </a:rPr>
+              <a:t>P1  </a:t>
+            </a:r>
+            <a:r>
+              <a:rPr sz="1000" b="1" i="0">
+                <a:solidFill>
+                  <a:srgbClr val="1F2937"/>
+                </a:solidFill>
+                <a:latin typeface="Calibri"/>
+              </a:rPr>
+              <a:t>Rollenüberladung Service Owner</a:t>
+            </a:r>
+          </a:p>
+        </p:txBody>
+      </p:sp>
+      <p:sp>
+        <p:nvSpPr>
+          <p:cNvPr id="35" name="TextBox 34"/>
+          <p:cNvSpPr txBox="1"/>
+          <p:nvPr/>
+        </p:nvSpPr>
+        <p:spPr>
+          <a:xfrm>
+            <a:off x="5745480" y="2590800"/>
+            <a:ext cx="5867400" cy="320040"/>
+          </a:xfrm>
+          <a:prstGeom prst="rect">
+            <a:avLst/>
+          </a:prstGeom>
+          <a:noFill/>
+          <a:ln>
+            <a:noFill/>
+          </a:ln>
+        </p:spPr>
+        <p:txBody>
+          <a:bodyPr wrap="square" anchor="t" lIns="45000" rIns="45000" tIns="15000" bIns="15000">
+            <a:spAutoFit/>
+          </a:bodyPr>
+          <a:lstStyle/>
+          <a:p>
+            <a:pPr algn="l">
+              <a:lnSpc>
+                <a:spcPct val="102000"/>
+              </a:lnSpc>
+            </a:pPr>
+            <a:r>
+              <a:rPr sz="850" b="0" i="0">
+                <a:solidFill>
+                  <a:srgbClr val="4B5563"/>
+                </a:solidFill>
+                <a:latin typeface="Calibri"/>
+              </a:rPr>
+              <a:t>Service fachlich verantworten UND alle Service Levels koordinieren = zwei Jobs.</a:t>
+            </a:r>
+          </a:p>
+        </p:txBody>
+      </p:sp>
+      <p:sp>
+        <p:nvSpPr>
+          <p:cNvPr id="36" name="Rounded Rectangle 35"/>
+          <p:cNvSpPr/>
+          <p:nvPr/>
+        </p:nvSpPr>
+        <p:spPr>
+          <a:xfrm>
+            <a:off x="5638800" y="2994660"/>
+            <a:ext cx="6019800" cy="655320"/>
+          </a:xfrm>
+          <a:prstGeom prst="roundRect">
+            <a:avLst>
+              <a:gd name="adj" fmla="val 8000"/>
+            </a:avLst>
+          </a:prstGeom>
+          <a:solidFill>
+            <a:srgbClr val="FFFFFF"/>
+          </a:solidFill>
+          <a:ln w="9525">
+            <a:solidFill>
+              <a:srgbClr val="D1D5DB"/>
+            </a:solidFill>
+          </a:ln>
+          <a:effectLst/>
+        </p:spPr>
+        <p:style>
+          <a:lnRef idx="1">
+            <a:schemeClr val="accent1"/>
+          </a:lnRef>
+          <a:fillRef idx="3">
+            <a:schemeClr val="accent1"/>
+          </a:fillRef>
+          <a:effectRef idx="2">
+            <a:schemeClr val="accent1"/>
+          </a:effectRef>
+          <a:fontRef idx="minor">
+            <a:schemeClr val="lt1"/>
+          </a:fontRef>
+        </p:style>
+        <p:txBody>
+          <a:bodyPr rtlCol="0" anchor="ctr"/>
+          <a:lstStyle/>
+          <a:p>
+            <a:pPr algn="ctr"/>
+          </a:p>
+        </p:txBody>
+      </p:sp>
+      <p:sp>
+        <p:nvSpPr>
+          <p:cNvPr id="37" name="Rectangle 36"/>
+          <p:cNvSpPr/>
+          <p:nvPr/>
+        </p:nvSpPr>
+        <p:spPr>
+          <a:xfrm>
+            <a:off x="5638800" y="2994660"/>
+            <a:ext cx="53340" cy="655320"/>
+          </a:xfrm>
+          <a:prstGeom prst="rect">
+            <a:avLst/>
+          </a:prstGeom>
+          <a:solidFill>
+            <a:srgbClr val="B91C1C"/>
+          </a:solidFill>
+          <a:ln>
+            <a:noFill/>
+          </a:ln>
+          <a:effectLst/>
+        </p:spPr>
+        <p:style>
+          <a:lnRef idx="1">
+            <a:schemeClr val="accent1"/>
+          </a:lnRef>
+          <a:fillRef idx="3">
+            <a:schemeClr val="accent1"/>
+          </a:fillRef>
+          <a:effectRef idx="2">
+            <a:schemeClr val="accent1"/>
+          </a:effectRef>
+          <a:fontRef idx="minor">
+            <a:schemeClr val="lt1"/>
+          </a:fontRef>
+        </p:style>
+        <p:txBody>
+          <a:bodyPr rtlCol="0" anchor="ctr"/>
+          <a:lstStyle/>
+          <a:p>
+            <a:pPr algn="ctr"/>
+          </a:p>
+        </p:txBody>
+      </p:sp>
+      <p:sp>
+        <p:nvSpPr>
+          <p:cNvPr id="38" name="TextBox 37"/>
+          <p:cNvSpPr txBox="1"/>
+          <p:nvPr/>
+        </p:nvSpPr>
+        <p:spPr>
+          <a:xfrm>
+            <a:off x="5745480" y="3032760"/>
+            <a:ext cx="5867400" cy="259080"/>
+          </a:xfrm>
+          <a:prstGeom prst="rect">
+            <a:avLst/>
+          </a:prstGeom>
+          <a:noFill/>
+          <a:ln>
+            <a:noFill/>
+          </a:ln>
+        </p:spPr>
+        <p:txBody>
+          <a:bodyPr wrap="square" anchor="t" lIns="45000" rIns="45000" tIns="15000" bIns="15000">
+            <a:spAutoFit/>
+          </a:bodyPr>
+          <a:lstStyle/>
+          <a:p>
+            <a:pPr algn="l"/>
+            <a:r>
+              <a:rPr sz="850" b="1" i="0">
+                <a:solidFill>
+                  <a:srgbClr val="B91C1C"/>
+                </a:solidFill>
+                <a:latin typeface="Calibri"/>
+              </a:rPr>
+              <a:t>P2  </a:t>
+            </a:r>
+            <a:r>
+              <a:rPr sz="1000" b="1" i="0">
+                <a:solidFill>
+                  <a:srgbClr val="1F2937"/>
+                </a:solidFill>
+                <a:latin typeface="Calibri"/>
+              </a:rPr>
+              <a:t>Keine Klammerfunktion</a:t>
+            </a:r>
+          </a:p>
+        </p:txBody>
+      </p:sp>
+      <p:sp>
+        <p:nvSpPr>
+          <p:cNvPr id="39" name="TextBox 38"/>
+          <p:cNvSpPr txBox="1"/>
+          <p:nvPr/>
+        </p:nvSpPr>
+        <p:spPr>
+          <a:xfrm>
+            <a:off x="5745480" y="3299460"/>
+            <a:ext cx="5867400" cy="320040"/>
+          </a:xfrm>
+          <a:prstGeom prst="rect">
+            <a:avLst/>
+          </a:prstGeom>
+          <a:noFill/>
+          <a:ln>
+            <a:noFill/>
+          </a:ln>
+        </p:spPr>
+        <p:txBody>
+          <a:bodyPr wrap="square" anchor="t" lIns="45000" rIns="45000" tIns="15000" bIns="15000">
+            <a:spAutoFit/>
+          </a:bodyPr>
+          <a:lstStyle/>
+          <a:p>
+            <a:pPr algn="l">
+              <a:lnSpc>
+                <a:spcPct val="102000"/>
+              </a:lnSpc>
+            </a:pPr>
+            <a:r>
+              <a:rPr sz="850" b="0" i="0">
+                <a:solidFill>
+                  <a:srgbClr val="4B5563"/>
+                </a:solidFill>
+                <a:latin typeface="Calibri"/>
+              </a:rPr>
+              <a:t>Niemand ist übergeordnet für alle Supportaktivitäten zuständig.</a:t>
+            </a:r>
+          </a:p>
+        </p:txBody>
+      </p:sp>
+      <p:sp>
+        <p:nvSpPr>
+          <p:cNvPr id="40" name="Rounded Rectangle 39"/>
+          <p:cNvSpPr/>
+          <p:nvPr/>
+        </p:nvSpPr>
+        <p:spPr>
+          <a:xfrm>
+            <a:off x="5638800" y="3703319"/>
+            <a:ext cx="6019800" cy="655320"/>
+          </a:xfrm>
+          <a:prstGeom prst="roundRect">
+            <a:avLst>
+              <a:gd name="adj" fmla="val 8000"/>
+            </a:avLst>
+          </a:prstGeom>
+          <a:solidFill>
+            <a:srgbClr val="FFFFFF"/>
+          </a:solidFill>
+          <a:ln w="9525">
+            <a:solidFill>
+              <a:srgbClr val="D1D5DB"/>
+            </a:solidFill>
+          </a:ln>
+          <a:effectLst/>
+        </p:spPr>
+        <p:style>
+          <a:lnRef idx="1">
+            <a:schemeClr val="accent1"/>
+          </a:lnRef>
+          <a:fillRef idx="3">
+            <a:schemeClr val="accent1"/>
+          </a:fillRef>
+          <a:effectRef idx="2">
+            <a:schemeClr val="accent1"/>
+          </a:effectRef>
+          <a:fontRef idx="minor">
+            <a:schemeClr val="lt1"/>
+          </a:fontRef>
+        </p:style>
+        <p:txBody>
+          <a:bodyPr rtlCol="0" anchor="ctr"/>
+          <a:lstStyle/>
+          <a:p>
+            <a:pPr algn="ctr"/>
+          </a:p>
+        </p:txBody>
+      </p:sp>
+      <p:sp>
+        <p:nvSpPr>
+          <p:cNvPr id="41" name="Rectangle 40"/>
+          <p:cNvSpPr/>
+          <p:nvPr/>
+        </p:nvSpPr>
+        <p:spPr>
+          <a:xfrm>
+            <a:off x="5638800" y="3703319"/>
+            <a:ext cx="53340" cy="655320"/>
+          </a:xfrm>
+          <a:prstGeom prst="rect">
+            <a:avLst/>
+          </a:prstGeom>
+          <a:solidFill>
+            <a:srgbClr val="B91C1C"/>
+          </a:solidFill>
+          <a:ln>
+            <a:noFill/>
+          </a:ln>
+          <a:effectLst/>
+        </p:spPr>
+        <p:style>
+          <a:lnRef idx="1">
+            <a:schemeClr val="accent1"/>
+          </a:lnRef>
+          <a:fillRef idx="3">
+            <a:schemeClr val="accent1"/>
+          </a:fillRef>
+          <a:effectRef idx="2">
+            <a:schemeClr val="accent1"/>
+          </a:effectRef>
+          <a:fontRef idx="minor">
+            <a:schemeClr val="lt1"/>
+          </a:fontRef>
+        </p:style>
+        <p:txBody>
+          <a:bodyPr rtlCol="0" anchor="ctr"/>
+          <a:lstStyle/>
+          <a:p>
+            <a:pPr algn="ctr"/>
+          </a:p>
+        </p:txBody>
+      </p:sp>
+      <p:sp>
+        <p:nvSpPr>
+          <p:cNvPr id="42" name="TextBox 41"/>
+          <p:cNvSpPr txBox="1"/>
+          <p:nvPr/>
+        </p:nvSpPr>
+        <p:spPr>
+          <a:xfrm>
+            <a:off x="5745480" y="3741419"/>
+            <a:ext cx="5867400" cy="259080"/>
+          </a:xfrm>
+          <a:prstGeom prst="rect">
+            <a:avLst/>
+          </a:prstGeom>
+          <a:noFill/>
+          <a:ln>
+            <a:noFill/>
+          </a:ln>
+        </p:spPr>
+        <p:txBody>
+          <a:bodyPr wrap="square" anchor="t" lIns="45000" rIns="45000" tIns="15000" bIns="15000">
+            <a:spAutoFit/>
+          </a:bodyPr>
+          <a:lstStyle/>
+          <a:p>
+            <a:pPr algn="l"/>
+            <a:r>
+              <a:rPr sz="850" b="1" i="0">
+                <a:solidFill>
+                  <a:srgbClr val="B91C1C"/>
+                </a:solidFill>
+                <a:latin typeface="Calibri"/>
+              </a:rPr>
+              <a:t>P3  </a:t>
+            </a:r>
+            <a:r>
+              <a:rPr sz="1000" b="1" i="0">
+                <a:solidFill>
+                  <a:srgbClr val="1F2937"/>
+                </a:solidFill>
+                <a:latin typeface="Calibri"/>
+              </a:rPr>
+              <a:t>Fragmentierte Provider-Steuerung</a:t>
+            </a:r>
+          </a:p>
+        </p:txBody>
+      </p:sp>
+      <p:sp>
+        <p:nvSpPr>
+          <p:cNvPr id="43" name="TextBox 42"/>
+          <p:cNvSpPr txBox="1"/>
+          <p:nvPr/>
+        </p:nvSpPr>
+        <p:spPr>
+          <a:xfrm>
+            <a:off x="5745480" y="4008119"/>
+            <a:ext cx="5867400" cy="320040"/>
+          </a:xfrm>
+          <a:prstGeom prst="rect">
+            <a:avLst/>
+          </a:prstGeom>
+          <a:noFill/>
+          <a:ln>
+            <a:noFill/>
+          </a:ln>
+        </p:spPr>
+        <p:txBody>
+          <a:bodyPr wrap="square" anchor="t" lIns="45000" rIns="45000" tIns="15000" bIns="15000">
+            <a:spAutoFit/>
+          </a:bodyPr>
+          <a:lstStyle/>
+          <a:p>
+            <a:pPr algn="l">
+              <a:lnSpc>
+                <a:spcPct val="102000"/>
+              </a:lnSpc>
+            </a:pPr>
+            <a:r>
+              <a:rPr sz="850" b="0" i="0">
+                <a:solidFill>
+                  <a:srgbClr val="4B5563"/>
+                </a:solidFill>
+                <a:latin typeface="Calibri"/>
+              </a:rPr>
+              <a:t>Jeder SO steuert DXC &amp; Co. einzeln — keine Skaleneffekte, uneinheitliche SLAs.</a:t>
+            </a:r>
+          </a:p>
+        </p:txBody>
+      </p:sp>
+      <p:sp>
+        <p:nvSpPr>
+          <p:cNvPr id="44" name="Rounded Rectangle 43"/>
+          <p:cNvSpPr/>
+          <p:nvPr/>
+        </p:nvSpPr>
+        <p:spPr>
+          <a:xfrm>
+            <a:off x="5638800" y="4411979"/>
+            <a:ext cx="6019800" cy="655320"/>
+          </a:xfrm>
+          <a:prstGeom prst="roundRect">
+            <a:avLst>
+              <a:gd name="adj" fmla="val 8000"/>
+            </a:avLst>
+          </a:prstGeom>
+          <a:solidFill>
+            <a:srgbClr val="FFFFFF"/>
+          </a:solidFill>
+          <a:ln w="9525">
+            <a:solidFill>
+              <a:srgbClr val="D1D5DB"/>
+            </a:solidFill>
+          </a:ln>
+          <a:effectLst/>
+        </p:spPr>
+        <p:style>
+          <a:lnRef idx="1">
+            <a:schemeClr val="accent1"/>
+          </a:lnRef>
+          <a:fillRef idx="3">
+            <a:schemeClr val="accent1"/>
+          </a:fillRef>
+          <a:effectRef idx="2">
+            <a:schemeClr val="accent1"/>
+          </a:effectRef>
+          <a:fontRef idx="minor">
+            <a:schemeClr val="lt1"/>
+          </a:fontRef>
+        </p:style>
+        <p:txBody>
+          <a:bodyPr rtlCol="0" anchor="ctr"/>
+          <a:lstStyle/>
+          <a:p>
+            <a:pPr algn="ctr"/>
+          </a:p>
+        </p:txBody>
+      </p:sp>
+      <p:sp>
+        <p:nvSpPr>
+          <p:cNvPr id="45" name="Rectangle 44"/>
+          <p:cNvSpPr/>
+          <p:nvPr/>
+        </p:nvSpPr>
+        <p:spPr>
+          <a:xfrm>
+            <a:off x="5638800" y="4411979"/>
+            <a:ext cx="53340" cy="655320"/>
+          </a:xfrm>
+          <a:prstGeom prst="rect">
+            <a:avLst/>
+          </a:prstGeom>
+          <a:solidFill>
+            <a:srgbClr val="B91C1C"/>
+          </a:solidFill>
+          <a:ln>
+            <a:noFill/>
+          </a:ln>
+          <a:effectLst/>
+        </p:spPr>
+        <p:style>
+          <a:lnRef idx="1">
+            <a:schemeClr val="accent1"/>
+          </a:lnRef>
+          <a:fillRef idx="3">
+            <a:schemeClr val="accent1"/>
+          </a:fillRef>
+          <a:effectRef idx="2">
+            <a:schemeClr val="accent1"/>
+          </a:effectRef>
+          <a:fontRef idx="minor">
+            <a:schemeClr val="lt1"/>
+          </a:fontRef>
+        </p:style>
+        <p:txBody>
+          <a:bodyPr rtlCol="0" anchor="ctr"/>
+          <a:lstStyle/>
+          <a:p>
+            <a:pPr algn="ctr"/>
+          </a:p>
+        </p:txBody>
+      </p:sp>
+      <p:sp>
+        <p:nvSpPr>
+          <p:cNvPr id="46" name="TextBox 45"/>
+          <p:cNvSpPr txBox="1"/>
+          <p:nvPr/>
+        </p:nvSpPr>
+        <p:spPr>
+          <a:xfrm>
+            <a:off x="5745480" y="4450079"/>
+            <a:ext cx="5867400" cy="259080"/>
+          </a:xfrm>
+          <a:prstGeom prst="rect">
+            <a:avLst/>
+          </a:prstGeom>
+          <a:noFill/>
+          <a:ln>
+            <a:noFill/>
+          </a:ln>
+        </p:spPr>
+        <p:txBody>
+          <a:bodyPr wrap="square" anchor="t" lIns="45000" rIns="45000" tIns="15000" bIns="15000">
+            <a:spAutoFit/>
+          </a:bodyPr>
+          <a:lstStyle/>
+          <a:p>
+            <a:pPr algn="l"/>
+            <a:r>
+              <a:rPr sz="850" b="1" i="0">
+                <a:solidFill>
+                  <a:srgbClr val="B91C1C"/>
+                </a:solidFill>
+                <a:latin typeface="Calibri"/>
+              </a:rPr>
+              <a:t>P4  </a:t>
+            </a:r>
+            <a:r>
+              <a:rPr sz="1000" b="1" i="0">
+                <a:solidFill>
+                  <a:srgbClr val="1F2937"/>
+                </a:solidFill>
+                <a:latin typeface="Calibri"/>
+              </a:rPr>
+              <a:t>Kein End-to-End-SLA über die Kette</a:t>
+            </a:r>
+          </a:p>
+        </p:txBody>
+      </p:sp>
+      <p:sp>
+        <p:nvSpPr>
+          <p:cNvPr id="47" name="TextBox 46"/>
+          <p:cNvSpPr txBox="1"/>
+          <p:nvPr/>
+        </p:nvSpPr>
+        <p:spPr>
+          <a:xfrm>
+            <a:off x="5745480" y="4716779"/>
+            <a:ext cx="5867400" cy="320040"/>
+          </a:xfrm>
+          <a:prstGeom prst="rect">
+            <a:avLst/>
+          </a:prstGeom>
+          <a:noFill/>
+          <a:ln>
+            <a:noFill/>
+          </a:ln>
+        </p:spPr>
+        <p:txBody>
+          <a:bodyPr wrap="square" anchor="t" lIns="45000" rIns="45000" tIns="15000" bIns="15000">
+            <a:spAutoFit/>
+          </a:bodyPr>
+          <a:lstStyle/>
+          <a:p>
+            <a:pPr algn="l">
+              <a:lnSpc>
+                <a:spcPct val="102000"/>
+              </a:lnSpc>
+            </a:pPr>
+            <a:r>
+              <a:rPr sz="850" b="0" i="0">
+                <a:solidFill>
+                  <a:srgbClr val="4B5563"/>
+                </a:solidFill>
+                <a:latin typeface="Calibri"/>
+              </a:rPr>
+              <a:t>App (DXC) + Infra (TSS) + Desk je eigene Zusage — niemand verantwortet das Ganze.</a:t>
+            </a:r>
+          </a:p>
+        </p:txBody>
+      </p:sp>
+      <p:sp>
+        <p:nvSpPr>
+          <p:cNvPr id="48" name="Rounded Rectangle 47"/>
+          <p:cNvSpPr/>
+          <p:nvPr/>
+        </p:nvSpPr>
+        <p:spPr>
+          <a:xfrm>
+            <a:off x="5638800" y="5120639"/>
+            <a:ext cx="6019800" cy="655320"/>
+          </a:xfrm>
+          <a:prstGeom prst="roundRect">
+            <a:avLst>
+              <a:gd name="adj" fmla="val 8000"/>
+            </a:avLst>
+          </a:prstGeom>
+          <a:solidFill>
+            <a:srgbClr val="FFFFFF"/>
+          </a:solidFill>
+          <a:ln w="9525">
+            <a:solidFill>
+              <a:srgbClr val="D1D5DB"/>
+            </a:solidFill>
+          </a:ln>
+          <a:effectLst/>
+        </p:spPr>
+        <p:style>
+          <a:lnRef idx="1">
+            <a:schemeClr val="accent1"/>
+          </a:lnRef>
+          <a:fillRef idx="3">
+            <a:schemeClr val="accent1"/>
+          </a:fillRef>
+          <a:effectRef idx="2">
+            <a:schemeClr val="accent1"/>
+          </a:effectRef>
+          <a:fontRef idx="minor">
+            <a:schemeClr val="lt1"/>
+          </a:fontRef>
+        </p:style>
+        <p:txBody>
+          <a:bodyPr rtlCol="0" anchor="ctr"/>
+          <a:lstStyle/>
+          <a:p>
+            <a:pPr algn="ctr"/>
+          </a:p>
+        </p:txBody>
+      </p:sp>
+      <p:sp>
+        <p:nvSpPr>
+          <p:cNvPr id="49" name="Rectangle 48"/>
+          <p:cNvSpPr/>
+          <p:nvPr/>
+        </p:nvSpPr>
+        <p:spPr>
+          <a:xfrm>
+            <a:off x="5638800" y="5120639"/>
+            <a:ext cx="53340" cy="655320"/>
+          </a:xfrm>
+          <a:prstGeom prst="rect">
+            <a:avLst/>
+          </a:prstGeom>
+          <a:solidFill>
+            <a:srgbClr val="B91C1C"/>
+          </a:solidFill>
+          <a:ln>
+            <a:noFill/>
+          </a:ln>
+          <a:effectLst/>
+        </p:spPr>
+        <p:style>
+          <a:lnRef idx="1">
+            <a:schemeClr val="accent1"/>
+          </a:lnRef>
+          <a:fillRef idx="3">
+            <a:schemeClr val="accent1"/>
+          </a:fillRef>
+          <a:effectRef idx="2">
+            <a:schemeClr val="accent1"/>
+          </a:effectRef>
+          <a:fontRef idx="minor">
+            <a:schemeClr val="lt1"/>
+          </a:fontRef>
+        </p:style>
+        <p:txBody>
+          <a:bodyPr rtlCol="0" anchor="ctr"/>
+          <a:lstStyle/>
+          <a:p>
+            <a:pPr algn="ctr"/>
+          </a:p>
+        </p:txBody>
+      </p:sp>
+      <p:sp>
+        <p:nvSpPr>
+          <p:cNvPr id="50" name="TextBox 49"/>
+          <p:cNvSpPr txBox="1"/>
+          <p:nvPr/>
+        </p:nvSpPr>
+        <p:spPr>
+          <a:xfrm>
+            <a:off x="5745480" y="5158739"/>
+            <a:ext cx="5867400" cy="259080"/>
+          </a:xfrm>
+          <a:prstGeom prst="rect">
+            <a:avLst/>
+          </a:prstGeom>
+          <a:noFill/>
+          <a:ln>
+            <a:noFill/>
+          </a:ln>
+        </p:spPr>
+        <p:txBody>
+          <a:bodyPr wrap="square" anchor="t" lIns="45000" rIns="45000" tIns="15000" bIns="15000">
+            <a:spAutoFit/>
+          </a:bodyPr>
+          <a:lstStyle/>
+          <a:p>
+            <a:pPr algn="l"/>
+            <a:r>
+              <a:rPr sz="850" b="1" i="0">
+                <a:solidFill>
+                  <a:srgbClr val="B91C1C"/>
+                </a:solidFill>
+                <a:latin typeface="Calibri"/>
+              </a:rPr>
+              <a:t>P5  </a:t>
+            </a:r>
+            <a:r>
+              <a:rPr sz="1000" b="1" i="0">
+                <a:solidFill>
+                  <a:srgbClr val="1F2937"/>
+                </a:solidFill>
+                <a:latin typeface="Calibri"/>
+              </a:rPr>
+              <a:t>Ungeregelte Schnittstellen</a:t>
+            </a:r>
+          </a:p>
+        </p:txBody>
+      </p:sp>
+      <p:sp>
+        <p:nvSpPr>
+          <p:cNvPr id="51" name="TextBox 50"/>
+          <p:cNvSpPr txBox="1"/>
+          <p:nvPr/>
+        </p:nvSpPr>
+        <p:spPr>
+          <a:xfrm>
+            <a:off x="5745480" y="5425439"/>
+            <a:ext cx="5867400" cy="320040"/>
+          </a:xfrm>
+          <a:prstGeom prst="rect">
+            <a:avLst/>
+          </a:prstGeom>
+          <a:noFill/>
+          <a:ln>
+            <a:noFill/>
+          </a:ln>
+        </p:spPr>
+        <p:txBody>
+          <a:bodyPr wrap="square" anchor="t" lIns="45000" rIns="45000" tIns="15000" bIns="15000">
+            <a:spAutoFit/>
+          </a:bodyPr>
+          <a:lstStyle/>
+          <a:p>
+            <a:pPr algn="l">
+              <a:lnSpc>
+                <a:spcPct val="102000"/>
+              </a:lnSpc>
+            </a:pPr>
+            <a:r>
+              <a:rPr sz="850" b="0" i="0">
+                <a:solidFill>
+                  <a:srgbClr val="4B5563"/>
+                </a:solidFill>
+                <a:latin typeface="Calibri"/>
+              </a:rPr>
+              <a:t>An Übergaben BSS↔TSS↔AMS↔SD versanden Tickets &amp; Eskalationen.</a:t>
+            </a:r>
+          </a:p>
+        </p:txBody>
+      </p:sp>
+      <p:sp>
+        <p:nvSpPr>
+          <p:cNvPr id="52" name="Rounded Rectangle 51"/>
+          <p:cNvSpPr/>
+          <p:nvPr/>
+        </p:nvSpPr>
+        <p:spPr>
+          <a:xfrm>
+            <a:off x="5638800" y="5829299"/>
+            <a:ext cx="6019800" cy="655320"/>
+          </a:xfrm>
+          <a:prstGeom prst="roundRect">
+            <a:avLst>
+              <a:gd name="adj" fmla="val 8000"/>
+            </a:avLst>
+          </a:prstGeom>
+          <a:solidFill>
+            <a:srgbClr val="FFFFFF"/>
+          </a:solidFill>
+          <a:ln w="9525">
+            <a:solidFill>
+              <a:srgbClr val="D1D5DB"/>
+            </a:solidFill>
+          </a:ln>
+          <a:effectLst/>
+        </p:spPr>
+        <p:style>
+          <a:lnRef idx="1">
+            <a:schemeClr val="accent1"/>
+          </a:lnRef>
+          <a:fillRef idx="3">
+            <a:schemeClr val="accent1"/>
+          </a:fillRef>
+          <a:effectRef idx="2">
+            <a:schemeClr val="accent1"/>
+          </a:effectRef>
+          <a:fontRef idx="minor">
+            <a:schemeClr val="lt1"/>
+          </a:fontRef>
+        </p:style>
+        <p:txBody>
+          <a:bodyPr rtlCol="0" anchor="ctr"/>
+          <a:lstStyle/>
+          <a:p>
+            <a:pPr algn="ctr"/>
+          </a:p>
+        </p:txBody>
+      </p:sp>
+      <p:sp>
+        <p:nvSpPr>
+          <p:cNvPr id="53" name="Rectangle 52"/>
+          <p:cNvSpPr/>
+          <p:nvPr/>
+        </p:nvSpPr>
+        <p:spPr>
+          <a:xfrm>
+            <a:off x="5638800" y="5829299"/>
+            <a:ext cx="53340" cy="655320"/>
+          </a:xfrm>
+          <a:prstGeom prst="rect">
+            <a:avLst/>
+          </a:prstGeom>
+          <a:solidFill>
+            <a:srgbClr val="B91C1C"/>
+          </a:solidFill>
+          <a:ln>
+            <a:noFill/>
+          </a:ln>
+          <a:effectLst/>
+        </p:spPr>
+        <p:style>
+          <a:lnRef idx="1">
+            <a:schemeClr val="accent1"/>
+          </a:lnRef>
+          <a:fillRef idx="3">
+            <a:schemeClr val="accent1"/>
+          </a:fillRef>
+          <a:effectRef idx="2">
+            <a:schemeClr val="accent1"/>
+          </a:effectRef>
+          <a:fontRef idx="minor">
+            <a:schemeClr val="lt1"/>
+          </a:fontRef>
+        </p:style>
+        <p:txBody>
+          <a:bodyPr rtlCol="0" anchor="ctr"/>
+          <a:lstStyle/>
+          <a:p>
+            <a:pPr algn="ctr"/>
+          </a:p>
+        </p:txBody>
+      </p:sp>
+      <p:sp>
+        <p:nvSpPr>
+          <p:cNvPr id="54" name="TextBox 53"/>
+          <p:cNvSpPr txBox="1"/>
+          <p:nvPr/>
+        </p:nvSpPr>
+        <p:spPr>
+          <a:xfrm>
+            <a:off x="5745480" y="5867399"/>
+            <a:ext cx="5867400" cy="259080"/>
+          </a:xfrm>
+          <a:prstGeom prst="rect">
+            <a:avLst/>
+          </a:prstGeom>
+          <a:noFill/>
+          <a:ln>
+            <a:noFill/>
+          </a:ln>
+        </p:spPr>
+        <p:txBody>
+          <a:bodyPr wrap="square" anchor="t" lIns="45000" rIns="45000" tIns="15000" bIns="15000">
+            <a:spAutoFit/>
+          </a:bodyPr>
+          <a:lstStyle/>
+          <a:p>
+            <a:pPr algn="l"/>
+            <a:r>
+              <a:rPr sz="850" b="1" i="0">
+                <a:solidFill>
+                  <a:srgbClr val="B91C1C"/>
+                </a:solidFill>
+                <a:latin typeface="Calibri"/>
+              </a:rPr>
+              <a:t>P6  </a:t>
+            </a:r>
+            <a:r>
+              <a:rPr sz="1000" b="1" i="0">
+                <a:solidFill>
+                  <a:srgbClr val="1F2937"/>
+                </a:solidFill>
+                <a:latin typeface="Calibri"/>
+              </a:rPr>
+              <a:t>Personen- statt Prozessabhängigkeit</a:t>
+            </a:r>
+          </a:p>
+        </p:txBody>
+      </p:sp>
+      <p:sp>
+        <p:nvSpPr>
+          <p:cNvPr id="55" name="TextBox 54"/>
+          <p:cNvSpPr txBox="1"/>
+          <p:nvPr/>
+        </p:nvSpPr>
+        <p:spPr>
+          <a:xfrm>
+            <a:off x="5745480" y="6134099"/>
+            <a:ext cx="5867400" cy="320040"/>
+          </a:xfrm>
+          <a:prstGeom prst="rect">
+            <a:avLst/>
+          </a:prstGeom>
+          <a:noFill/>
+          <a:ln>
+            <a:noFill/>
+          </a:ln>
+        </p:spPr>
+        <p:txBody>
+          <a:bodyPr wrap="square" anchor="t" lIns="45000" rIns="45000" tIns="15000" bIns="15000">
+            <a:spAutoFit/>
+          </a:bodyPr>
+          <a:lstStyle/>
+          <a:p>
+            <a:pPr algn="l">
+              <a:lnSpc>
+                <a:spcPct val="102000"/>
+              </a:lnSpc>
+            </a:pPr>
+            <a:r>
+              <a:rPr sz="850" b="0" i="0">
+                <a:solidFill>
+                  <a:srgbClr val="4B5563"/>
+                </a:solidFill>
+                <a:latin typeface="Calibri"/>
+              </a:rPr>
+              <a:t>„SO kennt Service am besten“ → Key-Person-Risiko, keine Skalierung, keine Transparenz.</a:t>
+            </a:r>
+          </a:p>
+        </p:txBody>
+      </p:sp>
+      <p:sp>
+        <p:nvSpPr>
+          <p:cNvPr id="56" name="TextBox 55"/>
+          <p:cNvSpPr txBox="1"/>
+          <p:nvPr/>
+        </p:nvSpPr>
+        <p:spPr>
+          <a:xfrm>
+            <a:off x="533400" y="6400800"/>
+            <a:ext cx="11125200" cy="266700"/>
+          </a:xfrm>
+          <a:prstGeom prst="rect">
+            <a:avLst/>
+          </a:prstGeom>
+          <a:noFill/>
+          <a:ln>
+            <a:noFill/>
+          </a:ln>
+        </p:spPr>
+        <p:txBody>
+          <a:bodyPr wrap="square" anchor="t" lIns="45000" rIns="45000" tIns="15000" bIns="15000">
+            <a:spAutoFit/>
+          </a:bodyPr>
+          <a:lstStyle/>
+          <a:p>
+            <a:pPr algn="l"/>
+            <a:r>
+              <a:rPr sz="1000" b="1" i="0">
+                <a:solidFill>
+                  <a:srgbClr val="B91C1C"/>
+                </a:solidFill>
+                <a:latin typeface="Calibri"/>
+              </a:rPr>
+              <a:t>Kernbefund:  </a:t>
+            </a:r>
+            <a:r>
+              <a:rPr sz="1000" b="0" i="0">
+                <a:solidFill>
+                  <a:srgbClr val="4B5563"/>
+                </a:solidFill>
+                <a:latin typeface="Calibri"/>
+              </a:rPr>
+              <a:t>Die IPS hat die richtigen Bausteine, aber keinen Dirigenten — Koordination ist Privatsache des Service Owners. Genau hier fordert BSS die „dedizierte Ressource“.</a:t>
+            </a:r>
+          </a:p>
+        </p:txBody>
+      </p:sp>
+    </p:spTree>
+  </p:cSld>
+  <p:clrMapOvr>
+    <a:masterClrMapping/>
+  </p:clrMapOvr>
+</p:sld>
+</file>
+
+<file path=ppt/slides/slide11.xml><?xml version="1.0" encoding="utf-8"?>
+<p:sld xmlns:a="http://schemas.openxmlformats.org/drawingml/2006/main" xmlns:p="http://schemas.openxmlformats.org/presentationml/2006/main" xmlns:r="http://schemas.openxmlformats.org/officeDocument/2006/relationships">
+  <p:cSld>
+    <p:spTree>
+      <p:nvGrpSpPr>
+        <p:cNvPr id="1" name=""/>
+        <p:cNvGrpSpPr/>
+        <p:nvPr/>
+      </p:nvGrpSpPr>
+      <p:grpSpPr/>
+      <p:sp>
+        <p:nvSpPr>
+          <p:cNvPr id="2" name="Rectangle 1"/>
+          <p:cNvSpPr/>
+          <p:nvPr/>
+        </p:nvSpPr>
+        <p:spPr>
+          <a:xfrm>
+            <a:off x="0" y="0"/>
+            <a:ext cx="12192000" cy="6858000"/>
+          </a:xfrm>
+          <a:prstGeom prst="rect">
+            <a:avLst/>
+          </a:prstGeom>
+          <a:solidFill>
+            <a:srgbClr val="FFFFFF"/>
+          </a:solidFill>
+          <a:ln>
+            <a:noFill/>
+          </a:ln>
+          <a:effectLst/>
+        </p:spPr>
+        <p:style>
+          <a:lnRef idx="1">
+            <a:schemeClr val="accent1"/>
+          </a:lnRef>
+          <a:fillRef idx="3">
+            <a:schemeClr val="accent1"/>
+          </a:fillRef>
+          <a:effectRef idx="2">
+            <a:schemeClr val="accent1"/>
+          </a:effectRef>
+          <a:fontRef idx="minor">
+            <a:schemeClr val="lt1"/>
+          </a:fontRef>
+        </p:style>
+        <p:txBody>
+          <a:bodyPr rtlCol="0" anchor="ctr"/>
+          <a:lstStyle/>
+          <a:p>
+            <a:pPr algn="ctr"/>
+          </a:p>
+        </p:txBody>
+      </p:sp>
+      <p:sp>
+        <p:nvSpPr>
+          <p:cNvPr id="3" name="Rectangle 2"/>
+          <p:cNvSpPr/>
+          <p:nvPr/>
+        </p:nvSpPr>
+        <p:spPr>
+          <a:xfrm>
+            <a:off x="0" y="0"/>
+            <a:ext cx="121920" cy="6858000"/>
+          </a:xfrm>
+          <a:prstGeom prst="rect">
+            <a:avLst/>
+          </a:prstGeom>
+          <a:solidFill>
+            <a:srgbClr val="F07F12"/>
+          </a:solidFill>
+          <a:ln>
+            <a:noFill/>
+          </a:ln>
+          <a:effectLst/>
+        </p:spPr>
+        <p:style>
+          <a:lnRef idx="1">
+            <a:schemeClr val="accent1"/>
+          </a:lnRef>
+          <a:fillRef idx="3">
+            <a:schemeClr val="accent1"/>
+          </a:fillRef>
+          <a:effectRef idx="2">
+            <a:schemeClr val="accent1"/>
+          </a:effectRef>
+          <a:fontRef idx="minor">
+            <a:schemeClr val="lt1"/>
+          </a:fontRef>
+        </p:style>
+        <p:txBody>
+          <a:bodyPr rtlCol="0" anchor="ctr"/>
+          <a:lstStyle/>
+          <a:p>
+            <a:pPr algn="ctr"/>
+          </a:p>
+        </p:txBody>
+      </p:sp>
+      <p:sp>
+        <p:nvSpPr>
+          <p:cNvPr id="4" name="TextBox 3"/>
+          <p:cNvSpPr txBox="1"/>
+          <p:nvPr/>
+        </p:nvSpPr>
+        <p:spPr>
+          <a:xfrm>
+            <a:off x="533400" y="381000"/>
+            <a:ext cx="9906000" cy="304800"/>
+          </a:xfrm>
+          <a:prstGeom prst="rect">
+            <a:avLst/>
+          </a:prstGeom>
+          <a:noFill/>
+          <a:ln>
+            <a:noFill/>
+          </a:ln>
+        </p:spPr>
+        <p:txBody>
+          <a:bodyPr wrap="square" anchor="t" lIns="45000" rIns="45000" tIns="15000" bIns="15000">
+            <a:spAutoFit/>
+          </a:bodyPr>
+          <a:lstStyle/>
+          <a:p>
+            <a:pPr algn="l"/>
+            <a:r>
+              <a:rPr sz="1100" b="1" i="0">
+                <a:solidFill>
+                  <a:srgbClr val="F07F12"/>
+                </a:solidFill>
+                <a:latin typeface="Calibri"/>
+              </a:rPr>
+              <a:t>OPERATIONS · ZIELMODELL</a:t>
+            </a:r>
+          </a:p>
+        </p:txBody>
+      </p:sp>
+      <p:sp>
+        <p:nvSpPr>
+          <p:cNvPr id="5" name="TextBox 4"/>
+          <p:cNvSpPr txBox="1"/>
+          <p:nvPr/>
+        </p:nvSpPr>
+        <p:spPr>
+          <a:xfrm>
+            <a:off x="533400" y="647700"/>
+            <a:ext cx="11125200" cy="685800"/>
+          </a:xfrm>
+          <a:prstGeom prst="rect">
+            <a:avLst/>
+          </a:prstGeom>
+          <a:noFill/>
+          <a:ln>
+            <a:noFill/>
+          </a:ln>
+        </p:spPr>
+        <p:txBody>
+          <a:bodyPr wrap="square" anchor="t" lIns="45000" rIns="45000" tIns="15000" bIns="15000">
+            <a:spAutoFit/>
+          </a:bodyPr>
+          <a:lstStyle/>
+          <a:p>
+            <a:pPr algn="l"/>
+            <a:r>
+              <a:rPr sz="2400" b="1" i="0">
+                <a:solidFill>
+                  <a:srgbClr val="1F2937"/>
+                </a:solidFill>
+                <a:latin typeface="Calibri"/>
+              </a:rPr>
+              <a:t>Eine Klammer trennt „WAS“ vom „WIE“ und bündelt die Koordination</a:t>
+            </a:r>
+          </a:p>
+        </p:txBody>
+      </p:sp>
+      <p:sp>
+        <p:nvSpPr>
+          <p:cNvPr id="6" name="Rectangle 5"/>
+          <p:cNvSpPr/>
+          <p:nvPr/>
+        </p:nvSpPr>
+        <p:spPr>
+          <a:xfrm>
+            <a:off x="533400" y="1333500"/>
+            <a:ext cx="11125200" cy="9144"/>
+          </a:xfrm>
+          <a:prstGeom prst="rect">
+            <a:avLst/>
+          </a:prstGeom>
+          <a:solidFill>
+            <a:srgbClr val="D1D5DB"/>
+          </a:solidFill>
+          <a:ln>
+            <a:noFill/>
+          </a:ln>
+          <a:effectLst/>
+        </p:spPr>
+        <p:style>
+          <a:lnRef idx="1">
+            <a:schemeClr val="accent1"/>
+          </a:lnRef>
+          <a:fillRef idx="3">
+            <a:schemeClr val="accent1"/>
+          </a:fillRef>
+          <a:effectRef idx="2">
+            <a:schemeClr val="accent1"/>
+          </a:effectRef>
+          <a:fontRef idx="minor">
+            <a:schemeClr val="lt1"/>
+          </a:fontRef>
+        </p:style>
+        <p:txBody>
+          <a:bodyPr rtlCol="0" anchor="ctr"/>
+          <a:lstStyle/>
+          <a:p>
+            <a:pPr algn="ctr"/>
+          </a:p>
+        </p:txBody>
+      </p:sp>
+      <p:sp>
+        <p:nvSpPr>
+          <p:cNvPr id="7" name="TextBox 6"/>
+          <p:cNvSpPr txBox="1"/>
+          <p:nvPr/>
+        </p:nvSpPr>
+        <p:spPr>
+          <a:xfrm>
+            <a:off x="11430000" y="6438900"/>
+            <a:ext cx="609600" cy="304800"/>
+          </a:xfrm>
+          <a:prstGeom prst="rect">
+            <a:avLst/>
+          </a:prstGeom>
+          <a:noFill/>
+          <a:ln>
+            <a:noFill/>
+          </a:ln>
+        </p:spPr>
+        <p:txBody>
+          <a:bodyPr wrap="square" anchor="t" lIns="45000" rIns="45000" tIns="15000" bIns="15000">
+            <a:spAutoFit/>
+          </a:bodyPr>
+          <a:lstStyle/>
+          <a:p>
+            <a:pPr algn="r"/>
+            <a:r>
+              <a:rPr sz="1000" b="0" i="0">
+                <a:solidFill>
+                  <a:srgbClr val="D1D5DB"/>
+                </a:solidFill>
+                <a:latin typeface="Calibri"/>
+              </a:rPr>
+              <a:t>11</a:t>
+            </a:r>
+          </a:p>
+        </p:txBody>
+      </p:sp>
+      <p:sp>
+        <p:nvSpPr>
+          <p:cNvPr id="8" name="TextBox 7"/>
+          <p:cNvSpPr txBox="1"/>
+          <p:nvPr/>
+        </p:nvSpPr>
+        <p:spPr>
+          <a:xfrm>
+            <a:off x="533400" y="6438900"/>
+            <a:ext cx="6858000" cy="304800"/>
+          </a:xfrm>
+          <a:prstGeom prst="rect">
+            <a:avLst/>
+          </a:prstGeom>
+          <a:noFill/>
+          <a:ln>
+            <a:noFill/>
+          </a:ln>
+        </p:spPr>
+        <p:txBody>
+          <a:bodyPr wrap="square" anchor="t" lIns="45000" rIns="45000" tIns="15000" bIns="15000">
+            <a:spAutoFit/>
+          </a:bodyPr>
+          <a:lstStyle/>
+          <a:p>
+            <a:pPr algn="l"/>
+            <a:r>
+              <a:rPr sz="900" b="0" i="0">
+                <a:solidFill>
+                  <a:srgbClr val="D1D5DB"/>
+                </a:solidFill>
+                <a:latin typeface="Calibri"/>
+              </a:rPr>
+              <a:t>IT-Ablauforganisation · Zielbild</a:t>
+            </a:r>
+          </a:p>
+        </p:txBody>
+      </p:sp>
+      <p:sp>
+        <p:nvSpPr>
+          <p:cNvPr id="9" name="TextBox 8"/>
+          <p:cNvSpPr txBox="1"/>
+          <p:nvPr/>
+        </p:nvSpPr>
+        <p:spPr>
+          <a:xfrm>
+            <a:off x="533400" y="1470660"/>
+            <a:ext cx="11125200" cy="304800"/>
+          </a:xfrm>
+          <a:prstGeom prst="rect">
+            <a:avLst/>
+          </a:prstGeom>
+          <a:noFill/>
+          <a:ln>
+            <a:noFill/>
+          </a:ln>
+        </p:spPr>
+        <p:txBody>
+          <a:bodyPr wrap="square" anchor="t" lIns="45000" rIns="45000" tIns="15000" bIns="15000">
+            <a:spAutoFit/>
+          </a:bodyPr>
+          <a:lstStyle/>
+          <a:p>
+            <a:pPr algn="l">
+              <a:lnSpc>
+                <a:spcPct val="112000"/>
+              </a:lnSpc>
+            </a:pPr>
+            <a:r>
+              <a:rPr sz="1050" b="0" i="0">
+                <a:solidFill>
+                  <a:srgbClr val="4B5563"/>
+                </a:solidFill>
+                <a:latin typeface="Calibri"/>
+              </a:rPr>
+              <a:t>Der Service Owner bleibt fürs Ergebnis (WAS) accountable. Die operative Koordination über alle Provider und internen Einheiten (WIE) übernimmt ein Service Delivery Manager.</a:t>
+            </a:r>
+          </a:p>
+        </p:txBody>
+      </p:sp>
+      <p:sp>
+        <p:nvSpPr>
+          <p:cNvPr id="10" name="Rounded Rectangle 9"/>
+          <p:cNvSpPr/>
+          <p:nvPr/>
+        </p:nvSpPr>
+        <p:spPr>
+          <a:xfrm>
+            <a:off x="533400" y="1905000"/>
+            <a:ext cx="3200400" cy="609600"/>
+          </a:xfrm>
+          <a:prstGeom prst="roundRect">
+            <a:avLst>
+              <a:gd name="adj" fmla="val 8000"/>
+            </a:avLst>
+          </a:prstGeom>
+          <a:solidFill>
+            <a:srgbClr val="F07F12"/>
+          </a:solidFill>
+          <a:ln>
+            <a:noFill/>
+          </a:ln>
+          <a:effectLst/>
+        </p:spPr>
+        <p:style>
+          <a:lnRef idx="1">
+            <a:schemeClr val="accent1"/>
+          </a:lnRef>
+          <a:fillRef idx="3">
+            <a:schemeClr val="accent1"/>
+          </a:fillRef>
+          <a:effectRef idx="2">
+            <a:schemeClr val="accent1"/>
+          </a:effectRef>
+          <a:fontRef idx="minor">
+            <a:schemeClr val="lt1"/>
+          </a:fontRef>
+        </p:style>
+        <p:txBody>
+          <a:bodyPr rtlCol="0" anchor="ctr"/>
+          <a:lstStyle/>
+          <a:p>
+            <a:pPr algn="ctr"/>
+          </a:p>
+        </p:txBody>
+      </p:sp>
+      <p:sp>
+        <p:nvSpPr>
+          <p:cNvPr id="11" name="TextBox 10"/>
+          <p:cNvSpPr txBox="1"/>
+          <p:nvPr/>
+        </p:nvSpPr>
+        <p:spPr>
+          <a:xfrm>
+            <a:off x="533400" y="1905000"/>
+            <a:ext cx="3200400" cy="609600"/>
+          </a:xfrm>
+          <a:prstGeom prst="rect">
+            <a:avLst/>
+          </a:prstGeom>
+          <a:noFill/>
+          <a:ln>
+            <a:noFill/>
+          </a:ln>
+        </p:spPr>
+        <p:txBody>
+          <a:bodyPr wrap="square" anchor="ctr" lIns="45000" rIns="45000" tIns="15000" bIns="15000">
+            <a:spAutoFit/>
+          </a:bodyPr>
+          <a:lstStyle/>
+          <a:p>
+            <a:pPr algn="ctr"/>
+            <a:r>
+              <a:rPr sz="1050" b="1" i="0">
+                <a:solidFill>
+                  <a:srgbClr val="FFFFFF"/>
+                </a:solidFill>
+                <a:latin typeface="Calibri"/>
+              </a:rPr>
+              <a:t>Service Owner</a:t>
+            </a:r>
+          </a:p>
+          <a:p>
+            <a:pPr algn="ctr"/>
+            <a:r>
+              <a:rPr sz="830" b="0" i="0">
+                <a:solidFill>
+                  <a:srgbClr val="FDE6CC"/>
+                </a:solidFill>
+                <a:latin typeface="Calibri"/>
+              </a:rPr>
+              <a:t>Ergebnis · WAS</a:t>
+            </a:r>
+          </a:p>
+        </p:txBody>
+      </p:sp>
+      <p:cxnSp>
+        <p:nvCxnSpPr>
+          <p:cNvPr id="12" name="Connector 11"/>
+          <p:cNvCxnSpPr/>
+          <p:nvPr/>
+        </p:nvCxnSpPr>
+        <p:spPr>
+          <a:xfrm>
+            <a:off x="2133600" y="2514600"/>
+            <a:ext cx="0" cy="228600"/>
+          </a:xfrm>
+          <a:prstGeom prst="line">
+            <a:avLst/>
+          </a:prstGeom>
+          <a:ln w="19050">
+            <a:solidFill>
+              <a:srgbClr val="2E7D32"/>
+            </a:solidFill>
+          </a:ln>
+          <a:effectLst/>
+        </p:spPr>
+        <p:style>
+          <a:lnRef idx="2">
+            <a:schemeClr val="accent1"/>
+          </a:lnRef>
+          <a:fillRef idx="0">
+            <a:schemeClr val="accent1"/>
+          </a:fillRef>
+          <a:effectRef idx="1">
+            <a:schemeClr val="accent1"/>
+          </a:effectRef>
+          <a:fontRef idx="minor">
+            <a:schemeClr val="tx1"/>
+          </a:fontRef>
+        </p:style>
+      </p:cxnSp>
+      <p:sp>
+        <p:nvSpPr>
+          <p:cNvPr id="13" name="Rounded Rectangle 12"/>
+          <p:cNvSpPr/>
+          <p:nvPr/>
+        </p:nvSpPr>
+        <p:spPr>
+          <a:xfrm>
+            <a:off x="533400" y="2743200"/>
+            <a:ext cx="3200400" cy="647700"/>
+          </a:xfrm>
+          <a:prstGeom prst="roundRect">
+            <a:avLst>
+              <a:gd name="adj" fmla="val 8000"/>
+            </a:avLst>
+          </a:prstGeom>
+          <a:solidFill>
+            <a:srgbClr val="FDE6CC"/>
+          </a:solidFill>
+          <a:ln w="15875">
+            <a:solidFill>
+              <a:srgbClr val="6B4FA0"/>
+            </a:solidFill>
+          </a:ln>
+          <a:effectLst/>
+        </p:spPr>
+        <p:style>
+          <a:lnRef idx="1">
+            <a:schemeClr val="accent1"/>
+          </a:lnRef>
+          <a:fillRef idx="3">
+            <a:schemeClr val="accent1"/>
+          </a:fillRef>
+          <a:effectRef idx="2">
+            <a:schemeClr val="accent1"/>
+          </a:effectRef>
+          <a:fontRef idx="minor">
+            <a:schemeClr val="lt1"/>
+          </a:fontRef>
+        </p:style>
+        <p:txBody>
+          <a:bodyPr rtlCol="0" anchor="ctr"/>
+          <a:lstStyle/>
+          <a:p>
+            <a:pPr algn="ctr"/>
+          </a:p>
+        </p:txBody>
+      </p:sp>
+      <p:sp>
+        <p:nvSpPr>
+          <p:cNvPr id="14" name="TextBox 13"/>
+          <p:cNvSpPr txBox="1"/>
+          <p:nvPr/>
+        </p:nvSpPr>
+        <p:spPr>
+          <a:xfrm>
+            <a:off x="533400" y="2743200"/>
+            <a:ext cx="3200400" cy="647700"/>
+          </a:xfrm>
+          <a:prstGeom prst="rect">
+            <a:avLst/>
+          </a:prstGeom>
+          <a:noFill/>
+          <a:ln>
+            <a:noFill/>
+          </a:ln>
+        </p:spPr>
+        <p:txBody>
+          <a:bodyPr wrap="square" anchor="ctr" lIns="45000" rIns="45000" tIns="15000" bIns="15000">
+            <a:spAutoFit/>
+          </a:bodyPr>
+          <a:lstStyle/>
+          <a:p>
+            <a:pPr algn="ctr"/>
+            <a:r>
+              <a:rPr sz="1050" b="1" i="0">
+                <a:solidFill>
+                  <a:srgbClr val="7A3D05"/>
+                </a:solidFill>
+                <a:latin typeface="Calibri"/>
+              </a:rPr>
+              <a:t>Service Delivery Manager</a:t>
+            </a:r>
+          </a:p>
+          <a:p>
+            <a:pPr algn="ctr"/>
+            <a:r>
+              <a:rPr sz="830" b="0" i="0">
+                <a:solidFill>
+                  <a:srgbClr val="B4531A"/>
+                </a:solidFill>
+                <a:latin typeface="Calibri"/>
+              </a:rPr>
+              <a:t>Koordination · WIE   (neu)</a:t>
+            </a:r>
+          </a:p>
+        </p:txBody>
+      </p:sp>
+      <p:sp>
+        <p:nvSpPr>
+          <p:cNvPr id="15" name="TextBox 14"/>
+          <p:cNvSpPr txBox="1"/>
+          <p:nvPr/>
+        </p:nvSpPr>
+        <p:spPr>
+          <a:xfrm>
+            <a:off x="2286000" y="2468880"/>
+            <a:ext cx="1447800" cy="228600"/>
+          </a:xfrm>
+          <a:prstGeom prst="rect">
+            <a:avLst/>
+          </a:prstGeom>
+          <a:noFill/>
+          <a:ln>
+            <a:noFill/>
+          </a:ln>
+        </p:spPr>
+        <p:txBody>
+          <a:bodyPr wrap="square" anchor="t" lIns="45000" rIns="45000" tIns="15000" bIns="15000">
+            <a:spAutoFit/>
+          </a:bodyPr>
+          <a:lstStyle/>
+          <a:p>
+            <a:pPr algn="l"/>
+            <a:r>
+              <a:rPr sz="750" b="0" i="1">
+                <a:solidFill>
+                  <a:srgbClr val="2E7D32"/>
+                </a:solidFill>
+                <a:latin typeface="Calibri"/>
+              </a:rPr>
+              <a:t>Ziele, SLA →</a:t>
+            </a:r>
+          </a:p>
+        </p:txBody>
+      </p:sp>
+      <p:cxnSp>
+        <p:nvCxnSpPr>
+          <p:cNvPr id="16" name="Connector 15"/>
+          <p:cNvCxnSpPr/>
+          <p:nvPr/>
+        </p:nvCxnSpPr>
+        <p:spPr>
+          <a:xfrm flipH="1">
+            <a:off x="838200" y="3390900"/>
+            <a:ext cx="1295400" cy="342900"/>
+          </a:xfrm>
+          <a:prstGeom prst="line">
+            <a:avLst/>
+          </a:prstGeom>
+          <a:ln w="12700">
+            <a:solidFill>
+              <a:srgbClr val="2E7D32"/>
+            </a:solidFill>
+          </a:ln>
+          <a:effectLst/>
+        </p:spPr>
+        <p:style>
+          <a:lnRef idx="2">
+            <a:schemeClr val="accent1"/>
+          </a:lnRef>
+          <a:fillRef idx="0">
+            <a:schemeClr val="accent1"/>
+          </a:fillRef>
+          <a:effectRef idx="1">
+            <a:schemeClr val="accent1"/>
+          </a:effectRef>
+          <a:fontRef idx="minor">
+            <a:schemeClr val="tx1"/>
+          </a:fontRef>
+        </p:style>
+      </p:cxnSp>
+      <p:cxnSp>
+        <p:nvCxnSpPr>
+          <p:cNvPr id="17" name="Connector 16"/>
+          <p:cNvCxnSpPr/>
+          <p:nvPr/>
+        </p:nvCxnSpPr>
+        <p:spPr>
+          <a:xfrm flipH="1">
+            <a:off x="1485900" y="3390900"/>
+            <a:ext cx="647700" cy="342900"/>
+          </a:xfrm>
+          <a:prstGeom prst="line">
+            <a:avLst/>
+          </a:prstGeom>
+          <a:ln w="12700">
+            <a:solidFill>
+              <a:srgbClr val="2E7D32"/>
+            </a:solidFill>
+          </a:ln>
+          <a:effectLst/>
+        </p:spPr>
+        <p:style>
+          <a:lnRef idx="2">
+            <a:schemeClr val="accent1"/>
+          </a:lnRef>
+          <a:fillRef idx="0">
+            <a:schemeClr val="accent1"/>
+          </a:fillRef>
+          <a:effectRef idx="1">
+            <a:schemeClr val="accent1"/>
+          </a:effectRef>
+          <a:fontRef idx="minor">
+            <a:schemeClr val="tx1"/>
+          </a:fontRef>
+        </p:style>
+      </p:cxnSp>
+      <p:cxnSp>
+        <p:nvCxnSpPr>
+          <p:cNvPr id="18" name="Connector 17"/>
+          <p:cNvCxnSpPr/>
+          <p:nvPr/>
+        </p:nvCxnSpPr>
+        <p:spPr>
+          <a:xfrm>
+            <a:off x="2133600" y="3390900"/>
+            <a:ext cx="0" cy="342900"/>
+          </a:xfrm>
+          <a:prstGeom prst="line">
+            <a:avLst/>
+          </a:prstGeom>
+          <a:ln w="12700">
+            <a:solidFill>
+              <a:srgbClr val="2E7D32"/>
+            </a:solidFill>
+          </a:ln>
+          <a:effectLst/>
+        </p:spPr>
+        <p:style>
+          <a:lnRef idx="2">
+            <a:schemeClr val="accent1"/>
+          </a:lnRef>
+          <a:fillRef idx="0">
+            <a:schemeClr val="accent1"/>
+          </a:fillRef>
+          <a:effectRef idx="1">
+            <a:schemeClr val="accent1"/>
+          </a:effectRef>
+          <a:fontRef idx="minor">
+            <a:schemeClr val="tx1"/>
+          </a:fontRef>
+        </p:style>
+      </p:cxnSp>
+      <p:cxnSp>
+        <p:nvCxnSpPr>
+          <p:cNvPr id="19" name="Connector 18"/>
+          <p:cNvCxnSpPr/>
+          <p:nvPr/>
+        </p:nvCxnSpPr>
+        <p:spPr>
+          <a:xfrm>
+            <a:off x="2133600" y="3390900"/>
+            <a:ext cx="647700" cy="342900"/>
+          </a:xfrm>
+          <a:prstGeom prst="line">
+            <a:avLst/>
+          </a:prstGeom>
+          <a:ln w="12700">
+            <a:solidFill>
+              <a:srgbClr val="2E7D32"/>
+            </a:solidFill>
+          </a:ln>
+          <a:effectLst/>
+        </p:spPr>
+        <p:style>
+          <a:lnRef idx="2">
+            <a:schemeClr val="accent1"/>
+          </a:lnRef>
+          <a:fillRef idx="0">
+            <a:schemeClr val="accent1"/>
+          </a:fillRef>
+          <a:effectRef idx="1">
+            <a:schemeClr val="accent1"/>
+          </a:effectRef>
+          <a:fontRef idx="minor">
+            <a:schemeClr val="tx1"/>
+          </a:fontRef>
+        </p:style>
+      </p:cxnSp>
+      <p:cxnSp>
+        <p:nvCxnSpPr>
+          <p:cNvPr id="20" name="Connector 19"/>
+          <p:cNvCxnSpPr/>
+          <p:nvPr/>
+        </p:nvCxnSpPr>
+        <p:spPr>
+          <a:xfrm>
+            <a:off x="2133600" y="3390900"/>
+            <a:ext cx="1295400" cy="342900"/>
+          </a:xfrm>
+          <a:prstGeom prst="line">
+            <a:avLst/>
+          </a:prstGeom>
+          <a:ln w="12700">
+            <a:solidFill>
+              <a:srgbClr val="2E7D32"/>
+            </a:solidFill>
+          </a:ln>
+          <a:effectLst/>
+        </p:spPr>
+        <p:style>
+          <a:lnRef idx="2">
+            <a:schemeClr val="accent1"/>
+          </a:lnRef>
+          <a:fillRef idx="0">
+            <a:schemeClr val="accent1"/>
+          </a:fillRef>
+          <a:effectRef idx="1">
+            <a:schemeClr val="accent1"/>
+          </a:effectRef>
+          <a:fontRef idx="minor">
+            <a:schemeClr val="tx1"/>
+          </a:fontRef>
+        </p:style>
+      </p:cxnSp>
+      <p:sp>
+        <p:nvSpPr>
+          <p:cNvPr id="21" name="Rounded Rectangle 20"/>
+          <p:cNvSpPr/>
+          <p:nvPr/>
+        </p:nvSpPr>
+        <p:spPr>
+          <a:xfrm>
+            <a:off x="533400" y="3733800"/>
+            <a:ext cx="609600" cy="647700"/>
+          </a:xfrm>
+          <a:prstGeom prst="roundRect">
+            <a:avLst>
+              <a:gd name="adj" fmla="val 8000"/>
+            </a:avLst>
+          </a:prstGeom>
+          <a:solidFill>
+            <a:srgbClr val="EBE6F5"/>
+          </a:solidFill>
+          <a:ln w="11430">
+            <a:solidFill>
+              <a:srgbClr val="6B4FA0"/>
+            </a:solidFill>
+          </a:ln>
+          <a:effectLst/>
+        </p:spPr>
+        <p:style>
+          <a:lnRef idx="1">
+            <a:schemeClr val="accent1"/>
+          </a:lnRef>
+          <a:fillRef idx="3">
+            <a:schemeClr val="accent1"/>
+          </a:fillRef>
+          <a:effectRef idx="2">
+            <a:schemeClr val="accent1"/>
+          </a:effectRef>
+          <a:fontRef idx="minor">
+            <a:schemeClr val="lt1"/>
+          </a:fontRef>
+        </p:style>
+        <p:txBody>
+          <a:bodyPr rtlCol="0" anchor="ctr"/>
+          <a:lstStyle/>
+          <a:p>
+            <a:pPr algn="ctr"/>
+          </a:p>
+        </p:txBody>
+      </p:sp>
+      <p:sp>
+        <p:nvSpPr>
+          <p:cNvPr id="22" name="TextBox 21"/>
+          <p:cNvSpPr txBox="1"/>
+          <p:nvPr/>
+        </p:nvSpPr>
+        <p:spPr>
+          <a:xfrm>
+            <a:off x="533400" y="3733800"/>
+            <a:ext cx="609600" cy="647700"/>
+          </a:xfrm>
+          <a:prstGeom prst="rect">
+            <a:avLst/>
+          </a:prstGeom>
+          <a:noFill/>
+          <a:ln>
+            <a:noFill/>
+          </a:ln>
+        </p:spPr>
+        <p:txBody>
+          <a:bodyPr wrap="square" anchor="ctr" lIns="45000" rIns="45000" tIns="15000" bIns="15000">
+            <a:spAutoFit/>
+          </a:bodyPr>
+          <a:lstStyle/>
+          <a:p>
+            <a:pPr algn="ctr">
+              <a:lnSpc>
+                <a:spcPct val="95000"/>
+              </a:lnSpc>
+            </a:pPr>
+            <a:r>
+              <a:rPr sz="700" b="1" i="0">
+                <a:solidFill>
+                  <a:srgbClr val="1F2937"/>
+                </a:solidFill>
+                <a:latin typeface="Calibri"/>
+              </a:rPr>
+              <a:t>AMS · DXC</a:t>
+            </a:r>
+          </a:p>
+        </p:txBody>
+      </p:sp>
+      <p:sp>
+        <p:nvSpPr>
+          <p:cNvPr id="23" name="Rounded Rectangle 22"/>
+          <p:cNvSpPr/>
+          <p:nvPr/>
+        </p:nvSpPr>
+        <p:spPr>
+          <a:xfrm>
+            <a:off x="1181100" y="3733800"/>
+            <a:ext cx="609600" cy="647700"/>
+          </a:xfrm>
+          <a:prstGeom prst="roundRect">
+            <a:avLst>
+              <a:gd name="adj" fmla="val 8000"/>
+            </a:avLst>
+          </a:prstGeom>
+          <a:solidFill>
+            <a:srgbClr val="EBE6F5"/>
+          </a:solidFill>
+          <a:ln w="11430">
+            <a:solidFill>
+              <a:srgbClr val="6B4FA0"/>
+            </a:solidFill>
+          </a:ln>
+          <a:effectLst/>
+        </p:spPr>
+        <p:style>
+          <a:lnRef idx="1">
+            <a:schemeClr val="accent1"/>
+          </a:lnRef>
+          <a:fillRef idx="3">
+            <a:schemeClr val="accent1"/>
+          </a:fillRef>
+          <a:effectRef idx="2">
+            <a:schemeClr val="accent1"/>
+          </a:effectRef>
+          <a:fontRef idx="minor">
+            <a:schemeClr val="lt1"/>
+          </a:fontRef>
+        </p:style>
+        <p:txBody>
+          <a:bodyPr rtlCol="0" anchor="ctr"/>
+          <a:lstStyle/>
+          <a:p>
+            <a:pPr algn="ctr"/>
+          </a:p>
+        </p:txBody>
+      </p:sp>
+      <p:sp>
+        <p:nvSpPr>
+          <p:cNvPr id="24" name="TextBox 23"/>
+          <p:cNvSpPr txBox="1"/>
+          <p:nvPr/>
+        </p:nvSpPr>
+        <p:spPr>
+          <a:xfrm>
+            <a:off x="1181100" y="3733800"/>
+            <a:ext cx="609600" cy="647700"/>
+          </a:xfrm>
+          <a:prstGeom prst="rect">
+            <a:avLst/>
+          </a:prstGeom>
+          <a:noFill/>
+          <a:ln>
+            <a:noFill/>
+          </a:ln>
+        </p:spPr>
+        <p:txBody>
+          <a:bodyPr wrap="square" anchor="ctr" lIns="45000" rIns="45000" tIns="15000" bIns="15000">
+            <a:spAutoFit/>
+          </a:bodyPr>
+          <a:lstStyle/>
+          <a:p>
+            <a:pPr algn="ctr">
+              <a:lnSpc>
+                <a:spcPct val="95000"/>
+              </a:lnSpc>
+            </a:pPr>
+            <a:r>
+              <a:rPr sz="700" b="1" i="0">
+                <a:solidFill>
+                  <a:srgbClr val="1F2937"/>
+                </a:solidFill>
+                <a:latin typeface="Calibri"/>
+              </a:rPr>
+              <a:t>weitere AMS /</a:t>
+            </a:r>
+          </a:p>
+          <a:p>
+            <a:pPr algn="ctr">
+              <a:lnSpc>
+                <a:spcPct val="95000"/>
+              </a:lnSpc>
+            </a:pPr>
+            <a:r>
+              <a:rPr sz="650" b="0" i="0">
+                <a:solidFill>
+                  <a:srgbClr val="4B5563"/>
+                </a:solidFill>
+                <a:latin typeface="Calibri"/>
+              </a:rPr>
+              <a:t>Ops-Provider</a:t>
+            </a:r>
+          </a:p>
+        </p:txBody>
+      </p:sp>
+      <p:sp>
+        <p:nvSpPr>
+          <p:cNvPr id="25" name="Rounded Rectangle 24"/>
+          <p:cNvSpPr/>
+          <p:nvPr/>
+        </p:nvSpPr>
+        <p:spPr>
+          <a:xfrm>
+            <a:off x="1828800" y="3733800"/>
+            <a:ext cx="609600" cy="647700"/>
+          </a:xfrm>
+          <a:prstGeom prst="roundRect">
+            <a:avLst>
+              <a:gd name="adj" fmla="val 8000"/>
+            </a:avLst>
+          </a:prstGeom>
+          <a:solidFill>
+            <a:srgbClr val="E4ECF4"/>
+          </a:solidFill>
+          <a:ln w="11430">
+            <a:solidFill>
+              <a:srgbClr val="2E5A8F"/>
+            </a:solidFill>
+          </a:ln>
+          <a:effectLst/>
+        </p:spPr>
+        <p:style>
+          <a:lnRef idx="1">
+            <a:schemeClr val="accent1"/>
+          </a:lnRef>
+          <a:fillRef idx="3">
+            <a:schemeClr val="accent1"/>
+          </a:fillRef>
+          <a:effectRef idx="2">
+            <a:schemeClr val="accent1"/>
+          </a:effectRef>
+          <a:fontRef idx="minor">
+            <a:schemeClr val="lt1"/>
+          </a:fontRef>
+        </p:style>
+        <p:txBody>
+          <a:bodyPr rtlCol="0" anchor="ctr"/>
+          <a:lstStyle/>
+          <a:p>
+            <a:pPr algn="ctr"/>
+          </a:p>
+        </p:txBody>
+      </p:sp>
+      <p:sp>
+        <p:nvSpPr>
+          <p:cNvPr id="26" name="TextBox 25"/>
+          <p:cNvSpPr txBox="1"/>
+          <p:nvPr/>
+        </p:nvSpPr>
+        <p:spPr>
+          <a:xfrm>
+            <a:off x="1828800" y="3733800"/>
+            <a:ext cx="609600" cy="647700"/>
+          </a:xfrm>
+          <a:prstGeom prst="rect">
+            <a:avLst/>
+          </a:prstGeom>
+          <a:noFill/>
+          <a:ln>
+            <a:noFill/>
+          </a:ln>
+        </p:spPr>
+        <p:txBody>
+          <a:bodyPr wrap="square" anchor="ctr" lIns="45000" rIns="45000" tIns="15000" bIns="15000">
+            <a:spAutoFit/>
+          </a:bodyPr>
+          <a:lstStyle/>
+          <a:p>
+            <a:pPr algn="ctr">
+              <a:lnSpc>
+                <a:spcPct val="95000"/>
+              </a:lnSpc>
+            </a:pPr>
+            <a:r>
+              <a:rPr sz="700" b="1" i="0">
+                <a:solidFill>
+                  <a:srgbClr val="1F2937"/>
+                </a:solidFill>
+                <a:latin typeface="Calibri"/>
+              </a:rPr>
+              <a:t>TSS · Infra-Ops</a:t>
+            </a:r>
+          </a:p>
+        </p:txBody>
+      </p:sp>
+      <p:sp>
+        <p:nvSpPr>
+          <p:cNvPr id="27" name="Rounded Rectangle 26"/>
+          <p:cNvSpPr/>
+          <p:nvPr/>
+        </p:nvSpPr>
+        <p:spPr>
+          <a:xfrm>
+            <a:off x="2476500" y="3733800"/>
+            <a:ext cx="609600" cy="647700"/>
+          </a:xfrm>
+          <a:prstGeom prst="roundRect">
+            <a:avLst>
+              <a:gd name="adj" fmla="val 8000"/>
+            </a:avLst>
+          </a:prstGeom>
+          <a:solidFill>
+            <a:srgbClr val="E4ECF4"/>
+          </a:solidFill>
+          <a:ln w="11430">
+            <a:solidFill>
+              <a:srgbClr val="2E5A8F"/>
+            </a:solidFill>
+          </a:ln>
+          <a:effectLst/>
+        </p:spPr>
+        <p:style>
+          <a:lnRef idx="1">
+            <a:schemeClr val="accent1"/>
+          </a:lnRef>
+          <a:fillRef idx="3">
+            <a:schemeClr val="accent1"/>
+          </a:fillRef>
+          <a:effectRef idx="2">
+            <a:schemeClr val="accent1"/>
+          </a:effectRef>
+          <a:fontRef idx="minor">
+            <a:schemeClr val="lt1"/>
+          </a:fontRef>
+        </p:style>
+        <p:txBody>
+          <a:bodyPr rtlCol="0" anchor="ctr"/>
+          <a:lstStyle/>
+          <a:p>
+            <a:pPr algn="ctr"/>
+          </a:p>
+        </p:txBody>
+      </p:sp>
+      <p:sp>
+        <p:nvSpPr>
+          <p:cNvPr id="28" name="TextBox 27"/>
+          <p:cNvSpPr txBox="1"/>
+          <p:nvPr/>
+        </p:nvSpPr>
+        <p:spPr>
+          <a:xfrm>
+            <a:off x="2476500" y="3733800"/>
+            <a:ext cx="609600" cy="647700"/>
+          </a:xfrm>
+          <a:prstGeom prst="rect">
+            <a:avLst/>
+          </a:prstGeom>
+          <a:noFill/>
+          <a:ln>
+            <a:noFill/>
+          </a:ln>
+        </p:spPr>
+        <p:txBody>
+          <a:bodyPr wrap="square" anchor="ctr" lIns="45000" rIns="45000" tIns="15000" bIns="15000">
+            <a:spAutoFit/>
+          </a:bodyPr>
+          <a:lstStyle/>
+          <a:p>
+            <a:pPr algn="ctr">
+              <a:lnSpc>
+                <a:spcPct val="95000"/>
+              </a:lnSpc>
+            </a:pPr>
+            <a:r>
+              <a:rPr sz="700" b="1" i="0">
+                <a:solidFill>
+                  <a:srgbClr val="1F2937"/>
+                </a:solidFill>
+                <a:latin typeface="Calibri"/>
+              </a:rPr>
+              <a:t>Service Desk</a:t>
+            </a:r>
+          </a:p>
+          <a:p>
+            <a:pPr algn="ctr">
+              <a:lnSpc>
+                <a:spcPct val="95000"/>
+              </a:lnSpc>
+            </a:pPr>
+            <a:r>
+              <a:rPr sz="650" b="0" i="0">
+                <a:solidFill>
+                  <a:srgbClr val="4B5563"/>
+                </a:solidFill>
+                <a:latin typeface="Calibri"/>
+              </a:rPr>
+              <a:t>(L1)</a:t>
+            </a:r>
+          </a:p>
+        </p:txBody>
+      </p:sp>
+      <p:sp>
+        <p:nvSpPr>
+          <p:cNvPr id="29" name="Rounded Rectangle 28"/>
+          <p:cNvSpPr/>
+          <p:nvPr/>
+        </p:nvSpPr>
+        <p:spPr>
+          <a:xfrm>
+            <a:off x="3124200" y="3733800"/>
+            <a:ext cx="609600" cy="647700"/>
+          </a:xfrm>
+          <a:prstGeom prst="roundRect">
+            <a:avLst>
+              <a:gd name="adj" fmla="val 8000"/>
+            </a:avLst>
+          </a:prstGeom>
+          <a:solidFill>
+            <a:srgbClr val="E4ECF4"/>
+          </a:solidFill>
+          <a:ln w="11430">
+            <a:solidFill>
+              <a:srgbClr val="2E5A8F"/>
+            </a:solidFill>
+          </a:ln>
+          <a:effectLst/>
+        </p:spPr>
+        <p:style>
+          <a:lnRef idx="1">
+            <a:schemeClr val="accent1"/>
+          </a:lnRef>
+          <a:fillRef idx="3">
+            <a:schemeClr val="accent1"/>
+          </a:fillRef>
+          <a:effectRef idx="2">
+            <a:schemeClr val="accent1"/>
+          </a:effectRef>
+          <a:fontRef idx="minor">
+            <a:schemeClr val="lt1"/>
+          </a:fontRef>
+        </p:style>
+        <p:txBody>
+          <a:bodyPr rtlCol="0" anchor="ctr"/>
+          <a:lstStyle/>
+          <a:p>
+            <a:pPr algn="ctr"/>
+          </a:p>
+        </p:txBody>
+      </p:sp>
+      <p:sp>
+        <p:nvSpPr>
+          <p:cNvPr id="30" name="TextBox 29"/>
+          <p:cNvSpPr txBox="1"/>
+          <p:nvPr/>
+        </p:nvSpPr>
+        <p:spPr>
+          <a:xfrm>
+            <a:off x="3124200" y="3733800"/>
+            <a:ext cx="609600" cy="647700"/>
+          </a:xfrm>
+          <a:prstGeom prst="rect">
+            <a:avLst/>
+          </a:prstGeom>
+          <a:noFill/>
+          <a:ln>
+            <a:noFill/>
+          </a:ln>
+        </p:spPr>
+        <p:txBody>
+          <a:bodyPr wrap="square" anchor="ctr" lIns="45000" rIns="45000" tIns="15000" bIns="15000">
+            <a:spAutoFit/>
+          </a:bodyPr>
+          <a:lstStyle/>
+          <a:p>
+            <a:pPr algn="ctr">
+              <a:lnSpc>
+                <a:spcPct val="95000"/>
+              </a:lnSpc>
+            </a:pPr>
+            <a:r>
+              <a:rPr sz="700" b="1" i="0">
+                <a:solidFill>
+                  <a:srgbClr val="1F2937"/>
+                </a:solidFill>
+                <a:latin typeface="Calibri"/>
+              </a:rPr>
+              <a:t>Regional</a:t>
+            </a:r>
+          </a:p>
+          <a:p>
+            <a:pPr algn="ctr">
+              <a:lnSpc>
+                <a:spcPct val="95000"/>
+              </a:lnSpc>
+            </a:pPr>
+            <a:r>
+              <a:rPr sz="650" b="0" i="0">
+                <a:solidFill>
+                  <a:srgbClr val="4B5563"/>
+                </a:solidFill>
+                <a:latin typeface="Calibri"/>
+              </a:rPr>
+              <a:t>Support Center</a:t>
+            </a:r>
+          </a:p>
+        </p:txBody>
+      </p:sp>
+      <p:sp>
+        <p:nvSpPr>
+          <p:cNvPr id="31" name="Rounded Rectangle 30"/>
+          <p:cNvSpPr/>
+          <p:nvPr/>
+        </p:nvSpPr>
+        <p:spPr>
+          <a:xfrm>
+            <a:off x="6400800" y="1905000"/>
+            <a:ext cx="5257800" cy="1714500"/>
+          </a:xfrm>
+          <a:prstGeom prst="roundRect">
+            <a:avLst>
+              <a:gd name="adj" fmla="val 8000"/>
+            </a:avLst>
+          </a:prstGeom>
+          <a:solidFill>
+            <a:srgbClr val="E3F2EA"/>
+          </a:solidFill>
+          <a:ln w="15875">
+            <a:solidFill>
+              <a:srgbClr val="2E7D32"/>
+            </a:solidFill>
+          </a:ln>
+          <a:effectLst/>
+        </p:spPr>
+        <p:style>
+          <a:lnRef idx="1">
+            <a:schemeClr val="accent1"/>
+          </a:lnRef>
+          <a:fillRef idx="3">
+            <a:schemeClr val="accent1"/>
+          </a:fillRef>
+          <a:effectRef idx="2">
+            <a:schemeClr val="accent1"/>
+          </a:effectRef>
+          <a:fontRef idx="minor">
+            <a:schemeClr val="lt1"/>
+          </a:fontRef>
+        </p:style>
+        <p:txBody>
+          <a:bodyPr rtlCol="0" anchor="ctr"/>
+          <a:lstStyle/>
+          <a:p>
+            <a:pPr algn="ctr"/>
+          </a:p>
+        </p:txBody>
+      </p:sp>
+      <p:sp>
+        <p:nvSpPr>
+          <p:cNvPr id="32" name="TextBox 31"/>
+          <p:cNvSpPr txBox="1"/>
+          <p:nvPr/>
+        </p:nvSpPr>
+        <p:spPr>
+          <a:xfrm>
+            <a:off x="6515100" y="1981200"/>
+            <a:ext cx="5029200" cy="457200"/>
+          </a:xfrm>
+          <a:prstGeom prst="rect">
+            <a:avLst/>
+          </a:prstGeom>
+          <a:noFill/>
+          <a:ln>
+            <a:noFill/>
+          </a:ln>
+        </p:spPr>
+        <p:txBody>
+          <a:bodyPr wrap="square" anchor="t" lIns="45000" rIns="45000" tIns="15000" bIns="15000">
+            <a:spAutoFit/>
+          </a:bodyPr>
+          <a:lstStyle/>
+          <a:p>
+            <a:pPr algn="l">
+              <a:lnSpc>
+                <a:spcPct val="105000"/>
+              </a:lnSpc>
+            </a:pPr>
+            <a:r>
+              <a:rPr sz="1000" b="1" i="0">
+                <a:solidFill>
+                  <a:srgbClr val="1C4A35"/>
+                </a:solidFill>
+                <a:latin typeface="Calibri"/>
+              </a:rPr>
+              <a:t>KLAMMER: Service Integration &amp; Operations (SIAM)</a:t>
+            </a:r>
+          </a:p>
+          <a:p>
+            <a:pPr algn="l">
+              <a:lnSpc>
+                <a:spcPct val="105000"/>
+              </a:lnSpc>
+            </a:pPr>
+            <a:r>
+              <a:rPr sz="850" b="0" i="1">
+                <a:solidFill>
+                  <a:srgbClr val="2E7D32"/>
+                </a:solidFill>
+                <a:latin typeface="Calibri"/>
+              </a:rPr>
+              <a:t>verankert im IPS Management Office</a:t>
+            </a:r>
+          </a:p>
+        </p:txBody>
+      </p:sp>
+      <p:sp>
+        <p:nvSpPr>
+          <p:cNvPr id="33" name="Rounded Rectangle 32"/>
+          <p:cNvSpPr/>
+          <p:nvPr/>
+        </p:nvSpPr>
+        <p:spPr>
+          <a:xfrm>
+            <a:off x="6515100" y="2514600"/>
+            <a:ext cx="2438400" cy="441960"/>
+          </a:xfrm>
+          <a:prstGeom prst="roundRect">
+            <a:avLst>
+              <a:gd name="adj" fmla="val 8000"/>
+            </a:avLst>
+          </a:prstGeom>
+          <a:solidFill>
+            <a:srgbClr val="FFFFFF"/>
+          </a:solidFill>
+          <a:ln w="9525">
+            <a:solidFill>
+              <a:srgbClr val="2E7D32"/>
+            </a:solidFill>
+          </a:ln>
+          <a:effectLst/>
+        </p:spPr>
+        <p:style>
+          <a:lnRef idx="1">
+            <a:schemeClr val="accent1"/>
+          </a:lnRef>
+          <a:fillRef idx="3">
+            <a:schemeClr val="accent1"/>
+          </a:fillRef>
+          <a:effectRef idx="2">
+            <a:schemeClr val="accent1"/>
+          </a:effectRef>
+          <a:fontRef idx="minor">
+            <a:schemeClr val="lt1"/>
+          </a:fontRef>
+        </p:style>
+        <p:txBody>
+          <a:bodyPr rtlCol="0" anchor="ctr"/>
+          <a:lstStyle/>
+          <a:p>
+            <a:pPr algn="ctr"/>
+          </a:p>
+        </p:txBody>
+      </p:sp>
+      <p:sp>
+        <p:nvSpPr>
+          <p:cNvPr id="34" name="TextBox 33"/>
+          <p:cNvSpPr txBox="1"/>
+          <p:nvPr/>
+        </p:nvSpPr>
+        <p:spPr>
+          <a:xfrm>
+            <a:off x="6515100" y="2514600"/>
+            <a:ext cx="2438400" cy="441960"/>
+          </a:xfrm>
+          <a:prstGeom prst="rect">
+            <a:avLst/>
+          </a:prstGeom>
+          <a:noFill/>
+          <a:ln>
+            <a:noFill/>
+          </a:ln>
+        </p:spPr>
+        <p:txBody>
+          <a:bodyPr wrap="square" anchor="ctr" lIns="45000" rIns="45000" tIns="15000" bIns="15000">
+            <a:spAutoFit/>
+          </a:bodyPr>
+          <a:lstStyle/>
+          <a:p>
+            <a:pPr algn="ctr"/>
+            <a:r>
+              <a:rPr sz="830" b="1" i="0">
+                <a:solidFill>
+                  <a:srgbClr val="1C4A35"/>
+                </a:solidFill>
+                <a:latin typeface="Calibri"/>
+              </a:rPr>
+              <a:t>Practice Supplier Mgmt</a:t>
+            </a:r>
+          </a:p>
+        </p:txBody>
+      </p:sp>
+      <p:sp>
+        <p:nvSpPr>
+          <p:cNvPr id="35" name="Rounded Rectangle 34"/>
+          <p:cNvSpPr/>
+          <p:nvPr/>
+        </p:nvSpPr>
+        <p:spPr>
+          <a:xfrm>
+            <a:off x="9067800" y="2514600"/>
+            <a:ext cx="2438400" cy="441960"/>
+          </a:xfrm>
+          <a:prstGeom prst="roundRect">
+            <a:avLst>
+              <a:gd name="adj" fmla="val 8000"/>
+            </a:avLst>
+          </a:prstGeom>
+          <a:solidFill>
+            <a:srgbClr val="FFFFFF"/>
+          </a:solidFill>
+          <a:ln w="9525">
+            <a:solidFill>
+              <a:srgbClr val="2E7D32"/>
+            </a:solidFill>
+          </a:ln>
+          <a:effectLst/>
+        </p:spPr>
+        <p:style>
+          <a:lnRef idx="1">
+            <a:schemeClr val="accent1"/>
+          </a:lnRef>
+          <a:fillRef idx="3">
+            <a:schemeClr val="accent1"/>
+          </a:fillRef>
+          <a:effectRef idx="2">
+            <a:schemeClr val="accent1"/>
+          </a:effectRef>
+          <a:fontRef idx="minor">
+            <a:schemeClr val="lt1"/>
+          </a:fontRef>
+        </p:style>
+        <p:txBody>
+          <a:bodyPr rtlCol="0" anchor="ctr"/>
+          <a:lstStyle/>
+          <a:p>
+            <a:pPr algn="ctr"/>
+          </a:p>
+        </p:txBody>
+      </p:sp>
+      <p:sp>
+        <p:nvSpPr>
+          <p:cNvPr id="36" name="TextBox 35"/>
+          <p:cNvSpPr txBox="1"/>
+          <p:nvPr/>
+        </p:nvSpPr>
+        <p:spPr>
+          <a:xfrm>
+            <a:off x="9067800" y="2514600"/>
+            <a:ext cx="2438400" cy="441960"/>
+          </a:xfrm>
+          <a:prstGeom prst="rect">
+            <a:avLst/>
+          </a:prstGeom>
+          <a:noFill/>
+          <a:ln>
+            <a:noFill/>
+          </a:ln>
+        </p:spPr>
+        <p:txBody>
+          <a:bodyPr wrap="square" anchor="ctr" lIns="45000" rIns="45000" tIns="15000" bIns="15000">
+            <a:spAutoFit/>
+          </a:bodyPr>
+          <a:lstStyle/>
+          <a:p>
+            <a:pPr algn="ctr"/>
+            <a:r>
+              <a:rPr sz="830" b="1" i="0">
+                <a:solidFill>
+                  <a:srgbClr val="1C4A35"/>
+                </a:solidFill>
+                <a:latin typeface="Calibri"/>
+              </a:rPr>
+              <a:t>Service Level Mgmt</a:t>
+            </a:r>
+          </a:p>
+        </p:txBody>
+      </p:sp>
+      <p:sp>
+        <p:nvSpPr>
+          <p:cNvPr id="37" name="Rounded Rectangle 36"/>
+          <p:cNvSpPr/>
+          <p:nvPr/>
+        </p:nvSpPr>
+        <p:spPr>
+          <a:xfrm>
+            <a:off x="6515100" y="3025140"/>
+            <a:ext cx="2438400" cy="441960"/>
+          </a:xfrm>
+          <a:prstGeom prst="roundRect">
+            <a:avLst>
+              <a:gd name="adj" fmla="val 8000"/>
+            </a:avLst>
+          </a:prstGeom>
+          <a:solidFill>
+            <a:srgbClr val="FFFFFF"/>
+          </a:solidFill>
+          <a:ln w="9525">
+            <a:solidFill>
+              <a:srgbClr val="2E7D32"/>
+            </a:solidFill>
+          </a:ln>
+          <a:effectLst/>
+        </p:spPr>
+        <p:style>
+          <a:lnRef idx="1">
+            <a:schemeClr val="accent1"/>
+          </a:lnRef>
+          <a:fillRef idx="3">
+            <a:schemeClr val="accent1"/>
+          </a:fillRef>
+          <a:effectRef idx="2">
+            <a:schemeClr val="accent1"/>
+          </a:effectRef>
+          <a:fontRef idx="minor">
+            <a:schemeClr val="lt1"/>
+          </a:fontRef>
+        </p:style>
+        <p:txBody>
+          <a:bodyPr rtlCol="0" anchor="ctr"/>
+          <a:lstStyle/>
+          <a:p>
+            <a:pPr algn="ctr"/>
+          </a:p>
+        </p:txBody>
+      </p:sp>
+      <p:sp>
+        <p:nvSpPr>
+          <p:cNvPr id="38" name="TextBox 37"/>
+          <p:cNvSpPr txBox="1"/>
+          <p:nvPr/>
+        </p:nvSpPr>
+        <p:spPr>
+          <a:xfrm>
+            <a:off x="6515100" y="3025140"/>
+            <a:ext cx="2438400" cy="441960"/>
+          </a:xfrm>
+          <a:prstGeom prst="rect">
+            <a:avLst/>
+          </a:prstGeom>
+          <a:noFill/>
+          <a:ln>
+            <a:noFill/>
+          </a:ln>
+        </p:spPr>
+        <p:txBody>
+          <a:bodyPr wrap="square" anchor="ctr" lIns="45000" rIns="45000" tIns="15000" bIns="15000">
+            <a:spAutoFit/>
+          </a:bodyPr>
+          <a:lstStyle/>
+          <a:p>
+            <a:pPr algn="ctr"/>
+            <a:r>
+              <a:rPr sz="830" b="1" i="0">
+                <a:solidFill>
+                  <a:srgbClr val="1C4A35"/>
+                </a:solidFill>
+                <a:latin typeface="Calibri"/>
+              </a:rPr>
+              <a:t>Major Incident Mgmt</a:t>
+            </a:r>
+          </a:p>
+        </p:txBody>
+      </p:sp>
+      <p:sp>
+        <p:nvSpPr>
+          <p:cNvPr id="39" name="Rounded Rectangle 38"/>
+          <p:cNvSpPr/>
+          <p:nvPr/>
+        </p:nvSpPr>
+        <p:spPr>
+          <a:xfrm>
+            <a:off x="9067800" y="3025140"/>
+            <a:ext cx="2438400" cy="441960"/>
+          </a:xfrm>
+          <a:prstGeom prst="roundRect">
+            <a:avLst>
+              <a:gd name="adj" fmla="val 8000"/>
+            </a:avLst>
+          </a:prstGeom>
+          <a:solidFill>
+            <a:srgbClr val="FFFFFF"/>
+          </a:solidFill>
+          <a:ln w="9525">
+            <a:solidFill>
+              <a:srgbClr val="2E7D32"/>
+            </a:solidFill>
+          </a:ln>
+          <a:effectLst/>
+        </p:spPr>
+        <p:style>
+          <a:lnRef idx="1">
+            <a:schemeClr val="accent1"/>
+          </a:lnRef>
+          <a:fillRef idx="3">
+            <a:schemeClr val="accent1"/>
+          </a:fillRef>
+          <a:effectRef idx="2">
+            <a:schemeClr val="accent1"/>
+          </a:effectRef>
+          <a:fontRef idx="minor">
+            <a:schemeClr val="lt1"/>
+          </a:fontRef>
+        </p:style>
+        <p:txBody>
+          <a:bodyPr rtlCol="0" anchor="ctr"/>
+          <a:lstStyle/>
+          <a:p>
+            <a:pPr algn="ctr"/>
+          </a:p>
+        </p:txBody>
+      </p:sp>
+      <p:sp>
+        <p:nvSpPr>
+          <p:cNvPr id="40" name="TextBox 39"/>
+          <p:cNvSpPr txBox="1"/>
+          <p:nvPr/>
+        </p:nvSpPr>
+        <p:spPr>
+          <a:xfrm>
+            <a:off x="9067800" y="3025140"/>
+            <a:ext cx="2438400" cy="441960"/>
+          </a:xfrm>
+          <a:prstGeom prst="rect">
+            <a:avLst/>
+          </a:prstGeom>
+          <a:noFill/>
+          <a:ln>
+            <a:noFill/>
+          </a:ln>
+        </p:spPr>
+        <p:txBody>
+          <a:bodyPr wrap="square" anchor="ctr" lIns="45000" rIns="45000" tIns="15000" bIns="15000">
+            <a:spAutoFit/>
+          </a:bodyPr>
+          <a:lstStyle/>
+          <a:p>
+            <a:pPr algn="ctr"/>
+            <a:r>
+              <a:rPr sz="830" b="1" i="0">
+                <a:solidFill>
+                  <a:srgbClr val="1C4A35"/>
+                </a:solidFill>
+                <a:latin typeface="Calibri"/>
+              </a:rPr>
+              <a:t>Prozess-Owner (Inc/Prob/Change)</a:t>
+            </a:r>
+          </a:p>
+        </p:txBody>
+      </p:sp>
+      <p:cxnSp>
+        <p:nvCxnSpPr>
+          <p:cNvPr id="41" name="Connector 40"/>
+          <p:cNvCxnSpPr/>
+          <p:nvPr/>
+        </p:nvCxnSpPr>
+        <p:spPr>
+          <a:xfrm flipH="1">
+            <a:off x="3733800" y="3048000"/>
+            <a:ext cx="2667000" cy="15240"/>
+          </a:xfrm>
+          <a:prstGeom prst="line">
+            <a:avLst/>
+          </a:prstGeom>
+          <a:ln w="15875">
+            <a:solidFill>
+              <a:srgbClr val="2E7D32"/>
+            </a:solidFill>
+            <a:prstDash val="dash"/>
+          </a:ln>
+          <a:effectLst/>
+        </p:spPr>
+        <p:style>
+          <a:lnRef idx="2">
+            <a:schemeClr val="accent1"/>
+          </a:lnRef>
+          <a:fillRef idx="0">
+            <a:schemeClr val="accent1"/>
+          </a:fillRef>
+          <a:effectRef idx="1">
+            <a:schemeClr val="accent1"/>
+          </a:effectRef>
+          <a:fontRef idx="minor">
+            <a:schemeClr val="tx1"/>
+          </a:fontRef>
+        </p:style>
+      </p:cxnSp>
+      <p:sp>
+        <p:nvSpPr>
+          <p:cNvPr id="42" name="TextBox 41"/>
+          <p:cNvSpPr txBox="1"/>
+          <p:nvPr/>
+        </p:nvSpPr>
+        <p:spPr>
+          <a:xfrm>
+            <a:off x="3810000" y="3398520"/>
+            <a:ext cx="2590800" cy="266700"/>
+          </a:xfrm>
+          <a:prstGeom prst="rect">
+            <a:avLst/>
+          </a:prstGeom>
+          <a:noFill/>
+          <a:ln>
+            <a:noFill/>
+          </a:ln>
+        </p:spPr>
+        <p:txBody>
+          <a:bodyPr wrap="square" anchor="t" lIns="45000" rIns="45000" tIns="15000" bIns="15000">
+            <a:spAutoFit/>
+          </a:bodyPr>
+          <a:lstStyle/>
+          <a:p>
+            <a:pPr algn="l"/>
+            <a:r>
+              <a:rPr sz="750" b="0" i="1">
+                <a:solidFill>
+                  <a:srgbClr val="2E7D32"/>
+                </a:solidFill>
+                <a:latin typeface="Calibri"/>
+              </a:rPr>
+              <a:t>Standards · Verträge · Prozesse</a:t>
+            </a:r>
+          </a:p>
+        </p:txBody>
+      </p:sp>
+      <p:sp>
+        <p:nvSpPr>
+          <p:cNvPr id="43" name="TextBox 42"/>
+          <p:cNvSpPr txBox="1"/>
+          <p:nvPr/>
+        </p:nvSpPr>
+        <p:spPr>
+          <a:xfrm>
+            <a:off x="533400" y="4572000"/>
+            <a:ext cx="11125200" cy="266700"/>
+          </a:xfrm>
+          <a:prstGeom prst="rect">
+            <a:avLst/>
+          </a:prstGeom>
+          <a:noFill/>
+          <a:ln>
+            <a:noFill/>
+          </a:ln>
+        </p:spPr>
+        <p:txBody>
+          <a:bodyPr wrap="square" anchor="t" lIns="45000" rIns="45000" tIns="15000" bIns="15000">
+            <a:spAutoFit/>
+          </a:bodyPr>
+          <a:lstStyle/>
+          <a:p>
+            <a:pPr algn="l"/>
+            <a:r>
+              <a:rPr sz="1250" b="1" i="0">
+                <a:solidFill>
+                  <a:srgbClr val="1F2937"/>
+                </a:solidFill>
+                <a:latin typeface="Calibri"/>
+              </a:rPr>
+              <a:t>Zusätzlich benötigt — zwei neue Rollen, ein neuer Ort</a:t>
+            </a:r>
+          </a:p>
+        </p:txBody>
+      </p:sp>
+      <p:sp>
+        <p:nvSpPr>
+          <p:cNvPr id="44" name="Rounded Rectangle 43"/>
+          <p:cNvSpPr/>
+          <p:nvPr/>
+        </p:nvSpPr>
+        <p:spPr>
+          <a:xfrm>
+            <a:off x="533400" y="4914900"/>
+            <a:ext cx="3604260" cy="1295400"/>
+          </a:xfrm>
+          <a:prstGeom prst="roundRect">
+            <a:avLst>
+              <a:gd name="adj" fmla="val 8000"/>
+            </a:avLst>
+          </a:prstGeom>
+          <a:solidFill>
+            <a:srgbClr val="FFFFFF"/>
+          </a:solidFill>
+          <a:ln w="11430">
+            <a:solidFill>
+              <a:srgbClr val="D1D5DB"/>
+            </a:solidFill>
+          </a:ln>
+          <a:effectLst/>
+        </p:spPr>
+        <p:style>
+          <a:lnRef idx="1">
+            <a:schemeClr val="accent1"/>
+          </a:lnRef>
+          <a:fillRef idx="3">
+            <a:schemeClr val="accent1"/>
+          </a:fillRef>
+          <a:effectRef idx="2">
+            <a:schemeClr val="accent1"/>
+          </a:effectRef>
+          <a:fontRef idx="minor">
+            <a:schemeClr val="lt1"/>
+          </a:fontRef>
+        </p:style>
+        <p:txBody>
+          <a:bodyPr rtlCol="0" anchor="ctr"/>
+          <a:lstStyle/>
+          <a:p>
+            <a:pPr algn="ctr"/>
+          </a:p>
+        </p:txBody>
+      </p:sp>
+      <p:sp>
+        <p:nvSpPr>
+          <p:cNvPr id="45" name="Rectangle 44"/>
+          <p:cNvSpPr/>
+          <p:nvPr/>
+        </p:nvSpPr>
+        <p:spPr>
+          <a:xfrm>
+            <a:off x="533400" y="4914900"/>
+            <a:ext cx="3604260" cy="68580"/>
+          </a:xfrm>
+          <a:prstGeom prst="rect">
+            <a:avLst/>
+          </a:prstGeom>
+          <a:solidFill>
+            <a:srgbClr val="F07F12"/>
+          </a:solidFill>
+          <a:ln>
+            <a:noFill/>
+          </a:ln>
+          <a:effectLst/>
+        </p:spPr>
+        <p:style>
+          <a:lnRef idx="1">
+            <a:schemeClr val="accent1"/>
+          </a:lnRef>
+          <a:fillRef idx="3">
+            <a:schemeClr val="accent1"/>
+          </a:fillRef>
+          <a:effectRef idx="2">
+            <a:schemeClr val="accent1"/>
+          </a:effectRef>
+          <a:fontRef idx="minor">
+            <a:schemeClr val="lt1"/>
+          </a:fontRef>
+        </p:style>
+        <p:txBody>
+          <a:bodyPr rtlCol="0" anchor="ctr"/>
+          <a:lstStyle/>
+          <a:p>
+            <a:pPr algn="ctr"/>
+          </a:p>
+        </p:txBody>
+      </p:sp>
+      <p:sp>
+        <p:nvSpPr>
+          <p:cNvPr id="46" name="TextBox 45"/>
+          <p:cNvSpPr txBox="1"/>
+          <p:nvPr/>
+        </p:nvSpPr>
+        <p:spPr>
+          <a:xfrm>
+            <a:off x="655320" y="5029200"/>
+            <a:ext cx="3375660" cy="304800"/>
+          </a:xfrm>
+          <a:prstGeom prst="rect">
+            <a:avLst/>
+          </a:prstGeom>
+          <a:noFill/>
+          <a:ln>
+            <a:noFill/>
+          </a:ln>
+        </p:spPr>
+        <p:txBody>
+          <a:bodyPr wrap="square" anchor="t" lIns="45000" rIns="45000" tIns="15000" bIns="15000">
+            <a:spAutoFit/>
+          </a:bodyPr>
+          <a:lstStyle/>
+          <a:p>
+            <a:pPr algn="l">
+              <a:lnSpc>
+                <a:spcPct val="105000"/>
+              </a:lnSpc>
+            </a:pPr>
+            <a:r>
+              <a:rPr sz="1030" b="1" i="0">
+                <a:solidFill>
+                  <a:srgbClr val="1F2937"/>
+                </a:solidFill>
+                <a:latin typeface="Calibri"/>
+              </a:rPr>
+              <a:t>Service Delivery Manager (neu)</a:t>
+            </a:r>
+          </a:p>
+        </p:txBody>
+      </p:sp>
+      <p:sp>
+        <p:nvSpPr>
+          <p:cNvPr id="47" name="TextBox 46"/>
+          <p:cNvSpPr txBox="1"/>
+          <p:nvPr/>
+        </p:nvSpPr>
+        <p:spPr>
+          <a:xfrm>
+            <a:off x="655320" y="5448300"/>
+            <a:ext cx="3375660" cy="685800"/>
+          </a:xfrm>
+          <a:prstGeom prst="rect">
+            <a:avLst/>
+          </a:prstGeom>
+          <a:noFill/>
+          <a:ln>
+            <a:noFill/>
+          </a:ln>
+        </p:spPr>
+        <p:txBody>
+          <a:bodyPr wrap="square" anchor="t" lIns="45000" rIns="45000" tIns="15000" bIns="15000">
+            <a:spAutoFit/>
+          </a:bodyPr>
+          <a:lstStyle/>
+          <a:p>
+            <a:pPr algn="l">
+              <a:lnSpc>
+                <a:spcPct val="112000"/>
+              </a:lnSpc>
+            </a:pPr>
+            <a:r>
+              <a:rPr sz="900" b="0" i="0">
+                <a:solidFill>
+                  <a:srgbClr val="4B5563"/>
+                </a:solidFill>
+                <a:latin typeface="Calibri"/>
+              </a:rPr>
+              <a:t>Die „dedizierte Ressource“, die BSS fordert: koordiniert alle AMS-Provider + interne Support-Einheiten (TSS, Service Desk, RSC) je Service-Cluster.</a:t>
+            </a:r>
+          </a:p>
+        </p:txBody>
+      </p:sp>
+      <p:sp>
+        <p:nvSpPr>
+          <p:cNvPr id="48" name="Rounded Rectangle 47"/>
+          <p:cNvSpPr/>
+          <p:nvPr/>
+        </p:nvSpPr>
+        <p:spPr>
+          <a:xfrm>
+            <a:off x="4328160" y="4914900"/>
+            <a:ext cx="3604260" cy="1295400"/>
+          </a:xfrm>
+          <a:prstGeom prst="roundRect">
+            <a:avLst>
+              <a:gd name="adj" fmla="val 8000"/>
+            </a:avLst>
+          </a:prstGeom>
+          <a:solidFill>
+            <a:srgbClr val="FFFFFF"/>
+          </a:solidFill>
+          <a:ln w="11430">
+            <a:solidFill>
+              <a:srgbClr val="D1D5DB"/>
+            </a:solidFill>
+          </a:ln>
+          <a:effectLst/>
+        </p:spPr>
+        <p:style>
+          <a:lnRef idx="1">
+            <a:schemeClr val="accent1"/>
+          </a:lnRef>
+          <a:fillRef idx="3">
+            <a:schemeClr val="accent1"/>
+          </a:fillRef>
+          <a:effectRef idx="2">
+            <a:schemeClr val="accent1"/>
+          </a:effectRef>
+          <a:fontRef idx="minor">
+            <a:schemeClr val="lt1"/>
+          </a:fontRef>
+        </p:style>
+        <p:txBody>
+          <a:bodyPr rtlCol="0" anchor="ctr"/>
+          <a:lstStyle/>
+          <a:p>
+            <a:pPr algn="ctr"/>
+          </a:p>
+        </p:txBody>
+      </p:sp>
+      <p:sp>
+        <p:nvSpPr>
+          <p:cNvPr id="49" name="Rectangle 48"/>
+          <p:cNvSpPr/>
+          <p:nvPr/>
+        </p:nvSpPr>
+        <p:spPr>
+          <a:xfrm>
+            <a:off x="4328160" y="4914900"/>
+            <a:ext cx="3604260" cy="68580"/>
+          </a:xfrm>
+          <a:prstGeom prst="rect">
+            <a:avLst/>
+          </a:prstGeom>
+          <a:solidFill>
+            <a:srgbClr val="2E7D32"/>
+          </a:solidFill>
+          <a:ln>
+            <a:noFill/>
+          </a:ln>
+          <a:effectLst/>
+        </p:spPr>
+        <p:style>
+          <a:lnRef idx="1">
+            <a:schemeClr val="accent1"/>
+          </a:lnRef>
+          <a:fillRef idx="3">
+            <a:schemeClr val="accent1"/>
+          </a:fillRef>
+          <a:effectRef idx="2">
+            <a:schemeClr val="accent1"/>
+          </a:effectRef>
+          <a:fontRef idx="minor">
+            <a:schemeClr val="lt1"/>
+          </a:fontRef>
+        </p:style>
+        <p:txBody>
+          <a:bodyPr rtlCol="0" anchor="ctr"/>
+          <a:lstStyle/>
+          <a:p>
+            <a:pPr algn="ctr"/>
+          </a:p>
+        </p:txBody>
+      </p:sp>
+      <p:sp>
+        <p:nvSpPr>
+          <p:cNvPr id="50" name="TextBox 49"/>
+          <p:cNvSpPr txBox="1"/>
+          <p:nvPr/>
+        </p:nvSpPr>
+        <p:spPr>
+          <a:xfrm>
+            <a:off x="4450080" y="5029200"/>
+            <a:ext cx="3375660" cy="304800"/>
+          </a:xfrm>
+          <a:prstGeom prst="rect">
+            <a:avLst/>
+          </a:prstGeom>
+          <a:noFill/>
+          <a:ln>
+            <a:noFill/>
+          </a:ln>
+        </p:spPr>
+        <p:txBody>
+          <a:bodyPr wrap="square" anchor="t" lIns="45000" rIns="45000" tIns="15000" bIns="15000">
+            <a:spAutoFit/>
+          </a:bodyPr>
+          <a:lstStyle/>
+          <a:p>
+            <a:pPr algn="l">
+              <a:lnSpc>
+                <a:spcPct val="105000"/>
+              </a:lnSpc>
+            </a:pPr>
+            <a:r>
+              <a:rPr sz="1030" b="1" i="0">
+                <a:solidFill>
+                  <a:srgbClr val="1F2937"/>
+                </a:solidFill>
+                <a:latin typeface="Calibri"/>
+              </a:rPr>
+              <a:t>SIAM / Service Integration Lead (neu)</a:t>
+            </a:r>
+          </a:p>
+        </p:txBody>
+      </p:sp>
+      <p:sp>
+        <p:nvSpPr>
+          <p:cNvPr id="51" name="TextBox 50"/>
+          <p:cNvSpPr txBox="1"/>
+          <p:nvPr/>
+        </p:nvSpPr>
+        <p:spPr>
+          <a:xfrm>
+            <a:off x="4450080" y="5448300"/>
+            <a:ext cx="3375660" cy="685800"/>
+          </a:xfrm>
+          <a:prstGeom prst="rect">
+            <a:avLst/>
+          </a:prstGeom>
+          <a:noFill/>
+          <a:ln>
+            <a:noFill/>
+          </a:ln>
+        </p:spPr>
+        <p:txBody>
+          <a:bodyPr wrap="square" anchor="t" lIns="45000" rIns="45000" tIns="15000" bIns="15000">
+            <a:spAutoFit/>
+          </a:bodyPr>
+          <a:lstStyle/>
+          <a:p>
+            <a:pPr algn="l">
+              <a:lnSpc>
+                <a:spcPct val="112000"/>
+              </a:lnSpc>
+            </a:pPr>
+            <a:r>
+              <a:rPr sz="900" b="0" i="0">
+                <a:solidFill>
+                  <a:srgbClr val="4B5563"/>
+                </a:solidFill>
+                <a:latin typeface="Calibri"/>
+              </a:rPr>
+              <a:t>Führt die Klammer: End-to-End-Prozesse, Provider-Integration, konsolidierte Service- &amp; Kostensicht.</a:t>
+            </a:r>
+          </a:p>
+        </p:txBody>
+      </p:sp>
+      <p:sp>
+        <p:nvSpPr>
+          <p:cNvPr id="52" name="Rounded Rectangle 51"/>
+          <p:cNvSpPr/>
+          <p:nvPr/>
+        </p:nvSpPr>
+        <p:spPr>
+          <a:xfrm>
+            <a:off x="8122920" y="4914900"/>
+            <a:ext cx="3604260" cy="1295400"/>
+          </a:xfrm>
+          <a:prstGeom prst="roundRect">
+            <a:avLst>
+              <a:gd name="adj" fmla="val 8000"/>
+            </a:avLst>
+          </a:prstGeom>
+          <a:solidFill>
+            <a:srgbClr val="FFFFFF"/>
+          </a:solidFill>
+          <a:ln w="11430">
+            <a:solidFill>
+              <a:srgbClr val="D1D5DB"/>
+            </a:solidFill>
+          </a:ln>
+          <a:effectLst/>
+        </p:spPr>
+        <p:style>
+          <a:lnRef idx="1">
+            <a:schemeClr val="accent1"/>
+          </a:lnRef>
+          <a:fillRef idx="3">
+            <a:schemeClr val="accent1"/>
+          </a:fillRef>
+          <a:effectRef idx="2">
+            <a:schemeClr val="accent1"/>
+          </a:effectRef>
+          <a:fontRef idx="minor">
+            <a:schemeClr val="lt1"/>
+          </a:fontRef>
+        </p:style>
+        <p:txBody>
+          <a:bodyPr rtlCol="0" anchor="ctr"/>
+          <a:lstStyle/>
+          <a:p>
+            <a:pPr algn="ctr"/>
+          </a:p>
+        </p:txBody>
+      </p:sp>
+      <p:sp>
+        <p:nvSpPr>
+          <p:cNvPr id="53" name="Rectangle 52"/>
+          <p:cNvSpPr/>
+          <p:nvPr/>
+        </p:nvSpPr>
+        <p:spPr>
+          <a:xfrm>
+            <a:off x="8122920" y="4914900"/>
+            <a:ext cx="3604260" cy="68580"/>
+          </a:xfrm>
+          <a:prstGeom prst="rect">
+            <a:avLst/>
+          </a:prstGeom>
+          <a:solidFill>
+            <a:srgbClr val="2E5A8F"/>
+          </a:solidFill>
+          <a:ln>
+            <a:noFill/>
+          </a:ln>
+          <a:effectLst/>
+        </p:spPr>
+        <p:style>
+          <a:lnRef idx="1">
+            <a:schemeClr val="accent1"/>
+          </a:lnRef>
+          <a:fillRef idx="3">
+            <a:schemeClr val="accent1"/>
+          </a:fillRef>
+          <a:effectRef idx="2">
+            <a:schemeClr val="accent1"/>
+          </a:effectRef>
+          <a:fontRef idx="minor">
+            <a:schemeClr val="lt1"/>
+          </a:fontRef>
+        </p:style>
+        <p:txBody>
+          <a:bodyPr rtlCol="0" anchor="ctr"/>
+          <a:lstStyle/>
+          <a:p>
+            <a:pPr algn="ctr"/>
+          </a:p>
+        </p:txBody>
+      </p:sp>
+      <p:sp>
+        <p:nvSpPr>
+          <p:cNvPr id="54" name="TextBox 53"/>
+          <p:cNvSpPr txBox="1"/>
+          <p:nvPr/>
+        </p:nvSpPr>
+        <p:spPr>
+          <a:xfrm>
+            <a:off x="8244839" y="5029200"/>
+            <a:ext cx="3375660" cy="304800"/>
+          </a:xfrm>
+          <a:prstGeom prst="rect">
+            <a:avLst/>
+          </a:prstGeom>
+          <a:noFill/>
+          <a:ln>
+            <a:noFill/>
+          </a:ln>
+        </p:spPr>
+        <p:txBody>
+          <a:bodyPr wrap="square" anchor="t" lIns="45000" rIns="45000" tIns="15000" bIns="15000">
+            <a:spAutoFit/>
+          </a:bodyPr>
+          <a:lstStyle/>
+          <a:p>
+            <a:pPr algn="l">
+              <a:lnSpc>
+                <a:spcPct val="105000"/>
+              </a:lnSpc>
+            </a:pPr>
+            <a:r>
+              <a:rPr sz="1030" b="1" i="0">
+                <a:solidFill>
+                  <a:srgbClr val="1F2937"/>
+                </a:solidFill>
+                <a:latin typeface="Calibri"/>
+              </a:rPr>
+              <a:t>Verortung: IPS Management Office</a:t>
+            </a:r>
+          </a:p>
+        </p:txBody>
+      </p:sp>
+      <p:sp>
+        <p:nvSpPr>
+          <p:cNvPr id="55" name="TextBox 54"/>
+          <p:cNvSpPr txBox="1"/>
+          <p:nvPr/>
+        </p:nvSpPr>
+        <p:spPr>
+          <a:xfrm>
+            <a:off x="8244839" y="5448300"/>
+            <a:ext cx="3375660" cy="685800"/>
+          </a:xfrm>
+          <a:prstGeom prst="rect">
+            <a:avLst/>
+          </a:prstGeom>
+          <a:noFill/>
+          <a:ln>
+            <a:noFill/>
+          </a:ln>
+        </p:spPr>
+        <p:txBody>
+          <a:bodyPr wrap="square" anchor="t" lIns="45000" rIns="45000" tIns="15000" bIns="15000">
+            <a:spAutoFit/>
+          </a:bodyPr>
+          <a:lstStyle/>
+          <a:p>
+            <a:pPr algn="l">
+              <a:lnSpc>
+                <a:spcPct val="112000"/>
+              </a:lnSpc>
+            </a:pPr>
+            <a:r>
+              <a:rPr sz="900" b="0" i="0">
+                <a:solidFill>
+                  <a:srgbClr val="4B5563"/>
+                </a:solidFill>
+                <a:latin typeface="Calibri"/>
+              </a:rPr>
+              <a:t>Neutral über BSS/TSS/Cyber; Andockpunkte (Governance, ITSM, Practice Supplier Mgmt, ServiceNow) sind dort schon vorhanden.</a:t>
+            </a:r>
+          </a:p>
+        </p:txBody>
+      </p:sp>
+      <p:sp>
+        <p:nvSpPr>
+          <p:cNvPr id="56" name="TextBox 55"/>
+          <p:cNvSpPr txBox="1"/>
+          <p:nvPr/>
+        </p:nvSpPr>
+        <p:spPr>
+          <a:xfrm>
+            <a:off x="533400" y="6362700"/>
+            <a:ext cx="11125200" cy="304800"/>
+          </a:xfrm>
+          <a:prstGeom prst="rect">
+            <a:avLst/>
+          </a:prstGeom>
+          <a:noFill/>
+          <a:ln>
+            <a:noFill/>
+          </a:ln>
+        </p:spPr>
+        <p:txBody>
+          <a:bodyPr wrap="square" anchor="t" lIns="45000" rIns="45000" tIns="15000" bIns="15000">
+            <a:spAutoFit/>
+          </a:bodyPr>
+          <a:lstStyle/>
+          <a:p>
+            <a:pPr algn="l"/>
+            <a:r>
+              <a:rPr sz="1000" b="1" i="0">
+                <a:solidFill>
+                  <a:srgbClr val="2E7D32"/>
+                </a:solidFill>
+                <a:latin typeface="Calibri"/>
+              </a:rPr>
+              <a:t>Fazit:  </a:t>
+            </a:r>
+            <a:r>
+              <a:rPr sz="1000" b="0" i="0">
+                <a:solidFill>
+                  <a:srgbClr val="4B5563"/>
+                </a:solidFill>
+                <a:latin typeface="Calibri"/>
+              </a:rPr>
+              <a:t>Keine neue Säule — eine Klammer. SIAM im IPS MO mit dem SDM als operativem Koordinator entlastet die Service Owner, bündelt die Provider-Steuerung und schließt die Schnittstellen.</a:t>
             </a:r>
           </a:p>
         </p:txBody>

</xml_diff>

<commit_message>
Add SDM-Rollenbeschreibung und Migrationsvorgehen
- Rollenbeschreibung Service Delivery Manager (eigenes HR-taugliches
  Dokument): Mission, Aufgaben, Abgrenzung, Mandat, KPIs, Profil, RACI
- Migrationsvorgehen in 5 Phasen (Setup -> Foundation -> Pilot -> Rollout
  -> Stabilisierung) inkl. Risiken/Gegenmassnahmen und Quick Wins

Deck erweitert auf 13 Slides (12: SDM-Rollenprofil, 13: Migrations-Roadmap),
Markdown um Abschnitt 11.

Co-Authored-By: Claude Opus 4.8 <noreply@anthropic.com>
Claude-Session: https://claude.ai/code/session_01HefpCknsZ9fVeMqj75mAqW
</commit_message>
<xml_diff>
--- a/2026_07_08_IT_Ablauforganisation_Homebase_Mannschaft.pptx
+++ b/2026_07_08_IT_Ablauforganisation_Homebase_Mannschaft.pptx
@@ -16,6 +16,8 @@
     <p:sldId id="264" r:id="rId15"/>
     <p:sldId id="265" r:id="rId16"/>
     <p:sldId id="266" r:id="rId17"/>
+    <p:sldId id="267" r:id="rId18"/>
+    <p:sldId id="268" r:id="rId19"/>
   </p:sldIdLst>
   <p:sldSz cx="12192000" cy="6858000" type="screen4x3"/>
   <p:notesSz cx="6858000" cy="9144000"/>
@@ -8581,6 +8583,3716 @@
                 <a:latin typeface="Calibri"/>
               </a:rPr>
               <a:t>Keine neue Säule — eine Klammer. SIAM im IPS MO mit dem SDM als operativem Koordinator entlastet die Service Owner, bündelt die Provider-Steuerung und schließt die Schnittstellen.</a:t>
+            </a:r>
+          </a:p>
+        </p:txBody>
+      </p:sp>
+    </p:spTree>
+  </p:cSld>
+  <p:clrMapOvr>
+    <a:masterClrMapping/>
+  </p:clrMapOvr>
+</p:sld>
+</file>
+
+<file path=ppt/slides/slide12.xml><?xml version="1.0" encoding="utf-8"?>
+<p:sld xmlns:a="http://schemas.openxmlformats.org/drawingml/2006/main" xmlns:p="http://schemas.openxmlformats.org/presentationml/2006/main" xmlns:r="http://schemas.openxmlformats.org/officeDocument/2006/relationships">
+  <p:cSld>
+    <p:spTree>
+      <p:nvGrpSpPr>
+        <p:cNvPr id="1" name=""/>
+        <p:cNvGrpSpPr/>
+        <p:nvPr/>
+      </p:nvGrpSpPr>
+      <p:grpSpPr/>
+      <p:sp>
+        <p:nvSpPr>
+          <p:cNvPr id="2" name="Rectangle 1"/>
+          <p:cNvSpPr/>
+          <p:nvPr/>
+        </p:nvSpPr>
+        <p:spPr>
+          <a:xfrm>
+            <a:off x="0" y="0"/>
+            <a:ext cx="12192000" cy="6858000"/>
+          </a:xfrm>
+          <a:prstGeom prst="rect">
+            <a:avLst/>
+          </a:prstGeom>
+          <a:solidFill>
+            <a:srgbClr val="FFFFFF"/>
+          </a:solidFill>
+          <a:ln>
+            <a:noFill/>
+          </a:ln>
+          <a:effectLst/>
+        </p:spPr>
+        <p:style>
+          <a:lnRef idx="1">
+            <a:schemeClr val="accent1"/>
+          </a:lnRef>
+          <a:fillRef idx="3">
+            <a:schemeClr val="accent1"/>
+          </a:fillRef>
+          <a:effectRef idx="2">
+            <a:schemeClr val="accent1"/>
+          </a:effectRef>
+          <a:fontRef idx="minor">
+            <a:schemeClr val="lt1"/>
+          </a:fontRef>
+        </p:style>
+        <p:txBody>
+          <a:bodyPr rtlCol="0" anchor="ctr"/>
+          <a:lstStyle/>
+          <a:p>
+            <a:pPr algn="ctr"/>
+          </a:p>
+        </p:txBody>
+      </p:sp>
+      <p:sp>
+        <p:nvSpPr>
+          <p:cNvPr id="3" name="Rectangle 2"/>
+          <p:cNvSpPr/>
+          <p:nvPr/>
+        </p:nvSpPr>
+        <p:spPr>
+          <a:xfrm>
+            <a:off x="0" y="0"/>
+            <a:ext cx="121920" cy="6858000"/>
+          </a:xfrm>
+          <a:prstGeom prst="rect">
+            <a:avLst/>
+          </a:prstGeom>
+          <a:solidFill>
+            <a:srgbClr val="F07F12"/>
+          </a:solidFill>
+          <a:ln>
+            <a:noFill/>
+          </a:ln>
+          <a:effectLst/>
+        </p:spPr>
+        <p:style>
+          <a:lnRef idx="1">
+            <a:schemeClr val="accent1"/>
+          </a:lnRef>
+          <a:fillRef idx="3">
+            <a:schemeClr val="accent1"/>
+          </a:fillRef>
+          <a:effectRef idx="2">
+            <a:schemeClr val="accent1"/>
+          </a:effectRef>
+          <a:fontRef idx="minor">
+            <a:schemeClr val="lt1"/>
+          </a:fontRef>
+        </p:style>
+        <p:txBody>
+          <a:bodyPr rtlCol="0" anchor="ctr"/>
+          <a:lstStyle/>
+          <a:p>
+            <a:pPr algn="ctr"/>
+          </a:p>
+        </p:txBody>
+      </p:sp>
+      <p:sp>
+        <p:nvSpPr>
+          <p:cNvPr id="4" name="TextBox 3"/>
+          <p:cNvSpPr txBox="1"/>
+          <p:nvPr/>
+        </p:nvSpPr>
+        <p:spPr>
+          <a:xfrm>
+            <a:off x="533400" y="381000"/>
+            <a:ext cx="9906000" cy="304800"/>
+          </a:xfrm>
+          <a:prstGeom prst="rect">
+            <a:avLst/>
+          </a:prstGeom>
+          <a:noFill/>
+          <a:ln>
+            <a:noFill/>
+          </a:ln>
+        </p:spPr>
+        <p:txBody>
+          <a:bodyPr wrap="square" anchor="t" lIns="45000" rIns="45000" tIns="15000" bIns="15000">
+            <a:spAutoFit/>
+          </a:bodyPr>
+          <a:lstStyle/>
+          <a:p>
+            <a:pPr algn="l"/>
+            <a:r>
+              <a:rPr sz="1100" b="1" i="0">
+                <a:solidFill>
+                  <a:srgbClr val="F07F12"/>
+                </a:solidFill>
+                <a:latin typeface="Calibri"/>
+              </a:rPr>
+              <a:t>NEUE ROLLE</a:t>
+            </a:r>
+          </a:p>
+        </p:txBody>
+      </p:sp>
+      <p:sp>
+        <p:nvSpPr>
+          <p:cNvPr id="5" name="TextBox 4"/>
+          <p:cNvSpPr txBox="1"/>
+          <p:nvPr/>
+        </p:nvSpPr>
+        <p:spPr>
+          <a:xfrm>
+            <a:off x="533400" y="647700"/>
+            <a:ext cx="11125200" cy="685800"/>
+          </a:xfrm>
+          <a:prstGeom prst="rect">
+            <a:avLst/>
+          </a:prstGeom>
+          <a:noFill/>
+          <a:ln>
+            <a:noFill/>
+          </a:ln>
+        </p:spPr>
+        <p:txBody>
+          <a:bodyPr wrap="square" anchor="t" lIns="45000" rIns="45000" tIns="15000" bIns="15000">
+            <a:spAutoFit/>
+          </a:bodyPr>
+          <a:lstStyle/>
+          <a:p>
+            <a:pPr algn="l"/>
+            <a:r>
+              <a:rPr sz="2400" b="1" i="0">
+                <a:solidFill>
+                  <a:srgbClr val="1F2937"/>
+                </a:solidFill>
+                <a:latin typeface="Calibri"/>
+              </a:rPr>
+              <a:t>Service Delivery Manager (SDM) – Rollenprofil</a:t>
+            </a:r>
+          </a:p>
+        </p:txBody>
+      </p:sp>
+      <p:sp>
+        <p:nvSpPr>
+          <p:cNvPr id="6" name="Rectangle 5"/>
+          <p:cNvSpPr/>
+          <p:nvPr/>
+        </p:nvSpPr>
+        <p:spPr>
+          <a:xfrm>
+            <a:off x="533400" y="1333500"/>
+            <a:ext cx="11125200" cy="9144"/>
+          </a:xfrm>
+          <a:prstGeom prst="rect">
+            <a:avLst/>
+          </a:prstGeom>
+          <a:solidFill>
+            <a:srgbClr val="D1D5DB"/>
+          </a:solidFill>
+          <a:ln>
+            <a:noFill/>
+          </a:ln>
+          <a:effectLst/>
+        </p:spPr>
+        <p:style>
+          <a:lnRef idx="1">
+            <a:schemeClr val="accent1"/>
+          </a:lnRef>
+          <a:fillRef idx="3">
+            <a:schemeClr val="accent1"/>
+          </a:fillRef>
+          <a:effectRef idx="2">
+            <a:schemeClr val="accent1"/>
+          </a:effectRef>
+          <a:fontRef idx="minor">
+            <a:schemeClr val="lt1"/>
+          </a:fontRef>
+        </p:style>
+        <p:txBody>
+          <a:bodyPr rtlCol="0" anchor="ctr"/>
+          <a:lstStyle/>
+          <a:p>
+            <a:pPr algn="ctr"/>
+          </a:p>
+        </p:txBody>
+      </p:sp>
+      <p:sp>
+        <p:nvSpPr>
+          <p:cNvPr id="7" name="TextBox 6"/>
+          <p:cNvSpPr txBox="1"/>
+          <p:nvPr/>
+        </p:nvSpPr>
+        <p:spPr>
+          <a:xfrm>
+            <a:off x="11430000" y="6438900"/>
+            <a:ext cx="609600" cy="304800"/>
+          </a:xfrm>
+          <a:prstGeom prst="rect">
+            <a:avLst/>
+          </a:prstGeom>
+          <a:noFill/>
+          <a:ln>
+            <a:noFill/>
+          </a:ln>
+        </p:spPr>
+        <p:txBody>
+          <a:bodyPr wrap="square" anchor="t" lIns="45000" rIns="45000" tIns="15000" bIns="15000">
+            <a:spAutoFit/>
+          </a:bodyPr>
+          <a:lstStyle/>
+          <a:p>
+            <a:pPr algn="r"/>
+            <a:r>
+              <a:rPr sz="1000" b="0" i="0">
+                <a:solidFill>
+                  <a:srgbClr val="D1D5DB"/>
+                </a:solidFill>
+                <a:latin typeface="Calibri"/>
+              </a:rPr>
+              <a:t>12</a:t>
+            </a:r>
+          </a:p>
+        </p:txBody>
+      </p:sp>
+      <p:sp>
+        <p:nvSpPr>
+          <p:cNvPr id="8" name="TextBox 7"/>
+          <p:cNvSpPr txBox="1"/>
+          <p:nvPr/>
+        </p:nvSpPr>
+        <p:spPr>
+          <a:xfrm>
+            <a:off x="533400" y="6438900"/>
+            <a:ext cx="6858000" cy="304800"/>
+          </a:xfrm>
+          <a:prstGeom prst="rect">
+            <a:avLst/>
+          </a:prstGeom>
+          <a:noFill/>
+          <a:ln>
+            <a:noFill/>
+          </a:ln>
+        </p:spPr>
+        <p:txBody>
+          <a:bodyPr wrap="square" anchor="t" lIns="45000" rIns="45000" tIns="15000" bIns="15000">
+            <a:spAutoFit/>
+          </a:bodyPr>
+          <a:lstStyle/>
+          <a:p>
+            <a:pPr algn="l"/>
+            <a:r>
+              <a:rPr sz="900" b="0" i="0">
+                <a:solidFill>
+                  <a:srgbClr val="D1D5DB"/>
+                </a:solidFill>
+                <a:latin typeface="Calibri"/>
+              </a:rPr>
+              <a:t>IT-Ablauforganisation · Zielbild</a:t>
+            </a:r>
+          </a:p>
+        </p:txBody>
+      </p:sp>
+      <p:sp>
+        <p:nvSpPr>
+          <p:cNvPr id="9" name="Rounded Rectangle 8"/>
+          <p:cNvSpPr/>
+          <p:nvPr/>
+        </p:nvSpPr>
+        <p:spPr>
+          <a:xfrm>
+            <a:off x="533400" y="1485900"/>
+            <a:ext cx="11125200" cy="647700"/>
+          </a:xfrm>
+          <a:prstGeom prst="roundRect">
+            <a:avLst>
+              <a:gd name="adj" fmla="val 8000"/>
+            </a:avLst>
+          </a:prstGeom>
+          <a:solidFill>
+            <a:srgbClr val="FDE6CC"/>
+          </a:solidFill>
+          <a:ln>
+            <a:noFill/>
+          </a:ln>
+          <a:effectLst/>
+        </p:spPr>
+        <p:style>
+          <a:lnRef idx="1">
+            <a:schemeClr val="accent1"/>
+          </a:lnRef>
+          <a:fillRef idx="3">
+            <a:schemeClr val="accent1"/>
+          </a:fillRef>
+          <a:effectRef idx="2">
+            <a:schemeClr val="accent1"/>
+          </a:effectRef>
+          <a:fontRef idx="minor">
+            <a:schemeClr val="lt1"/>
+          </a:fontRef>
+        </p:style>
+        <p:txBody>
+          <a:bodyPr rtlCol="0" anchor="ctr"/>
+          <a:lstStyle/>
+          <a:p>
+            <a:pPr algn="ctr"/>
+          </a:p>
+        </p:txBody>
+      </p:sp>
+      <p:sp>
+        <p:nvSpPr>
+          <p:cNvPr id="10" name="Rectangle 9"/>
+          <p:cNvSpPr/>
+          <p:nvPr/>
+        </p:nvSpPr>
+        <p:spPr>
+          <a:xfrm>
+            <a:off x="533400" y="1485900"/>
+            <a:ext cx="76200" cy="647700"/>
+          </a:xfrm>
+          <a:prstGeom prst="rect">
+            <a:avLst/>
+          </a:prstGeom>
+          <a:solidFill>
+            <a:srgbClr val="F07F12"/>
+          </a:solidFill>
+          <a:ln>
+            <a:noFill/>
+          </a:ln>
+          <a:effectLst/>
+        </p:spPr>
+        <p:style>
+          <a:lnRef idx="1">
+            <a:schemeClr val="accent1"/>
+          </a:lnRef>
+          <a:fillRef idx="3">
+            <a:schemeClr val="accent1"/>
+          </a:fillRef>
+          <a:effectRef idx="2">
+            <a:schemeClr val="accent1"/>
+          </a:effectRef>
+          <a:fontRef idx="minor">
+            <a:schemeClr val="lt1"/>
+          </a:fontRef>
+        </p:style>
+        <p:txBody>
+          <a:bodyPr rtlCol="0" anchor="ctr"/>
+          <a:lstStyle/>
+          <a:p>
+            <a:pPr algn="ctr"/>
+          </a:p>
+        </p:txBody>
+      </p:sp>
+      <p:sp>
+        <p:nvSpPr>
+          <p:cNvPr id="11" name="TextBox 10"/>
+          <p:cNvSpPr txBox="1"/>
+          <p:nvPr/>
+        </p:nvSpPr>
+        <p:spPr>
+          <a:xfrm>
+            <a:off x="723900" y="1524000"/>
+            <a:ext cx="10820400" cy="571500"/>
+          </a:xfrm>
+          <a:prstGeom prst="rect">
+            <a:avLst/>
+          </a:prstGeom>
+          <a:noFill/>
+          <a:ln>
+            <a:noFill/>
+          </a:ln>
+        </p:spPr>
+        <p:txBody>
+          <a:bodyPr wrap="square" anchor="ctr" lIns="45000" rIns="45000" tIns="15000" bIns="15000">
+            <a:spAutoFit/>
+          </a:bodyPr>
+          <a:lstStyle/>
+          <a:p>
+            <a:pPr algn="l">
+              <a:lnSpc>
+                <a:spcPct val="115000"/>
+              </a:lnSpc>
+            </a:pPr>
+            <a:r>
+              <a:rPr sz="1100" b="1" i="0">
+                <a:solidFill>
+                  <a:srgbClr val="B4531A"/>
+                </a:solidFill>
+                <a:latin typeface="Calibri"/>
+              </a:rPr>
+              <a:t>Mission:  </a:t>
+            </a:r>
+            <a:r>
+              <a:rPr sz="1100" b="0" i="0">
+                <a:solidFill>
+                  <a:srgbClr val="1F2937"/>
+                </a:solidFill>
+                <a:latin typeface="Calibri"/>
+              </a:rPr>
+              <a:t>Sichert den durchgängigen, wirtschaftlichen Betrieb eines Service-Clusters, indem er/sie alle internen Support-Einheiten und externen Dienstleister end-to-end koordiniert – und entlastet den Service Owner vom operativen „Wie“.</a:t>
+            </a:r>
+          </a:p>
+        </p:txBody>
+      </p:sp>
+      <p:sp>
+        <p:nvSpPr>
+          <p:cNvPr id="12" name="Rounded Rectangle 11"/>
+          <p:cNvSpPr/>
+          <p:nvPr/>
+        </p:nvSpPr>
+        <p:spPr>
+          <a:xfrm>
+            <a:off x="533400" y="2286000"/>
+            <a:ext cx="5448300" cy="1943100"/>
+          </a:xfrm>
+          <a:prstGeom prst="roundRect">
+            <a:avLst>
+              <a:gd name="adj" fmla="val 8000"/>
+            </a:avLst>
+          </a:prstGeom>
+          <a:solidFill>
+            <a:srgbClr val="FFFFFF"/>
+          </a:solidFill>
+          <a:ln w="11430">
+            <a:solidFill>
+              <a:srgbClr val="D1D5DB"/>
+            </a:solidFill>
+          </a:ln>
+          <a:effectLst/>
+        </p:spPr>
+        <p:style>
+          <a:lnRef idx="1">
+            <a:schemeClr val="accent1"/>
+          </a:lnRef>
+          <a:fillRef idx="3">
+            <a:schemeClr val="accent1"/>
+          </a:fillRef>
+          <a:effectRef idx="2">
+            <a:schemeClr val="accent1"/>
+          </a:effectRef>
+          <a:fontRef idx="minor">
+            <a:schemeClr val="lt1"/>
+          </a:fontRef>
+        </p:style>
+        <p:txBody>
+          <a:bodyPr rtlCol="0" anchor="ctr"/>
+          <a:lstStyle/>
+          <a:p>
+            <a:pPr algn="ctr"/>
+          </a:p>
+        </p:txBody>
+      </p:sp>
+      <p:sp>
+        <p:nvSpPr>
+          <p:cNvPr id="13" name="Rectangle 12"/>
+          <p:cNvSpPr/>
+          <p:nvPr/>
+        </p:nvSpPr>
+        <p:spPr>
+          <a:xfrm>
+            <a:off x="533400" y="2286000"/>
+            <a:ext cx="5448300" cy="68580"/>
+          </a:xfrm>
+          <a:prstGeom prst="rect">
+            <a:avLst/>
+          </a:prstGeom>
+          <a:solidFill>
+            <a:srgbClr val="F07F12"/>
+          </a:solidFill>
+          <a:ln>
+            <a:noFill/>
+          </a:ln>
+          <a:effectLst/>
+        </p:spPr>
+        <p:style>
+          <a:lnRef idx="1">
+            <a:schemeClr val="accent1"/>
+          </a:lnRef>
+          <a:fillRef idx="3">
+            <a:schemeClr val="accent1"/>
+          </a:fillRef>
+          <a:effectRef idx="2">
+            <a:schemeClr val="accent1"/>
+          </a:effectRef>
+          <a:fontRef idx="minor">
+            <a:schemeClr val="lt1"/>
+          </a:fontRef>
+        </p:style>
+        <p:txBody>
+          <a:bodyPr rtlCol="0" anchor="ctr"/>
+          <a:lstStyle/>
+          <a:p>
+            <a:pPr algn="ctr"/>
+          </a:p>
+        </p:txBody>
+      </p:sp>
+      <p:sp>
+        <p:nvSpPr>
+          <p:cNvPr id="14" name="TextBox 13"/>
+          <p:cNvSpPr txBox="1"/>
+          <p:nvPr/>
+        </p:nvSpPr>
+        <p:spPr>
+          <a:xfrm>
+            <a:off x="670560" y="2392680"/>
+            <a:ext cx="5181600" cy="266700"/>
+          </a:xfrm>
+          <a:prstGeom prst="rect">
+            <a:avLst/>
+          </a:prstGeom>
+          <a:noFill/>
+          <a:ln>
+            <a:noFill/>
+          </a:ln>
+        </p:spPr>
+        <p:txBody>
+          <a:bodyPr wrap="square" anchor="t" lIns="45000" rIns="45000" tIns="15000" bIns="15000">
+            <a:spAutoFit/>
+          </a:bodyPr>
+          <a:lstStyle/>
+          <a:p>
+            <a:pPr algn="l"/>
+            <a:r>
+              <a:rPr sz="1150" b="1" i="0">
+                <a:solidFill>
+                  <a:srgbClr val="1F2937"/>
+                </a:solidFill>
+                <a:latin typeface="Calibri"/>
+              </a:rPr>
+              <a:t>Kernaufgaben</a:t>
+            </a:r>
+          </a:p>
+        </p:txBody>
+      </p:sp>
+      <p:sp>
+        <p:nvSpPr>
+          <p:cNvPr id="15" name="TextBox 14"/>
+          <p:cNvSpPr txBox="1"/>
+          <p:nvPr/>
+        </p:nvSpPr>
+        <p:spPr>
+          <a:xfrm>
+            <a:off x="670560" y="2712720"/>
+            <a:ext cx="5181600" cy="1447800"/>
+          </a:xfrm>
+          <a:prstGeom prst="rect">
+            <a:avLst/>
+          </a:prstGeom>
+          <a:noFill/>
+          <a:ln>
+            <a:noFill/>
+          </a:ln>
+        </p:spPr>
+        <p:txBody>
+          <a:bodyPr wrap="square" anchor="t" lIns="45000" rIns="45000" tIns="15000" bIns="15000">
+            <a:spAutoFit/>
+          </a:bodyPr>
+          <a:lstStyle/>
+          <a:p>
+            <a:pPr algn="l">
+              <a:lnSpc>
+                <a:spcPct val="105000"/>
+              </a:lnSpc>
+              <a:spcAft>
+                <a:spcPts val="300"/>
+              </a:spcAft>
+            </a:pPr>
+            <a:r>
+              <a:rPr sz="919" b="0" i="0">
+                <a:solidFill>
+                  <a:srgbClr val="4B5563"/>
+                </a:solidFill>
+                <a:latin typeface="Calibri"/>
+              </a:rPr>
+              <a:t>•  E2E-Koordination aller Support-Ebenen (L1 Desk, L2/L3 intern &amp; Provider, Onsite/RSC)</a:t>
+            </a:r>
+          </a:p>
+          <a:p>
+            <a:pPr algn="l">
+              <a:lnSpc>
+                <a:spcPct val="105000"/>
+              </a:lnSpc>
+              <a:spcAft>
+                <a:spcPts val="300"/>
+              </a:spcAft>
+            </a:pPr>
+            <a:r>
+              <a:rPr sz="919" b="0" i="0">
+                <a:solidFill>
+                  <a:srgbClr val="4B5563"/>
+                </a:solidFill>
+                <a:latin typeface="Calibri"/>
+              </a:rPr>
+              <a:t>•  Tägliche Steuerung der AMS-/Ops-Dienstleister (Tickets, UC/SLA, Eskalation)</a:t>
+            </a:r>
+          </a:p>
+          <a:p>
+            <a:pPr algn="l">
+              <a:lnSpc>
+                <a:spcPct val="105000"/>
+              </a:lnSpc>
+              <a:spcAft>
+                <a:spcPts val="300"/>
+              </a:spcAft>
+            </a:pPr>
+            <a:r>
+              <a:rPr sz="919" b="0" i="0">
+                <a:solidFill>
+                  <a:srgbClr val="4B5563"/>
+                </a:solidFill>
+                <a:latin typeface="Calibri"/>
+              </a:rPr>
+              <a:t>•  Sicherstellung des End-to-End-SLA über die gesamte Kette</a:t>
+            </a:r>
+          </a:p>
+          <a:p>
+            <a:pPr algn="l">
+              <a:lnSpc>
+                <a:spcPct val="105000"/>
+              </a:lnSpc>
+              <a:spcAft>
+                <a:spcPts val="300"/>
+              </a:spcAft>
+            </a:pPr>
+            <a:r>
+              <a:rPr sz="919" b="0" i="0">
+                <a:solidFill>
+                  <a:srgbClr val="4B5563"/>
+                </a:solidFill>
+                <a:latin typeface="Calibri"/>
+              </a:rPr>
+              <a:t>•  Betrieb der Ops-Rituale: Service Operations Review, Provider Jour Fixe</a:t>
+            </a:r>
+          </a:p>
+          <a:p>
+            <a:pPr algn="l">
+              <a:lnSpc>
+                <a:spcPct val="105000"/>
+              </a:lnSpc>
+              <a:spcAft>
+                <a:spcPts val="300"/>
+              </a:spcAft>
+            </a:pPr>
+            <a:r>
+              <a:rPr sz="919" b="0" i="0">
+                <a:solidFill>
+                  <a:srgbClr val="4B5563"/>
+                </a:solidFill>
+                <a:latin typeface="Calibri"/>
+              </a:rPr>
+              <a:t>•  Incident-/Problem-/Change-Koordination über Einheiten hinweg</a:t>
+            </a:r>
+          </a:p>
+          <a:p>
+            <a:pPr algn="l">
+              <a:lnSpc>
+                <a:spcPct val="105000"/>
+              </a:lnSpc>
+              <a:spcAft>
+                <a:spcPts val="300"/>
+              </a:spcAft>
+            </a:pPr>
+            <a:r>
+              <a:rPr sz="919" b="0" i="0">
+                <a:solidFill>
+                  <a:srgbClr val="4B5563"/>
+                </a:solidFill>
+                <a:latin typeface="Calibri"/>
+              </a:rPr>
+              <a:t>•  Konsolidiertes Reporting (Health, SLA, Provider, Kosten) in ServiceNow</a:t>
+            </a:r>
+          </a:p>
+        </p:txBody>
+      </p:sp>
+      <p:sp>
+        <p:nvSpPr>
+          <p:cNvPr id="16" name="Rounded Rectangle 15"/>
+          <p:cNvSpPr/>
+          <p:nvPr/>
+        </p:nvSpPr>
+        <p:spPr>
+          <a:xfrm>
+            <a:off x="6210300" y="2286000"/>
+            <a:ext cx="5448300" cy="1943100"/>
+          </a:xfrm>
+          <a:prstGeom prst="roundRect">
+            <a:avLst>
+              <a:gd name="adj" fmla="val 8000"/>
+            </a:avLst>
+          </a:prstGeom>
+          <a:solidFill>
+            <a:srgbClr val="FFFFFF"/>
+          </a:solidFill>
+          <a:ln w="11430">
+            <a:solidFill>
+              <a:srgbClr val="D1D5DB"/>
+            </a:solidFill>
+          </a:ln>
+          <a:effectLst/>
+        </p:spPr>
+        <p:style>
+          <a:lnRef idx="1">
+            <a:schemeClr val="accent1"/>
+          </a:lnRef>
+          <a:fillRef idx="3">
+            <a:schemeClr val="accent1"/>
+          </a:fillRef>
+          <a:effectRef idx="2">
+            <a:schemeClr val="accent1"/>
+          </a:effectRef>
+          <a:fontRef idx="minor">
+            <a:schemeClr val="lt1"/>
+          </a:fontRef>
+        </p:style>
+        <p:txBody>
+          <a:bodyPr rtlCol="0" anchor="ctr"/>
+          <a:lstStyle/>
+          <a:p>
+            <a:pPr algn="ctr"/>
+          </a:p>
+        </p:txBody>
+      </p:sp>
+      <p:sp>
+        <p:nvSpPr>
+          <p:cNvPr id="17" name="Rectangle 16"/>
+          <p:cNvSpPr/>
+          <p:nvPr/>
+        </p:nvSpPr>
+        <p:spPr>
+          <a:xfrm>
+            <a:off x="6210300" y="2286000"/>
+            <a:ext cx="5448300" cy="68580"/>
+          </a:xfrm>
+          <a:prstGeom prst="rect">
+            <a:avLst/>
+          </a:prstGeom>
+          <a:solidFill>
+            <a:srgbClr val="B91C1C"/>
+          </a:solidFill>
+          <a:ln>
+            <a:noFill/>
+          </a:ln>
+          <a:effectLst/>
+        </p:spPr>
+        <p:style>
+          <a:lnRef idx="1">
+            <a:schemeClr val="accent1"/>
+          </a:lnRef>
+          <a:fillRef idx="3">
+            <a:schemeClr val="accent1"/>
+          </a:fillRef>
+          <a:effectRef idx="2">
+            <a:schemeClr val="accent1"/>
+          </a:effectRef>
+          <a:fontRef idx="minor">
+            <a:schemeClr val="lt1"/>
+          </a:fontRef>
+        </p:style>
+        <p:txBody>
+          <a:bodyPr rtlCol="0" anchor="ctr"/>
+          <a:lstStyle/>
+          <a:p>
+            <a:pPr algn="ctr"/>
+          </a:p>
+        </p:txBody>
+      </p:sp>
+      <p:sp>
+        <p:nvSpPr>
+          <p:cNvPr id="18" name="TextBox 17"/>
+          <p:cNvSpPr txBox="1"/>
+          <p:nvPr/>
+        </p:nvSpPr>
+        <p:spPr>
+          <a:xfrm>
+            <a:off x="6347460" y="2392680"/>
+            <a:ext cx="5181600" cy="266700"/>
+          </a:xfrm>
+          <a:prstGeom prst="rect">
+            <a:avLst/>
+          </a:prstGeom>
+          <a:noFill/>
+          <a:ln>
+            <a:noFill/>
+          </a:ln>
+        </p:spPr>
+        <p:txBody>
+          <a:bodyPr wrap="square" anchor="t" lIns="45000" rIns="45000" tIns="15000" bIns="15000">
+            <a:spAutoFit/>
+          </a:bodyPr>
+          <a:lstStyle/>
+          <a:p>
+            <a:pPr algn="l"/>
+            <a:r>
+              <a:rPr sz="1150" b="1" i="0">
+                <a:solidFill>
+                  <a:srgbClr val="1F2937"/>
+                </a:solidFill>
+                <a:latin typeface="Calibri"/>
+              </a:rPr>
+              <a:t>Macht NICHT (Abgrenzung)</a:t>
+            </a:r>
+          </a:p>
+        </p:txBody>
+      </p:sp>
+      <p:sp>
+        <p:nvSpPr>
+          <p:cNvPr id="19" name="TextBox 18"/>
+          <p:cNvSpPr txBox="1"/>
+          <p:nvPr/>
+        </p:nvSpPr>
+        <p:spPr>
+          <a:xfrm>
+            <a:off x="6347460" y="2712720"/>
+            <a:ext cx="5181600" cy="1447800"/>
+          </a:xfrm>
+          <a:prstGeom prst="rect">
+            <a:avLst/>
+          </a:prstGeom>
+          <a:noFill/>
+          <a:ln>
+            <a:noFill/>
+          </a:ln>
+        </p:spPr>
+        <p:txBody>
+          <a:bodyPr wrap="square" anchor="t" lIns="45000" rIns="45000" tIns="15000" bIns="15000">
+            <a:spAutoFit/>
+          </a:bodyPr>
+          <a:lstStyle/>
+          <a:p>
+            <a:pPr algn="l">
+              <a:lnSpc>
+                <a:spcPct val="105000"/>
+              </a:lnSpc>
+              <a:spcAft>
+                <a:spcPts val="300"/>
+              </a:spcAft>
+            </a:pPr>
+            <a:r>
+              <a:rPr sz="919" b="0" i="0">
+                <a:solidFill>
+                  <a:srgbClr val="4B5563"/>
+                </a:solidFill>
+                <a:latin typeface="Calibri"/>
+              </a:rPr>
+              <a:t>•  Fachliche Service-Definition, Priorisierung, Business-Wert → Service Owner</a:t>
+            </a:r>
+          </a:p>
+          <a:p>
+            <a:pPr algn="l">
+              <a:lnSpc>
+                <a:spcPct val="105000"/>
+              </a:lnSpc>
+              <a:spcAft>
+                <a:spcPts val="300"/>
+              </a:spcAft>
+            </a:pPr>
+            <a:r>
+              <a:rPr sz="919" b="0" i="0">
+                <a:solidFill>
+                  <a:srgbClr val="4B5563"/>
+                </a:solidFill>
+                <a:latin typeface="Calibri"/>
+              </a:rPr>
+              <a:t>•  Vertragshoheit, kommerzielle Verhandlung, Lieferantenauswahl → Practice Supplier Mgmt / Einkauf</a:t>
+            </a:r>
+          </a:p>
+          <a:p>
+            <a:pPr algn="l">
+              <a:lnSpc>
+                <a:spcPct val="105000"/>
+              </a:lnSpc>
+              <a:spcAft>
+                <a:spcPts val="300"/>
+              </a:spcAft>
+            </a:pPr>
+            <a:r>
+              <a:rPr sz="919" b="0" i="0">
+                <a:solidFill>
+                  <a:srgbClr val="4B5563"/>
+                </a:solidFill>
+                <a:latin typeface="Calibri"/>
+              </a:rPr>
+              <a:t>•  Technische Betriebsausführung → TSS-Ops-Teams / Provider</a:t>
+            </a:r>
+          </a:p>
+          <a:p>
+            <a:pPr algn="l">
+              <a:lnSpc>
+                <a:spcPct val="105000"/>
+              </a:lnSpc>
+              <a:spcAft>
+                <a:spcPts val="300"/>
+              </a:spcAft>
+            </a:pPr>
+            <a:r>
+              <a:rPr sz="919" b="0" i="0">
+                <a:solidFill>
+                  <a:srgbClr val="4B5563"/>
+                </a:solidFill>
+                <a:latin typeface="Calibri"/>
+              </a:rPr>
+              <a:t>•  Disziplinarische Führung der Support-Mitarbeitenden → Linie (Homebase)</a:t>
+            </a:r>
+          </a:p>
+        </p:txBody>
+      </p:sp>
+      <p:sp>
+        <p:nvSpPr>
+          <p:cNvPr id="20" name="Rounded Rectangle 19"/>
+          <p:cNvSpPr/>
+          <p:nvPr/>
+        </p:nvSpPr>
+        <p:spPr>
+          <a:xfrm>
+            <a:off x="533400" y="4381500"/>
+            <a:ext cx="5448300" cy="1943100"/>
+          </a:xfrm>
+          <a:prstGeom prst="roundRect">
+            <a:avLst>
+              <a:gd name="adj" fmla="val 8000"/>
+            </a:avLst>
+          </a:prstGeom>
+          <a:solidFill>
+            <a:srgbClr val="FFFFFF"/>
+          </a:solidFill>
+          <a:ln w="11430">
+            <a:solidFill>
+              <a:srgbClr val="D1D5DB"/>
+            </a:solidFill>
+          </a:ln>
+          <a:effectLst/>
+        </p:spPr>
+        <p:style>
+          <a:lnRef idx="1">
+            <a:schemeClr val="accent1"/>
+          </a:lnRef>
+          <a:fillRef idx="3">
+            <a:schemeClr val="accent1"/>
+          </a:fillRef>
+          <a:effectRef idx="2">
+            <a:schemeClr val="accent1"/>
+          </a:effectRef>
+          <a:fontRef idx="minor">
+            <a:schemeClr val="lt1"/>
+          </a:fontRef>
+        </p:style>
+        <p:txBody>
+          <a:bodyPr rtlCol="0" anchor="ctr"/>
+          <a:lstStyle/>
+          <a:p>
+            <a:pPr algn="ctr"/>
+          </a:p>
+        </p:txBody>
+      </p:sp>
+      <p:sp>
+        <p:nvSpPr>
+          <p:cNvPr id="21" name="Rectangle 20"/>
+          <p:cNvSpPr/>
+          <p:nvPr/>
+        </p:nvSpPr>
+        <p:spPr>
+          <a:xfrm>
+            <a:off x="533400" y="4381500"/>
+            <a:ext cx="5448300" cy="68580"/>
+          </a:xfrm>
+          <a:prstGeom prst="rect">
+            <a:avLst/>
+          </a:prstGeom>
+          <a:solidFill>
+            <a:srgbClr val="2E5A8F"/>
+          </a:solidFill>
+          <a:ln>
+            <a:noFill/>
+          </a:ln>
+          <a:effectLst/>
+        </p:spPr>
+        <p:style>
+          <a:lnRef idx="1">
+            <a:schemeClr val="accent1"/>
+          </a:lnRef>
+          <a:fillRef idx="3">
+            <a:schemeClr val="accent1"/>
+          </a:fillRef>
+          <a:effectRef idx="2">
+            <a:schemeClr val="accent1"/>
+          </a:effectRef>
+          <a:fontRef idx="minor">
+            <a:schemeClr val="lt1"/>
+          </a:fontRef>
+        </p:style>
+        <p:txBody>
+          <a:bodyPr rtlCol="0" anchor="ctr"/>
+          <a:lstStyle/>
+          <a:p>
+            <a:pPr algn="ctr"/>
+          </a:p>
+        </p:txBody>
+      </p:sp>
+      <p:sp>
+        <p:nvSpPr>
+          <p:cNvPr id="22" name="TextBox 21"/>
+          <p:cNvSpPr txBox="1"/>
+          <p:nvPr/>
+        </p:nvSpPr>
+        <p:spPr>
+          <a:xfrm>
+            <a:off x="670560" y="4488180"/>
+            <a:ext cx="5181600" cy="266700"/>
+          </a:xfrm>
+          <a:prstGeom prst="rect">
+            <a:avLst/>
+          </a:prstGeom>
+          <a:noFill/>
+          <a:ln>
+            <a:noFill/>
+          </a:ln>
+        </p:spPr>
+        <p:txBody>
+          <a:bodyPr wrap="square" anchor="t" lIns="45000" rIns="45000" tIns="15000" bIns="15000">
+            <a:spAutoFit/>
+          </a:bodyPr>
+          <a:lstStyle/>
+          <a:p>
+            <a:pPr algn="l"/>
+            <a:r>
+              <a:rPr sz="1150" b="1" i="0">
+                <a:solidFill>
+                  <a:srgbClr val="1F2937"/>
+                </a:solidFill>
+                <a:latin typeface="Calibri"/>
+              </a:rPr>
+              <a:t>Mandat &amp; KPIs</a:t>
+            </a:r>
+          </a:p>
+        </p:txBody>
+      </p:sp>
+      <p:sp>
+        <p:nvSpPr>
+          <p:cNvPr id="23" name="TextBox 22"/>
+          <p:cNvSpPr txBox="1"/>
+          <p:nvPr/>
+        </p:nvSpPr>
+        <p:spPr>
+          <a:xfrm>
+            <a:off x="670560" y="4808220"/>
+            <a:ext cx="5181600" cy="1447800"/>
+          </a:xfrm>
+          <a:prstGeom prst="rect">
+            <a:avLst/>
+          </a:prstGeom>
+          <a:noFill/>
+          <a:ln>
+            <a:noFill/>
+          </a:ln>
+        </p:spPr>
+        <p:txBody>
+          <a:bodyPr wrap="square" anchor="t" lIns="45000" rIns="45000" tIns="15000" bIns="15000">
+            <a:spAutoFit/>
+          </a:bodyPr>
+          <a:lstStyle/>
+          <a:p>
+            <a:pPr algn="l">
+              <a:lnSpc>
+                <a:spcPct val="105000"/>
+              </a:lnSpc>
+              <a:spcAft>
+                <a:spcPts val="300"/>
+              </a:spcAft>
+            </a:pPr>
+            <a:r>
+              <a:rPr sz="919" b="0" i="0">
+                <a:solidFill>
+                  <a:srgbClr val="4B5563"/>
+                </a:solidFill>
+                <a:latin typeface="Calibri"/>
+              </a:rPr>
+              <a:t>•  Fachliches Weisungsrecht ggü. beteiligten Einheiten &amp; Providern im Service-Kontext</a:t>
+            </a:r>
+          </a:p>
+          <a:p>
+            <a:pPr algn="l">
+              <a:lnSpc>
+                <a:spcPct val="105000"/>
+              </a:lnSpc>
+              <a:spcAft>
+                <a:spcPts val="300"/>
+              </a:spcAft>
+            </a:pPr>
+            <a:r>
+              <a:rPr sz="919" b="0" i="0">
+                <a:solidFill>
+                  <a:srgbClr val="4B5563"/>
+                </a:solidFill>
+                <a:latin typeface="Calibri"/>
+              </a:rPr>
+              <a:t>•  Eskalationsrecht bei SLA-Gefährdung, Auslöser Major Incident</a:t>
+            </a:r>
+          </a:p>
+          <a:p>
+            <a:pPr algn="l">
+              <a:lnSpc>
+                <a:spcPct val="105000"/>
+              </a:lnSpc>
+              <a:spcAft>
+                <a:spcPts val="300"/>
+              </a:spcAft>
+            </a:pPr>
+            <a:r>
+              <a:rPr sz="919" b="0" i="0">
+                <a:solidFill>
+                  <a:srgbClr val="4B5563"/>
+                </a:solidFill>
+                <a:latin typeface="Calibri"/>
+              </a:rPr>
+              <a:t>•  KPIs: E2E-SLA-Erfüllung · MTTR · Provider-SLA · Erstlösungsquote · Kosten/Service</a:t>
+            </a:r>
+          </a:p>
+        </p:txBody>
+      </p:sp>
+      <p:sp>
+        <p:nvSpPr>
+          <p:cNvPr id="24" name="Rounded Rectangle 23"/>
+          <p:cNvSpPr/>
+          <p:nvPr/>
+        </p:nvSpPr>
+        <p:spPr>
+          <a:xfrm>
+            <a:off x="6210300" y="4381500"/>
+            <a:ext cx="5448300" cy="1943100"/>
+          </a:xfrm>
+          <a:prstGeom prst="roundRect">
+            <a:avLst>
+              <a:gd name="adj" fmla="val 8000"/>
+            </a:avLst>
+          </a:prstGeom>
+          <a:solidFill>
+            <a:srgbClr val="FFFFFF"/>
+          </a:solidFill>
+          <a:ln w="11430">
+            <a:solidFill>
+              <a:srgbClr val="D1D5DB"/>
+            </a:solidFill>
+          </a:ln>
+          <a:effectLst/>
+        </p:spPr>
+        <p:style>
+          <a:lnRef idx="1">
+            <a:schemeClr val="accent1"/>
+          </a:lnRef>
+          <a:fillRef idx="3">
+            <a:schemeClr val="accent1"/>
+          </a:fillRef>
+          <a:effectRef idx="2">
+            <a:schemeClr val="accent1"/>
+          </a:effectRef>
+          <a:fontRef idx="minor">
+            <a:schemeClr val="lt1"/>
+          </a:fontRef>
+        </p:style>
+        <p:txBody>
+          <a:bodyPr rtlCol="0" anchor="ctr"/>
+          <a:lstStyle/>
+          <a:p>
+            <a:pPr algn="ctr"/>
+          </a:p>
+        </p:txBody>
+      </p:sp>
+      <p:sp>
+        <p:nvSpPr>
+          <p:cNvPr id="25" name="Rectangle 24"/>
+          <p:cNvSpPr/>
+          <p:nvPr/>
+        </p:nvSpPr>
+        <p:spPr>
+          <a:xfrm>
+            <a:off x="6210300" y="4381500"/>
+            <a:ext cx="5448300" cy="68580"/>
+          </a:xfrm>
+          <a:prstGeom prst="rect">
+            <a:avLst/>
+          </a:prstGeom>
+          <a:solidFill>
+            <a:srgbClr val="6B4FA0"/>
+          </a:solidFill>
+          <a:ln>
+            <a:noFill/>
+          </a:ln>
+          <a:effectLst/>
+        </p:spPr>
+        <p:style>
+          <a:lnRef idx="1">
+            <a:schemeClr val="accent1"/>
+          </a:lnRef>
+          <a:fillRef idx="3">
+            <a:schemeClr val="accent1"/>
+          </a:fillRef>
+          <a:effectRef idx="2">
+            <a:schemeClr val="accent1"/>
+          </a:effectRef>
+          <a:fontRef idx="minor">
+            <a:schemeClr val="lt1"/>
+          </a:fontRef>
+        </p:style>
+        <p:txBody>
+          <a:bodyPr rtlCol="0" anchor="ctr"/>
+          <a:lstStyle/>
+          <a:p>
+            <a:pPr algn="ctr"/>
+          </a:p>
+        </p:txBody>
+      </p:sp>
+      <p:sp>
+        <p:nvSpPr>
+          <p:cNvPr id="26" name="TextBox 25"/>
+          <p:cNvSpPr txBox="1"/>
+          <p:nvPr/>
+        </p:nvSpPr>
+        <p:spPr>
+          <a:xfrm>
+            <a:off x="6347460" y="4488180"/>
+            <a:ext cx="5181600" cy="266700"/>
+          </a:xfrm>
+          <a:prstGeom prst="rect">
+            <a:avLst/>
+          </a:prstGeom>
+          <a:noFill/>
+          <a:ln>
+            <a:noFill/>
+          </a:ln>
+        </p:spPr>
+        <p:txBody>
+          <a:bodyPr wrap="square" anchor="t" lIns="45000" rIns="45000" tIns="15000" bIns="15000">
+            <a:spAutoFit/>
+          </a:bodyPr>
+          <a:lstStyle/>
+          <a:p>
+            <a:pPr algn="l"/>
+            <a:r>
+              <a:rPr sz="1150" b="1" i="0">
+                <a:solidFill>
+                  <a:srgbClr val="1F2937"/>
+                </a:solidFill>
+                <a:latin typeface="Calibri"/>
+              </a:rPr>
+              <a:t>Profil &amp; Skills</a:t>
+            </a:r>
+          </a:p>
+        </p:txBody>
+      </p:sp>
+      <p:sp>
+        <p:nvSpPr>
+          <p:cNvPr id="27" name="TextBox 26"/>
+          <p:cNvSpPr txBox="1"/>
+          <p:nvPr/>
+        </p:nvSpPr>
+        <p:spPr>
+          <a:xfrm>
+            <a:off x="6347460" y="4808220"/>
+            <a:ext cx="5181600" cy="1447800"/>
+          </a:xfrm>
+          <a:prstGeom prst="rect">
+            <a:avLst/>
+          </a:prstGeom>
+          <a:noFill/>
+          <a:ln>
+            <a:noFill/>
+          </a:ln>
+        </p:spPr>
+        <p:txBody>
+          <a:bodyPr wrap="square" anchor="t" lIns="45000" rIns="45000" tIns="15000" bIns="15000">
+            <a:spAutoFit/>
+          </a:bodyPr>
+          <a:lstStyle/>
+          <a:p>
+            <a:pPr algn="l">
+              <a:lnSpc>
+                <a:spcPct val="105000"/>
+              </a:lnSpc>
+              <a:spcAft>
+                <a:spcPts val="300"/>
+              </a:spcAft>
+            </a:pPr>
+            <a:r>
+              <a:rPr sz="919" b="0" i="0">
+                <a:solidFill>
+                  <a:srgbClr val="4B5563"/>
+                </a:solidFill>
+                <a:latin typeface="Calibri"/>
+              </a:rPr>
+              <a:t>•  ITIL 4 / ITSM (Service Integration, Inc/Prob/Change), SIAM-Verständnis</a:t>
+            </a:r>
+          </a:p>
+          <a:p>
+            <a:pPr algn="l">
+              <a:lnSpc>
+                <a:spcPct val="105000"/>
+              </a:lnSpc>
+              <a:spcAft>
+                <a:spcPts val="300"/>
+              </a:spcAft>
+            </a:pPr>
+            <a:r>
+              <a:rPr sz="919" b="0" i="0">
+                <a:solidFill>
+                  <a:srgbClr val="4B5563"/>
+                </a:solidFill>
+                <a:latin typeface="Calibri"/>
+              </a:rPr>
+              <a:t>•  Provider-/Vendor-Management, Vertrags- &amp; SLA-Kompetenz</a:t>
+            </a:r>
+          </a:p>
+          <a:p>
+            <a:pPr algn="l">
+              <a:lnSpc>
+                <a:spcPct val="105000"/>
+              </a:lnSpc>
+              <a:spcAft>
+                <a:spcPts val="300"/>
+              </a:spcAft>
+            </a:pPr>
+            <a:r>
+              <a:rPr sz="919" b="0" i="0">
+                <a:solidFill>
+                  <a:srgbClr val="4B5563"/>
+                </a:solidFill>
+                <a:latin typeface="Calibri"/>
+              </a:rPr>
+              <a:t>•  Erfahrung mit AMS (z. B. SAP/DXC) und Infrastruktur-Betrieb; ServiceNow</a:t>
+            </a:r>
+          </a:p>
+          <a:p>
+            <a:pPr algn="l">
+              <a:lnSpc>
+                <a:spcPct val="105000"/>
+              </a:lnSpc>
+              <a:spcAft>
+                <a:spcPts val="300"/>
+              </a:spcAft>
+            </a:pPr>
+            <a:r>
+              <a:rPr sz="919" b="0" i="0">
+                <a:solidFill>
+                  <a:srgbClr val="4B5563"/>
+                </a:solidFill>
+                <a:latin typeface="Calibri"/>
+              </a:rPr>
+              <a:t>•  Laterale Führung &amp; Durchsetzungsstärke ohne disziplinarische Macht; DE/EN</a:t>
+            </a:r>
+          </a:p>
+        </p:txBody>
+      </p:sp>
+    </p:spTree>
+  </p:cSld>
+  <p:clrMapOvr>
+    <a:masterClrMapping/>
+  </p:clrMapOvr>
+</p:sld>
+</file>
+
+<file path=ppt/slides/slide13.xml><?xml version="1.0" encoding="utf-8"?>
+<p:sld xmlns:a="http://schemas.openxmlformats.org/drawingml/2006/main" xmlns:p="http://schemas.openxmlformats.org/presentationml/2006/main" xmlns:r="http://schemas.openxmlformats.org/officeDocument/2006/relationships">
+  <p:cSld>
+    <p:spTree>
+      <p:nvGrpSpPr>
+        <p:cNvPr id="1" name=""/>
+        <p:cNvGrpSpPr/>
+        <p:nvPr/>
+      </p:nvGrpSpPr>
+      <p:grpSpPr/>
+      <p:sp>
+        <p:nvSpPr>
+          <p:cNvPr id="2" name="Rectangle 1"/>
+          <p:cNvSpPr/>
+          <p:nvPr/>
+        </p:nvSpPr>
+        <p:spPr>
+          <a:xfrm>
+            <a:off x="0" y="0"/>
+            <a:ext cx="12192000" cy="6858000"/>
+          </a:xfrm>
+          <a:prstGeom prst="rect">
+            <a:avLst/>
+          </a:prstGeom>
+          <a:solidFill>
+            <a:srgbClr val="FFFFFF"/>
+          </a:solidFill>
+          <a:ln>
+            <a:noFill/>
+          </a:ln>
+          <a:effectLst/>
+        </p:spPr>
+        <p:style>
+          <a:lnRef idx="1">
+            <a:schemeClr val="accent1"/>
+          </a:lnRef>
+          <a:fillRef idx="3">
+            <a:schemeClr val="accent1"/>
+          </a:fillRef>
+          <a:effectRef idx="2">
+            <a:schemeClr val="accent1"/>
+          </a:effectRef>
+          <a:fontRef idx="minor">
+            <a:schemeClr val="lt1"/>
+          </a:fontRef>
+        </p:style>
+        <p:txBody>
+          <a:bodyPr rtlCol="0" anchor="ctr"/>
+          <a:lstStyle/>
+          <a:p>
+            <a:pPr algn="ctr"/>
+          </a:p>
+        </p:txBody>
+      </p:sp>
+      <p:sp>
+        <p:nvSpPr>
+          <p:cNvPr id="3" name="Rectangle 2"/>
+          <p:cNvSpPr/>
+          <p:nvPr/>
+        </p:nvSpPr>
+        <p:spPr>
+          <a:xfrm>
+            <a:off x="0" y="0"/>
+            <a:ext cx="121920" cy="6858000"/>
+          </a:xfrm>
+          <a:prstGeom prst="rect">
+            <a:avLst/>
+          </a:prstGeom>
+          <a:solidFill>
+            <a:srgbClr val="F07F12"/>
+          </a:solidFill>
+          <a:ln>
+            <a:noFill/>
+          </a:ln>
+          <a:effectLst/>
+        </p:spPr>
+        <p:style>
+          <a:lnRef idx="1">
+            <a:schemeClr val="accent1"/>
+          </a:lnRef>
+          <a:fillRef idx="3">
+            <a:schemeClr val="accent1"/>
+          </a:fillRef>
+          <a:effectRef idx="2">
+            <a:schemeClr val="accent1"/>
+          </a:effectRef>
+          <a:fontRef idx="minor">
+            <a:schemeClr val="lt1"/>
+          </a:fontRef>
+        </p:style>
+        <p:txBody>
+          <a:bodyPr rtlCol="0" anchor="ctr"/>
+          <a:lstStyle/>
+          <a:p>
+            <a:pPr algn="ctr"/>
+          </a:p>
+        </p:txBody>
+      </p:sp>
+      <p:sp>
+        <p:nvSpPr>
+          <p:cNvPr id="4" name="TextBox 3"/>
+          <p:cNvSpPr txBox="1"/>
+          <p:nvPr/>
+        </p:nvSpPr>
+        <p:spPr>
+          <a:xfrm>
+            <a:off x="533400" y="381000"/>
+            <a:ext cx="9906000" cy="304800"/>
+          </a:xfrm>
+          <a:prstGeom prst="rect">
+            <a:avLst/>
+          </a:prstGeom>
+          <a:noFill/>
+          <a:ln>
+            <a:noFill/>
+          </a:ln>
+        </p:spPr>
+        <p:txBody>
+          <a:bodyPr wrap="square" anchor="t" lIns="45000" rIns="45000" tIns="15000" bIns="15000">
+            <a:spAutoFit/>
+          </a:bodyPr>
+          <a:lstStyle/>
+          <a:p>
+            <a:pPr algn="l"/>
+            <a:r>
+              <a:rPr sz="1100" b="1" i="0">
+                <a:solidFill>
+                  <a:srgbClr val="F07F12"/>
+                </a:solidFill>
+                <a:latin typeface="Calibri"/>
+              </a:rPr>
+              <a:t>UMSETZUNG</a:t>
+            </a:r>
+          </a:p>
+        </p:txBody>
+      </p:sp>
+      <p:sp>
+        <p:nvSpPr>
+          <p:cNvPr id="5" name="TextBox 4"/>
+          <p:cNvSpPr txBox="1"/>
+          <p:nvPr/>
+        </p:nvSpPr>
+        <p:spPr>
+          <a:xfrm>
+            <a:off x="533400" y="647700"/>
+            <a:ext cx="11125200" cy="685800"/>
+          </a:xfrm>
+          <a:prstGeom prst="rect">
+            <a:avLst/>
+          </a:prstGeom>
+          <a:noFill/>
+          <a:ln>
+            <a:noFill/>
+          </a:ln>
+        </p:spPr>
+        <p:txBody>
+          <a:bodyPr wrap="square" anchor="t" lIns="45000" rIns="45000" tIns="15000" bIns="15000">
+            <a:spAutoFit/>
+          </a:bodyPr>
+          <a:lstStyle/>
+          <a:p>
+            <a:pPr algn="l"/>
+            <a:r>
+              <a:rPr sz="2400" b="1" i="0">
+                <a:solidFill>
+                  <a:srgbClr val="1F2937"/>
+                </a:solidFill>
+                <a:latin typeface="Calibri"/>
+              </a:rPr>
+              <a:t>Migration: vom „pro Service Owner“ zur SIAM-Klammer</a:t>
+            </a:r>
+          </a:p>
+        </p:txBody>
+      </p:sp>
+      <p:sp>
+        <p:nvSpPr>
+          <p:cNvPr id="6" name="Rectangle 5"/>
+          <p:cNvSpPr/>
+          <p:nvPr/>
+        </p:nvSpPr>
+        <p:spPr>
+          <a:xfrm>
+            <a:off x="533400" y="1333500"/>
+            <a:ext cx="11125200" cy="9144"/>
+          </a:xfrm>
+          <a:prstGeom prst="rect">
+            <a:avLst/>
+          </a:prstGeom>
+          <a:solidFill>
+            <a:srgbClr val="D1D5DB"/>
+          </a:solidFill>
+          <a:ln>
+            <a:noFill/>
+          </a:ln>
+          <a:effectLst/>
+        </p:spPr>
+        <p:style>
+          <a:lnRef idx="1">
+            <a:schemeClr val="accent1"/>
+          </a:lnRef>
+          <a:fillRef idx="3">
+            <a:schemeClr val="accent1"/>
+          </a:fillRef>
+          <a:effectRef idx="2">
+            <a:schemeClr val="accent1"/>
+          </a:effectRef>
+          <a:fontRef idx="minor">
+            <a:schemeClr val="lt1"/>
+          </a:fontRef>
+        </p:style>
+        <p:txBody>
+          <a:bodyPr rtlCol="0" anchor="ctr"/>
+          <a:lstStyle/>
+          <a:p>
+            <a:pPr algn="ctr"/>
+          </a:p>
+        </p:txBody>
+      </p:sp>
+      <p:sp>
+        <p:nvSpPr>
+          <p:cNvPr id="7" name="TextBox 6"/>
+          <p:cNvSpPr txBox="1"/>
+          <p:nvPr/>
+        </p:nvSpPr>
+        <p:spPr>
+          <a:xfrm>
+            <a:off x="11430000" y="6438900"/>
+            <a:ext cx="609600" cy="304800"/>
+          </a:xfrm>
+          <a:prstGeom prst="rect">
+            <a:avLst/>
+          </a:prstGeom>
+          <a:noFill/>
+          <a:ln>
+            <a:noFill/>
+          </a:ln>
+        </p:spPr>
+        <p:txBody>
+          <a:bodyPr wrap="square" anchor="t" lIns="45000" rIns="45000" tIns="15000" bIns="15000">
+            <a:spAutoFit/>
+          </a:bodyPr>
+          <a:lstStyle/>
+          <a:p>
+            <a:pPr algn="r"/>
+            <a:r>
+              <a:rPr sz="1000" b="0" i="0">
+                <a:solidFill>
+                  <a:srgbClr val="D1D5DB"/>
+                </a:solidFill>
+                <a:latin typeface="Calibri"/>
+              </a:rPr>
+              <a:t>13</a:t>
+            </a:r>
+          </a:p>
+        </p:txBody>
+      </p:sp>
+      <p:sp>
+        <p:nvSpPr>
+          <p:cNvPr id="8" name="TextBox 7"/>
+          <p:cNvSpPr txBox="1"/>
+          <p:nvPr/>
+        </p:nvSpPr>
+        <p:spPr>
+          <a:xfrm>
+            <a:off x="533400" y="6438900"/>
+            <a:ext cx="6858000" cy="304800"/>
+          </a:xfrm>
+          <a:prstGeom prst="rect">
+            <a:avLst/>
+          </a:prstGeom>
+          <a:noFill/>
+          <a:ln>
+            <a:noFill/>
+          </a:ln>
+        </p:spPr>
+        <p:txBody>
+          <a:bodyPr wrap="square" anchor="t" lIns="45000" rIns="45000" tIns="15000" bIns="15000">
+            <a:spAutoFit/>
+          </a:bodyPr>
+          <a:lstStyle/>
+          <a:p>
+            <a:pPr algn="l"/>
+            <a:r>
+              <a:rPr sz="900" b="0" i="0">
+                <a:solidFill>
+                  <a:srgbClr val="D1D5DB"/>
+                </a:solidFill>
+                <a:latin typeface="Calibri"/>
+              </a:rPr>
+              <a:t>IT-Ablauforganisation · Zielbild</a:t>
+            </a:r>
+          </a:p>
+        </p:txBody>
+      </p:sp>
+      <p:sp>
+        <p:nvSpPr>
+          <p:cNvPr id="9" name="TextBox 8"/>
+          <p:cNvSpPr txBox="1"/>
+          <p:nvPr/>
+        </p:nvSpPr>
+        <p:spPr>
+          <a:xfrm>
+            <a:off x="533400" y="1470660"/>
+            <a:ext cx="11125200" cy="304800"/>
+          </a:xfrm>
+          <a:prstGeom prst="rect">
+            <a:avLst/>
+          </a:prstGeom>
+          <a:noFill/>
+          <a:ln>
+            <a:noFill/>
+          </a:ln>
+        </p:spPr>
+        <p:txBody>
+          <a:bodyPr wrap="square" anchor="t" lIns="45000" rIns="45000" tIns="15000" bIns="15000">
+            <a:spAutoFit/>
+          </a:bodyPr>
+          <a:lstStyle/>
+          <a:p>
+            <a:pPr algn="l">
+              <a:lnSpc>
+                <a:spcPct val="110000"/>
+              </a:lnSpc>
+            </a:pPr>
+            <a:r>
+              <a:rPr sz="1050" b="0" i="0">
+                <a:solidFill>
+                  <a:srgbClr val="4B5563"/>
+                </a:solidFill>
+                <a:latin typeface="Calibri"/>
+              </a:rPr>
+              <a:t>Wellenweise über ~12 Monate – ohne Big Bang. Der Service Owner behält seine Accountability; die Koordination wandert schrittweise in die Klammer.</a:t>
+            </a:r>
+          </a:p>
+        </p:txBody>
+      </p:sp>
+      <p:sp>
+        <p:nvSpPr>
+          <p:cNvPr id="10" name="Rectangle 9"/>
+          <p:cNvSpPr/>
+          <p:nvPr/>
+        </p:nvSpPr>
+        <p:spPr>
+          <a:xfrm>
+            <a:off x="533400" y="2232660"/>
+            <a:ext cx="11125200" cy="13716"/>
+          </a:xfrm>
+          <a:prstGeom prst="rect">
+            <a:avLst/>
+          </a:prstGeom>
+          <a:solidFill>
+            <a:srgbClr val="D1D5DB"/>
+          </a:solidFill>
+          <a:ln>
+            <a:noFill/>
+          </a:ln>
+          <a:effectLst/>
+        </p:spPr>
+        <p:style>
+          <a:lnRef idx="1">
+            <a:schemeClr val="accent1"/>
+          </a:lnRef>
+          <a:fillRef idx="3">
+            <a:schemeClr val="accent1"/>
+          </a:fillRef>
+          <a:effectRef idx="2">
+            <a:schemeClr val="accent1"/>
+          </a:effectRef>
+          <a:fontRef idx="minor">
+            <a:schemeClr val="lt1"/>
+          </a:fontRef>
+        </p:style>
+        <p:txBody>
+          <a:bodyPr rtlCol="0" anchor="ctr"/>
+          <a:lstStyle/>
+          <a:p>
+            <a:pPr algn="ctr"/>
+          </a:p>
+        </p:txBody>
+      </p:sp>
+      <p:sp>
+        <p:nvSpPr>
+          <p:cNvPr id="11" name="Oval 10"/>
+          <p:cNvSpPr/>
+          <p:nvPr/>
+        </p:nvSpPr>
+        <p:spPr>
+          <a:xfrm>
+            <a:off x="1531620" y="2171700"/>
+            <a:ext cx="137160" cy="137160"/>
+          </a:xfrm>
+          <a:prstGeom prst="ellipse">
+            <a:avLst/>
+          </a:prstGeom>
+          <a:solidFill>
+            <a:srgbClr val="2C3E50"/>
+          </a:solidFill>
+          <a:ln>
+            <a:noFill/>
+          </a:ln>
+          <a:effectLst/>
+        </p:spPr>
+        <p:style>
+          <a:lnRef idx="1">
+            <a:schemeClr val="accent1"/>
+          </a:lnRef>
+          <a:fillRef idx="3">
+            <a:schemeClr val="accent1"/>
+          </a:fillRef>
+          <a:effectRef idx="2">
+            <a:schemeClr val="accent1"/>
+          </a:effectRef>
+          <a:fontRef idx="minor">
+            <a:schemeClr val="lt1"/>
+          </a:fontRef>
+        </p:style>
+        <p:txBody>
+          <a:bodyPr rtlCol="0" anchor="ctr"/>
+          <a:lstStyle/>
+          <a:p>
+            <a:pPr algn="ctr"/>
+          </a:p>
+        </p:txBody>
+      </p:sp>
+      <p:sp>
+        <p:nvSpPr>
+          <p:cNvPr id="12" name="Rounded Rectangle 11"/>
+          <p:cNvSpPr/>
+          <p:nvPr/>
+        </p:nvSpPr>
+        <p:spPr>
+          <a:xfrm>
+            <a:off x="533400" y="2438400"/>
+            <a:ext cx="2133600" cy="609600"/>
+          </a:xfrm>
+          <a:prstGeom prst="roundRect">
+            <a:avLst>
+              <a:gd name="adj" fmla="val 8000"/>
+            </a:avLst>
+          </a:prstGeom>
+          <a:solidFill>
+            <a:srgbClr val="2C3E50"/>
+          </a:solidFill>
+          <a:ln>
+            <a:noFill/>
+          </a:ln>
+          <a:effectLst/>
+        </p:spPr>
+        <p:style>
+          <a:lnRef idx="1">
+            <a:schemeClr val="accent1"/>
+          </a:lnRef>
+          <a:fillRef idx="3">
+            <a:schemeClr val="accent1"/>
+          </a:fillRef>
+          <a:effectRef idx="2">
+            <a:schemeClr val="accent1"/>
+          </a:effectRef>
+          <a:fontRef idx="minor">
+            <a:schemeClr val="lt1"/>
+          </a:fontRef>
+        </p:style>
+        <p:txBody>
+          <a:bodyPr rtlCol="0" anchor="ctr"/>
+          <a:lstStyle/>
+          <a:p>
+            <a:pPr algn="ctr"/>
+          </a:p>
+        </p:txBody>
+      </p:sp>
+      <p:sp>
+        <p:nvSpPr>
+          <p:cNvPr id="13" name="TextBox 12"/>
+          <p:cNvSpPr txBox="1"/>
+          <p:nvPr/>
+        </p:nvSpPr>
+        <p:spPr>
+          <a:xfrm>
+            <a:off x="533400" y="2438400"/>
+            <a:ext cx="2133600" cy="609600"/>
+          </a:xfrm>
+          <a:prstGeom prst="rect">
+            <a:avLst/>
+          </a:prstGeom>
+          <a:noFill/>
+          <a:ln>
+            <a:noFill/>
+          </a:ln>
+        </p:spPr>
+        <p:txBody>
+          <a:bodyPr wrap="square" anchor="ctr" lIns="45000" rIns="45000" tIns="15000" bIns="15000">
+            <a:spAutoFit/>
+          </a:bodyPr>
+          <a:lstStyle/>
+          <a:p>
+            <a:pPr algn="ctr"/>
+            <a:r>
+              <a:rPr sz="950" b="1" i="0">
+                <a:solidFill>
+                  <a:srgbClr val="FFFFFF"/>
+                </a:solidFill>
+                <a:latin typeface="Calibri"/>
+              </a:rPr>
+              <a:t>PHASE 0</a:t>
+            </a:r>
+          </a:p>
+          <a:p>
+            <a:pPr algn="ctr"/>
+            <a:r>
+              <a:rPr sz="800" b="0" i="0">
+                <a:solidFill>
+                  <a:srgbClr val="FFFFFF"/>
+                </a:solidFill>
+                <a:latin typeface="Calibri"/>
+              </a:rPr>
+              <a:t>Wo. 1–4</a:t>
+            </a:r>
+          </a:p>
+        </p:txBody>
+      </p:sp>
+      <p:sp>
+        <p:nvSpPr>
+          <p:cNvPr id="14" name="Rounded Rectangle 13"/>
+          <p:cNvSpPr/>
+          <p:nvPr/>
+        </p:nvSpPr>
+        <p:spPr>
+          <a:xfrm>
+            <a:off x="533400" y="3124200"/>
+            <a:ext cx="2133600" cy="2819400"/>
+          </a:xfrm>
+          <a:prstGeom prst="roundRect">
+            <a:avLst>
+              <a:gd name="adj" fmla="val 8000"/>
+            </a:avLst>
+          </a:prstGeom>
+          <a:solidFill>
+            <a:srgbClr val="FFFFFF"/>
+          </a:solidFill>
+          <a:ln w="10160">
+            <a:solidFill>
+              <a:srgbClr val="D1D5DB"/>
+            </a:solidFill>
+          </a:ln>
+          <a:effectLst/>
+        </p:spPr>
+        <p:style>
+          <a:lnRef idx="1">
+            <a:schemeClr val="accent1"/>
+          </a:lnRef>
+          <a:fillRef idx="3">
+            <a:schemeClr val="accent1"/>
+          </a:fillRef>
+          <a:effectRef idx="2">
+            <a:schemeClr val="accent1"/>
+          </a:effectRef>
+          <a:fontRef idx="minor">
+            <a:schemeClr val="lt1"/>
+          </a:fontRef>
+        </p:style>
+        <p:txBody>
+          <a:bodyPr rtlCol="0" anchor="ctr"/>
+          <a:lstStyle/>
+          <a:p>
+            <a:pPr algn="ctr"/>
+          </a:p>
+        </p:txBody>
+      </p:sp>
+      <p:sp>
+        <p:nvSpPr>
+          <p:cNvPr id="15" name="TextBox 14"/>
+          <p:cNvSpPr txBox="1"/>
+          <p:nvPr/>
+        </p:nvSpPr>
+        <p:spPr>
+          <a:xfrm>
+            <a:off x="624840" y="3200400"/>
+            <a:ext cx="1950720" cy="304800"/>
+          </a:xfrm>
+          <a:prstGeom prst="rect">
+            <a:avLst/>
+          </a:prstGeom>
+          <a:noFill/>
+          <a:ln>
+            <a:noFill/>
+          </a:ln>
+        </p:spPr>
+        <p:txBody>
+          <a:bodyPr wrap="square" anchor="t" lIns="45000" rIns="45000" tIns="15000" bIns="15000">
+            <a:spAutoFit/>
+          </a:bodyPr>
+          <a:lstStyle/>
+          <a:p>
+            <a:pPr algn="l">
+              <a:lnSpc>
+                <a:spcPct val="100000"/>
+              </a:lnSpc>
+            </a:pPr>
+            <a:r>
+              <a:rPr sz="1000" b="1" i="0">
+                <a:solidFill>
+                  <a:srgbClr val="2C3E50"/>
+                </a:solidFill>
+                <a:latin typeface="Calibri"/>
+              </a:rPr>
+              <a:t>Setup &amp; Mandat</a:t>
+            </a:r>
+          </a:p>
+        </p:txBody>
+      </p:sp>
+      <p:sp>
+        <p:nvSpPr>
+          <p:cNvPr id="16" name="TextBox 15"/>
+          <p:cNvSpPr txBox="1"/>
+          <p:nvPr/>
+        </p:nvSpPr>
+        <p:spPr>
+          <a:xfrm>
+            <a:off x="624840" y="3543300"/>
+            <a:ext cx="1950720" cy="2362200"/>
+          </a:xfrm>
+          <a:prstGeom prst="rect">
+            <a:avLst/>
+          </a:prstGeom>
+          <a:noFill/>
+          <a:ln>
+            <a:noFill/>
+          </a:ln>
+        </p:spPr>
+        <p:txBody>
+          <a:bodyPr wrap="square" anchor="t" lIns="45000" rIns="45000" tIns="15000" bIns="15000">
+            <a:spAutoFit/>
+          </a:bodyPr>
+          <a:lstStyle/>
+          <a:p>
+            <a:pPr algn="l">
+              <a:lnSpc>
+                <a:spcPct val="103000"/>
+              </a:lnSpc>
+              <a:spcAft>
+                <a:spcPts val="300"/>
+              </a:spcAft>
+            </a:pPr>
+            <a:r>
+              <a:rPr sz="800" b="0" i="0">
+                <a:solidFill>
+                  <a:srgbClr val="4B5563"/>
+                </a:solidFill>
+                <a:latin typeface="Calibri"/>
+              </a:rPr>
+              <a:t>•  CIO-Entscheid: Klammer im IPS MO</a:t>
+            </a:r>
+          </a:p>
+          <a:p>
+            <a:pPr algn="l">
+              <a:lnSpc>
+                <a:spcPct val="103000"/>
+              </a:lnSpc>
+              <a:spcAft>
+                <a:spcPts val="300"/>
+              </a:spcAft>
+            </a:pPr>
+            <a:r>
+              <a:rPr sz="800" b="0" i="0">
+                <a:solidFill>
+                  <a:srgbClr val="4B5563"/>
+                </a:solidFill>
+                <a:latin typeface="Calibri"/>
+              </a:rPr>
+              <a:t>•  SIAM-Lead benennen</a:t>
+            </a:r>
+          </a:p>
+          <a:p>
+            <a:pPr algn="l">
+              <a:lnSpc>
+                <a:spcPct val="103000"/>
+              </a:lnSpc>
+              <a:spcAft>
+                <a:spcPts val="300"/>
+              </a:spcAft>
+            </a:pPr>
+            <a:r>
+              <a:rPr sz="800" b="0" i="0">
+                <a:solidFill>
+                  <a:srgbClr val="4B5563"/>
+                </a:solidFill>
+                <a:latin typeface="Calibri"/>
+              </a:rPr>
+              <a:t>•  Zielbild &amp; Guardrails</a:t>
+            </a:r>
+          </a:p>
+        </p:txBody>
+      </p:sp>
+      <p:sp>
+        <p:nvSpPr>
+          <p:cNvPr id="17" name="Oval 16"/>
+          <p:cNvSpPr/>
+          <p:nvPr/>
+        </p:nvSpPr>
+        <p:spPr>
+          <a:xfrm>
+            <a:off x="3779520" y="2171700"/>
+            <a:ext cx="137160" cy="137160"/>
+          </a:xfrm>
+          <a:prstGeom prst="ellipse">
+            <a:avLst/>
+          </a:prstGeom>
+          <a:solidFill>
+            <a:srgbClr val="2E5A8F"/>
+          </a:solidFill>
+          <a:ln>
+            <a:noFill/>
+          </a:ln>
+          <a:effectLst/>
+        </p:spPr>
+        <p:style>
+          <a:lnRef idx="1">
+            <a:schemeClr val="accent1"/>
+          </a:lnRef>
+          <a:fillRef idx="3">
+            <a:schemeClr val="accent1"/>
+          </a:fillRef>
+          <a:effectRef idx="2">
+            <a:schemeClr val="accent1"/>
+          </a:effectRef>
+          <a:fontRef idx="minor">
+            <a:schemeClr val="lt1"/>
+          </a:fontRef>
+        </p:style>
+        <p:txBody>
+          <a:bodyPr rtlCol="0" anchor="ctr"/>
+          <a:lstStyle/>
+          <a:p>
+            <a:pPr algn="ctr"/>
+          </a:p>
+        </p:txBody>
+      </p:sp>
+      <p:sp>
+        <p:nvSpPr>
+          <p:cNvPr id="18" name="Rounded Rectangle 17"/>
+          <p:cNvSpPr/>
+          <p:nvPr/>
+        </p:nvSpPr>
+        <p:spPr>
+          <a:xfrm>
+            <a:off x="2781300" y="2438400"/>
+            <a:ext cx="2133600" cy="609600"/>
+          </a:xfrm>
+          <a:prstGeom prst="roundRect">
+            <a:avLst>
+              <a:gd name="adj" fmla="val 8000"/>
+            </a:avLst>
+          </a:prstGeom>
+          <a:solidFill>
+            <a:srgbClr val="2E5A8F"/>
+          </a:solidFill>
+          <a:ln>
+            <a:noFill/>
+          </a:ln>
+          <a:effectLst/>
+        </p:spPr>
+        <p:style>
+          <a:lnRef idx="1">
+            <a:schemeClr val="accent1"/>
+          </a:lnRef>
+          <a:fillRef idx="3">
+            <a:schemeClr val="accent1"/>
+          </a:fillRef>
+          <a:effectRef idx="2">
+            <a:schemeClr val="accent1"/>
+          </a:effectRef>
+          <a:fontRef idx="minor">
+            <a:schemeClr val="lt1"/>
+          </a:fontRef>
+        </p:style>
+        <p:txBody>
+          <a:bodyPr rtlCol="0" anchor="ctr"/>
+          <a:lstStyle/>
+          <a:p>
+            <a:pPr algn="ctr"/>
+          </a:p>
+        </p:txBody>
+      </p:sp>
+      <p:sp>
+        <p:nvSpPr>
+          <p:cNvPr id="19" name="TextBox 18"/>
+          <p:cNvSpPr txBox="1"/>
+          <p:nvPr/>
+        </p:nvSpPr>
+        <p:spPr>
+          <a:xfrm>
+            <a:off x="2781300" y="2438400"/>
+            <a:ext cx="2133600" cy="609600"/>
+          </a:xfrm>
+          <a:prstGeom prst="rect">
+            <a:avLst/>
+          </a:prstGeom>
+          <a:noFill/>
+          <a:ln>
+            <a:noFill/>
+          </a:ln>
+        </p:spPr>
+        <p:txBody>
+          <a:bodyPr wrap="square" anchor="ctr" lIns="45000" rIns="45000" tIns="15000" bIns="15000">
+            <a:spAutoFit/>
+          </a:bodyPr>
+          <a:lstStyle/>
+          <a:p>
+            <a:pPr algn="ctr"/>
+            <a:r>
+              <a:rPr sz="950" b="1" i="0">
+                <a:solidFill>
+                  <a:srgbClr val="FFFFFF"/>
+                </a:solidFill>
+                <a:latin typeface="Calibri"/>
+              </a:rPr>
+              <a:t>PHASE 1</a:t>
+            </a:r>
+          </a:p>
+          <a:p>
+            <a:pPr algn="ctr"/>
+            <a:r>
+              <a:rPr sz="800" b="0" i="0">
+                <a:solidFill>
+                  <a:srgbClr val="FFFFFF"/>
+                </a:solidFill>
+                <a:latin typeface="Calibri"/>
+              </a:rPr>
+              <a:t>M 1–3</a:t>
+            </a:r>
+          </a:p>
+        </p:txBody>
+      </p:sp>
+      <p:sp>
+        <p:nvSpPr>
+          <p:cNvPr id="20" name="Rounded Rectangle 19"/>
+          <p:cNvSpPr/>
+          <p:nvPr/>
+        </p:nvSpPr>
+        <p:spPr>
+          <a:xfrm>
+            <a:off x="2781300" y="3124200"/>
+            <a:ext cx="2133600" cy="2819400"/>
+          </a:xfrm>
+          <a:prstGeom prst="roundRect">
+            <a:avLst>
+              <a:gd name="adj" fmla="val 8000"/>
+            </a:avLst>
+          </a:prstGeom>
+          <a:solidFill>
+            <a:srgbClr val="FFFFFF"/>
+          </a:solidFill>
+          <a:ln w="10160">
+            <a:solidFill>
+              <a:srgbClr val="D1D5DB"/>
+            </a:solidFill>
+          </a:ln>
+          <a:effectLst/>
+        </p:spPr>
+        <p:style>
+          <a:lnRef idx="1">
+            <a:schemeClr val="accent1"/>
+          </a:lnRef>
+          <a:fillRef idx="3">
+            <a:schemeClr val="accent1"/>
+          </a:fillRef>
+          <a:effectRef idx="2">
+            <a:schemeClr val="accent1"/>
+          </a:effectRef>
+          <a:fontRef idx="minor">
+            <a:schemeClr val="lt1"/>
+          </a:fontRef>
+        </p:style>
+        <p:txBody>
+          <a:bodyPr rtlCol="0" anchor="ctr"/>
+          <a:lstStyle/>
+          <a:p>
+            <a:pPr algn="ctr"/>
+          </a:p>
+        </p:txBody>
+      </p:sp>
+      <p:sp>
+        <p:nvSpPr>
+          <p:cNvPr id="21" name="TextBox 20"/>
+          <p:cNvSpPr txBox="1"/>
+          <p:nvPr/>
+        </p:nvSpPr>
+        <p:spPr>
+          <a:xfrm>
+            <a:off x="2872740" y="3200400"/>
+            <a:ext cx="1950720" cy="304800"/>
+          </a:xfrm>
+          <a:prstGeom prst="rect">
+            <a:avLst/>
+          </a:prstGeom>
+          <a:noFill/>
+          <a:ln>
+            <a:noFill/>
+          </a:ln>
+        </p:spPr>
+        <p:txBody>
+          <a:bodyPr wrap="square" anchor="t" lIns="45000" rIns="45000" tIns="15000" bIns="15000">
+            <a:spAutoFit/>
+          </a:bodyPr>
+          <a:lstStyle/>
+          <a:p>
+            <a:pPr algn="l">
+              <a:lnSpc>
+                <a:spcPct val="100000"/>
+              </a:lnSpc>
+            </a:pPr>
+            <a:r>
+              <a:rPr sz="1000" b="1" i="0">
+                <a:solidFill>
+                  <a:srgbClr val="2E5A8F"/>
+                </a:solidFill>
+                <a:latin typeface="Calibri"/>
+              </a:rPr>
+              <a:t>Foundation</a:t>
+            </a:r>
+          </a:p>
+        </p:txBody>
+      </p:sp>
+      <p:sp>
+        <p:nvSpPr>
+          <p:cNvPr id="22" name="TextBox 21"/>
+          <p:cNvSpPr txBox="1"/>
+          <p:nvPr/>
+        </p:nvSpPr>
+        <p:spPr>
+          <a:xfrm>
+            <a:off x="2872740" y="3543300"/>
+            <a:ext cx="1950720" cy="2362200"/>
+          </a:xfrm>
+          <a:prstGeom prst="rect">
+            <a:avLst/>
+          </a:prstGeom>
+          <a:noFill/>
+          <a:ln>
+            <a:noFill/>
+          </a:ln>
+        </p:spPr>
+        <p:txBody>
+          <a:bodyPr wrap="square" anchor="t" lIns="45000" rIns="45000" tIns="15000" bIns="15000">
+            <a:spAutoFit/>
+          </a:bodyPr>
+          <a:lstStyle/>
+          <a:p>
+            <a:pPr algn="l">
+              <a:lnSpc>
+                <a:spcPct val="103000"/>
+              </a:lnSpc>
+              <a:spcAft>
+                <a:spcPts val="300"/>
+              </a:spcAft>
+            </a:pPr>
+            <a:r>
+              <a:rPr sz="800" b="0" i="0">
+                <a:solidFill>
+                  <a:srgbClr val="4B5563"/>
+                </a:solidFill>
+                <a:latin typeface="Calibri"/>
+              </a:rPr>
+              <a:t>•  ITSM-Prozesse auf ServiceNow harmonisieren</a:t>
+            </a:r>
+          </a:p>
+          <a:p>
+            <a:pPr algn="l">
+              <a:lnSpc>
+                <a:spcPct val="103000"/>
+              </a:lnSpc>
+              <a:spcAft>
+                <a:spcPts val="300"/>
+              </a:spcAft>
+            </a:pPr>
+            <a:r>
+              <a:rPr sz="800" b="0" i="0">
+                <a:solidFill>
+                  <a:srgbClr val="4B5563"/>
+                </a:solidFill>
+                <a:latin typeface="Calibri"/>
+              </a:rPr>
+              <a:t>•  Practice Supplier Mgmt stärken (SLA/KPI/Stammdaten)</a:t>
+            </a:r>
+          </a:p>
+          <a:p>
+            <a:pPr algn="l">
+              <a:lnSpc>
+                <a:spcPct val="103000"/>
+              </a:lnSpc>
+              <a:spcAft>
+                <a:spcPts val="300"/>
+              </a:spcAft>
+            </a:pPr>
+            <a:r>
+              <a:rPr sz="800" b="0" i="0">
+                <a:solidFill>
+                  <a:srgbClr val="4B5563"/>
+                </a:solidFill>
+                <a:latin typeface="Calibri"/>
+              </a:rPr>
+              <a:t>•  Service-Kataster: Einheiten &amp; Provider je Service mappen</a:t>
+            </a:r>
+          </a:p>
+        </p:txBody>
+      </p:sp>
+      <p:sp>
+        <p:nvSpPr>
+          <p:cNvPr id="23" name="Oval 22"/>
+          <p:cNvSpPr/>
+          <p:nvPr/>
+        </p:nvSpPr>
+        <p:spPr>
+          <a:xfrm>
+            <a:off x="6027420" y="2171700"/>
+            <a:ext cx="137160" cy="137160"/>
+          </a:xfrm>
+          <a:prstGeom prst="ellipse">
+            <a:avLst/>
+          </a:prstGeom>
+          <a:solidFill>
+            <a:srgbClr val="F07F12"/>
+          </a:solidFill>
+          <a:ln>
+            <a:noFill/>
+          </a:ln>
+          <a:effectLst/>
+        </p:spPr>
+        <p:style>
+          <a:lnRef idx="1">
+            <a:schemeClr val="accent1"/>
+          </a:lnRef>
+          <a:fillRef idx="3">
+            <a:schemeClr val="accent1"/>
+          </a:fillRef>
+          <a:effectRef idx="2">
+            <a:schemeClr val="accent1"/>
+          </a:effectRef>
+          <a:fontRef idx="minor">
+            <a:schemeClr val="lt1"/>
+          </a:fontRef>
+        </p:style>
+        <p:txBody>
+          <a:bodyPr rtlCol="0" anchor="ctr"/>
+          <a:lstStyle/>
+          <a:p>
+            <a:pPr algn="ctr"/>
+          </a:p>
+        </p:txBody>
+      </p:sp>
+      <p:sp>
+        <p:nvSpPr>
+          <p:cNvPr id="24" name="Rounded Rectangle 23"/>
+          <p:cNvSpPr/>
+          <p:nvPr/>
+        </p:nvSpPr>
+        <p:spPr>
+          <a:xfrm>
+            <a:off x="5029200" y="2438400"/>
+            <a:ext cx="2133600" cy="609600"/>
+          </a:xfrm>
+          <a:prstGeom prst="roundRect">
+            <a:avLst>
+              <a:gd name="adj" fmla="val 8000"/>
+            </a:avLst>
+          </a:prstGeom>
+          <a:solidFill>
+            <a:srgbClr val="F07F12"/>
+          </a:solidFill>
+          <a:ln>
+            <a:noFill/>
+          </a:ln>
+          <a:effectLst/>
+        </p:spPr>
+        <p:style>
+          <a:lnRef idx="1">
+            <a:schemeClr val="accent1"/>
+          </a:lnRef>
+          <a:fillRef idx="3">
+            <a:schemeClr val="accent1"/>
+          </a:fillRef>
+          <a:effectRef idx="2">
+            <a:schemeClr val="accent1"/>
+          </a:effectRef>
+          <a:fontRef idx="minor">
+            <a:schemeClr val="lt1"/>
+          </a:fontRef>
+        </p:style>
+        <p:txBody>
+          <a:bodyPr rtlCol="0" anchor="ctr"/>
+          <a:lstStyle/>
+          <a:p>
+            <a:pPr algn="ctr"/>
+          </a:p>
+        </p:txBody>
+      </p:sp>
+      <p:sp>
+        <p:nvSpPr>
+          <p:cNvPr id="25" name="TextBox 24"/>
+          <p:cNvSpPr txBox="1"/>
+          <p:nvPr/>
+        </p:nvSpPr>
+        <p:spPr>
+          <a:xfrm>
+            <a:off x="5029200" y="2438400"/>
+            <a:ext cx="2133600" cy="609600"/>
+          </a:xfrm>
+          <a:prstGeom prst="rect">
+            <a:avLst/>
+          </a:prstGeom>
+          <a:noFill/>
+          <a:ln>
+            <a:noFill/>
+          </a:ln>
+        </p:spPr>
+        <p:txBody>
+          <a:bodyPr wrap="square" anchor="ctr" lIns="45000" rIns="45000" tIns="15000" bIns="15000">
+            <a:spAutoFit/>
+          </a:bodyPr>
+          <a:lstStyle/>
+          <a:p>
+            <a:pPr algn="ctr"/>
+            <a:r>
+              <a:rPr sz="950" b="1" i="0">
+                <a:solidFill>
+                  <a:srgbClr val="FFFFFF"/>
+                </a:solidFill>
+                <a:latin typeface="Calibri"/>
+              </a:rPr>
+              <a:t>PHASE 2</a:t>
+            </a:r>
+          </a:p>
+          <a:p>
+            <a:pPr algn="ctr"/>
+            <a:r>
+              <a:rPr sz="800" b="0" i="0">
+                <a:solidFill>
+                  <a:srgbClr val="FFFFFF"/>
+                </a:solidFill>
+                <a:latin typeface="Calibri"/>
+              </a:rPr>
+              <a:t>M 3–6</a:t>
+            </a:r>
+          </a:p>
+        </p:txBody>
+      </p:sp>
+      <p:sp>
+        <p:nvSpPr>
+          <p:cNvPr id="26" name="Rounded Rectangle 25"/>
+          <p:cNvSpPr/>
+          <p:nvPr/>
+        </p:nvSpPr>
+        <p:spPr>
+          <a:xfrm>
+            <a:off x="5029200" y="3124200"/>
+            <a:ext cx="2133600" cy="2819400"/>
+          </a:xfrm>
+          <a:prstGeom prst="roundRect">
+            <a:avLst>
+              <a:gd name="adj" fmla="val 8000"/>
+            </a:avLst>
+          </a:prstGeom>
+          <a:solidFill>
+            <a:srgbClr val="FFFFFF"/>
+          </a:solidFill>
+          <a:ln w="10160">
+            <a:solidFill>
+              <a:srgbClr val="D1D5DB"/>
+            </a:solidFill>
+          </a:ln>
+          <a:effectLst/>
+        </p:spPr>
+        <p:style>
+          <a:lnRef idx="1">
+            <a:schemeClr val="accent1"/>
+          </a:lnRef>
+          <a:fillRef idx="3">
+            <a:schemeClr val="accent1"/>
+          </a:fillRef>
+          <a:effectRef idx="2">
+            <a:schemeClr val="accent1"/>
+          </a:effectRef>
+          <a:fontRef idx="minor">
+            <a:schemeClr val="lt1"/>
+          </a:fontRef>
+        </p:style>
+        <p:txBody>
+          <a:bodyPr rtlCol="0" anchor="ctr"/>
+          <a:lstStyle/>
+          <a:p>
+            <a:pPr algn="ctr"/>
+          </a:p>
+        </p:txBody>
+      </p:sp>
+      <p:sp>
+        <p:nvSpPr>
+          <p:cNvPr id="27" name="TextBox 26"/>
+          <p:cNvSpPr txBox="1"/>
+          <p:nvPr/>
+        </p:nvSpPr>
+        <p:spPr>
+          <a:xfrm>
+            <a:off x="5120640" y="3200400"/>
+            <a:ext cx="1950720" cy="304800"/>
+          </a:xfrm>
+          <a:prstGeom prst="rect">
+            <a:avLst/>
+          </a:prstGeom>
+          <a:noFill/>
+          <a:ln>
+            <a:noFill/>
+          </a:ln>
+        </p:spPr>
+        <p:txBody>
+          <a:bodyPr wrap="square" anchor="t" lIns="45000" rIns="45000" tIns="15000" bIns="15000">
+            <a:spAutoFit/>
+          </a:bodyPr>
+          <a:lstStyle/>
+          <a:p>
+            <a:pPr algn="l">
+              <a:lnSpc>
+                <a:spcPct val="100000"/>
+              </a:lnSpc>
+            </a:pPr>
+            <a:r>
+              <a:rPr sz="1000" b="1" i="0">
+                <a:solidFill>
+                  <a:srgbClr val="F07F12"/>
+                </a:solidFill>
+                <a:latin typeface="Calibri"/>
+              </a:rPr>
+              <a:t>Pilot</a:t>
+            </a:r>
+          </a:p>
+        </p:txBody>
+      </p:sp>
+      <p:sp>
+        <p:nvSpPr>
+          <p:cNvPr id="28" name="TextBox 27"/>
+          <p:cNvSpPr txBox="1"/>
+          <p:nvPr/>
+        </p:nvSpPr>
+        <p:spPr>
+          <a:xfrm>
+            <a:off x="5120640" y="3543300"/>
+            <a:ext cx="1950720" cy="2362200"/>
+          </a:xfrm>
+          <a:prstGeom prst="rect">
+            <a:avLst/>
+          </a:prstGeom>
+          <a:noFill/>
+          <a:ln>
+            <a:noFill/>
+          </a:ln>
+        </p:spPr>
+        <p:txBody>
+          <a:bodyPr wrap="square" anchor="t" lIns="45000" rIns="45000" tIns="15000" bIns="15000">
+            <a:spAutoFit/>
+          </a:bodyPr>
+          <a:lstStyle/>
+          <a:p>
+            <a:pPr algn="l">
+              <a:lnSpc>
+                <a:spcPct val="103000"/>
+              </a:lnSpc>
+              <a:spcAft>
+                <a:spcPts val="300"/>
+              </a:spcAft>
+            </a:pPr>
+            <a:r>
+              <a:rPr sz="800" b="0" i="0">
+                <a:solidFill>
+                  <a:srgbClr val="4B5563"/>
+                </a:solidFill>
+                <a:latin typeface="Calibri"/>
+              </a:rPr>
+              <a:t>•  1 Pilot-Cluster (z. B. SAP: DXC + TSS + Desk)</a:t>
+            </a:r>
+          </a:p>
+          <a:p>
+            <a:pPr algn="l">
+              <a:lnSpc>
+                <a:spcPct val="103000"/>
+              </a:lnSpc>
+              <a:spcAft>
+                <a:spcPts val="300"/>
+              </a:spcAft>
+            </a:pPr>
+            <a:r>
+              <a:rPr sz="800" b="0" i="0">
+                <a:solidFill>
+                  <a:srgbClr val="4B5563"/>
+                </a:solidFill>
+                <a:latin typeface="Calibri"/>
+              </a:rPr>
+              <a:t>•  SDM besetzen, OLAs/UCs schließen</a:t>
+            </a:r>
+          </a:p>
+          <a:p>
+            <a:pPr algn="l">
+              <a:lnSpc>
+                <a:spcPct val="103000"/>
+              </a:lnSpc>
+              <a:spcAft>
+                <a:spcPts val="300"/>
+              </a:spcAft>
+            </a:pPr>
+            <a:r>
+              <a:rPr sz="800" b="0" i="0">
+                <a:solidFill>
+                  <a:srgbClr val="4B5563"/>
+                </a:solidFill>
+                <a:latin typeface="Calibri"/>
+              </a:rPr>
+              <a:t>•  Service Operations Review starten</a:t>
+            </a:r>
+          </a:p>
+          <a:p>
+            <a:pPr algn="l">
+              <a:lnSpc>
+                <a:spcPct val="103000"/>
+              </a:lnSpc>
+              <a:spcAft>
+                <a:spcPts val="300"/>
+              </a:spcAft>
+            </a:pPr>
+            <a:r>
+              <a:rPr sz="800" b="0" i="0">
+                <a:solidFill>
+                  <a:srgbClr val="4B5563"/>
+                </a:solidFill>
+                <a:latin typeface="Calibri"/>
+              </a:rPr>
+              <a:t>•  E2E-SLA messen · Lessons Learned</a:t>
+            </a:r>
+          </a:p>
+        </p:txBody>
+      </p:sp>
+      <p:sp>
+        <p:nvSpPr>
+          <p:cNvPr id="29" name="Oval 28"/>
+          <p:cNvSpPr/>
+          <p:nvPr/>
+        </p:nvSpPr>
+        <p:spPr>
+          <a:xfrm>
+            <a:off x="8275320" y="2171700"/>
+            <a:ext cx="137160" cy="137160"/>
+          </a:xfrm>
+          <a:prstGeom prst="ellipse">
+            <a:avLst/>
+          </a:prstGeom>
+          <a:solidFill>
+            <a:srgbClr val="6B4FA0"/>
+          </a:solidFill>
+          <a:ln>
+            <a:noFill/>
+          </a:ln>
+          <a:effectLst/>
+        </p:spPr>
+        <p:style>
+          <a:lnRef idx="1">
+            <a:schemeClr val="accent1"/>
+          </a:lnRef>
+          <a:fillRef idx="3">
+            <a:schemeClr val="accent1"/>
+          </a:fillRef>
+          <a:effectRef idx="2">
+            <a:schemeClr val="accent1"/>
+          </a:effectRef>
+          <a:fontRef idx="minor">
+            <a:schemeClr val="lt1"/>
+          </a:fontRef>
+        </p:style>
+        <p:txBody>
+          <a:bodyPr rtlCol="0" anchor="ctr"/>
+          <a:lstStyle/>
+          <a:p>
+            <a:pPr algn="ctr"/>
+          </a:p>
+        </p:txBody>
+      </p:sp>
+      <p:sp>
+        <p:nvSpPr>
+          <p:cNvPr id="30" name="Rounded Rectangle 29"/>
+          <p:cNvSpPr/>
+          <p:nvPr/>
+        </p:nvSpPr>
+        <p:spPr>
+          <a:xfrm>
+            <a:off x="7277100" y="2438400"/>
+            <a:ext cx="2133600" cy="609600"/>
+          </a:xfrm>
+          <a:prstGeom prst="roundRect">
+            <a:avLst>
+              <a:gd name="adj" fmla="val 8000"/>
+            </a:avLst>
+          </a:prstGeom>
+          <a:solidFill>
+            <a:srgbClr val="6B4FA0"/>
+          </a:solidFill>
+          <a:ln>
+            <a:noFill/>
+          </a:ln>
+          <a:effectLst/>
+        </p:spPr>
+        <p:style>
+          <a:lnRef idx="1">
+            <a:schemeClr val="accent1"/>
+          </a:lnRef>
+          <a:fillRef idx="3">
+            <a:schemeClr val="accent1"/>
+          </a:fillRef>
+          <a:effectRef idx="2">
+            <a:schemeClr val="accent1"/>
+          </a:effectRef>
+          <a:fontRef idx="minor">
+            <a:schemeClr val="lt1"/>
+          </a:fontRef>
+        </p:style>
+        <p:txBody>
+          <a:bodyPr rtlCol="0" anchor="ctr"/>
+          <a:lstStyle/>
+          <a:p>
+            <a:pPr algn="ctr"/>
+          </a:p>
+        </p:txBody>
+      </p:sp>
+      <p:sp>
+        <p:nvSpPr>
+          <p:cNvPr id="31" name="TextBox 30"/>
+          <p:cNvSpPr txBox="1"/>
+          <p:nvPr/>
+        </p:nvSpPr>
+        <p:spPr>
+          <a:xfrm>
+            <a:off x="7277100" y="2438400"/>
+            <a:ext cx="2133600" cy="609600"/>
+          </a:xfrm>
+          <a:prstGeom prst="rect">
+            <a:avLst/>
+          </a:prstGeom>
+          <a:noFill/>
+          <a:ln>
+            <a:noFill/>
+          </a:ln>
+        </p:spPr>
+        <p:txBody>
+          <a:bodyPr wrap="square" anchor="ctr" lIns="45000" rIns="45000" tIns="15000" bIns="15000">
+            <a:spAutoFit/>
+          </a:bodyPr>
+          <a:lstStyle/>
+          <a:p>
+            <a:pPr algn="ctr"/>
+            <a:r>
+              <a:rPr sz="950" b="1" i="0">
+                <a:solidFill>
+                  <a:srgbClr val="FFFFFF"/>
+                </a:solidFill>
+                <a:latin typeface="Calibri"/>
+              </a:rPr>
+              <a:t>PHASE 3</a:t>
+            </a:r>
+          </a:p>
+          <a:p>
+            <a:pPr algn="ctr"/>
+            <a:r>
+              <a:rPr sz="800" b="0" i="0">
+                <a:solidFill>
+                  <a:srgbClr val="FFFFFF"/>
+                </a:solidFill>
+                <a:latin typeface="Calibri"/>
+              </a:rPr>
+              <a:t>M 6–12</a:t>
+            </a:r>
+          </a:p>
+        </p:txBody>
+      </p:sp>
+      <p:sp>
+        <p:nvSpPr>
+          <p:cNvPr id="32" name="Rounded Rectangle 31"/>
+          <p:cNvSpPr/>
+          <p:nvPr/>
+        </p:nvSpPr>
+        <p:spPr>
+          <a:xfrm>
+            <a:off x="7277100" y="3124200"/>
+            <a:ext cx="2133600" cy="2819400"/>
+          </a:xfrm>
+          <a:prstGeom prst="roundRect">
+            <a:avLst>
+              <a:gd name="adj" fmla="val 8000"/>
+            </a:avLst>
+          </a:prstGeom>
+          <a:solidFill>
+            <a:srgbClr val="FFFFFF"/>
+          </a:solidFill>
+          <a:ln w="10160">
+            <a:solidFill>
+              <a:srgbClr val="D1D5DB"/>
+            </a:solidFill>
+          </a:ln>
+          <a:effectLst/>
+        </p:spPr>
+        <p:style>
+          <a:lnRef idx="1">
+            <a:schemeClr val="accent1"/>
+          </a:lnRef>
+          <a:fillRef idx="3">
+            <a:schemeClr val="accent1"/>
+          </a:fillRef>
+          <a:effectRef idx="2">
+            <a:schemeClr val="accent1"/>
+          </a:effectRef>
+          <a:fontRef idx="minor">
+            <a:schemeClr val="lt1"/>
+          </a:fontRef>
+        </p:style>
+        <p:txBody>
+          <a:bodyPr rtlCol="0" anchor="ctr"/>
+          <a:lstStyle/>
+          <a:p>
+            <a:pPr algn="ctr"/>
+          </a:p>
+        </p:txBody>
+      </p:sp>
+      <p:sp>
+        <p:nvSpPr>
+          <p:cNvPr id="33" name="TextBox 32"/>
+          <p:cNvSpPr txBox="1"/>
+          <p:nvPr/>
+        </p:nvSpPr>
+        <p:spPr>
+          <a:xfrm>
+            <a:off x="7368540" y="3200400"/>
+            <a:ext cx="1950720" cy="304800"/>
+          </a:xfrm>
+          <a:prstGeom prst="rect">
+            <a:avLst/>
+          </a:prstGeom>
+          <a:noFill/>
+          <a:ln>
+            <a:noFill/>
+          </a:ln>
+        </p:spPr>
+        <p:txBody>
+          <a:bodyPr wrap="square" anchor="t" lIns="45000" rIns="45000" tIns="15000" bIns="15000">
+            <a:spAutoFit/>
+          </a:bodyPr>
+          <a:lstStyle/>
+          <a:p>
+            <a:pPr algn="l">
+              <a:lnSpc>
+                <a:spcPct val="100000"/>
+              </a:lnSpc>
+            </a:pPr>
+            <a:r>
+              <a:rPr sz="1000" b="1" i="0">
+                <a:solidFill>
+                  <a:srgbClr val="6B4FA0"/>
+                </a:solidFill>
+                <a:latin typeface="Calibri"/>
+              </a:rPr>
+              <a:t>Rollout</a:t>
+            </a:r>
+          </a:p>
+        </p:txBody>
+      </p:sp>
+      <p:sp>
+        <p:nvSpPr>
+          <p:cNvPr id="34" name="TextBox 33"/>
+          <p:cNvSpPr txBox="1"/>
+          <p:nvPr/>
+        </p:nvSpPr>
+        <p:spPr>
+          <a:xfrm>
+            <a:off x="7368540" y="3543300"/>
+            <a:ext cx="1950720" cy="2362200"/>
+          </a:xfrm>
+          <a:prstGeom prst="rect">
+            <a:avLst/>
+          </a:prstGeom>
+          <a:noFill/>
+          <a:ln>
+            <a:noFill/>
+          </a:ln>
+        </p:spPr>
+        <p:txBody>
+          <a:bodyPr wrap="square" anchor="t" lIns="45000" rIns="45000" tIns="15000" bIns="15000">
+            <a:spAutoFit/>
+          </a:bodyPr>
+          <a:lstStyle/>
+          <a:p>
+            <a:pPr algn="l">
+              <a:lnSpc>
+                <a:spcPct val="103000"/>
+              </a:lnSpc>
+              <a:spcAft>
+                <a:spcPts val="300"/>
+              </a:spcAft>
+            </a:pPr>
+            <a:r>
+              <a:rPr sz="800" b="0" i="0">
+                <a:solidFill>
+                  <a:srgbClr val="4B5563"/>
+                </a:solidFill>
+                <a:latin typeface="Calibri"/>
+              </a:rPr>
+              <a:t>•  Cluster wellenweise anbinden, SDM-Team aufbauen</a:t>
+            </a:r>
+          </a:p>
+          <a:p>
+            <a:pPr algn="l">
+              <a:lnSpc>
+                <a:spcPct val="103000"/>
+              </a:lnSpc>
+              <a:spcAft>
+                <a:spcPts val="300"/>
+              </a:spcAft>
+            </a:pPr>
+            <a:r>
+              <a:rPr sz="800" b="0" i="0">
+                <a:solidFill>
+                  <a:srgbClr val="4B5563"/>
+                </a:solidFill>
+                <a:latin typeface="Calibri"/>
+              </a:rPr>
+              <a:t>•  Supplier &amp; Operations Board etablieren</a:t>
+            </a:r>
+          </a:p>
+          <a:p>
+            <a:pPr algn="l">
+              <a:lnSpc>
+                <a:spcPct val="103000"/>
+              </a:lnSpc>
+              <a:spcAft>
+                <a:spcPts val="300"/>
+              </a:spcAft>
+            </a:pPr>
+            <a:r>
+              <a:rPr sz="800" b="0" i="0">
+                <a:solidFill>
+                  <a:srgbClr val="4B5563"/>
+                </a:solidFill>
+                <a:latin typeface="Calibri"/>
+              </a:rPr>
+              <a:t>•  Major-Incident-Prozess zentralisieren</a:t>
+            </a:r>
+          </a:p>
+          <a:p>
+            <a:pPr algn="l">
+              <a:lnSpc>
+                <a:spcPct val="103000"/>
+              </a:lnSpc>
+              <a:spcAft>
+                <a:spcPts val="300"/>
+              </a:spcAft>
+            </a:pPr>
+            <a:r>
+              <a:rPr sz="800" b="0" i="0">
+                <a:solidFill>
+                  <a:srgbClr val="4B5563"/>
+                </a:solidFill>
+                <a:latin typeface="Calibri"/>
+              </a:rPr>
+              <a:t>•  Dashboards produktiv</a:t>
+            </a:r>
+          </a:p>
+        </p:txBody>
+      </p:sp>
+      <p:sp>
+        <p:nvSpPr>
+          <p:cNvPr id="35" name="Oval 34"/>
+          <p:cNvSpPr/>
+          <p:nvPr/>
+        </p:nvSpPr>
+        <p:spPr>
+          <a:xfrm>
+            <a:off x="10523220" y="2171700"/>
+            <a:ext cx="137160" cy="137160"/>
+          </a:xfrm>
+          <a:prstGeom prst="ellipse">
+            <a:avLst/>
+          </a:prstGeom>
+          <a:solidFill>
+            <a:srgbClr val="2E7D32"/>
+          </a:solidFill>
+          <a:ln>
+            <a:noFill/>
+          </a:ln>
+          <a:effectLst/>
+        </p:spPr>
+        <p:style>
+          <a:lnRef idx="1">
+            <a:schemeClr val="accent1"/>
+          </a:lnRef>
+          <a:fillRef idx="3">
+            <a:schemeClr val="accent1"/>
+          </a:fillRef>
+          <a:effectRef idx="2">
+            <a:schemeClr val="accent1"/>
+          </a:effectRef>
+          <a:fontRef idx="minor">
+            <a:schemeClr val="lt1"/>
+          </a:fontRef>
+        </p:style>
+        <p:txBody>
+          <a:bodyPr rtlCol="0" anchor="ctr"/>
+          <a:lstStyle/>
+          <a:p>
+            <a:pPr algn="ctr"/>
+          </a:p>
+        </p:txBody>
+      </p:sp>
+      <p:sp>
+        <p:nvSpPr>
+          <p:cNvPr id="36" name="Rounded Rectangle 35"/>
+          <p:cNvSpPr/>
+          <p:nvPr/>
+        </p:nvSpPr>
+        <p:spPr>
+          <a:xfrm>
+            <a:off x="9525000" y="2438400"/>
+            <a:ext cx="2133600" cy="609600"/>
+          </a:xfrm>
+          <a:prstGeom prst="roundRect">
+            <a:avLst>
+              <a:gd name="adj" fmla="val 8000"/>
+            </a:avLst>
+          </a:prstGeom>
+          <a:solidFill>
+            <a:srgbClr val="2E7D32"/>
+          </a:solidFill>
+          <a:ln>
+            <a:noFill/>
+          </a:ln>
+          <a:effectLst/>
+        </p:spPr>
+        <p:style>
+          <a:lnRef idx="1">
+            <a:schemeClr val="accent1"/>
+          </a:lnRef>
+          <a:fillRef idx="3">
+            <a:schemeClr val="accent1"/>
+          </a:fillRef>
+          <a:effectRef idx="2">
+            <a:schemeClr val="accent1"/>
+          </a:effectRef>
+          <a:fontRef idx="minor">
+            <a:schemeClr val="lt1"/>
+          </a:fontRef>
+        </p:style>
+        <p:txBody>
+          <a:bodyPr rtlCol="0" anchor="ctr"/>
+          <a:lstStyle/>
+          <a:p>
+            <a:pPr algn="ctr"/>
+          </a:p>
+        </p:txBody>
+      </p:sp>
+      <p:sp>
+        <p:nvSpPr>
+          <p:cNvPr id="37" name="TextBox 36"/>
+          <p:cNvSpPr txBox="1"/>
+          <p:nvPr/>
+        </p:nvSpPr>
+        <p:spPr>
+          <a:xfrm>
+            <a:off x="9525000" y="2438400"/>
+            <a:ext cx="2133600" cy="609600"/>
+          </a:xfrm>
+          <a:prstGeom prst="rect">
+            <a:avLst/>
+          </a:prstGeom>
+          <a:noFill/>
+          <a:ln>
+            <a:noFill/>
+          </a:ln>
+        </p:spPr>
+        <p:txBody>
+          <a:bodyPr wrap="square" anchor="ctr" lIns="45000" rIns="45000" tIns="15000" bIns="15000">
+            <a:spAutoFit/>
+          </a:bodyPr>
+          <a:lstStyle/>
+          <a:p>
+            <a:pPr algn="ctr"/>
+            <a:r>
+              <a:rPr sz="950" b="1" i="0">
+                <a:solidFill>
+                  <a:srgbClr val="FFFFFF"/>
+                </a:solidFill>
+                <a:latin typeface="Calibri"/>
+              </a:rPr>
+              <a:t>PHASE 4</a:t>
+            </a:r>
+          </a:p>
+          <a:p>
+            <a:pPr algn="ctr"/>
+            <a:r>
+              <a:rPr sz="800" b="0" i="0">
+                <a:solidFill>
+                  <a:srgbClr val="FFFFFF"/>
+                </a:solidFill>
+                <a:latin typeface="Calibri"/>
+              </a:rPr>
+              <a:t>ab M 12</a:t>
+            </a:r>
+          </a:p>
+        </p:txBody>
+      </p:sp>
+      <p:sp>
+        <p:nvSpPr>
+          <p:cNvPr id="38" name="Rounded Rectangle 37"/>
+          <p:cNvSpPr/>
+          <p:nvPr/>
+        </p:nvSpPr>
+        <p:spPr>
+          <a:xfrm>
+            <a:off x="9525000" y="3124200"/>
+            <a:ext cx="2133600" cy="2819400"/>
+          </a:xfrm>
+          <a:prstGeom prst="roundRect">
+            <a:avLst>
+              <a:gd name="adj" fmla="val 8000"/>
+            </a:avLst>
+          </a:prstGeom>
+          <a:solidFill>
+            <a:srgbClr val="FFFFFF"/>
+          </a:solidFill>
+          <a:ln w="10160">
+            <a:solidFill>
+              <a:srgbClr val="D1D5DB"/>
+            </a:solidFill>
+          </a:ln>
+          <a:effectLst/>
+        </p:spPr>
+        <p:style>
+          <a:lnRef idx="1">
+            <a:schemeClr val="accent1"/>
+          </a:lnRef>
+          <a:fillRef idx="3">
+            <a:schemeClr val="accent1"/>
+          </a:fillRef>
+          <a:effectRef idx="2">
+            <a:schemeClr val="accent1"/>
+          </a:effectRef>
+          <a:fontRef idx="minor">
+            <a:schemeClr val="lt1"/>
+          </a:fontRef>
+        </p:style>
+        <p:txBody>
+          <a:bodyPr rtlCol="0" anchor="ctr"/>
+          <a:lstStyle/>
+          <a:p>
+            <a:pPr algn="ctr"/>
+          </a:p>
+        </p:txBody>
+      </p:sp>
+      <p:sp>
+        <p:nvSpPr>
+          <p:cNvPr id="39" name="TextBox 38"/>
+          <p:cNvSpPr txBox="1"/>
+          <p:nvPr/>
+        </p:nvSpPr>
+        <p:spPr>
+          <a:xfrm>
+            <a:off x="9616440" y="3200400"/>
+            <a:ext cx="1950720" cy="304800"/>
+          </a:xfrm>
+          <a:prstGeom prst="rect">
+            <a:avLst/>
+          </a:prstGeom>
+          <a:noFill/>
+          <a:ln>
+            <a:noFill/>
+          </a:ln>
+        </p:spPr>
+        <p:txBody>
+          <a:bodyPr wrap="square" anchor="t" lIns="45000" rIns="45000" tIns="15000" bIns="15000">
+            <a:spAutoFit/>
+          </a:bodyPr>
+          <a:lstStyle/>
+          <a:p>
+            <a:pPr algn="l">
+              <a:lnSpc>
+                <a:spcPct val="100000"/>
+              </a:lnSpc>
+            </a:pPr>
+            <a:r>
+              <a:rPr sz="1000" b="1" i="0">
+                <a:solidFill>
+                  <a:srgbClr val="2E7D32"/>
+                </a:solidFill>
+                <a:latin typeface="Calibri"/>
+              </a:rPr>
+              <a:t>Stabilisierung &amp; CI</a:t>
+            </a:r>
+          </a:p>
+        </p:txBody>
+      </p:sp>
+      <p:sp>
+        <p:nvSpPr>
+          <p:cNvPr id="40" name="TextBox 39"/>
+          <p:cNvSpPr txBox="1"/>
+          <p:nvPr/>
+        </p:nvSpPr>
+        <p:spPr>
+          <a:xfrm>
+            <a:off x="9616440" y="3543300"/>
+            <a:ext cx="1950720" cy="2362200"/>
+          </a:xfrm>
+          <a:prstGeom prst="rect">
+            <a:avLst/>
+          </a:prstGeom>
+          <a:noFill/>
+          <a:ln>
+            <a:noFill/>
+          </a:ln>
+        </p:spPr>
+        <p:txBody>
+          <a:bodyPr wrap="square" anchor="t" lIns="45000" rIns="45000" tIns="15000" bIns="15000">
+            <a:spAutoFit/>
+          </a:bodyPr>
+          <a:lstStyle/>
+          <a:p>
+            <a:pPr algn="l">
+              <a:lnSpc>
+                <a:spcPct val="103000"/>
+              </a:lnSpc>
+              <a:spcAft>
+                <a:spcPts val="300"/>
+              </a:spcAft>
+            </a:pPr>
+            <a:r>
+              <a:rPr sz="800" b="0" i="0">
+                <a:solidFill>
+                  <a:srgbClr val="4B5563"/>
+                </a:solidFill>
+                <a:latin typeface="Calibri"/>
+              </a:rPr>
+              <a:t>•  Betriebsmodell als Standard</a:t>
+            </a:r>
+          </a:p>
+          <a:p>
+            <a:pPr algn="l">
+              <a:lnSpc>
+                <a:spcPct val="103000"/>
+              </a:lnSpc>
+              <a:spcAft>
+                <a:spcPts val="300"/>
+              </a:spcAft>
+            </a:pPr>
+            <a:r>
+              <a:rPr sz="800" b="0" i="0">
+                <a:solidFill>
+                  <a:srgbClr val="4B5563"/>
+                </a:solidFill>
+                <a:latin typeface="Calibri"/>
+              </a:rPr>
+              <a:t>•  KPI-Steuerung</a:t>
+            </a:r>
+          </a:p>
+          <a:p>
+            <a:pPr algn="l">
+              <a:lnSpc>
+                <a:spcPct val="103000"/>
+              </a:lnSpc>
+              <a:spcAft>
+                <a:spcPts val="300"/>
+              </a:spcAft>
+            </a:pPr>
+            <a:r>
+              <a:rPr sz="800" b="0" i="0">
+                <a:solidFill>
+                  <a:srgbClr val="4B5563"/>
+                </a:solidFill>
+                <a:latin typeface="Calibri"/>
+              </a:rPr>
+              <a:t>•  Kontinuierliche Verbesserung</a:t>
+            </a:r>
+          </a:p>
+        </p:txBody>
+      </p:sp>
+      <p:sp>
+        <p:nvSpPr>
+          <p:cNvPr id="41" name="TextBox 40"/>
+          <p:cNvSpPr txBox="1"/>
+          <p:nvPr/>
+        </p:nvSpPr>
+        <p:spPr>
+          <a:xfrm>
+            <a:off x="533400" y="6019800"/>
+            <a:ext cx="11125200" cy="266700"/>
+          </a:xfrm>
+          <a:prstGeom prst="rect">
+            <a:avLst/>
+          </a:prstGeom>
+          <a:noFill/>
+          <a:ln>
+            <a:noFill/>
+          </a:ln>
+        </p:spPr>
+        <p:txBody>
+          <a:bodyPr wrap="square" anchor="t" lIns="45000" rIns="45000" tIns="15000" bIns="15000">
+            <a:spAutoFit/>
+          </a:bodyPr>
+          <a:lstStyle/>
+          <a:p>
+            <a:pPr algn="l"/>
+            <a:r>
+              <a:rPr sz="1100" b="1" i="0">
+                <a:solidFill>
+                  <a:srgbClr val="1F2937"/>
+                </a:solidFill>
+                <a:latin typeface="Calibri"/>
+              </a:rPr>
+              <a:t>Zentrale Risiken &amp; Gegenmaßnahmen</a:t>
+            </a:r>
+          </a:p>
+        </p:txBody>
+      </p:sp>
+      <p:sp>
+        <p:nvSpPr>
+          <p:cNvPr id="42" name="Rounded Rectangle 41"/>
+          <p:cNvSpPr/>
+          <p:nvPr/>
+        </p:nvSpPr>
+        <p:spPr>
+          <a:xfrm>
+            <a:off x="533400" y="6324600"/>
+            <a:ext cx="3604260" cy="365760"/>
+          </a:xfrm>
+          <a:prstGeom prst="roundRect">
+            <a:avLst>
+              <a:gd name="adj" fmla="val 8000"/>
+            </a:avLst>
+          </a:prstGeom>
+          <a:solidFill>
+            <a:srgbClr val="F7F7F7"/>
+          </a:solidFill>
+          <a:ln>
+            <a:noFill/>
+          </a:ln>
+          <a:effectLst/>
+        </p:spPr>
+        <p:style>
+          <a:lnRef idx="1">
+            <a:schemeClr val="accent1"/>
+          </a:lnRef>
+          <a:fillRef idx="3">
+            <a:schemeClr val="accent1"/>
+          </a:fillRef>
+          <a:effectRef idx="2">
+            <a:schemeClr val="accent1"/>
+          </a:effectRef>
+          <a:fontRef idx="minor">
+            <a:schemeClr val="lt1"/>
+          </a:fontRef>
+        </p:style>
+        <p:txBody>
+          <a:bodyPr rtlCol="0" anchor="ctr"/>
+          <a:lstStyle/>
+          <a:p>
+            <a:pPr algn="ctr"/>
+          </a:p>
+        </p:txBody>
+      </p:sp>
+      <p:sp>
+        <p:nvSpPr>
+          <p:cNvPr id="43" name="TextBox 42"/>
+          <p:cNvSpPr txBox="1"/>
+          <p:nvPr/>
+        </p:nvSpPr>
+        <p:spPr>
+          <a:xfrm>
+            <a:off x="624840" y="6332220"/>
+            <a:ext cx="3451860" cy="350520"/>
+          </a:xfrm>
+          <a:prstGeom prst="rect">
+            <a:avLst/>
+          </a:prstGeom>
+          <a:noFill/>
+          <a:ln>
+            <a:noFill/>
+          </a:ln>
+        </p:spPr>
+        <p:txBody>
+          <a:bodyPr wrap="square" anchor="ctr" lIns="45000" rIns="45000" tIns="15000" bIns="15000">
+            <a:spAutoFit/>
+          </a:bodyPr>
+          <a:lstStyle/>
+          <a:p>
+            <a:pPr algn="l">
+              <a:lnSpc>
+                <a:spcPct val="100000"/>
+              </a:lnSpc>
+            </a:pPr>
+            <a:r>
+              <a:rPr sz="780" b="1" i="0">
+                <a:solidFill>
+                  <a:srgbClr val="B91C1C"/>
+                </a:solidFill>
+                <a:latin typeface="Calibri"/>
+              </a:rPr>
+              <a:t>Widerstand der Service Owner (Machtverlust)  </a:t>
+            </a:r>
+            <a:r>
+              <a:rPr sz="780" b="0" i="0">
+                <a:solidFill>
+                  <a:srgbClr val="4B5563"/>
+                </a:solidFill>
+                <a:latin typeface="Calibri"/>
+              </a:rPr>
+              <a:t>→ klare WAS/WIE-Trennung – SO behält Accountability, wird entlastet</a:t>
+            </a:r>
+          </a:p>
+        </p:txBody>
+      </p:sp>
+      <p:sp>
+        <p:nvSpPr>
+          <p:cNvPr id="44" name="Rounded Rectangle 43"/>
+          <p:cNvSpPr/>
+          <p:nvPr/>
+        </p:nvSpPr>
+        <p:spPr>
+          <a:xfrm>
+            <a:off x="4328160" y="6324600"/>
+            <a:ext cx="3604260" cy="365760"/>
+          </a:xfrm>
+          <a:prstGeom prst="roundRect">
+            <a:avLst>
+              <a:gd name="adj" fmla="val 8000"/>
+            </a:avLst>
+          </a:prstGeom>
+          <a:solidFill>
+            <a:srgbClr val="F7F7F7"/>
+          </a:solidFill>
+          <a:ln>
+            <a:noFill/>
+          </a:ln>
+          <a:effectLst/>
+        </p:spPr>
+        <p:style>
+          <a:lnRef idx="1">
+            <a:schemeClr val="accent1"/>
+          </a:lnRef>
+          <a:fillRef idx="3">
+            <a:schemeClr val="accent1"/>
+          </a:fillRef>
+          <a:effectRef idx="2">
+            <a:schemeClr val="accent1"/>
+          </a:effectRef>
+          <a:fontRef idx="minor">
+            <a:schemeClr val="lt1"/>
+          </a:fontRef>
+        </p:style>
+        <p:txBody>
+          <a:bodyPr rtlCol="0" anchor="ctr"/>
+          <a:lstStyle/>
+          <a:p>
+            <a:pPr algn="ctr"/>
+          </a:p>
+        </p:txBody>
+      </p:sp>
+      <p:sp>
+        <p:nvSpPr>
+          <p:cNvPr id="45" name="TextBox 44"/>
+          <p:cNvSpPr txBox="1"/>
+          <p:nvPr/>
+        </p:nvSpPr>
+        <p:spPr>
+          <a:xfrm>
+            <a:off x="4419600" y="6332220"/>
+            <a:ext cx="3451860" cy="350520"/>
+          </a:xfrm>
+          <a:prstGeom prst="rect">
+            <a:avLst/>
+          </a:prstGeom>
+          <a:noFill/>
+          <a:ln>
+            <a:noFill/>
+          </a:ln>
+        </p:spPr>
+        <p:txBody>
+          <a:bodyPr wrap="square" anchor="ctr" lIns="45000" rIns="45000" tIns="15000" bIns="15000">
+            <a:spAutoFit/>
+          </a:bodyPr>
+          <a:lstStyle/>
+          <a:p>
+            <a:pPr algn="l">
+              <a:lnSpc>
+                <a:spcPct val="100000"/>
+              </a:lnSpc>
+            </a:pPr>
+            <a:r>
+              <a:rPr sz="780" b="1" i="0">
+                <a:solidFill>
+                  <a:srgbClr val="B91C1C"/>
+                </a:solidFill>
+                <a:latin typeface="Calibri"/>
+              </a:rPr>
+              <a:t>„SO kennt Service am besten“  </a:t>
+            </a:r>
+            <a:r>
+              <a:rPr sz="780" b="0" i="0">
+                <a:solidFill>
+                  <a:srgbClr val="4B5563"/>
+                </a:solidFill>
+                <a:latin typeface="Calibri"/>
+              </a:rPr>
+              <a:t>→ SDM arbeitet MIT dem SO, Wissenstransfer, SO bleibt fachlicher Sponsor</a:t>
+            </a:r>
+          </a:p>
+        </p:txBody>
+      </p:sp>
+      <p:sp>
+        <p:nvSpPr>
+          <p:cNvPr id="46" name="Rounded Rectangle 45"/>
+          <p:cNvSpPr/>
+          <p:nvPr/>
+        </p:nvSpPr>
+        <p:spPr>
+          <a:xfrm>
+            <a:off x="8122920" y="6324600"/>
+            <a:ext cx="3604260" cy="365760"/>
+          </a:xfrm>
+          <a:prstGeom prst="roundRect">
+            <a:avLst>
+              <a:gd name="adj" fmla="val 8000"/>
+            </a:avLst>
+          </a:prstGeom>
+          <a:solidFill>
+            <a:srgbClr val="F7F7F7"/>
+          </a:solidFill>
+          <a:ln>
+            <a:noFill/>
+          </a:ln>
+          <a:effectLst/>
+        </p:spPr>
+        <p:style>
+          <a:lnRef idx="1">
+            <a:schemeClr val="accent1"/>
+          </a:lnRef>
+          <a:fillRef idx="3">
+            <a:schemeClr val="accent1"/>
+          </a:fillRef>
+          <a:effectRef idx="2">
+            <a:schemeClr val="accent1"/>
+          </a:effectRef>
+          <a:fontRef idx="minor">
+            <a:schemeClr val="lt1"/>
+          </a:fontRef>
+        </p:style>
+        <p:txBody>
+          <a:bodyPr rtlCol="0" anchor="ctr"/>
+          <a:lstStyle/>
+          <a:p>
+            <a:pPr algn="ctr"/>
+          </a:p>
+        </p:txBody>
+      </p:sp>
+      <p:sp>
+        <p:nvSpPr>
+          <p:cNvPr id="47" name="TextBox 46"/>
+          <p:cNvSpPr txBox="1"/>
+          <p:nvPr/>
+        </p:nvSpPr>
+        <p:spPr>
+          <a:xfrm>
+            <a:off x="8214360" y="6332220"/>
+            <a:ext cx="3451860" cy="350520"/>
+          </a:xfrm>
+          <a:prstGeom prst="rect">
+            <a:avLst/>
+          </a:prstGeom>
+          <a:noFill/>
+          <a:ln>
+            <a:noFill/>
+          </a:ln>
+        </p:spPr>
+        <p:txBody>
+          <a:bodyPr wrap="square" anchor="ctr" lIns="45000" rIns="45000" tIns="15000" bIns="15000">
+            <a:spAutoFit/>
+          </a:bodyPr>
+          <a:lstStyle/>
+          <a:p>
+            <a:pPr algn="l">
+              <a:lnSpc>
+                <a:spcPct val="100000"/>
+              </a:lnSpc>
+            </a:pPr>
+            <a:r>
+              <a:rPr sz="780" b="1" i="0">
+                <a:solidFill>
+                  <a:srgbClr val="B91C1C"/>
+                </a:solidFill>
+                <a:latin typeface="Calibri"/>
+              </a:rPr>
+              <a:t>Verträge nicht back-to-back (UC≤OLA≤SLA)  </a:t>
+            </a:r>
+            <a:r>
+              <a:rPr sz="780" b="0" i="0">
+                <a:solidFill>
+                  <a:srgbClr val="4B5563"/>
+                </a:solidFill>
+                <a:latin typeface="Calibri"/>
+              </a:rPr>
+              <a:t>→ Practice Supplier Mgmt priorisiert UC-Anpassung</a:t>
             </a:r>
           </a:p>
         </p:txBody>

</xml_diff>

<commit_message>
Add SDM-Pool-Modell und Verortungsentscheidung zentral vs. verteilt
- SDM ist ein Pool (je Cluster ein SDM), gefuehrt von einem Head of Service
  Delivery im IPS MO; zentral verankert (Solid-Line), dezentral eingesetzt
  (Dotted-Line an die Cluster)
- Begruendung, warum SDMs NICHT in die Liefereinheiten berichten sollten
  (Peer-koordiniert-Peer, Standard-Drift, Silo-Rueckfall)
- Head-of-SDM-Hybrid (zentral + verteilt) bewertet: tragfaehig nur mit
  Solid-Line und zentralem Mandat; Unterscheidung Sitz vs. Berichtslinie

Deck erweitert auf 15 Slides (14: SDM-Pool-Org, 15: zentral vs. verteilt),
Rollenbeschreibung und Markdown Abschnitt 10 ergaenzt.

Co-Authored-By: Claude Opus 4.8 <noreply@anthropic.com>
Claude-Session: https://claude.ai/code/session_01HefpCknsZ9fVeMqj75mAqW
</commit_message>
<xml_diff>
--- a/2026_07_08_IT_Ablauforganisation_Homebase_Mannschaft.pptx
+++ b/2026_07_08_IT_Ablauforganisation_Homebase_Mannschaft.pptx
@@ -18,6 +18,8 @@
     <p:sldId id="266" r:id="rId17"/>
     <p:sldId id="267" r:id="rId18"/>
     <p:sldId id="268" r:id="rId19"/>
+    <p:sldId id="269" r:id="rId20"/>
+    <p:sldId id="270" r:id="rId21"/>
   </p:sldIdLst>
   <p:sldSz cx="12192000" cy="6858000" type="screen4x3"/>
   <p:notesSz cx="6858000" cy="9144000"/>
@@ -12293,6 +12295,3431 @@
                 <a:latin typeface="Calibri"/>
               </a:rPr>
               <a:t>→ Practice Supplier Mgmt priorisiert UC-Anpassung</a:t>
+            </a:r>
+          </a:p>
+        </p:txBody>
+      </p:sp>
+    </p:spTree>
+  </p:cSld>
+  <p:clrMapOvr>
+    <a:masterClrMapping/>
+  </p:clrMapOvr>
+</p:sld>
+</file>
+
+<file path=ppt/slides/slide14.xml><?xml version="1.0" encoding="utf-8"?>
+<p:sld xmlns:a="http://schemas.openxmlformats.org/drawingml/2006/main" xmlns:p="http://schemas.openxmlformats.org/presentationml/2006/main" xmlns:r="http://schemas.openxmlformats.org/officeDocument/2006/relationships">
+  <p:cSld>
+    <p:spTree>
+      <p:nvGrpSpPr>
+        <p:cNvPr id="1" name=""/>
+        <p:cNvGrpSpPr/>
+        <p:nvPr/>
+      </p:nvGrpSpPr>
+      <p:grpSpPr/>
+      <p:sp>
+        <p:nvSpPr>
+          <p:cNvPr id="2" name="Rectangle 1"/>
+          <p:cNvSpPr/>
+          <p:nvPr/>
+        </p:nvSpPr>
+        <p:spPr>
+          <a:xfrm>
+            <a:off x="0" y="0"/>
+            <a:ext cx="12192000" cy="6858000"/>
+          </a:xfrm>
+          <a:prstGeom prst="rect">
+            <a:avLst/>
+          </a:prstGeom>
+          <a:solidFill>
+            <a:srgbClr val="FFFFFF"/>
+          </a:solidFill>
+          <a:ln>
+            <a:noFill/>
+          </a:ln>
+          <a:effectLst/>
+        </p:spPr>
+        <p:style>
+          <a:lnRef idx="1">
+            <a:schemeClr val="accent1"/>
+          </a:lnRef>
+          <a:fillRef idx="3">
+            <a:schemeClr val="accent1"/>
+          </a:fillRef>
+          <a:effectRef idx="2">
+            <a:schemeClr val="accent1"/>
+          </a:effectRef>
+          <a:fontRef idx="minor">
+            <a:schemeClr val="lt1"/>
+          </a:fontRef>
+        </p:style>
+        <p:txBody>
+          <a:bodyPr rtlCol="0" anchor="ctr"/>
+          <a:lstStyle/>
+          <a:p>
+            <a:pPr algn="ctr"/>
+          </a:p>
+        </p:txBody>
+      </p:sp>
+      <p:sp>
+        <p:nvSpPr>
+          <p:cNvPr id="3" name="Rectangle 2"/>
+          <p:cNvSpPr/>
+          <p:nvPr/>
+        </p:nvSpPr>
+        <p:spPr>
+          <a:xfrm>
+            <a:off x="0" y="0"/>
+            <a:ext cx="121920" cy="6858000"/>
+          </a:xfrm>
+          <a:prstGeom prst="rect">
+            <a:avLst/>
+          </a:prstGeom>
+          <a:solidFill>
+            <a:srgbClr val="F07F12"/>
+          </a:solidFill>
+          <a:ln>
+            <a:noFill/>
+          </a:ln>
+          <a:effectLst/>
+        </p:spPr>
+        <p:style>
+          <a:lnRef idx="1">
+            <a:schemeClr val="accent1"/>
+          </a:lnRef>
+          <a:fillRef idx="3">
+            <a:schemeClr val="accent1"/>
+          </a:fillRef>
+          <a:effectRef idx="2">
+            <a:schemeClr val="accent1"/>
+          </a:effectRef>
+          <a:fontRef idx="minor">
+            <a:schemeClr val="lt1"/>
+          </a:fontRef>
+        </p:style>
+        <p:txBody>
+          <a:bodyPr rtlCol="0" anchor="ctr"/>
+          <a:lstStyle/>
+          <a:p>
+            <a:pPr algn="ctr"/>
+          </a:p>
+        </p:txBody>
+      </p:sp>
+      <p:sp>
+        <p:nvSpPr>
+          <p:cNvPr id="4" name="TextBox 3"/>
+          <p:cNvSpPr txBox="1"/>
+          <p:nvPr/>
+        </p:nvSpPr>
+        <p:spPr>
+          <a:xfrm>
+            <a:off x="533400" y="381000"/>
+            <a:ext cx="9906000" cy="304800"/>
+          </a:xfrm>
+          <a:prstGeom prst="rect">
+            <a:avLst/>
+          </a:prstGeom>
+          <a:noFill/>
+          <a:ln>
+            <a:noFill/>
+          </a:ln>
+        </p:spPr>
+        <p:txBody>
+          <a:bodyPr wrap="square" anchor="t" lIns="45000" rIns="45000" tIns="15000" bIns="15000">
+            <a:spAutoFit/>
+          </a:bodyPr>
+          <a:lstStyle/>
+          <a:p>
+            <a:pPr algn="l"/>
+            <a:r>
+              <a:rPr sz="1100" b="1" i="0">
+                <a:solidFill>
+                  <a:srgbClr val="F07F12"/>
+                </a:solidFill>
+                <a:latin typeface="Calibri"/>
+              </a:rPr>
+              <a:t>SDM-VERORTUNG</a:t>
+            </a:r>
+          </a:p>
+        </p:txBody>
+      </p:sp>
+      <p:sp>
+        <p:nvSpPr>
+          <p:cNvPr id="5" name="TextBox 4"/>
+          <p:cNvSpPr txBox="1"/>
+          <p:nvPr/>
+        </p:nvSpPr>
+        <p:spPr>
+          <a:xfrm>
+            <a:off x="533400" y="647700"/>
+            <a:ext cx="11125200" cy="685800"/>
+          </a:xfrm>
+          <a:prstGeom prst="rect">
+            <a:avLst/>
+          </a:prstGeom>
+          <a:noFill/>
+          <a:ln>
+            <a:noFill/>
+          </a:ln>
+        </p:spPr>
+        <p:txBody>
+          <a:bodyPr wrap="square" anchor="t" lIns="45000" rIns="45000" tIns="15000" bIns="15000">
+            <a:spAutoFit/>
+          </a:bodyPr>
+          <a:lstStyle/>
+          <a:p>
+            <a:pPr algn="l"/>
+            <a:r>
+              <a:rPr sz="2400" b="1" i="0">
+                <a:solidFill>
+                  <a:srgbClr val="1F2937"/>
+                </a:solidFill>
+                <a:latin typeface="Calibri"/>
+              </a:rPr>
+              <a:t>Nicht einer, sondern ein Pool — zentral verankert, dezentral eingesetzt</a:t>
+            </a:r>
+          </a:p>
+        </p:txBody>
+      </p:sp>
+      <p:sp>
+        <p:nvSpPr>
+          <p:cNvPr id="6" name="Rectangle 5"/>
+          <p:cNvSpPr/>
+          <p:nvPr/>
+        </p:nvSpPr>
+        <p:spPr>
+          <a:xfrm>
+            <a:off x="533400" y="1333500"/>
+            <a:ext cx="11125200" cy="9144"/>
+          </a:xfrm>
+          <a:prstGeom prst="rect">
+            <a:avLst/>
+          </a:prstGeom>
+          <a:solidFill>
+            <a:srgbClr val="D1D5DB"/>
+          </a:solidFill>
+          <a:ln>
+            <a:noFill/>
+          </a:ln>
+          <a:effectLst/>
+        </p:spPr>
+        <p:style>
+          <a:lnRef idx="1">
+            <a:schemeClr val="accent1"/>
+          </a:lnRef>
+          <a:fillRef idx="3">
+            <a:schemeClr val="accent1"/>
+          </a:fillRef>
+          <a:effectRef idx="2">
+            <a:schemeClr val="accent1"/>
+          </a:effectRef>
+          <a:fontRef idx="minor">
+            <a:schemeClr val="lt1"/>
+          </a:fontRef>
+        </p:style>
+        <p:txBody>
+          <a:bodyPr rtlCol="0" anchor="ctr"/>
+          <a:lstStyle/>
+          <a:p>
+            <a:pPr algn="ctr"/>
+          </a:p>
+        </p:txBody>
+      </p:sp>
+      <p:sp>
+        <p:nvSpPr>
+          <p:cNvPr id="7" name="TextBox 6"/>
+          <p:cNvSpPr txBox="1"/>
+          <p:nvPr/>
+        </p:nvSpPr>
+        <p:spPr>
+          <a:xfrm>
+            <a:off x="11430000" y="6438900"/>
+            <a:ext cx="609600" cy="304800"/>
+          </a:xfrm>
+          <a:prstGeom prst="rect">
+            <a:avLst/>
+          </a:prstGeom>
+          <a:noFill/>
+          <a:ln>
+            <a:noFill/>
+          </a:ln>
+        </p:spPr>
+        <p:txBody>
+          <a:bodyPr wrap="square" anchor="t" lIns="45000" rIns="45000" tIns="15000" bIns="15000">
+            <a:spAutoFit/>
+          </a:bodyPr>
+          <a:lstStyle/>
+          <a:p>
+            <a:pPr algn="r"/>
+            <a:r>
+              <a:rPr sz="1000" b="0" i="0">
+                <a:solidFill>
+                  <a:srgbClr val="D1D5DB"/>
+                </a:solidFill>
+                <a:latin typeface="Calibri"/>
+              </a:rPr>
+              <a:t>14</a:t>
+            </a:r>
+          </a:p>
+        </p:txBody>
+      </p:sp>
+      <p:sp>
+        <p:nvSpPr>
+          <p:cNvPr id="8" name="TextBox 7"/>
+          <p:cNvSpPr txBox="1"/>
+          <p:nvPr/>
+        </p:nvSpPr>
+        <p:spPr>
+          <a:xfrm>
+            <a:off x="533400" y="6438900"/>
+            <a:ext cx="6858000" cy="304800"/>
+          </a:xfrm>
+          <a:prstGeom prst="rect">
+            <a:avLst/>
+          </a:prstGeom>
+          <a:noFill/>
+          <a:ln>
+            <a:noFill/>
+          </a:ln>
+        </p:spPr>
+        <p:txBody>
+          <a:bodyPr wrap="square" anchor="t" lIns="45000" rIns="45000" tIns="15000" bIns="15000">
+            <a:spAutoFit/>
+          </a:bodyPr>
+          <a:lstStyle/>
+          <a:p>
+            <a:pPr algn="l"/>
+            <a:r>
+              <a:rPr sz="900" b="0" i="0">
+                <a:solidFill>
+                  <a:srgbClr val="D1D5DB"/>
+                </a:solidFill>
+                <a:latin typeface="Calibri"/>
+              </a:rPr>
+              <a:t>IT-Ablauforganisation · Zielbild</a:t>
+            </a:r>
+          </a:p>
+        </p:txBody>
+      </p:sp>
+      <p:sp>
+        <p:nvSpPr>
+          <p:cNvPr id="9" name="TextBox 8"/>
+          <p:cNvSpPr txBox="1"/>
+          <p:nvPr/>
+        </p:nvSpPr>
+        <p:spPr>
+          <a:xfrm>
+            <a:off x="533400" y="1470660"/>
+            <a:ext cx="11125200" cy="304800"/>
+          </a:xfrm>
+          <a:prstGeom prst="rect">
+            <a:avLst/>
+          </a:prstGeom>
+          <a:noFill/>
+          <a:ln>
+            <a:noFill/>
+          </a:ln>
+        </p:spPr>
+        <p:txBody>
+          <a:bodyPr wrap="square" anchor="t" lIns="45000" rIns="45000" tIns="15000" bIns="15000">
+            <a:spAutoFit/>
+          </a:bodyPr>
+          <a:lstStyle/>
+          <a:p>
+            <a:pPr algn="l">
+              <a:lnSpc>
+                <a:spcPct val="110000"/>
+              </a:lnSpc>
+            </a:pPr>
+            <a:r>
+              <a:rPr sz="1050" b="0" i="0">
+                <a:solidFill>
+                  <a:srgbClr val="4B5563"/>
+                </a:solidFill>
+                <a:latin typeface="Calibri"/>
+              </a:rPr>
+              <a:t>Je Service-Cluster ein SDM (große Cluster ggf. ein Team). Alle SDMs haben dieselbe Heimat im IPS MO und werden fachlich an die Cluster ausgeliehen.</a:t>
+            </a:r>
+          </a:p>
+        </p:txBody>
+      </p:sp>
+      <p:sp>
+        <p:nvSpPr>
+          <p:cNvPr id="10" name="Rounded Rectangle 9"/>
+          <p:cNvSpPr/>
+          <p:nvPr/>
+        </p:nvSpPr>
+        <p:spPr>
+          <a:xfrm>
+            <a:off x="4267200" y="1905000"/>
+            <a:ext cx="3657600" cy="426720"/>
+          </a:xfrm>
+          <a:prstGeom prst="roundRect">
+            <a:avLst>
+              <a:gd name="adj" fmla="val 8000"/>
+            </a:avLst>
+          </a:prstGeom>
+          <a:solidFill>
+            <a:srgbClr val="2E5A8F"/>
+          </a:solidFill>
+          <a:ln>
+            <a:noFill/>
+          </a:ln>
+          <a:effectLst/>
+        </p:spPr>
+        <p:style>
+          <a:lnRef idx="1">
+            <a:schemeClr val="accent1"/>
+          </a:lnRef>
+          <a:fillRef idx="3">
+            <a:schemeClr val="accent1"/>
+          </a:fillRef>
+          <a:effectRef idx="2">
+            <a:schemeClr val="accent1"/>
+          </a:effectRef>
+          <a:fontRef idx="minor">
+            <a:schemeClr val="lt1"/>
+          </a:fontRef>
+        </p:style>
+        <p:txBody>
+          <a:bodyPr rtlCol="0" anchor="ctr"/>
+          <a:lstStyle/>
+          <a:p>
+            <a:pPr algn="ctr"/>
+          </a:p>
+        </p:txBody>
+      </p:sp>
+      <p:sp>
+        <p:nvSpPr>
+          <p:cNvPr id="11" name="TextBox 10"/>
+          <p:cNvSpPr txBox="1"/>
+          <p:nvPr/>
+        </p:nvSpPr>
+        <p:spPr>
+          <a:xfrm>
+            <a:off x="4267200" y="1905000"/>
+            <a:ext cx="3657600" cy="426720"/>
+          </a:xfrm>
+          <a:prstGeom prst="rect">
+            <a:avLst/>
+          </a:prstGeom>
+          <a:noFill/>
+          <a:ln>
+            <a:noFill/>
+          </a:ln>
+        </p:spPr>
+        <p:txBody>
+          <a:bodyPr wrap="square" anchor="ctr" lIns="45000" rIns="45000" tIns="15000" bIns="15000">
+            <a:spAutoFit/>
+          </a:bodyPr>
+          <a:lstStyle/>
+          <a:p>
+            <a:pPr algn="ctr"/>
+            <a:r>
+              <a:rPr sz="1050" b="1" i="0">
+                <a:solidFill>
+                  <a:srgbClr val="FFFFFF"/>
+                </a:solidFill>
+                <a:latin typeface="Calibri"/>
+              </a:rPr>
+              <a:t>IPS Management Office</a:t>
+            </a:r>
+          </a:p>
+        </p:txBody>
+      </p:sp>
+      <p:cxnSp>
+        <p:nvCxnSpPr>
+          <p:cNvPr id="12" name="Connector 11"/>
+          <p:cNvCxnSpPr/>
+          <p:nvPr/>
+        </p:nvCxnSpPr>
+        <p:spPr>
+          <a:xfrm>
+            <a:off x="6096000" y="2331720"/>
+            <a:ext cx="0" cy="121920"/>
+          </a:xfrm>
+          <a:prstGeom prst="line">
+            <a:avLst/>
+          </a:prstGeom>
+          <a:ln w="15875">
+            <a:solidFill>
+              <a:srgbClr val="D1D5DB"/>
+            </a:solidFill>
+          </a:ln>
+          <a:effectLst/>
+        </p:spPr>
+        <p:style>
+          <a:lnRef idx="2">
+            <a:schemeClr val="accent1"/>
+          </a:lnRef>
+          <a:fillRef idx="0">
+            <a:schemeClr val="accent1"/>
+          </a:fillRef>
+          <a:effectRef idx="1">
+            <a:schemeClr val="accent1"/>
+          </a:effectRef>
+          <a:fontRef idx="minor">
+            <a:schemeClr val="tx1"/>
+          </a:fontRef>
+        </p:style>
+      </p:cxnSp>
+      <p:sp>
+        <p:nvSpPr>
+          <p:cNvPr id="13" name="Rounded Rectangle 12"/>
+          <p:cNvSpPr/>
+          <p:nvPr/>
+        </p:nvSpPr>
+        <p:spPr>
+          <a:xfrm>
+            <a:off x="4267200" y="2453640"/>
+            <a:ext cx="3657600" cy="426720"/>
+          </a:xfrm>
+          <a:prstGeom prst="roundRect">
+            <a:avLst>
+              <a:gd name="adj" fmla="val 8000"/>
+            </a:avLst>
+          </a:prstGeom>
+          <a:solidFill>
+            <a:srgbClr val="2E7D5B"/>
+          </a:solidFill>
+          <a:ln>
+            <a:noFill/>
+          </a:ln>
+          <a:effectLst/>
+        </p:spPr>
+        <p:style>
+          <a:lnRef idx="1">
+            <a:schemeClr val="accent1"/>
+          </a:lnRef>
+          <a:fillRef idx="3">
+            <a:schemeClr val="accent1"/>
+          </a:fillRef>
+          <a:effectRef idx="2">
+            <a:schemeClr val="accent1"/>
+          </a:effectRef>
+          <a:fontRef idx="minor">
+            <a:schemeClr val="lt1"/>
+          </a:fontRef>
+        </p:style>
+        <p:txBody>
+          <a:bodyPr rtlCol="0" anchor="ctr"/>
+          <a:lstStyle/>
+          <a:p>
+            <a:pPr algn="ctr"/>
+          </a:p>
+        </p:txBody>
+      </p:sp>
+      <p:sp>
+        <p:nvSpPr>
+          <p:cNvPr id="14" name="TextBox 13"/>
+          <p:cNvSpPr txBox="1"/>
+          <p:nvPr/>
+        </p:nvSpPr>
+        <p:spPr>
+          <a:xfrm>
+            <a:off x="4267200" y="2453640"/>
+            <a:ext cx="3657600" cy="426720"/>
+          </a:xfrm>
+          <a:prstGeom prst="rect">
+            <a:avLst/>
+          </a:prstGeom>
+          <a:noFill/>
+          <a:ln>
+            <a:noFill/>
+          </a:ln>
+        </p:spPr>
+        <p:txBody>
+          <a:bodyPr wrap="square" anchor="ctr" lIns="45000" rIns="45000" tIns="15000" bIns="15000">
+            <a:spAutoFit/>
+          </a:bodyPr>
+          <a:lstStyle/>
+          <a:p>
+            <a:pPr algn="ctr"/>
+            <a:r>
+              <a:rPr sz="1000" b="1" i="0">
+                <a:solidFill>
+                  <a:srgbClr val="FFFFFF"/>
+                </a:solidFill>
+                <a:latin typeface="Calibri"/>
+              </a:rPr>
+              <a:t>Service Integration &amp; Operations (SIAM)</a:t>
+            </a:r>
+          </a:p>
+        </p:txBody>
+      </p:sp>
+      <p:cxnSp>
+        <p:nvCxnSpPr>
+          <p:cNvPr id="15" name="Connector 14"/>
+          <p:cNvCxnSpPr/>
+          <p:nvPr/>
+        </p:nvCxnSpPr>
+        <p:spPr>
+          <a:xfrm>
+            <a:off x="6096000" y="2880360"/>
+            <a:ext cx="0" cy="121920"/>
+          </a:xfrm>
+          <a:prstGeom prst="line">
+            <a:avLst/>
+          </a:prstGeom>
+          <a:ln w="15875">
+            <a:solidFill>
+              <a:srgbClr val="D1D5DB"/>
+            </a:solidFill>
+          </a:ln>
+          <a:effectLst/>
+        </p:spPr>
+        <p:style>
+          <a:lnRef idx="2">
+            <a:schemeClr val="accent1"/>
+          </a:lnRef>
+          <a:fillRef idx="0">
+            <a:schemeClr val="accent1"/>
+          </a:fillRef>
+          <a:effectRef idx="1">
+            <a:schemeClr val="accent1"/>
+          </a:effectRef>
+          <a:fontRef idx="minor">
+            <a:schemeClr val="tx1"/>
+          </a:fontRef>
+        </p:style>
+      </p:cxnSp>
+      <p:sp>
+        <p:nvSpPr>
+          <p:cNvPr id="16" name="Rounded Rectangle 15"/>
+          <p:cNvSpPr/>
+          <p:nvPr/>
+        </p:nvSpPr>
+        <p:spPr>
+          <a:xfrm>
+            <a:off x="4267200" y="3002280"/>
+            <a:ext cx="3657600" cy="426720"/>
+          </a:xfrm>
+          <a:prstGeom prst="roundRect">
+            <a:avLst>
+              <a:gd name="adj" fmla="val 8000"/>
+            </a:avLst>
+          </a:prstGeom>
+          <a:solidFill>
+            <a:srgbClr val="F07F12"/>
+          </a:solidFill>
+          <a:ln>
+            <a:noFill/>
+          </a:ln>
+          <a:effectLst/>
+        </p:spPr>
+        <p:style>
+          <a:lnRef idx="1">
+            <a:schemeClr val="accent1"/>
+          </a:lnRef>
+          <a:fillRef idx="3">
+            <a:schemeClr val="accent1"/>
+          </a:fillRef>
+          <a:effectRef idx="2">
+            <a:schemeClr val="accent1"/>
+          </a:effectRef>
+          <a:fontRef idx="minor">
+            <a:schemeClr val="lt1"/>
+          </a:fontRef>
+        </p:style>
+        <p:txBody>
+          <a:bodyPr rtlCol="0" anchor="ctr"/>
+          <a:lstStyle/>
+          <a:p>
+            <a:pPr algn="ctr"/>
+          </a:p>
+        </p:txBody>
+      </p:sp>
+      <p:sp>
+        <p:nvSpPr>
+          <p:cNvPr id="17" name="TextBox 16"/>
+          <p:cNvSpPr txBox="1"/>
+          <p:nvPr/>
+        </p:nvSpPr>
+        <p:spPr>
+          <a:xfrm>
+            <a:off x="4267200" y="3002280"/>
+            <a:ext cx="3657600" cy="426720"/>
+          </a:xfrm>
+          <a:prstGeom prst="rect">
+            <a:avLst/>
+          </a:prstGeom>
+          <a:noFill/>
+          <a:ln>
+            <a:noFill/>
+          </a:ln>
+        </p:spPr>
+        <p:txBody>
+          <a:bodyPr wrap="square" anchor="ctr" lIns="45000" rIns="45000" tIns="15000" bIns="15000">
+            <a:spAutoFit/>
+          </a:bodyPr>
+          <a:lstStyle/>
+          <a:p>
+            <a:pPr algn="ctr"/>
+            <a:r>
+              <a:rPr sz="950" b="1" i="0">
+                <a:solidFill>
+                  <a:srgbClr val="FFFFFF"/>
+                </a:solidFill>
+                <a:latin typeface="Calibri"/>
+              </a:rPr>
+              <a:t>Head of Service Delivery (führt den SDM-Pool)</a:t>
+            </a:r>
+          </a:p>
+        </p:txBody>
+      </p:sp>
+      <p:cxnSp>
+        <p:nvCxnSpPr>
+          <p:cNvPr id="18" name="Connector 17"/>
+          <p:cNvCxnSpPr/>
+          <p:nvPr/>
+        </p:nvCxnSpPr>
+        <p:spPr>
+          <a:xfrm flipH="1">
+            <a:off x="1600200" y="3429000"/>
+            <a:ext cx="4495800" cy="381000"/>
+          </a:xfrm>
+          <a:prstGeom prst="line">
+            <a:avLst/>
+          </a:prstGeom>
+          <a:ln w="12700">
+            <a:solidFill>
+              <a:srgbClr val="F07F12"/>
+            </a:solidFill>
+          </a:ln>
+          <a:effectLst/>
+        </p:spPr>
+        <p:style>
+          <a:lnRef idx="2">
+            <a:schemeClr val="accent1"/>
+          </a:lnRef>
+          <a:fillRef idx="0">
+            <a:schemeClr val="accent1"/>
+          </a:fillRef>
+          <a:effectRef idx="1">
+            <a:schemeClr val="accent1"/>
+          </a:effectRef>
+          <a:fontRef idx="minor">
+            <a:schemeClr val="tx1"/>
+          </a:fontRef>
+        </p:style>
+      </p:cxnSp>
+      <p:cxnSp>
+        <p:nvCxnSpPr>
+          <p:cNvPr id="19" name="Connector 18"/>
+          <p:cNvCxnSpPr/>
+          <p:nvPr/>
+        </p:nvCxnSpPr>
+        <p:spPr>
+          <a:xfrm flipH="1">
+            <a:off x="3848100" y="3429000"/>
+            <a:ext cx="2247900" cy="381000"/>
+          </a:xfrm>
+          <a:prstGeom prst="line">
+            <a:avLst/>
+          </a:prstGeom>
+          <a:ln w="12700">
+            <a:solidFill>
+              <a:srgbClr val="F07F12"/>
+            </a:solidFill>
+          </a:ln>
+          <a:effectLst/>
+        </p:spPr>
+        <p:style>
+          <a:lnRef idx="2">
+            <a:schemeClr val="accent1"/>
+          </a:lnRef>
+          <a:fillRef idx="0">
+            <a:schemeClr val="accent1"/>
+          </a:fillRef>
+          <a:effectRef idx="1">
+            <a:schemeClr val="accent1"/>
+          </a:effectRef>
+          <a:fontRef idx="minor">
+            <a:schemeClr val="tx1"/>
+          </a:fontRef>
+        </p:style>
+      </p:cxnSp>
+      <p:cxnSp>
+        <p:nvCxnSpPr>
+          <p:cNvPr id="20" name="Connector 19"/>
+          <p:cNvCxnSpPr/>
+          <p:nvPr/>
+        </p:nvCxnSpPr>
+        <p:spPr>
+          <a:xfrm>
+            <a:off x="6096000" y="3429000"/>
+            <a:ext cx="0" cy="381000"/>
+          </a:xfrm>
+          <a:prstGeom prst="line">
+            <a:avLst/>
+          </a:prstGeom>
+          <a:ln w="12700">
+            <a:solidFill>
+              <a:srgbClr val="F07F12"/>
+            </a:solidFill>
+          </a:ln>
+          <a:effectLst/>
+        </p:spPr>
+        <p:style>
+          <a:lnRef idx="2">
+            <a:schemeClr val="accent1"/>
+          </a:lnRef>
+          <a:fillRef idx="0">
+            <a:schemeClr val="accent1"/>
+          </a:fillRef>
+          <a:effectRef idx="1">
+            <a:schemeClr val="accent1"/>
+          </a:effectRef>
+          <a:fontRef idx="minor">
+            <a:schemeClr val="tx1"/>
+          </a:fontRef>
+        </p:style>
+      </p:cxnSp>
+      <p:cxnSp>
+        <p:nvCxnSpPr>
+          <p:cNvPr id="21" name="Connector 20"/>
+          <p:cNvCxnSpPr/>
+          <p:nvPr/>
+        </p:nvCxnSpPr>
+        <p:spPr>
+          <a:xfrm>
+            <a:off x="6096000" y="3429000"/>
+            <a:ext cx="2247900" cy="381000"/>
+          </a:xfrm>
+          <a:prstGeom prst="line">
+            <a:avLst/>
+          </a:prstGeom>
+          <a:ln w="12700">
+            <a:solidFill>
+              <a:srgbClr val="F07F12"/>
+            </a:solidFill>
+          </a:ln>
+          <a:effectLst/>
+        </p:spPr>
+        <p:style>
+          <a:lnRef idx="2">
+            <a:schemeClr val="accent1"/>
+          </a:lnRef>
+          <a:fillRef idx="0">
+            <a:schemeClr val="accent1"/>
+          </a:fillRef>
+          <a:effectRef idx="1">
+            <a:schemeClr val="accent1"/>
+          </a:effectRef>
+          <a:fontRef idx="minor">
+            <a:schemeClr val="tx1"/>
+          </a:fontRef>
+        </p:style>
+      </p:cxnSp>
+      <p:cxnSp>
+        <p:nvCxnSpPr>
+          <p:cNvPr id="22" name="Connector 21"/>
+          <p:cNvCxnSpPr/>
+          <p:nvPr/>
+        </p:nvCxnSpPr>
+        <p:spPr>
+          <a:xfrm>
+            <a:off x="6096000" y="3429000"/>
+            <a:ext cx="4495800" cy="381000"/>
+          </a:xfrm>
+          <a:prstGeom prst="line">
+            <a:avLst/>
+          </a:prstGeom>
+          <a:ln w="12700">
+            <a:solidFill>
+              <a:srgbClr val="F07F12"/>
+            </a:solidFill>
+          </a:ln>
+          <a:effectLst/>
+        </p:spPr>
+        <p:style>
+          <a:lnRef idx="2">
+            <a:schemeClr val="accent1"/>
+          </a:lnRef>
+          <a:fillRef idx="0">
+            <a:schemeClr val="accent1"/>
+          </a:fillRef>
+          <a:effectRef idx="1">
+            <a:schemeClr val="accent1"/>
+          </a:effectRef>
+          <a:fontRef idx="minor">
+            <a:schemeClr val="tx1"/>
+          </a:fontRef>
+        </p:style>
+      </p:cxnSp>
+      <p:sp>
+        <p:nvSpPr>
+          <p:cNvPr id="23" name="Rounded Rectangle 22"/>
+          <p:cNvSpPr/>
+          <p:nvPr/>
+        </p:nvSpPr>
+        <p:spPr>
+          <a:xfrm>
+            <a:off x="533400" y="3810000"/>
+            <a:ext cx="2133600" cy="495300"/>
+          </a:xfrm>
+          <a:prstGeom prst="roundRect">
+            <a:avLst>
+              <a:gd name="adj" fmla="val 8000"/>
+            </a:avLst>
+          </a:prstGeom>
+          <a:solidFill>
+            <a:srgbClr val="FDE6CC"/>
+          </a:solidFill>
+          <a:ln w="12700">
+            <a:solidFill>
+              <a:srgbClr val="F07F12"/>
+            </a:solidFill>
+          </a:ln>
+          <a:effectLst/>
+        </p:spPr>
+        <p:style>
+          <a:lnRef idx="1">
+            <a:schemeClr val="accent1"/>
+          </a:lnRef>
+          <a:fillRef idx="3">
+            <a:schemeClr val="accent1"/>
+          </a:fillRef>
+          <a:effectRef idx="2">
+            <a:schemeClr val="accent1"/>
+          </a:effectRef>
+          <a:fontRef idx="minor">
+            <a:schemeClr val="lt1"/>
+          </a:fontRef>
+        </p:style>
+        <p:txBody>
+          <a:bodyPr rtlCol="0" anchor="ctr"/>
+          <a:lstStyle/>
+          <a:p>
+            <a:pPr algn="ctr"/>
+          </a:p>
+        </p:txBody>
+      </p:sp>
+      <p:sp>
+        <p:nvSpPr>
+          <p:cNvPr id="24" name="TextBox 23"/>
+          <p:cNvSpPr txBox="1"/>
+          <p:nvPr/>
+        </p:nvSpPr>
+        <p:spPr>
+          <a:xfrm>
+            <a:off x="533400" y="3810000"/>
+            <a:ext cx="2133600" cy="495300"/>
+          </a:xfrm>
+          <a:prstGeom prst="rect">
+            <a:avLst/>
+          </a:prstGeom>
+          <a:noFill/>
+          <a:ln>
+            <a:noFill/>
+          </a:ln>
+        </p:spPr>
+        <p:txBody>
+          <a:bodyPr wrap="square" anchor="ctr" lIns="45000" rIns="45000" tIns="15000" bIns="15000">
+            <a:spAutoFit/>
+          </a:bodyPr>
+          <a:lstStyle/>
+          <a:p>
+            <a:pPr algn="ctr"/>
+            <a:r>
+              <a:rPr sz="880" b="1" i="0">
+                <a:solidFill>
+                  <a:srgbClr val="7A3D05"/>
+                </a:solidFill>
+                <a:latin typeface="Calibri"/>
+              </a:rPr>
+              <a:t>SDM · SAP / BSS</a:t>
+            </a:r>
+          </a:p>
+        </p:txBody>
+      </p:sp>
+      <p:cxnSp>
+        <p:nvCxnSpPr>
+          <p:cNvPr id="25" name="Connector 24"/>
+          <p:cNvCxnSpPr/>
+          <p:nvPr/>
+        </p:nvCxnSpPr>
+        <p:spPr>
+          <a:xfrm>
+            <a:off x="1600200" y="4305300"/>
+            <a:ext cx="0" cy="190500"/>
+          </a:xfrm>
+          <a:prstGeom prst="line">
+            <a:avLst/>
+          </a:prstGeom>
+          <a:ln w="11430">
+            <a:solidFill>
+              <a:srgbClr val="6B4FA0"/>
+            </a:solidFill>
+            <a:prstDash val="dash"/>
+          </a:ln>
+          <a:effectLst/>
+        </p:spPr>
+        <p:style>
+          <a:lnRef idx="2">
+            <a:schemeClr val="accent1"/>
+          </a:lnRef>
+          <a:fillRef idx="0">
+            <a:schemeClr val="accent1"/>
+          </a:fillRef>
+          <a:effectRef idx="1">
+            <a:schemeClr val="accent1"/>
+          </a:effectRef>
+          <a:fontRef idx="minor">
+            <a:schemeClr val="tx1"/>
+          </a:fontRef>
+        </p:style>
+      </p:cxnSp>
+      <p:sp>
+        <p:nvSpPr>
+          <p:cNvPr id="26" name="Rounded Rectangle 25"/>
+          <p:cNvSpPr/>
+          <p:nvPr/>
+        </p:nvSpPr>
+        <p:spPr>
+          <a:xfrm>
+            <a:off x="533400" y="4495800"/>
+            <a:ext cx="2133600" cy="495300"/>
+          </a:xfrm>
+          <a:prstGeom prst="roundRect">
+            <a:avLst>
+              <a:gd name="adj" fmla="val 8000"/>
+            </a:avLst>
+          </a:prstGeom>
+          <a:solidFill>
+            <a:srgbClr val="E4ECF4"/>
+          </a:solidFill>
+          <a:ln w="11430">
+            <a:solidFill>
+              <a:srgbClr val="2E5A8F"/>
+            </a:solidFill>
+          </a:ln>
+          <a:effectLst/>
+        </p:spPr>
+        <p:style>
+          <a:lnRef idx="1">
+            <a:schemeClr val="accent1"/>
+          </a:lnRef>
+          <a:fillRef idx="3">
+            <a:schemeClr val="accent1"/>
+          </a:fillRef>
+          <a:effectRef idx="2">
+            <a:schemeClr val="accent1"/>
+          </a:effectRef>
+          <a:fontRef idx="minor">
+            <a:schemeClr val="lt1"/>
+          </a:fontRef>
+        </p:style>
+        <p:txBody>
+          <a:bodyPr rtlCol="0" anchor="ctr"/>
+          <a:lstStyle/>
+          <a:p>
+            <a:pPr algn="ctr"/>
+          </a:p>
+        </p:txBody>
+      </p:sp>
+      <p:sp>
+        <p:nvSpPr>
+          <p:cNvPr id="27" name="TextBox 26"/>
+          <p:cNvSpPr txBox="1"/>
+          <p:nvPr/>
+        </p:nvSpPr>
+        <p:spPr>
+          <a:xfrm>
+            <a:off x="533400" y="4495800"/>
+            <a:ext cx="2133600" cy="495300"/>
+          </a:xfrm>
+          <a:prstGeom prst="rect">
+            <a:avLst/>
+          </a:prstGeom>
+          <a:noFill/>
+          <a:ln>
+            <a:noFill/>
+          </a:ln>
+        </p:spPr>
+        <p:txBody>
+          <a:bodyPr wrap="square" anchor="ctr" lIns="45000" rIns="45000" tIns="15000" bIns="15000">
+            <a:spAutoFit/>
+          </a:bodyPr>
+          <a:lstStyle/>
+          <a:p>
+            <a:pPr algn="ctr">
+              <a:lnSpc>
+                <a:spcPct val="95000"/>
+              </a:lnSpc>
+            </a:pPr>
+            <a:r>
+              <a:rPr sz="700" b="0" i="0">
+                <a:solidFill>
+                  <a:srgbClr val="2E5A8F"/>
+                </a:solidFill>
+                <a:latin typeface="Calibri"/>
+              </a:rPr>
+              <a:t>Cluster:</a:t>
+            </a:r>
+          </a:p>
+          <a:p>
+            <a:pPr algn="ctr">
+              <a:lnSpc>
+                <a:spcPct val="95000"/>
+              </a:lnSpc>
+            </a:pPr>
+            <a:r>
+              <a:rPr sz="800" b="1" i="0">
+                <a:solidFill>
+                  <a:srgbClr val="1F2937"/>
+                </a:solidFill>
+                <a:latin typeface="Calibri"/>
+              </a:rPr>
+              <a:t>SAP &amp; Business Apps</a:t>
+            </a:r>
+          </a:p>
+        </p:txBody>
+      </p:sp>
+      <p:sp>
+        <p:nvSpPr>
+          <p:cNvPr id="28" name="Rounded Rectangle 27"/>
+          <p:cNvSpPr/>
+          <p:nvPr/>
+        </p:nvSpPr>
+        <p:spPr>
+          <a:xfrm>
+            <a:off x="2781300" y="3810000"/>
+            <a:ext cx="2133600" cy="495300"/>
+          </a:xfrm>
+          <a:prstGeom prst="roundRect">
+            <a:avLst>
+              <a:gd name="adj" fmla="val 8000"/>
+            </a:avLst>
+          </a:prstGeom>
+          <a:solidFill>
+            <a:srgbClr val="FDE6CC"/>
+          </a:solidFill>
+          <a:ln w="12700">
+            <a:solidFill>
+              <a:srgbClr val="F07F12"/>
+            </a:solidFill>
+          </a:ln>
+          <a:effectLst/>
+        </p:spPr>
+        <p:style>
+          <a:lnRef idx="1">
+            <a:schemeClr val="accent1"/>
+          </a:lnRef>
+          <a:fillRef idx="3">
+            <a:schemeClr val="accent1"/>
+          </a:fillRef>
+          <a:effectRef idx="2">
+            <a:schemeClr val="accent1"/>
+          </a:effectRef>
+          <a:fontRef idx="minor">
+            <a:schemeClr val="lt1"/>
+          </a:fontRef>
+        </p:style>
+        <p:txBody>
+          <a:bodyPr rtlCol="0" anchor="ctr"/>
+          <a:lstStyle/>
+          <a:p>
+            <a:pPr algn="ctr"/>
+          </a:p>
+        </p:txBody>
+      </p:sp>
+      <p:sp>
+        <p:nvSpPr>
+          <p:cNvPr id="29" name="TextBox 28"/>
+          <p:cNvSpPr txBox="1"/>
+          <p:nvPr/>
+        </p:nvSpPr>
+        <p:spPr>
+          <a:xfrm>
+            <a:off x="2781300" y="3810000"/>
+            <a:ext cx="2133600" cy="495300"/>
+          </a:xfrm>
+          <a:prstGeom prst="rect">
+            <a:avLst/>
+          </a:prstGeom>
+          <a:noFill/>
+          <a:ln>
+            <a:noFill/>
+          </a:ln>
+        </p:spPr>
+        <p:txBody>
+          <a:bodyPr wrap="square" anchor="ctr" lIns="45000" rIns="45000" tIns="15000" bIns="15000">
+            <a:spAutoFit/>
+          </a:bodyPr>
+          <a:lstStyle/>
+          <a:p>
+            <a:pPr algn="ctr"/>
+            <a:r>
+              <a:rPr sz="880" b="1" i="0">
+                <a:solidFill>
+                  <a:srgbClr val="7A3D05"/>
+                </a:solidFill>
+                <a:latin typeface="Calibri"/>
+              </a:rPr>
+              <a:t>SDM · Workplace</a:t>
+            </a:r>
+          </a:p>
+        </p:txBody>
+      </p:sp>
+      <p:cxnSp>
+        <p:nvCxnSpPr>
+          <p:cNvPr id="30" name="Connector 29"/>
+          <p:cNvCxnSpPr/>
+          <p:nvPr/>
+        </p:nvCxnSpPr>
+        <p:spPr>
+          <a:xfrm>
+            <a:off x="3848100" y="4305300"/>
+            <a:ext cx="0" cy="190500"/>
+          </a:xfrm>
+          <a:prstGeom prst="line">
+            <a:avLst/>
+          </a:prstGeom>
+          <a:ln w="11430">
+            <a:solidFill>
+              <a:srgbClr val="6B4FA0"/>
+            </a:solidFill>
+            <a:prstDash val="dash"/>
+          </a:ln>
+          <a:effectLst/>
+        </p:spPr>
+        <p:style>
+          <a:lnRef idx="2">
+            <a:schemeClr val="accent1"/>
+          </a:lnRef>
+          <a:fillRef idx="0">
+            <a:schemeClr val="accent1"/>
+          </a:fillRef>
+          <a:effectRef idx="1">
+            <a:schemeClr val="accent1"/>
+          </a:effectRef>
+          <a:fontRef idx="minor">
+            <a:schemeClr val="tx1"/>
+          </a:fontRef>
+        </p:style>
+      </p:cxnSp>
+      <p:sp>
+        <p:nvSpPr>
+          <p:cNvPr id="31" name="Rounded Rectangle 30"/>
+          <p:cNvSpPr/>
+          <p:nvPr/>
+        </p:nvSpPr>
+        <p:spPr>
+          <a:xfrm>
+            <a:off x="2781300" y="4495800"/>
+            <a:ext cx="2133600" cy="495300"/>
+          </a:xfrm>
+          <a:prstGeom prst="roundRect">
+            <a:avLst>
+              <a:gd name="adj" fmla="val 8000"/>
+            </a:avLst>
+          </a:prstGeom>
+          <a:solidFill>
+            <a:srgbClr val="E4ECF4"/>
+          </a:solidFill>
+          <a:ln w="11430">
+            <a:solidFill>
+              <a:srgbClr val="2E5A8F"/>
+            </a:solidFill>
+          </a:ln>
+          <a:effectLst/>
+        </p:spPr>
+        <p:style>
+          <a:lnRef idx="1">
+            <a:schemeClr val="accent1"/>
+          </a:lnRef>
+          <a:fillRef idx="3">
+            <a:schemeClr val="accent1"/>
+          </a:fillRef>
+          <a:effectRef idx="2">
+            <a:schemeClr val="accent1"/>
+          </a:effectRef>
+          <a:fontRef idx="minor">
+            <a:schemeClr val="lt1"/>
+          </a:fontRef>
+        </p:style>
+        <p:txBody>
+          <a:bodyPr rtlCol="0" anchor="ctr"/>
+          <a:lstStyle/>
+          <a:p>
+            <a:pPr algn="ctr"/>
+          </a:p>
+        </p:txBody>
+      </p:sp>
+      <p:sp>
+        <p:nvSpPr>
+          <p:cNvPr id="32" name="TextBox 31"/>
+          <p:cNvSpPr txBox="1"/>
+          <p:nvPr/>
+        </p:nvSpPr>
+        <p:spPr>
+          <a:xfrm>
+            <a:off x="2781300" y="4495800"/>
+            <a:ext cx="2133600" cy="495300"/>
+          </a:xfrm>
+          <a:prstGeom prst="rect">
+            <a:avLst/>
+          </a:prstGeom>
+          <a:noFill/>
+          <a:ln>
+            <a:noFill/>
+          </a:ln>
+        </p:spPr>
+        <p:txBody>
+          <a:bodyPr wrap="square" anchor="ctr" lIns="45000" rIns="45000" tIns="15000" bIns="15000">
+            <a:spAutoFit/>
+          </a:bodyPr>
+          <a:lstStyle/>
+          <a:p>
+            <a:pPr algn="ctr">
+              <a:lnSpc>
+                <a:spcPct val="95000"/>
+              </a:lnSpc>
+            </a:pPr>
+            <a:r>
+              <a:rPr sz="700" b="0" i="0">
+                <a:solidFill>
+                  <a:srgbClr val="2E5A8F"/>
+                </a:solidFill>
+                <a:latin typeface="Calibri"/>
+              </a:rPr>
+              <a:t>Cluster:</a:t>
+            </a:r>
+          </a:p>
+          <a:p>
+            <a:pPr algn="ctr">
+              <a:lnSpc>
+                <a:spcPct val="95000"/>
+              </a:lnSpc>
+            </a:pPr>
+            <a:r>
+              <a:rPr sz="800" b="1" i="0">
+                <a:solidFill>
+                  <a:srgbClr val="1F2937"/>
+                </a:solidFill>
+                <a:latin typeface="Calibri"/>
+              </a:rPr>
+              <a:t>Modern Workplace</a:t>
+            </a:r>
+          </a:p>
+        </p:txBody>
+      </p:sp>
+      <p:sp>
+        <p:nvSpPr>
+          <p:cNvPr id="33" name="Rounded Rectangle 32"/>
+          <p:cNvSpPr/>
+          <p:nvPr/>
+        </p:nvSpPr>
+        <p:spPr>
+          <a:xfrm>
+            <a:off x="5029200" y="3810000"/>
+            <a:ext cx="2133600" cy="495300"/>
+          </a:xfrm>
+          <a:prstGeom prst="roundRect">
+            <a:avLst>
+              <a:gd name="adj" fmla="val 8000"/>
+            </a:avLst>
+          </a:prstGeom>
+          <a:solidFill>
+            <a:srgbClr val="FDE6CC"/>
+          </a:solidFill>
+          <a:ln w="12700">
+            <a:solidFill>
+              <a:srgbClr val="F07F12"/>
+            </a:solidFill>
+          </a:ln>
+          <a:effectLst/>
+        </p:spPr>
+        <p:style>
+          <a:lnRef idx="1">
+            <a:schemeClr val="accent1"/>
+          </a:lnRef>
+          <a:fillRef idx="3">
+            <a:schemeClr val="accent1"/>
+          </a:fillRef>
+          <a:effectRef idx="2">
+            <a:schemeClr val="accent1"/>
+          </a:effectRef>
+          <a:fontRef idx="minor">
+            <a:schemeClr val="lt1"/>
+          </a:fontRef>
+        </p:style>
+        <p:txBody>
+          <a:bodyPr rtlCol="0" anchor="ctr"/>
+          <a:lstStyle/>
+          <a:p>
+            <a:pPr algn="ctr"/>
+          </a:p>
+        </p:txBody>
+      </p:sp>
+      <p:sp>
+        <p:nvSpPr>
+          <p:cNvPr id="34" name="TextBox 33"/>
+          <p:cNvSpPr txBox="1"/>
+          <p:nvPr/>
+        </p:nvSpPr>
+        <p:spPr>
+          <a:xfrm>
+            <a:off x="5029200" y="3810000"/>
+            <a:ext cx="2133600" cy="495300"/>
+          </a:xfrm>
+          <a:prstGeom prst="rect">
+            <a:avLst/>
+          </a:prstGeom>
+          <a:noFill/>
+          <a:ln>
+            <a:noFill/>
+          </a:ln>
+        </p:spPr>
+        <p:txBody>
+          <a:bodyPr wrap="square" anchor="ctr" lIns="45000" rIns="45000" tIns="15000" bIns="15000">
+            <a:spAutoFit/>
+          </a:bodyPr>
+          <a:lstStyle/>
+          <a:p>
+            <a:pPr algn="ctr"/>
+            <a:r>
+              <a:rPr sz="880" b="1" i="0">
+                <a:solidFill>
+                  <a:srgbClr val="7A3D05"/>
+                </a:solidFill>
+                <a:latin typeface="Calibri"/>
+              </a:rPr>
+              <a:t>SDM · Network</a:t>
+            </a:r>
+          </a:p>
+        </p:txBody>
+      </p:sp>
+      <p:cxnSp>
+        <p:nvCxnSpPr>
+          <p:cNvPr id="35" name="Connector 34"/>
+          <p:cNvCxnSpPr/>
+          <p:nvPr/>
+        </p:nvCxnSpPr>
+        <p:spPr>
+          <a:xfrm>
+            <a:off x="6096000" y="4305300"/>
+            <a:ext cx="0" cy="190500"/>
+          </a:xfrm>
+          <a:prstGeom prst="line">
+            <a:avLst/>
+          </a:prstGeom>
+          <a:ln w="11430">
+            <a:solidFill>
+              <a:srgbClr val="6B4FA0"/>
+            </a:solidFill>
+            <a:prstDash val="dash"/>
+          </a:ln>
+          <a:effectLst/>
+        </p:spPr>
+        <p:style>
+          <a:lnRef idx="2">
+            <a:schemeClr val="accent1"/>
+          </a:lnRef>
+          <a:fillRef idx="0">
+            <a:schemeClr val="accent1"/>
+          </a:fillRef>
+          <a:effectRef idx="1">
+            <a:schemeClr val="accent1"/>
+          </a:effectRef>
+          <a:fontRef idx="minor">
+            <a:schemeClr val="tx1"/>
+          </a:fontRef>
+        </p:style>
+      </p:cxnSp>
+      <p:sp>
+        <p:nvSpPr>
+          <p:cNvPr id="36" name="Rounded Rectangle 35"/>
+          <p:cNvSpPr/>
+          <p:nvPr/>
+        </p:nvSpPr>
+        <p:spPr>
+          <a:xfrm>
+            <a:off x="5029200" y="4495800"/>
+            <a:ext cx="2133600" cy="495300"/>
+          </a:xfrm>
+          <a:prstGeom prst="roundRect">
+            <a:avLst>
+              <a:gd name="adj" fmla="val 8000"/>
+            </a:avLst>
+          </a:prstGeom>
+          <a:solidFill>
+            <a:srgbClr val="E4ECF4"/>
+          </a:solidFill>
+          <a:ln w="11430">
+            <a:solidFill>
+              <a:srgbClr val="2E5A8F"/>
+            </a:solidFill>
+          </a:ln>
+          <a:effectLst/>
+        </p:spPr>
+        <p:style>
+          <a:lnRef idx="1">
+            <a:schemeClr val="accent1"/>
+          </a:lnRef>
+          <a:fillRef idx="3">
+            <a:schemeClr val="accent1"/>
+          </a:fillRef>
+          <a:effectRef idx="2">
+            <a:schemeClr val="accent1"/>
+          </a:effectRef>
+          <a:fontRef idx="minor">
+            <a:schemeClr val="lt1"/>
+          </a:fontRef>
+        </p:style>
+        <p:txBody>
+          <a:bodyPr rtlCol="0" anchor="ctr"/>
+          <a:lstStyle/>
+          <a:p>
+            <a:pPr algn="ctr"/>
+          </a:p>
+        </p:txBody>
+      </p:sp>
+      <p:sp>
+        <p:nvSpPr>
+          <p:cNvPr id="37" name="TextBox 36"/>
+          <p:cNvSpPr txBox="1"/>
+          <p:nvPr/>
+        </p:nvSpPr>
+        <p:spPr>
+          <a:xfrm>
+            <a:off x="5029200" y="4495800"/>
+            <a:ext cx="2133600" cy="495300"/>
+          </a:xfrm>
+          <a:prstGeom prst="rect">
+            <a:avLst/>
+          </a:prstGeom>
+          <a:noFill/>
+          <a:ln>
+            <a:noFill/>
+          </a:ln>
+        </p:spPr>
+        <p:txBody>
+          <a:bodyPr wrap="square" anchor="ctr" lIns="45000" rIns="45000" tIns="15000" bIns="15000">
+            <a:spAutoFit/>
+          </a:bodyPr>
+          <a:lstStyle/>
+          <a:p>
+            <a:pPr algn="ctr">
+              <a:lnSpc>
+                <a:spcPct val="95000"/>
+              </a:lnSpc>
+            </a:pPr>
+            <a:r>
+              <a:rPr sz="700" b="0" i="0">
+                <a:solidFill>
+                  <a:srgbClr val="2E5A8F"/>
+                </a:solidFill>
+                <a:latin typeface="Calibri"/>
+              </a:rPr>
+              <a:t>Cluster:</a:t>
+            </a:r>
+          </a:p>
+          <a:p>
+            <a:pPr algn="ctr">
+              <a:lnSpc>
+                <a:spcPct val="95000"/>
+              </a:lnSpc>
+            </a:pPr>
+            <a:r>
+              <a:rPr sz="800" b="1" i="0">
+                <a:solidFill>
+                  <a:srgbClr val="1F2937"/>
+                </a:solidFill>
+                <a:latin typeface="Calibri"/>
+              </a:rPr>
+              <a:t>Network &amp; Connectivity</a:t>
+            </a:r>
+          </a:p>
+        </p:txBody>
+      </p:sp>
+      <p:sp>
+        <p:nvSpPr>
+          <p:cNvPr id="38" name="Rounded Rectangle 37"/>
+          <p:cNvSpPr/>
+          <p:nvPr/>
+        </p:nvSpPr>
+        <p:spPr>
+          <a:xfrm>
+            <a:off x="7277100" y="3810000"/>
+            <a:ext cx="2133600" cy="495300"/>
+          </a:xfrm>
+          <a:prstGeom prst="roundRect">
+            <a:avLst>
+              <a:gd name="adj" fmla="val 8000"/>
+            </a:avLst>
+          </a:prstGeom>
+          <a:solidFill>
+            <a:srgbClr val="FDE6CC"/>
+          </a:solidFill>
+          <a:ln w="12700">
+            <a:solidFill>
+              <a:srgbClr val="F07F12"/>
+            </a:solidFill>
+          </a:ln>
+          <a:effectLst/>
+        </p:spPr>
+        <p:style>
+          <a:lnRef idx="1">
+            <a:schemeClr val="accent1"/>
+          </a:lnRef>
+          <a:fillRef idx="3">
+            <a:schemeClr val="accent1"/>
+          </a:fillRef>
+          <a:effectRef idx="2">
+            <a:schemeClr val="accent1"/>
+          </a:effectRef>
+          <a:fontRef idx="minor">
+            <a:schemeClr val="lt1"/>
+          </a:fontRef>
+        </p:style>
+        <p:txBody>
+          <a:bodyPr rtlCol="0" anchor="ctr"/>
+          <a:lstStyle/>
+          <a:p>
+            <a:pPr algn="ctr"/>
+          </a:p>
+        </p:txBody>
+      </p:sp>
+      <p:sp>
+        <p:nvSpPr>
+          <p:cNvPr id="39" name="TextBox 38"/>
+          <p:cNvSpPr txBox="1"/>
+          <p:nvPr/>
+        </p:nvSpPr>
+        <p:spPr>
+          <a:xfrm>
+            <a:off x="7277100" y="3810000"/>
+            <a:ext cx="2133600" cy="495300"/>
+          </a:xfrm>
+          <a:prstGeom prst="rect">
+            <a:avLst/>
+          </a:prstGeom>
+          <a:noFill/>
+          <a:ln>
+            <a:noFill/>
+          </a:ln>
+        </p:spPr>
+        <p:txBody>
+          <a:bodyPr wrap="square" anchor="ctr" lIns="45000" rIns="45000" tIns="15000" bIns="15000">
+            <a:spAutoFit/>
+          </a:bodyPr>
+          <a:lstStyle/>
+          <a:p>
+            <a:pPr algn="ctr"/>
+            <a:r>
+              <a:rPr sz="880" b="1" i="0">
+                <a:solidFill>
+                  <a:srgbClr val="7A3D05"/>
+                </a:solidFill>
+                <a:latin typeface="Calibri"/>
+              </a:rPr>
+              <a:t>SDM · Compute/IAM</a:t>
+            </a:r>
+          </a:p>
+        </p:txBody>
+      </p:sp>
+      <p:cxnSp>
+        <p:nvCxnSpPr>
+          <p:cNvPr id="40" name="Connector 39"/>
+          <p:cNvCxnSpPr/>
+          <p:nvPr/>
+        </p:nvCxnSpPr>
+        <p:spPr>
+          <a:xfrm>
+            <a:off x="8343900" y="4305300"/>
+            <a:ext cx="0" cy="190500"/>
+          </a:xfrm>
+          <a:prstGeom prst="line">
+            <a:avLst/>
+          </a:prstGeom>
+          <a:ln w="11430">
+            <a:solidFill>
+              <a:srgbClr val="6B4FA0"/>
+            </a:solidFill>
+            <a:prstDash val="dash"/>
+          </a:ln>
+          <a:effectLst/>
+        </p:spPr>
+        <p:style>
+          <a:lnRef idx="2">
+            <a:schemeClr val="accent1"/>
+          </a:lnRef>
+          <a:fillRef idx="0">
+            <a:schemeClr val="accent1"/>
+          </a:fillRef>
+          <a:effectRef idx="1">
+            <a:schemeClr val="accent1"/>
+          </a:effectRef>
+          <a:fontRef idx="minor">
+            <a:schemeClr val="tx1"/>
+          </a:fontRef>
+        </p:style>
+      </p:cxnSp>
+      <p:sp>
+        <p:nvSpPr>
+          <p:cNvPr id="41" name="Rounded Rectangle 40"/>
+          <p:cNvSpPr/>
+          <p:nvPr/>
+        </p:nvSpPr>
+        <p:spPr>
+          <a:xfrm>
+            <a:off x="7277100" y="4495800"/>
+            <a:ext cx="2133600" cy="495300"/>
+          </a:xfrm>
+          <a:prstGeom prst="roundRect">
+            <a:avLst>
+              <a:gd name="adj" fmla="val 8000"/>
+            </a:avLst>
+          </a:prstGeom>
+          <a:solidFill>
+            <a:srgbClr val="E4ECF4"/>
+          </a:solidFill>
+          <a:ln w="11430">
+            <a:solidFill>
+              <a:srgbClr val="2E5A8F"/>
+            </a:solidFill>
+          </a:ln>
+          <a:effectLst/>
+        </p:spPr>
+        <p:style>
+          <a:lnRef idx="1">
+            <a:schemeClr val="accent1"/>
+          </a:lnRef>
+          <a:fillRef idx="3">
+            <a:schemeClr val="accent1"/>
+          </a:fillRef>
+          <a:effectRef idx="2">
+            <a:schemeClr val="accent1"/>
+          </a:effectRef>
+          <a:fontRef idx="minor">
+            <a:schemeClr val="lt1"/>
+          </a:fontRef>
+        </p:style>
+        <p:txBody>
+          <a:bodyPr rtlCol="0" anchor="ctr"/>
+          <a:lstStyle/>
+          <a:p>
+            <a:pPr algn="ctr"/>
+          </a:p>
+        </p:txBody>
+      </p:sp>
+      <p:sp>
+        <p:nvSpPr>
+          <p:cNvPr id="42" name="TextBox 41"/>
+          <p:cNvSpPr txBox="1"/>
+          <p:nvPr/>
+        </p:nvSpPr>
+        <p:spPr>
+          <a:xfrm>
+            <a:off x="7277100" y="4495800"/>
+            <a:ext cx="2133600" cy="495300"/>
+          </a:xfrm>
+          <a:prstGeom prst="rect">
+            <a:avLst/>
+          </a:prstGeom>
+          <a:noFill/>
+          <a:ln>
+            <a:noFill/>
+          </a:ln>
+        </p:spPr>
+        <p:txBody>
+          <a:bodyPr wrap="square" anchor="ctr" lIns="45000" rIns="45000" tIns="15000" bIns="15000">
+            <a:spAutoFit/>
+          </a:bodyPr>
+          <a:lstStyle/>
+          <a:p>
+            <a:pPr algn="ctr">
+              <a:lnSpc>
+                <a:spcPct val="95000"/>
+              </a:lnSpc>
+            </a:pPr>
+            <a:r>
+              <a:rPr sz="700" b="0" i="0">
+                <a:solidFill>
+                  <a:srgbClr val="2E5A8F"/>
+                </a:solidFill>
+                <a:latin typeface="Calibri"/>
+              </a:rPr>
+              <a:t>Cluster:</a:t>
+            </a:r>
+          </a:p>
+          <a:p>
+            <a:pPr algn="ctr">
+              <a:lnSpc>
+                <a:spcPct val="95000"/>
+              </a:lnSpc>
+            </a:pPr>
+            <a:r>
+              <a:rPr sz="800" b="1" i="0">
+                <a:solidFill>
+                  <a:srgbClr val="1F2937"/>
+                </a:solidFill>
+                <a:latin typeface="Calibri"/>
+              </a:rPr>
+              <a:t>Compute · Cloud · IAM</a:t>
+            </a:r>
+          </a:p>
+        </p:txBody>
+      </p:sp>
+      <p:sp>
+        <p:nvSpPr>
+          <p:cNvPr id="43" name="Rounded Rectangle 42"/>
+          <p:cNvSpPr/>
+          <p:nvPr/>
+        </p:nvSpPr>
+        <p:spPr>
+          <a:xfrm>
+            <a:off x="9525000" y="3810000"/>
+            <a:ext cx="2133600" cy="495300"/>
+          </a:xfrm>
+          <a:prstGeom prst="roundRect">
+            <a:avLst>
+              <a:gd name="adj" fmla="val 8000"/>
+            </a:avLst>
+          </a:prstGeom>
+          <a:solidFill>
+            <a:srgbClr val="FDE6CC"/>
+          </a:solidFill>
+          <a:ln w="12700">
+            <a:solidFill>
+              <a:srgbClr val="F07F12"/>
+            </a:solidFill>
+          </a:ln>
+          <a:effectLst/>
+        </p:spPr>
+        <p:style>
+          <a:lnRef idx="1">
+            <a:schemeClr val="accent1"/>
+          </a:lnRef>
+          <a:fillRef idx="3">
+            <a:schemeClr val="accent1"/>
+          </a:fillRef>
+          <a:effectRef idx="2">
+            <a:schemeClr val="accent1"/>
+          </a:effectRef>
+          <a:fontRef idx="minor">
+            <a:schemeClr val="lt1"/>
+          </a:fontRef>
+        </p:style>
+        <p:txBody>
+          <a:bodyPr rtlCol="0" anchor="ctr"/>
+          <a:lstStyle/>
+          <a:p>
+            <a:pPr algn="ctr"/>
+          </a:p>
+        </p:txBody>
+      </p:sp>
+      <p:sp>
+        <p:nvSpPr>
+          <p:cNvPr id="44" name="TextBox 43"/>
+          <p:cNvSpPr txBox="1"/>
+          <p:nvPr/>
+        </p:nvSpPr>
+        <p:spPr>
+          <a:xfrm>
+            <a:off x="9525000" y="3810000"/>
+            <a:ext cx="2133600" cy="495300"/>
+          </a:xfrm>
+          <a:prstGeom prst="rect">
+            <a:avLst/>
+          </a:prstGeom>
+          <a:noFill/>
+          <a:ln>
+            <a:noFill/>
+          </a:ln>
+        </p:spPr>
+        <p:txBody>
+          <a:bodyPr wrap="square" anchor="ctr" lIns="45000" rIns="45000" tIns="15000" bIns="15000">
+            <a:spAutoFit/>
+          </a:bodyPr>
+          <a:lstStyle/>
+          <a:p>
+            <a:pPr algn="ctr"/>
+            <a:r>
+              <a:rPr sz="880" b="1" i="0">
+                <a:solidFill>
+                  <a:srgbClr val="7A3D05"/>
+                </a:solidFill>
+                <a:latin typeface="Calibri"/>
+              </a:rPr>
+              <a:t>SDM · Service Desk</a:t>
+            </a:r>
+          </a:p>
+        </p:txBody>
+      </p:sp>
+      <p:cxnSp>
+        <p:nvCxnSpPr>
+          <p:cNvPr id="45" name="Connector 44"/>
+          <p:cNvCxnSpPr/>
+          <p:nvPr/>
+        </p:nvCxnSpPr>
+        <p:spPr>
+          <a:xfrm>
+            <a:off x="10591800" y="4305300"/>
+            <a:ext cx="0" cy="190500"/>
+          </a:xfrm>
+          <a:prstGeom prst="line">
+            <a:avLst/>
+          </a:prstGeom>
+          <a:ln w="11430">
+            <a:solidFill>
+              <a:srgbClr val="6B4FA0"/>
+            </a:solidFill>
+            <a:prstDash val="dash"/>
+          </a:ln>
+          <a:effectLst/>
+        </p:spPr>
+        <p:style>
+          <a:lnRef idx="2">
+            <a:schemeClr val="accent1"/>
+          </a:lnRef>
+          <a:fillRef idx="0">
+            <a:schemeClr val="accent1"/>
+          </a:fillRef>
+          <a:effectRef idx="1">
+            <a:schemeClr val="accent1"/>
+          </a:effectRef>
+          <a:fontRef idx="minor">
+            <a:schemeClr val="tx1"/>
+          </a:fontRef>
+        </p:style>
+      </p:cxnSp>
+      <p:sp>
+        <p:nvSpPr>
+          <p:cNvPr id="46" name="Rounded Rectangle 45"/>
+          <p:cNvSpPr/>
+          <p:nvPr/>
+        </p:nvSpPr>
+        <p:spPr>
+          <a:xfrm>
+            <a:off x="9525000" y="4495800"/>
+            <a:ext cx="2133600" cy="495300"/>
+          </a:xfrm>
+          <a:prstGeom prst="roundRect">
+            <a:avLst>
+              <a:gd name="adj" fmla="val 8000"/>
+            </a:avLst>
+          </a:prstGeom>
+          <a:solidFill>
+            <a:srgbClr val="E4ECF4"/>
+          </a:solidFill>
+          <a:ln w="11430">
+            <a:solidFill>
+              <a:srgbClr val="2E5A8F"/>
+            </a:solidFill>
+          </a:ln>
+          <a:effectLst/>
+        </p:spPr>
+        <p:style>
+          <a:lnRef idx="1">
+            <a:schemeClr val="accent1"/>
+          </a:lnRef>
+          <a:fillRef idx="3">
+            <a:schemeClr val="accent1"/>
+          </a:fillRef>
+          <a:effectRef idx="2">
+            <a:schemeClr val="accent1"/>
+          </a:effectRef>
+          <a:fontRef idx="minor">
+            <a:schemeClr val="lt1"/>
+          </a:fontRef>
+        </p:style>
+        <p:txBody>
+          <a:bodyPr rtlCol="0" anchor="ctr"/>
+          <a:lstStyle/>
+          <a:p>
+            <a:pPr algn="ctr"/>
+          </a:p>
+        </p:txBody>
+      </p:sp>
+      <p:sp>
+        <p:nvSpPr>
+          <p:cNvPr id="47" name="TextBox 46"/>
+          <p:cNvSpPr txBox="1"/>
+          <p:nvPr/>
+        </p:nvSpPr>
+        <p:spPr>
+          <a:xfrm>
+            <a:off x="9525000" y="4495800"/>
+            <a:ext cx="2133600" cy="495300"/>
+          </a:xfrm>
+          <a:prstGeom prst="rect">
+            <a:avLst/>
+          </a:prstGeom>
+          <a:noFill/>
+          <a:ln>
+            <a:noFill/>
+          </a:ln>
+        </p:spPr>
+        <p:txBody>
+          <a:bodyPr wrap="square" anchor="ctr" lIns="45000" rIns="45000" tIns="15000" bIns="15000">
+            <a:spAutoFit/>
+          </a:bodyPr>
+          <a:lstStyle/>
+          <a:p>
+            <a:pPr algn="ctr">
+              <a:lnSpc>
+                <a:spcPct val="95000"/>
+              </a:lnSpc>
+            </a:pPr>
+            <a:r>
+              <a:rPr sz="700" b="0" i="0">
+                <a:solidFill>
+                  <a:srgbClr val="2E5A8F"/>
+                </a:solidFill>
+                <a:latin typeface="Calibri"/>
+              </a:rPr>
+              <a:t>Cluster:</a:t>
+            </a:r>
+          </a:p>
+          <a:p>
+            <a:pPr algn="ctr">
+              <a:lnSpc>
+                <a:spcPct val="95000"/>
+              </a:lnSpc>
+            </a:pPr>
+            <a:r>
+              <a:rPr sz="800" b="1" i="0">
+                <a:solidFill>
+                  <a:srgbClr val="1F2937"/>
+                </a:solidFill>
+                <a:latin typeface="Calibri"/>
+              </a:rPr>
+              <a:t>ITSM / End-User (quer)</a:t>
+            </a:r>
+          </a:p>
+        </p:txBody>
+      </p:sp>
+      <p:sp>
+        <p:nvSpPr>
+          <p:cNvPr id="48" name="TextBox 47"/>
+          <p:cNvSpPr txBox="1"/>
+          <p:nvPr/>
+        </p:nvSpPr>
+        <p:spPr>
+          <a:xfrm>
+            <a:off x="533400" y="5143500"/>
+            <a:ext cx="11125200" cy="228600"/>
+          </a:xfrm>
+          <a:prstGeom prst="rect">
+            <a:avLst/>
+          </a:prstGeom>
+          <a:noFill/>
+          <a:ln>
+            <a:noFill/>
+          </a:ln>
+        </p:spPr>
+        <p:txBody>
+          <a:bodyPr wrap="square" anchor="t" lIns="45000" rIns="45000" tIns="15000" bIns="15000">
+            <a:spAutoFit/>
+          </a:bodyPr>
+          <a:lstStyle/>
+          <a:p>
+            <a:pPr algn="l"/>
+            <a:r>
+              <a:rPr sz="900" b="1" i="0">
+                <a:solidFill>
+                  <a:srgbClr val="F07F12"/>
+                </a:solidFill>
+                <a:latin typeface="Calibri"/>
+              </a:rPr>
+              <a:t>——  </a:t>
+            </a:r>
+            <a:r>
+              <a:rPr sz="900" b="0" i="0">
+                <a:solidFill>
+                  <a:srgbClr val="4B5563"/>
+                </a:solidFill>
+                <a:latin typeface="Calibri"/>
+              </a:rPr>
+              <a:t>Solid-Line: Heimat &amp; Führung (Head of SDM)      </a:t>
+            </a:r>
+            <a:r>
+              <a:rPr sz="900" b="1" i="0">
+                <a:solidFill>
+                  <a:srgbClr val="6B4FA0"/>
+                </a:solidFill>
+                <a:latin typeface="Calibri"/>
+              </a:rPr>
+              <a:t>- - -  </a:t>
+            </a:r>
+            <a:r>
+              <a:rPr sz="900" b="0" i="0">
+                <a:solidFill>
+                  <a:srgbClr val="4B5563"/>
+                </a:solidFill>
+                <a:latin typeface="Calibri"/>
+              </a:rPr>
+              <a:t>Dotted-Line: fachlicher Einsatz im Cluster</a:t>
+            </a:r>
+          </a:p>
+        </p:txBody>
+      </p:sp>
+      <p:sp>
+        <p:nvSpPr>
+          <p:cNvPr id="49" name="Rounded Rectangle 48"/>
+          <p:cNvSpPr/>
+          <p:nvPr/>
+        </p:nvSpPr>
+        <p:spPr>
+          <a:xfrm>
+            <a:off x="533400" y="5448300"/>
+            <a:ext cx="11125200" cy="952500"/>
+          </a:xfrm>
+          <a:prstGeom prst="roundRect">
+            <a:avLst>
+              <a:gd name="adj" fmla="val 8000"/>
+            </a:avLst>
+          </a:prstGeom>
+          <a:solidFill>
+            <a:srgbClr val="F7F7F7"/>
+          </a:solidFill>
+          <a:ln>
+            <a:noFill/>
+          </a:ln>
+          <a:effectLst/>
+        </p:spPr>
+        <p:style>
+          <a:lnRef idx="1">
+            <a:schemeClr val="accent1"/>
+          </a:lnRef>
+          <a:fillRef idx="3">
+            <a:schemeClr val="accent1"/>
+          </a:fillRef>
+          <a:effectRef idx="2">
+            <a:schemeClr val="accent1"/>
+          </a:effectRef>
+          <a:fontRef idx="minor">
+            <a:schemeClr val="lt1"/>
+          </a:fontRef>
+        </p:style>
+        <p:txBody>
+          <a:bodyPr rtlCol="0" anchor="ctr"/>
+          <a:lstStyle/>
+          <a:p>
+            <a:pPr algn="ctr"/>
+          </a:p>
+        </p:txBody>
+      </p:sp>
+      <p:sp>
+        <p:nvSpPr>
+          <p:cNvPr id="50" name="TextBox 49"/>
+          <p:cNvSpPr txBox="1"/>
+          <p:nvPr/>
+        </p:nvSpPr>
+        <p:spPr>
+          <a:xfrm>
+            <a:off x="685800" y="5516880"/>
+            <a:ext cx="10820400" cy="304800"/>
+          </a:xfrm>
+          <a:prstGeom prst="rect">
+            <a:avLst/>
+          </a:prstGeom>
+          <a:noFill/>
+          <a:ln>
+            <a:noFill/>
+          </a:ln>
+        </p:spPr>
+        <p:txBody>
+          <a:bodyPr wrap="square" anchor="t" lIns="45000" rIns="45000" tIns="15000" bIns="15000">
+            <a:spAutoFit/>
+          </a:bodyPr>
+          <a:lstStyle/>
+          <a:p>
+            <a:pPr algn="l"/>
+            <a:r>
+              <a:rPr sz="1050" b="1" i="0">
+                <a:solidFill>
+                  <a:srgbClr val="1F2937"/>
+                </a:solidFill>
+                <a:latin typeface="Calibri"/>
+              </a:rPr>
+              <a:t>Sizing-Regel — nicht nach Anzahl Services, sondern nach Koordinationslast</a:t>
+            </a:r>
+          </a:p>
+        </p:txBody>
+      </p:sp>
+      <p:sp>
+        <p:nvSpPr>
+          <p:cNvPr id="51" name="TextBox 50"/>
+          <p:cNvSpPr txBox="1"/>
+          <p:nvPr/>
+        </p:nvSpPr>
+        <p:spPr>
+          <a:xfrm>
+            <a:off x="685800" y="5821680"/>
+            <a:ext cx="10820400" cy="533400"/>
+          </a:xfrm>
+          <a:prstGeom prst="rect">
+            <a:avLst/>
+          </a:prstGeom>
+          <a:noFill/>
+          <a:ln>
+            <a:noFill/>
+          </a:ln>
+        </p:spPr>
+        <p:txBody>
+          <a:bodyPr wrap="square" anchor="t" lIns="45000" rIns="45000" tIns="15000" bIns="15000">
+            <a:spAutoFit/>
+          </a:bodyPr>
+          <a:lstStyle/>
+          <a:p>
+            <a:pPr algn="l">
+              <a:lnSpc>
+                <a:spcPct val="115000"/>
+              </a:lnSpc>
+            </a:pPr>
+            <a:r>
+              <a:rPr sz="950" b="0" i="0">
+                <a:solidFill>
+                  <a:srgbClr val="4B5563"/>
+                </a:solidFill>
+                <a:latin typeface="Calibri"/>
+              </a:rPr>
+              <a:t>Maßstab: Zahl beteiligter Provider + interner Einheiten, Kritikalität, Ticketvolumen. Faustwert: ein SDM steuert eine große oder eine Handvoll mittlerer Services. Kleine/verwandte Services bündeln; große Cluster (z. B. SAP/DXC) ggf. mit zweitem SDM. Head of Service Delivery balanciert die Last über den Pool.</a:t>
+            </a:r>
+          </a:p>
+        </p:txBody>
+      </p:sp>
+    </p:spTree>
+  </p:cSld>
+  <p:clrMapOvr>
+    <a:masterClrMapping/>
+  </p:clrMapOvr>
+</p:sld>
+</file>
+
+<file path=ppt/slides/slide15.xml><?xml version="1.0" encoding="utf-8"?>
+<p:sld xmlns:a="http://schemas.openxmlformats.org/drawingml/2006/main" xmlns:p="http://schemas.openxmlformats.org/presentationml/2006/main" xmlns:r="http://schemas.openxmlformats.org/officeDocument/2006/relationships">
+  <p:cSld>
+    <p:spTree>
+      <p:nvGrpSpPr>
+        <p:cNvPr id="1" name=""/>
+        <p:cNvGrpSpPr/>
+        <p:nvPr/>
+      </p:nvGrpSpPr>
+      <p:grpSpPr/>
+      <p:sp>
+        <p:nvSpPr>
+          <p:cNvPr id="2" name="Rectangle 1"/>
+          <p:cNvSpPr/>
+          <p:nvPr/>
+        </p:nvSpPr>
+        <p:spPr>
+          <a:xfrm>
+            <a:off x="0" y="0"/>
+            <a:ext cx="12192000" cy="6858000"/>
+          </a:xfrm>
+          <a:prstGeom prst="rect">
+            <a:avLst/>
+          </a:prstGeom>
+          <a:solidFill>
+            <a:srgbClr val="FFFFFF"/>
+          </a:solidFill>
+          <a:ln>
+            <a:noFill/>
+          </a:ln>
+          <a:effectLst/>
+        </p:spPr>
+        <p:style>
+          <a:lnRef idx="1">
+            <a:schemeClr val="accent1"/>
+          </a:lnRef>
+          <a:fillRef idx="3">
+            <a:schemeClr val="accent1"/>
+          </a:fillRef>
+          <a:effectRef idx="2">
+            <a:schemeClr val="accent1"/>
+          </a:effectRef>
+          <a:fontRef idx="minor">
+            <a:schemeClr val="lt1"/>
+          </a:fontRef>
+        </p:style>
+        <p:txBody>
+          <a:bodyPr rtlCol="0" anchor="ctr"/>
+          <a:lstStyle/>
+          <a:p>
+            <a:pPr algn="ctr"/>
+          </a:p>
+        </p:txBody>
+      </p:sp>
+      <p:sp>
+        <p:nvSpPr>
+          <p:cNvPr id="3" name="Rectangle 2"/>
+          <p:cNvSpPr/>
+          <p:nvPr/>
+        </p:nvSpPr>
+        <p:spPr>
+          <a:xfrm>
+            <a:off x="0" y="0"/>
+            <a:ext cx="121920" cy="6858000"/>
+          </a:xfrm>
+          <a:prstGeom prst="rect">
+            <a:avLst/>
+          </a:prstGeom>
+          <a:solidFill>
+            <a:srgbClr val="F07F12"/>
+          </a:solidFill>
+          <a:ln>
+            <a:noFill/>
+          </a:ln>
+          <a:effectLst/>
+        </p:spPr>
+        <p:style>
+          <a:lnRef idx="1">
+            <a:schemeClr val="accent1"/>
+          </a:lnRef>
+          <a:fillRef idx="3">
+            <a:schemeClr val="accent1"/>
+          </a:fillRef>
+          <a:effectRef idx="2">
+            <a:schemeClr val="accent1"/>
+          </a:effectRef>
+          <a:fontRef idx="minor">
+            <a:schemeClr val="lt1"/>
+          </a:fontRef>
+        </p:style>
+        <p:txBody>
+          <a:bodyPr rtlCol="0" anchor="ctr"/>
+          <a:lstStyle/>
+          <a:p>
+            <a:pPr algn="ctr"/>
+          </a:p>
+        </p:txBody>
+      </p:sp>
+      <p:sp>
+        <p:nvSpPr>
+          <p:cNvPr id="4" name="TextBox 3"/>
+          <p:cNvSpPr txBox="1"/>
+          <p:nvPr/>
+        </p:nvSpPr>
+        <p:spPr>
+          <a:xfrm>
+            <a:off x="533400" y="381000"/>
+            <a:ext cx="9906000" cy="304800"/>
+          </a:xfrm>
+          <a:prstGeom prst="rect">
+            <a:avLst/>
+          </a:prstGeom>
+          <a:noFill/>
+          <a:ln>
+            <a:noFill/>
+          </a:ln>
+        </p:spPr>
+        <p:txBody>
+          <a:bodyPr wrap="square" anchor="t" lIns="45000" rIns="45000" tIns="15000" bIns="15000">
+            <a:spAutoFit/>
+          </a:bodyPr>
+          <a:lstStyle/>
+          <a:p>
+            <a:pPr algn="l"/>
+            <a:r>
+              <a:rPr sz="1100" b="1" i="0">
+                <a:solidFill>
+                  <a:srgbClr val="F07F12"/>
+                </a:solidFill>
+                <a:latin typeface="Calibri"/>
+              </a:rPr>
+              <a:t>VERORTUNGSENTSCHEIDUNG</a:t>
+            </a:r>
+          </a:p>
+        </p:txBody>
+      </p:sp>
+      <p:sp>
+        <p:nvSpPr>
+          <p:cNvPr id="5" name="TextBox 4"/>
+          <p:cNvSpPr txBox="1"/>
+          <p:nvPr/>
+        </p:nvSpPr>
+        <p:spPr>
+          <a:xfrm>
+            <a:off x="533400" y="647700"/>
+            <a:ext cx="11125200" cy="685800"/>
+          </a:xfrm>
+          <a:prstGeom prst="rect">
+            <a:avLst/>
+          </a:prstGeom>
+          <a:noFill/>
+          <a:ln>
+            <a:noFill/>
+          </a:ln>
+        </p:spPr>
+        <p:txBody>
+          <a:bodyPr wrap="square" anchor="t" lIns="45000" rIns="45000" tIns="15000" bIns="15000">
+            <a:spAutoFit/>
+          </a:bodyPr>
+          <a:lstStyle/>
+          <a:p>
+            <a:pPr algn="l"/>
+            <a:r>
+              <a:rPr sz="2400" b="1" i="0">
+                <a:solidFill>
+                  <a:srgbClr val="1F2937"/>
+                </a:solidFill>
+                <a:latin typeface="Calibri"/>
+              </a:rPr>
+              <a:t>Zentraler SDM-Pool statt verteilter Berichtslinien</a:t>
+            </a:r>
+          </a:p>
+        </p:txBody>
+      </p:sp>
+      <p:sp>
+        <p:nvSpPr>
+          <p:cNvPr id="6" name="Rectangle 5"/>
+          <p:cNvSpPr/>
+          <p:nvPr/>
+        </p:nvSpPr>
+        <p:spPr>
+          <a:xfrm>
+            <a:off x="533400" y="1333500"/>
+            <a:ext cx="11125200" cy="9144"/>
+          </a:xfrm>
+          <a:prstGeom prst="rect">
+            <a:avLst/>
+          </a:prstGeom>
+          <a:solidFill>
+            <a:srgbClr val="D1D5DB"/>
+          </a:solidFill>
+          <a:ln>
+            <a:noFill/>
+          </a:ln>
+          <a:effectLst/>
+        </p:spPr>
+        <p:style>
+          <a:lnRef idx="1">
+            <a:schemeClr val="accent1"/>
+          </a:lnRef>
+          <a:fillRef idx="3">
+            <a:schemeClr val="accent1"/>
+          </a:fillRef>
+          <a:effectRef idx="2">
+            <a:schemeClr val="accent1"/>
+          </a:effectRef>
+          <a:fontRef idx="minor">
+            <a:schemeClr val="lt1"/>
+          </a:fontRef>
+        </p:style>
+        <p:txBody>
+          <a:bodyPr rtlCol="0" anchor="ctr"/>
+          <a:lstStyle/>
+          <a:p>
+            <a:pPr algn="ctr"/>
+          </a:p>
+        </p:txBody>
+      </p:sp>
+      <p:sp>
+        <p:nvSpPr>
+          <p:cNvPr id="7" name="TextBox 6"/>
+          <p:cNvSpPr txBox="1"/>
+          <p:nvPr/>
+        </p:nvSpPr>
+        <p:spPr>
+          <a:xfrm>
+            <a:off x="11430000" y="6438900"/>
+            <a:ext cx="609600" cy="304800"/>
+          </a:xfrm>
+          <a:prstGeom prst="rect">
+            <a:avLst/>
+          </a:prstGeom>
+          <a:noFill/>
+          <a:ln>
+            <a:noFill/>
+          </a:ln>
+        </p:spPr>
+        <p:txBody>
+          <a:bodyPr wrap="square" anchor="t" lIns="45000" rIns="45000" tIns="15000" bIns="15000">
+            <a:spAutoFit/>
+          </a:bodyPr>
+          <a:lstStyle/>
+          <a:p>
+            <a:pPr algn="r"/>
+            <a:r>
+              <a:rPr sz="1000" b="0" i="0">
+                <a:solidFill>
+                  <a:srgbClr val="D1D5DB"/>
+                </a:solidFill>
+                <a:latin typeface="Calibri"/>
+              </a:rPr>
+              <a:t>15</a:t>
+            </a:r>
+          </a:p>
+        </p:txBody>
+      </p:sp>
+      <p:sp>
+        <p:nvSpPr>
+          <p:cNvPr id="8" name="TextBox 7"/>
+          <p:cNvSpPr txBox="1"/>
+          <p:nvPr/>
+        </p:nvSpPr>
+        <p:spPr>
+          <a:xfrm>
+            <a:off x="533400" y="6438900"/>
+            <a:ext cx="6858000" cy="304800"/>
+          </a:xfrm>
+          <a:prstGeom prst="rect">
+            <a:avLst/>
+          </a:prstGeom>
+          <a:noFill/>
+          <a:ln>
+            <a:noFill/>
+          </a:ln>
+        </p:spPr>
+        <p:txBody>
+          <a:bodyPr wrap="square" anchor="t" lIns="45000" rIns="45000" tIns="15000" bIns="15000">
+            <a:spAutoFit/>
+          </a:bodyPr>
+          <a:lstStyle/>
+          <a:p>
+            <a:pPr algn="l"/>
+            <a:r>
+              <a:rPr sz="900" b="0" i="0">
+                <a:solidFill>
+                  <a:srgbClr val="D1D5DB"/>
+                </a:solidFill>
+                <a:latin typeface="Calibri"/>
+              </a:rPr>
+              <a:t>IT-Ablauforganisation · Zielbild</a:t>
+            </a:r>
+          </a:p>
+        </p:txBody>
+      </p:sp>
+      <p:sp>
+        <p:nvSpPr>
+          <p:cNvPr id="9" name="TextBox 8"/>
+          <p:cNvSpPr txBox="1"/>
+          <p:nvPr/>
+        </p:nvSpPr>
+        <p:spPr>
+          <a:xfrm>
+            <a:off x="533400" y="1470660"/>
+            <a:ext cx="11125200" cy="381000"/>
+          </a:xfrm>
+          <a:prstGeom prst="rect">
+            <a:avLst/>
+          </a:prstGeom>
+          <a:noFill/>
+          <a:ln>
+            <a:noFill/>
+          </a:ln>
+        </p:spPr>
+        <p:txBody>
+          <a:bodyPr wrap="square" anchor="t" lIns="45000" rIns="45000" tIns="15000" bIns="15000">
+            <a:spAutoFit/>
+          </a:bodyPr>
+          <a:lstStyle/>
+          <a:p>
+            <a:pPr algn="l">
+              <a:lnSpc>
+                <a:spcPct val="115000"/>
+              </a:lnSpc>
+            </a:pPr>
+            <a:r>
+              <a:rPr sz="1150" b="1" i="0">
+                <a:solidFill>
+                  <a:srgbClr val="1F2937"/>
+                </a:solidFill>
+                <a:latin typeface="Calibri"/>
+              </a:rPr>
+              <a:t>Entscheidend ist, was „verteilt“ meint:  </a:t>
+            </a:r>
+            <a:r>
+              <a:rPr sz="1150" b="0" i="0">
+                <a:solidFill>
+                  <a:srgbClr val="4B5563"/>
+                </a:solidFill>
+                <a:latin typeface="Calibri"/>
+              </a:rPr>
+              <a:t>verteilter </a:t>
+            </a:r>
+            <a:r>
+              <a:rPr sz="1150" b="1" i="0">
+                <a:solidFill>
+                  <a:srgbClr val="2E5A8F"/>
+                </a:solidFill>
+                <a:latin typeface="Calibri"/>
+              </a:rPr>
+              <a:t>Sitz/Einsatz</a:t>
+            </a:r>
+            <a:r>
+              <a:rPr sz="1150" b="0" i="0">
+                <a:solidFill>
+                  <a:srgbClr val="4B5563"/>
+                </a:solidFill>
+                <a:latin typeface="Calibri"/>
+              </a:rPr>
+              <a:t> ist gut — verteilte </a:t>
+            </a:r>
+            <a:r>
+              <a:rPr sz="1150" b="1" i="0">
+                <a:solidFill>
+                  <a:srgbClr val="B91C1C"/>
+                </a:solidFill>
+                <a:latin typeface="Calibri"/>
+              </a:rPr>
+              <a:t>Berichtslinie</a:t>
+            </a:r>
+            <a:r>
+              <a:rPr sz="1150" b="0" i="0">
+                <a:solidFill>
+                  <a:srgbClr val="4B5563"/>
+                </a:solidFill>
+                <a:latin typeface="Calibri"/>
+              </a:rPr>
+              <a:t> in die Liefereinheiten ist riskant.</a:t>
+            </a:r>
+          </a:p>
+        </p:txBody>
+      </p:sp>
+      <p:sp>
+        <p:nvSpPr>
+          <p:cNvPr id="10" name="Rounded Rectangle 9"/>
+          <p:cNvSpPr/>
+          <p:nvPr/>
+        </p:nvSpPr>
+        <p:spPr>
+          <a:xfrm>
+            <a:off x="533400" y="2057400"/>
+            <a:ext cx="5448300" cy="1981200"/>
+          </a:xfrm>
+          <a:prstGeom prst="roundRect">
+            <a:avLst>
+              <a:gd name="adj" fmla="val 8000"/>
+            </a:avLst>
+          </a:prstGeom>
+          <a:solidFill>
+            <a:srgbClr val="FFFFFF"/>
+          </a:solidFill>
+          <a:ln w="15875">
+            <a:solidFill>
+              <a:srgbClr val="2E7D32"/>
+            </a:solidFill>
+          </a:ln>
+          <a:effectLst/>
+        </p:spPr>
+        <p:style>
+          <a:lnRef idx="1">
+            <a:schemeClr val="accent1"/>
+          </a:lnRef>
+          <a:fillRef idx="3">
+            <a:schemeClr val="accent1"/>
+          </a:fillRef>
+          <a:effectRef idx="2">
+            <a:schemeClr val="accent1"/>
+          </a:effectRef>
+          <a:fontRef idx="minor">
+            <a:schemeClr val="lt1"/>
+          </a:fontRef>
+        </p:style>
+        <p:txBody>
+          <a:bodyPr rtlCol="0" anchor="ctr"/>
+          <a:lstStyle/>
+          <a:p>
+            <a:pPr algn="ctr"/>
+          </a:p>
+        </p:txBody>
+      </p:sp>
+      <p:sp>
+        <p:nvSpPr>
+          <p:cNvPr id="11" name="Rectangle 10"/>
+          <p:cNvSpPr/>
+          <p:nvPr/>
+        </p:nvSpPr>
+        <p:spPr>
+          <a:xfrm>
+            <a:off x="533400" y="2057400"/>
+            <a:ext cx="5448300" cy="381000"/>
+          </a:xfrm>
+          <a:prstGeom prst="rect">
+            <a:avLst/>
+          </a:prstGeom>
+          <a:solidFill>
+            <a:srgbClr val="E3F2EA"/>
+          </a:solidFill>
+          <a:ln>
+            <a:noFill/>
+          </a:ln>
+          <a:effectLst/>
+        </p:spPr>
+        <p:style>
+          <a:lnRef idx="1">
+            <a:schemeClr val="accent1"/>
+          </a:lnRef>
+          <a:fillRef idx="3">
+            <a:schemeClr val="accent1"/>
+          </a:fillRef>
+          <a:effectRef idx="2">
+            <a:schemeClr val="accent1"/>
+          </a:effectRef>
+          <a:fontRef idx="minor">
+            <a:schemeClr val="lt1"/>
+          </a:fontRef>
+        </p:style>
+        <p:txBody>
+          <a:bodyPr rtlCol="0" anchor="ctr"/>
+          <a:lstStyle/>
+          <a:p>
+            <a:pPr algn="ctr"/>
+          </a:p>
+        </p:txBody>
+      </p:sp>
+      <p:sp>
+        <p:nvSpPr>
+          <p:cNvPr id="12" name="TextBox 11"/>
+          <p:cNvSpPr txBox="1"/>
+          <p:nvPr/>
+        </p:nvSpPr>
+        <p:spPr>
+          <a:xfrm>
+            <a:off x="670560" y="2057400"/>
+            <a:ext cx="5181600" cy="381000"/>
+          </a:xfrm>
+          <a:prstGeom prst="rect">
+            <a:avLst/>
+          </a:prstGeom>
+          <a:noFill/>
+          <a:ln>
+            <a:noFill/>
+          </a:ln>
+        </p:spPr>
+        <p:txBody>
+          <a:bodyPr wrap="square" anchor="ctr" lIns="45000" rIns="45000" tIns="15000" bIns="15000">
+            <a:spAutoFit/>
+          </a:bodyPr>
+          <a:lstStyle/>
+          <a:p>
+            <a:pPr algn="l"/>
+            <a:r>
+              <a:rPr sz="1100" b="1" i="0">
+                <a:solidFill>
+                  <a:srgbClr val="1C4A35"/>
+                </a:solidFill>
+                <a:latin typeface="Calibri"/>
+              </a:rPr>
+              <a:t>✓  Zentraler Pool im IPS MO  (Empfehlung)</a:t>
+            </a:r>
+          </a:p>
+        </p:txBody>
+      </p:sp>
+      <p:sp>
+        <p:nvSpPr>
+          <p:cNvPr id="13" name="TextBox 12"/>
+          <p:cNvSpPr txBox="1"/>
+          <p:nvPr/>
+        </p:nvSpPr>
+        <p:spPr>
+          <a:xfrm>
+            <a:off x="685800" y="2514600"/>
+            <a:ext cx="5181600" cy="1447800"/>
+          </a:xfrm>
+          <a:prstGeom prst="rect">
+            <a:avLst/>
+          </a:prstGeom>
+          <a:noFill/>
+          <a:ln>
+            <a:noFill/>
+          </a:ln>
+        </p:spPr>
+        <p:txBody>
+          <a:bodyPr wrap="square" anchor="t" lIns="45000" rIns="45000" tIns="15000" bIns="15000">
+            <a:spAutoFit/>
+          </a:bodyPr>
+          <a:lstStyle/>
+          <a:p>
+            <a:pPr algn="l">
+              <a:lnSpc>
+                <a:spcPct val="110000"/>
+              </a:lnSpc>
+              <a:spcAft>
+                <a:spcPts val="400"/>
+              </a:spcAft>
+            </a:pPr>
+            <a:r>
+              <a:rPr sz="930" b="0" i="0">
+                <a:solidFill>
+                  <a:srgbClr val="1F2937"/>
+                </a:solidFill>
+                <a:latin typeface="Calibri"/>
+              </a:rPr>
+              <a:t>•  Neutrales Mandat über BSS / TSS / Cyber</a:t>
+            </a:r>
+          </a:p>
+          <a:p>
+            <a:pPr algn="l">
+              <a:lnSpc>
+                <a:spcPct val="110000"/>
+              </a:lnSpc>
+              <a:spcAft>
+                <a:spcPts val="400"/>
+              </a:spcAft>
+            </a:pPr>
+            <a:r>
+              <a:rPr sz="930" b="0" i="0">
+                <a:solidFill>
+                  <a:srgbClr val="1F2937"/>
+                </a:solidFill>
+                <a:latin typeface="Calibri"/>
+              </a:rPr>
+              <a:t>•  Ein Standard: Methode, KPIs, ServiceNow, Vertretung</a:t>
+            </a:r>
+          </a:p>
+          <a:p>
+            <a:pPr algn="l">
+              <a:lnSpc>
+                <a:spcPct val="110000"/>
+              </a:lnSpc>
+              <a:spcAft>
+                <a:spcPts val="400"/>
+              </a:spcAft>
+            </a:pPr>
+            <a:r>
+              <a:rPr sz="930" b="0" i="0">
+                <a:solidFill>
+                  <a:srgbClr val="1F2937"/>
+                </a:solidFill>
+                <a:latin typeface="Calibri"/>
+              </a:rPr>
+              <a:t>•  Gegenseitige Vertretung &amp; Karrierepfad im Pool</a:t>
+            </a:r>
+          </a:p>
+          <a:p>
+            <a:pPr algn="l">
+              <a:lnSpc>
+                <a:spcPct val="110000"/>
+              </a:lnSpc>
+              <a:spcAft>
+                <a:spcPts val="400"/>
+              </a:spcAft>
+            </a:pPr>
+            <a:r>
+              <a:rPr sz="930" b="0" i="0">
+                <a:solidFill>
+                  <a:srgbClr val="1F2937"/>
+                </a:solidFill>
+                <a:latin typeface="Calibri"/>
+              </a:rPr>
+              <a:t>•  Head of SDM balanciert Kapazität über Cluster</a:t>
+            </a:r>
+          </a:p>
+          <a:p>
+            <a:pPr algn="l">
+              <a:lnSpc>
+                <a:spcPct val="110000"/>
+              </a:lnSpc>
+              <a:spcAft>
+                <a:spcPts val="400"/>
+              </a:spcAft>
+            </a:pPr>
+            <a:r>
+              <a:rPr sz="930" b="0" i="0">
+                <a:solidFill>
+                  <a:srgbClr val="1F2937"/>
+                </a:solidFill>
+                <a:latin typeface="Calibri"/>
+              </a:rPr>
+              <a:t>•  Kein Rückfall in „pro-Service-Owner“-Silos</a:t>
+            </a:r>
+          </a:p>
+        </p:txBody>
+      </p:sp>
+      <p:sp>
+        <p:nvSpPr>
+          <p:cNvPr id="14" name="Rounded Rectangle 13"/>
+          <p:cNvSpPr/>
+          <p:nvPr/>
+        </p:nvSpPr>
+        <p:spPr>
+          <a:xfrm>
+            <a:off x="6210300" y="2057400"/>
+            <a:ext cx="5448300" cy="1981200"/>
+          </a:xfrm>
+          <a:prstGeom prst="roundRect">
+            <a:avLst>
+              <a:gd name="adj" fmla="val 8000"/>
+            </a:avLst>
+          </a:prstGeom>
+          <a:solidFill>
+            <a:srgbClr val="FFFFFF"/>
+          </a:solidFill>
+          <a:ln w="15875">
+            <a:solidFill>
+              <a:srgbClr val="B91C1C"/>
+            </a:solidFill>
+          </a:ln>
+          <a:effectLst/>
+        </p:spPr>
+        <p:style>
+          <a:lnRef idx="1">
+            <a:schemeClr val="accent1"/>
+          </a:lnRef>
+          <a:fillRef idx="3">
+            <a:schemeClr val="accent1"/>
+          </a:fillRef>
+          <a:effectRef idx="2">
+            <a:schemeClr val="accent1"/>
+          </a:effectRef>
+          <a:fontRef idx="minor">
+            <a:schemeClr val="lt1"/>
+          </a:fontRef>
+        </p:style>
+        <p:txBody>
+          <a:bodyPr rtlCol="0" anchor="ctr"/>
+          <a:lstStyle/>
+          <a:p>
+            <a:pPr algn="ctr"/>
+          </a:p>
+        </p:txBody>
+      </p:sp>
+      <p:sp>
+        <p:nvSpPr>
+          <p:cNvPr id="15" name="Rectangle 14"/>
+          <p:cNvSpPr/>
+          <p:nvPr/>
+        </p:nvSpPr>
+        <p:spPr>
+          <a:xfrm>
+            <a:off x="6210300" y="2057400"/>
+            <a:ext cx="5448300" cy="381000"/>
+          </a:xfrm>
+          <a:prstGeom prst="rect">
+            <a:avLst/>
+          </a:prstGeom>
+          <a:solidFill>
+            <a:srgbClr val="FBE4E1"/>
+          </a:solidFill>
+          <a:ln>
+            <a:noFill/>
+          </a:ln>
+          <a:effectLst/>
+        </p:spPr>
+        <p:style>
+          <a:lnRef idx="1">
+            <a:schemeClr val="accent1"/>
+          </a:lnRef>
+          <a:fillRef idx="3">
+            <a:schemeClr val="accent1"/>
+          </a:fillRef>
+          <a:effectRef idx="2">
+            <a:schemeClr val="accent1"/>
+          </a:effectRef>
+          <a:fontRef idx="minor">
+            <a:schemeClr val="lt1"/>
+          </a:fontRef>
+        </p:style>
+        <p:txBody>
+          <a:bodyPr rtlCol="0" anchor="ctr"/>
+          <a:lstStyle/>
+          <a:p>
+            <a:pPr algn="ctr"/>
+          </a:p>
+        </p:txBody>
+      </p:sp>
+      <p:sp>
+        <p:nvSpPr>
+          <p:cNvPr id="16" name="TextBox 15"/>
+          <p:cNvSpPr txBox="1"/>
+          <p:nvPr/>
+        </p:nvSpPr>
+        <p:spPr>
+          <a:xfrm>
+            <a:off x="6347460" y="2057400"/>
+            <a:ext cx="5181600" cy="381000"/>
+          </a:xfrm>
+          <a:prstGeom prst="rect">
+            <a:avLst/>
+          </a:prstGeom>
+          <a:noFill/>
+          <a:ln>
+            <a:noFill/>
+          </a:ln>
+        </p:spPr>
+        <p:txBody>
+          <a:bodyPr wrap="square" anchor="ctr" lIns="45000" rIns="45000" tIns="15000" bIns="15000">
+            <a:spAutoFit/>
+          </a:bodyPr>
+          <a:lstStyle/>
+          <a:p>
+            <a:pPr algn="l"/>
+            <a:r>
+              <a:rPr sz="1100" b="1" i="0">
+                <a:solidFill>
+                  <a:srgbClr val="B91C1C"/>
+                </a:solidFill>
+                <a:latin typeface="Calibri"/>
+              </a:rPr>
+              <a:t>✗  SDMs berichten IN die Einheiten  (Risiko)</a:t>
+            </a:r>
+          </a:p>
+        </p:txBody>
+      </p:sp>
+      <p:sp>
+        <p:nvSpPr>
+          <p:cNvPr id="17" name="TextBox 16"/>
+          <p:cNvSpPr txBox="1"/>
+          <p:nvPr/>
+        </p:nvSpPr>
+        <p:spPr>
+          <a:xfrm>
+            <a:off x="6362700" y="2514600"/>
+            <a:ext cx="5181600" cy="1447800"/>
+          </a:xfrm>
+          <a:prstGeom prst="rect">
+            <a:avLst/>
+          </a:prstGeom>
+          <a:noFill/>
+          <a:ln>
+            <a:noFill/>
+          </a:ln>
+        </p:spPr>
+        <p:txBody>
+          <a:bodyPr wrap="square" anchor="t" lIns="45000" rIns="45000" tIns="15000" bIns="15000">
+            <a:spAutoFit/>
+          </a:bodyPr>
+          <a:lstStyle/>
+          <a:p>
+            <a:pPr algn="l">
+              <a:lnSpc>
+                <a:spcPct val="110000"/>
+              </a:lnSpc>
+              <a:spcAft>
+                <a:spcPts val="400"/>
+              </a:spcAft>
+            </a:pPr>
+            <a:r>
+              <a:rPr sz="930" b="0" i="0">
+                <a:solidFill>
+                  <a:srgbClr val="1F2937"/>
+                </a:solidFill>
+                <a:latin typeface="Calibri"/>
+              </a:rPr>
+              <a:t>•  Peer koordiniert Peer → schwaches Mandat</a:t>
+            </a:r>
+          </a:p>
+          <a:p>
+            <a:pPr algn="l">
+              <a:lnSpc>
+                <a:spcPct val="110000"/>
+              </a:lnSpc>
+              <a:spcAft>
+                <a:spcPts val="400"/>
+              </a:spcAft>
+            </a:pPr>
+            <a:r>
+              <a:rPr sz="930" b="0" i="0">
+                <a:solidFill>
+                  <a:srgbClr val="1F2937"/>
+                </a:solidFill>
+                <a:latin typeface="Calibri"/>
+              </a:rPr>
+              <a:t>•  Loyalitätskonflikt zur eigenen Einheit</a:t>
+            </a:r>
+          </a:p>
+          <a:p>
+            <a:pPr algn="l">
+              <a:lnSpc>
+                <a:spcPct val="110000"/>
+              </a:lnSpc>
+              <a:spcAft>
+                <a:spcPts val="400"/>
+              </a:spcAft>
+            </a:pPr>
+            <a:r>
+              <a:rPr sz="930" b="0" i="0">
+                <a:solidFill>
+                  <a:srgbClr val="1F2937"/>
+                </a:solidFill>
+                <a:latin typeface="Calibri"/>
+              </a:rPr>
+              <a:t>•  „Acht Dialekte“: Methode/KPI/Tool driften</a:t>
+            </a:r>
+          </a:p>
+          <a:p>
+            <a:pPr algn="l">
+              <a:lnSpc>
+                <a:spcPct val="110000"/>
+              </a:lnSpc>
+              <a:spcAft>
+                <a:spcPts val="400"/>
+              </a:spcAft>
+            </a:pPr>
+            <a:r>
+              <a:rPr sz="930" b="0" i="0">
+                <a:solidFill>
+                  <a:srgbClr val="1F2937"/>
+                </a:solidFill>
+                <a:latin typeface="Calibri"/>
+              </a:rPr>
+              <a:t>•  Head of SDM trägt Verantwortung ohne Autorität</a:t>
+            </a:r>
+          </a:p>
+          <a:p>
+            <a:pPr algn="l">
+              <a:lnSpc>
+                <a:spcPct val="110000"/>
+              </a:lnSpc>
+              <a:spcAft>
+                <a:spcPts val="400"/>
+              </a:spcAft>
+            </a:pPr>
+            <a:r>
+              <a:rPr sz="930" b="0" i="0">
+                <a:solidFill>
+                  <a:srgbClr val="1F2937"/>
+                </a:solidFill>
+                <a:latin typeface="Calibri"/>
+              </a:rPr>
+              <a:t>•  Faktischer Rückfall zum heutigen Status quo</a:t>
+            </a:r>
+          </a:p>
+        </p:txBody>
+      </p:sp>
+      <p:sp>
+        <p:nvSpPr>
+          <p:cNvPr id="18" name="Rounded Rectangle 17"/>
+          <p:cNvSpPr/>
+          <p:nvPr/>
+        </p:nvSpPr>
+        <p:spPr>
+          <a:xfrm>
+            <a:off x="533400" y="4267200"/>
+            <a:ext cx="11125200" cy="990600"/>
+          </a:xfrm>
+          <a:prstGeom prst="roundRect">
+            <a:avLst>
+              <a:gd name="adj" fmla="val 8000"/>
+            </a:avLst>
+          </a:prstGeom>
+          <a:solidFill>
+            <a:srgbClr val="FDE6CC"/>
+          </a:solidFill>
+          <a:ln>
+            <a:noFill/>
+          </a:ln>
+          <a:effectLst/>
+        </p:spPr>
+        <p:style>
+          <a:lnRef idx="1">
+            <a:schemeClr val="accent1"/>
+          </a:lnRef>
+          <a:fillRef idx="3">
+            <a:schemeClr val="accent1"/>
+          </a:fillRef>
+          <a:effectRef idx="2">
+            <a:schemeClr val="accent1"/>
+          </a:effectRef>
+          <a:fontRef idx="minor">
+            <a:schemeClr val="lt1"/>
+          </a:fontRef>
+        </p:style>
+        <p:txBody>
+          <a:bodyPr rtlCol="0" anchor="ctr"/>
+          <a:lstStyle/>
+          <a:p>
+            <a:pPr algn="ctr"/>
+          </a:p>
+        </p:txBody>
+      </p:sp>
+      <p:sp>
+        <p:nvSpPr>
+          <p:cNvPr id="19" name="Rectangle 18"/>
+          <p:cNvSpPr/>
+          <p:nvPr/>
+        </p:nvSpPr>
+        <p:spPr>
+          <a:xfrm>
+            <a:off x="533400" y="4267200"/>
+            <a:ext cx="76200" cy="990600"/>
+          </a:xfrm>
+          <a:prstGeom prst="rect">
+            <a:avLst/>
+          </a:prstGeom>
+          <a:solidFill>
+            <a:srgbClr val="F07F12"/>
+          </a:solidFill>
+          <a:ln>
+            <a:noFill/>
+          </a:ln>
+          <a:effectLst/>
+        </p:spPr>
+        <p:style>
+          <a:lnRef idx="1">
+            <a:schemeClr val="accent1"/>
+          </a:lnRef>
+          <a:fillRef idx="3">
+            <a:schemeClr val="accent1"/>
+          </a:fillRef>
+          <a:effectRef idx="2">
+            <a:schemeClr val="accent1"/>
+          </a:effectRef>
+          <a:fontRef idx="minor">
+            <a:schemeClr val="lt1"/>
+          </a:fontRef>
+        </p:style>
+        <p:txBody>
+          <a:bodyPr rtlCol="0" anchor="ctr"/>
+          <a:lstStyle/>
+          <a:p>
+            <a:pPr algn="ctr"/>
+          </a:p>
+        </p:txBody>
+      </p:sp>
+      <p:sp>
+        <p:nvSpPr>
+          <p:cNvPr id="20" name="TextBox 19"/>
+          <p:cNvSpPr txBox="1"/>
+          <p:nvPr/>
+        </p:nvSpPr>
+        <p:spPr>
+          <a:xfrm>
+            <a:off x="723900" y="4328160"/>
+            <a:ext cx="10820400" cy="304800"/>
+          </a:xfrm>
+          <a:prstGeom prst="rect">
+            <a:avLst/>
+          </a:prstGeom>
+          <a:noFill/>
+          <a:ln>
+            <a:noFill/>
+          </a:ln>
+        </p:spPr>
+        <p:txBody>
+          <a:bodyPr wrap="square" anchor="t" lIns="45000" rIns="45000" tIns="15000" bIns="15000">
+            <a:spAutoFit/>
+          </a:bodyPr>
+          <a:lstStyle/>
+          <a:p>
+            <a:pPr algn="l"/>
+            <a:r>
+              <a:rPr sz="1150" b="1" i="0">
+                <a:solidFill>
+                  <a:srgbClr val="B4531A"/>
+                </a:solidFill>
+                <a:latin typeface="Calibri"/>
+              </a:rPr>
+              <a:t>Head of SDM zentral + SDMs verteilt — geht das?</a:t>
+            </a:r>
+          </a:p>
+        </p:txBody>
+      </p:sp>
+      <p:sp>
+        <p:nvSpPr>
+          <p:cNvPr id="21" name="TextBox 20"/>
+          <p:cNvSpPr txBox="1"/>
+          <p:nvPr/>
+        </p:nvSpPr>
+        <p:spPr>
+          <a:xfrm>
+            <a:off x="723900" y="4617720"/>
+            <a:ext cx="10820400" cy="609600"/>
+          </a:xfrm>
+          <a:prstGeom prst="rect">
+            <a:avLst/>
+          </a:prstGeom>
+          <a:noFill/>
+          <a:ln>
+            <a:noFill/>
+          </a:ln>
+        </p:spPr>
+        <p:txBody>
+          <a:bodyPr wrap="square" anchor="t" lIns="45000" rIns="45000" tIns="15000" bIns="15000">
+            <a:spAutoFit/>
+          </a:bodyPr>
+          <a:lstStyle/>
+          <a:p>
+            <a:pPr algn="l">
+              <a:lnSpc>
+                <a:spcPct val="115000"/>
+              </a:lnSpc>
+            </a:pPr>
+            <a:r>
+              <a:rPr sz="1050" b="1" i="0">
+                <a:solidFill>
+                  <a:srgbClr val="1F2937"/>
+                </a:solidFill>
+                <a:latin typeface="Calibri"/>
+              </a:rPr>
+              <a:t>Ja — unter Bedingungen. </a:t>
+            </a:r>
+            <a:r>
+              <a:rPr sz="1050" b="0" i="0">
+                <a:solidFill>
+                  <a:srgbClr val="4B5563"/>
+                </a:solidFill>
+                <a:latin typeface="Calibri"/>
+              </a:rPr>
+              <a:t>Tragfähig, solange der Head of SDM eine fachliche </a:t>
+            </a:r>
+            <a:r>
+              <a:rPr sz="1050" b="1" i="0">
+                <a:solidFill>
+                  <a:srgbClr val="1F2937"/>
+                </a:solidFill>
+                <a:latin typeface="Calibri"/>
+              </a:rPr>
+              <a:t>Solid-Line</a:t>
+            </a:r>
+            <a:r>
+              <a:rPr sz="1050" b="0" i="0">
+                <a:solidFill>
+                  <a:srgbClr val="4B5563"/>
+                </a:solidFill>
+                <a:latin typeface="Calibri"/>
+              </a:rPr>
+              <a:t> zu allen SDMs hat und Methode, KPIs, Tooling sowie das einheitenübergreifende Mandat zentral bleiben. Dann ist es faktisch der zentrale Pool mit dezentralem Einsatz — nicht „verteilt“ im problematischen Sinn. Ohne diese Guardrails kippt es in die rechte Spalte.</a:t>
+            </a:r>
+          </a:p>
+        </p:txBody>
+      </p:sp>
+      <p:sp>
+        <p:nvSpPr>
+          <p:cNvPr id="22" name="Rounded Rectangle 21"/>
+          <p:cNvSpPr/>
+          <p:nvPr/>
+        </p:nvSpPr>
+        <p:spPr>
+          <a:xfrm>
+            <a:off x="533400" y="5448300"/>
+            <a:ext cx="11125200" cy="914400"/>
+          </a:xfrm>
+          <a:prstGeom prst="roundRect">
+            <a:avLst>
+              <a:gd name="adj" fmla="val 8000"/>
+            </a:avLst>
+          </a:prstGeom>
+          <a:solidFill>
+            <a:srgbClr val="E3F2EA"/>
+          </a:solidFill>
+          <a:ln>
+            <a:noFill/>
+          </a:ln>
+          <a:effectLst/>
+        </p:spPr>
+        <p:style>
+          <a:lnRef idx="1">
+            <a:schemeClr val="accent1"/>
+          </a:lnRef>
+          <a:fillRef idx="3">
+            <a:schemeClr val="accent1"/>
+          </a:fillRef>
+          <a:effectRef idx="2">
+            <a:schemeClr val="accent1"/>
+          </a:effectRef>
+          <a:fontRef idx="minor">
+            <a:schemeClr val="lt1"/>
+          </a:fontRef>
+        </p:style>
+        <p:txBody>
+          <a:bodyPr rtlCol="0" anchor="ctr"/>
+          <a:lstStyle/>
+          <a:p>
+            <a:pPr algn="ctr"/>
+          </a:p>
+        </p:txBody>
+      </p:sp>
+      <p:sp>
+        <p:nvSpPr>
+          <p:cNvPr id="23" name="TextBox 22"/>
+          <p:cNvSpPr txBox="1"/>
+          <p:nvPr/>
+        </p:nvSpPr>
+        <p:spPr>
+          <a:xfrm>
+            <a:off x="723900" y="5509260"/>
+            <a:ext cx="10820400" cy="304800"/>
+          </a:xfrm>
+          <a:prstGeom prst="rect">
+            <a:avLst/>
+          </a:prstGeom>
+          <a:noFill/>
+          <a:ln>
+            <a:noFill/>
+          </a:ln>
+        </p:spPr>
+        <p:txBody>
+          <a:bodyPr wrap="square" anchor="t" lIns="45000" rIns="45000" tIns="15000" bIns="15000">
+            <a:spAutoFit/>
+          </a:bodyPr>
+          <a:lstStyle/>
+          <a:p>
+            <a:pPr algn="l"/>
+            <a:r>
+              <a:rPr sz="1050" b="1" i="0">
+                <a:solidFill>
+                  <a:srgbClr val="1C4A35"/>
+                </a:solidFill>
+                <a:latin typeface="Calibri"/>
+              </a:rPr>
+              <a:t>Empfehlung</a:t>
+            </a:r>
+          </a:p>
+        </p:txBody>
+      </p:sp>
+      <p:sp>
+        <p:nvSpPr>
+          <p:cNvPr id="24" name="TextBox 23"/>
+          <p:cNvSpPr txBox="1"/>
+          <p:nvPr/>
+        </p:nvSpPr>
+        <p:spPr>
+          <a:xfrm>
+            <a:off x="723900" y="5791200"/>
+            <a:ext cx="10820400" cy="533400"/>
+          </a:xfrm>
+          <a:prstGeom prst="rect">
+            <a:avLst/>
+          </a:prstGeom>
+          <a:noFill/>
+          <a:ln>
+            <a:noFill/>
+          </a:ln>
+        </p:spPr>
+        <p:txBody>
+          <a:bodyPr wrap="square" anchor="t" lIns="45000" rIns="45000" tIns="15000" bIns="15000">
+            <a:spAutoFit/>
+          </a:bodyPr>
+          <a:lstStyle/>
+          <a:p>
+            <a:pPr algn="l">
+              <a:lnSpc>
+                <a:spcPct val="115000"/>
+              </a:lnSpc>
+            </a:pPr>
+            <a:r>
+              <a:rPr sz="1000" b="1" i="0">
+                <a:solidFill>
+                  <a:srgbClr val="1F2937"/>
+                </a:solidFill>
+                <a:latin typeface="Calibri"/>
+              </a:rPr>
+              <a:t>Zielbild: </a:t>
+            </a:r>
+            <a:r>
+              <a:rPr sz="1000" b="0" i="0">
+                <a:solidFill>
+                  <a:srgbClr val="4B5563"/>
+                </a:solidFill>
+                <a:latin typeface="Calibri"/>
+              </a:rPr>
+              <a:t>zentraler SDM-Pool im IPS MO. </a:t>
+            </a:r>
+            <a:r>
+              <a:rPr sz="1000" b="1" i="0">
+                <a:solidFill>
+                  <a:srgbClr val="1F2937"/>
+                </a:solidFill>
+                <a:latin typeface="Calibri"/>
+              </a:rPr>
+              <a:t>Übergang / politischer Kompromiss: </a:t>
+            </a:r>
+            <a:r>
+              <a:rPr sz="1000" b="0" i="0">
+                <a:solidFill>
+                  <a:srgbClr val="4B5563"/>
+                </a:solidFill>
+                <a:latin typeface="Calibri"/>
+              </a:rPr>
+              <a:t>Head of SDM zentral, SDMs co-located in den Clustern, aber mit Solid-Line zum Head of SDM — als Phase-3-Etappe der Migration. Entscheidend ist die Berichtslinie, nicht der Schreibtisch.</a:t>
             </a:r>
           </a:p>
         </p:txBody>

</xml_diff>